<commit_message>
E3: deck slide 1 — paleta pastel, tipografía, íconos y tres pilares
Co-Authored-By: Claude Sonnet 4.6 <noreply@anthropic.com>
</commit_message>
<xml_diff>
--- a/business/CareSignal_Pitch_Deck.pptx
+++ b/business/CareSignal_Pitch_Deck.pptx
@@ -883,11 +883,11 @@
             <a:avLst/>
           </a:prstGeom>
           <a:solidFill>
-            <a:srgbClr val="0A0A0A"/>
+            <a:srgbClr val="FAFAF8"/>
           </a:solidFill>
           <a:ln w="12700">
             <a:solidFill>
-              <a:srgbClr val="0A0A0A"/>
+              <a:srgbClr val="FAFAF8"/>
             </a:solidFill>
             <a:prstDash val="solid"/>
           </a:ln>
@@ -902,17 +902,17 @@
         <p:spPr>
           <a:xfrm>
             <a:off x="0" y="0"/>
-            <a:ext cx="109728" cy="6858000"/>
-          </a:xfrm>
-          <a:prstGeom prst="rect">
-            <a:avLst/>
-          </a:prstGeom>
-          <a:solidFill>
-            <a:srgbClr val="2563EB"/>
+            <a:ext cx="12192000" cy="73152"/>
+          </a:xfrm>
+          <a:prstGeom prst="rect">
+            <a:avLst/>
+          </a:prstGeom>
+          <a:solidFill>
+            <a:srgbClr val="5B8DB8"/>
           </a:solidFill>
           <a:ln w="12700">
             <a:solidFill>
-              <a:srgbClr val="2563EB"/>
+              <a:srgbClr val="5B8DB8"/>
             </a:solidFill>
             <a:prstDash val="solid"/>
           </a:ln>
@@ -920,14 +920,39 @@
       </p:sp>
       <p:sp>
         <p:nvSpPr>
-          <p:cNvPr id="4" name="Text 2"/>
+          <p:cNvPr id="4" name="Shape 2"/>
           <p:cNvSpPr/>
           <p:nvPr/>
         </p:nvSpPr>
         <p:spPr>
           <a:xfrm>
-            <a:off x="365760" y="1005840"/>
-            <a:ext cx="8229600" cy="914400"/>
+            <a:off x="0" y="6510528"/>
+            <a:ext cx="12192000" cy="73152"/>
+          </a:xfrm>
+          <a:prstGeom prst="rect">
+            <a:avLst/>
+          </a:prstGeom>
+          <a:solidFill>
+            <a:srgbClr val="C4786A"/>
+          </a:solidFill>
+          <a:ln w="12700">
+            <a:solidFill>
+              <a:srgbClr val="C4786A"/>
+            </a:solidFill>
+            <a:prstDash val="solid"/>
+          </a:ln>
+        </p:spPr>
+      </p:sp>
+      <p:sp>
+        <p:nvSpPr>
+          <p:cNvPr id="5" name="Text 3"/>
+          <p:cNvSpPr/>
+          <p:nvPr/>
+        </p:nvSpPr>
+        <p:spPr>
+          <a:xfrm>
+            <a:off x="457200" y="822960"/>
+            <a:ext cx="914400" cy="914400"/>
           </a:xfrm>
           <a:prstGeom prst="rect">
             <a:avLst/>
@@ -939,13 +964,49 @@
           <a:bodyPr wrap="square" rtlCol="0" anchor="ctr"/>
           <a:lstStyle/>
           <a:p>
+            <a:pPr algn="ctr" indent="0" marL="0">
+              <a:buNone/>
+            </a:pPr>
+            <a:r>
+              <a:rPr lang="en-US" sz="4800" dirty="0">
+                <a:solidFill>
+                  <a:srgbClr val="000000"/>
+                </a:solidFill>
+              </a:rPr>
+              <a:t>🛡️</a:t>
+            </a:r>
+            <a:endParaRPr lang="en-US" sz="4800" dirty="0"/>
+          </a:p>
+        </p:txBody>
+      </p:sp>
+      <p:sp>
+        <p:nvSpPr>
+          <p:cNvPr id="6" name="Text 4"/>
+          <p:cNvSpPr/>
+          <p:nvPr/>
+        </p:nvSpPr>
+        <p:spPr>
+          <a:xfrm>
+            <a:off x="1463040" y="868680"/>
+            <a:ext cx="7132320" cy="822960"/>
+          </a:xfrm>
+          <a:prstGeom prst="rect">
+            <a:avLst/>
+          </a:prstGeom>
+          <a:noFill/>
+          <a:ln/>
+        </p:spPr>
+        <p:txBody>
+          <a:bodyPr wrap="square" rtlCol="0" anchor="ctr"/>
+          <a:lstStyle/>
+          <a:p>
             <a:pPr indent="0" marL="0">
               <a:buNone/>
             </a:pPr>
             <a:r>
-              <a:rPr lang="en-US" sz="5400" b="1" dirty="0">
+              <a:rPr lang="en-US" b="1" dirty="0">
                 <a:solidFill>
-                  <a:srgbClr val="F8FAFC"/>
+                  <a:srgbClr val="2D3748"/>
                 </a:solidFill>
                 <a:latin typeface="Arial" pitchFamily="34" charset="0"/>
                 <a:ea typeface="Arial" pitchFamily="34" charset="-122"/>
@@ -953,20 +1014,20 @@
               </a:rPr>
               <a:t>CareSignal</a:t>
             </a:r>
-            <a:endParaRPr lang="en-US" sz="5400" dirty="0"/>
+            <a:endParaRPr lang="en-US" dirty="0"/>
           </a:p>
         </p:txBody>
       </p:sp>
       <p:sp>
         <p:nvSpPr>
-          <p:cNvPr id="5" name="Text 3"/>
+          <p:cNvPr id="7" name="Text 5"/>
           <p:cNvSpPr/>
           <p:nvPr/>
         </p:nvSpPr>
         <p:spPr>
           <a:xfrm>
-            <a:off x="365760" y="1920240"/>
-            <a:ext cx="7772400" cy="457200"/>
+            <a:off x="1463040" y="1691640"/>
+            <a:ext cx="7132320" cy="411480"/>
           </a:xfrm>
           <a:prstGeom prst="rect">
             <a:avLst/>
@@ -982,9 +1043,9 @@
               <a:buNone/>
             </a:pPr>
             <a:r>
-              <a:rPr lang="en-US" sz="2000" dirty="0">
+              <a:rPr lang="en-US" dirty="0">
                 <a:solidFill>
-                  <a:srgbClr val="3B82F6"/>
+                  <a:srgbClr val="5B8DB8"/>
                 </a:solidFill>
                 <a:latin typeface="Arial" pitchFamily="34" charset="0"/>
                 <a:ea typeface="Arial" pitchFamily="34" charset="-122"/>
@@ -992,28 +1053,28 @@
               </a:rPr>
               <a:t>Trazabilidad operativa para residencias de adultos mayores</a:t>
             </a:r>
-            <a:endParaRPr lang="en-US" sz="2000" dirty="0"/>
+            <a:endParaRPr lang="en-US" dirty="0"/>
           </a:p>
         </p:txBody>
       </p:sp>
       <p:sp>
         <p:nvSpPr>
-          <p:cNvPr id="6" name="Shape 4"/>
+          <p:cNvPr id="8" name="Shape 6"/>
           <p:cNvSpPr/>
           <p:nvPr/>
         </p:nvSpPr>
         <p:spPr>
           <a:xfrm>
-            <a:off x="365760" y="2514600"/>
-            <a:ext cx="8046720" cy="0"/>
+            <a:off x="457200" y="2286000"/>
+            <a:ext cx="8375904" cy="0"/>
           </a:xfrm>
           <a:prstGeom prst="line">
             <a:avLst/>
           </a:prstGeom>
           <a:noFill/>
-          <a:ln w="19050">
+          <a:ln w="15240">
             <a:solidFill>
-              <a:srgbClr val="2563EB"/>
+              <a:srgbClr val="E2E8F0"/>
             </a:solidFill>
             <a:prstDash val="solid"/>
           </a:ln>
@@ -1021,14 +1082,41 @@
       </p:sp>
       <p:sp>
         <p:nvSpPr>
-          <p:cNvPr id="7" name="Text 5"/>
+          <p:cNvPr id="9" name="Shape 7"/>
           <p:cNvSpPr/>
           <p:nvPr/>
         </p:nvSpPr>
         <p:spPr>
           <a:xfrm>
-            <a:off x="365760" y="2697480"/>
-            <a:ext cx="6400800" cy="320040"/>
+            <a:off x="457200" y="2560320"/>
+            <a:ext cx="2606040" cy="2011680"/>
+          </a:xfrm>
+          <a:prstGeom prst="roundRect">
+            <a:avLst>
+              <a:gd name="adj" fmla="val 3636"/>
+            </a:avLst>
+          </a:prstGeom>
+          <a:solidFill>
+            <a:srgbClr val="F0EDE8"/>
+          </a:solidFill>
+          <a:ln w="6350">
+            <a:solidFill>
+              <a:srgbClr val="E2E8F0"/>
+            </a:solidFill>
+            <a:prstDash val="solid"/>
+          </a:ln>
+        </p:spPr>
+      </p:sp>
+      <p:sp>
+        <p:nvSpPr>
+          <p:cNvPr id="10" name="Text 8"/>
+          <p:cNvSpPr/>
+          <p:nvPr/>
+        </p:nvSpPr>
+        <p:spPr>
+          <a:xfrm>
+            <a:off x="457200" y="2697480"/>
+            <a:ext cx="2606040" cy="548640"/>
           </a:xfrm>
           <a:prstGeom prst="rect">
             <a:avLst/>
@@ -1040,112 +1128,131 @@
           <a:bodyPr wrap="square" rtlCol="0" anchor="ctr"/>
           <a:lstStyle/>
           <a:p>
-            <a:pPr indent="0" marL="0">
+            <a:pPr algn="ctr" indent="0" marL="0">
               <a:buNone/>
             </a:pPr>
             <a:r>
+              <a:rPr lang="en-US" sz="3000" dirty="0">
+                <a:solidFill>
+                  <a:srgbClr val="000000"/>
+                </a:solidFill>
+              </a:rPr>
+              <a:t>⏱️</a:t>
+            </a:r>
+            <a:endParaRPr lang="en-US" sz="3000" dirty="0"/>
+          </a:p>
+        </p:txBody>
+      </p:sp>
+      <p:sp>
+        <p:nvSpPr>
+          <p:cNvPr id="11" name="Text 9"/>
+          <p:cNvSpPr/>
+          <p:nvPr/>
+        </p:nvSpPr>
+        <p:spPr>
+          <a:xfrm>
+            <a:off x="457200" y="3291840"/>
+            <a:ext cx="2606040" cy="1005840"/>
+          </a:xfrm>
+          <a:prstGeom prst="rect">
+            <a:avLst/>
+          </a:prstGeom>
+          <a:noFill/>
+          <a:ln/>
+        </p:spPr>
+        <p:txBody>
+          <a:bodyPr wrap="square" rtlCol="0" anchor="ctr"/>
+          <a:lstStyle/>
+          <a:p>
+            <a:pPr algn="ctr" indent="0" marL="0">
+              <a:buNone/>
+            </a:pPr>
+            <a:r>
               <a:rPr lang="en-US" sz="1300" dirty="0">
                 <a:solidFill>
-                  <a:srgbClr val="94A3B8"/>
+                  <a:srgbClr val="2D3748"/>
                 </a:solidFill>
                 <a:latin typeface="Arial" pitchFamily="34" charset="0"/>
                 <a:ea typeface="Arial" pitchFamily="34" charset="-122"/>
                 <a:cs typeface="Arial" pitchFamily="34" charset="-120"/>
               </a:rPr>
-              <a:t>Pitch · 4 minutos · WomenCISO 4 / MenCISO 1</a:t>
+              <a:t>Detección</a:t>
             </a:r>
             <a:endParaRPr lang="en-US" sz="1300" dirty="0"/>
           </a:p>
-        </p:txBody>
-      </p:sp>
-      <p:sp>
-        <p:nvSpPr>
-          <p:cNvPr id="8" name="Text 6"/>
-          <p:cNvSpPr/>
-          <p:nvPr/>
-        </p:nvSpPr>
-        <p:spPr>
-          <a:xfrm>
-            <a:off x="365760" y="3108960"/>
-            <a:ext cx="3657600" cy="274320"/>
-          </a:xfrm>
-          <a:prstGeom prst="rect">
-            <a:avLst/>
-          </a:prstGeom>
-          <a:noFill/>
-          <a:ln/>
-        </p:spPr>
-        <p:txBody>
-          <a:bodyPr wrap="square" rtlCol="0" anchor="ctr"/>
-          <a:lstStyle/>
-          <a:p>
-            <a:pPr indent="0" marL="0">
+          <a:p>
+            <a:pPr algn="ctr" indent="0" marL="0">
               <a:buNone/>
             </a:pPr>
             <a:r>
-              <a:rPr lang="en-US" sz="1200" dirty="0">
+              <a:rPr lang="en-US" sz="1300" dirty="0">
                 <a:solidFill>
-                  <a:srgbClr val="94A3B8"/>
+                  <a:srgbClr val="2D3748"/>
                 </a:solidFill>
                 <a:latin typeface="Arial" pitchFamily="34" charset="0"/>
                 <a:ea typeface="Arial" pitchFamily="34" charset="-122"/>
                 <a:cs typeface="Arial" pitchFamily="34" charset="-120"/>
               </a:rPr>
-              <a:t>Agosto 2026</a:t>
-            </a:r>
-            <a:endParaRPr lang="en-US" sz="1200" dirty="0"/>
-          </a:p>
-        </p:txBody>
-      </p:sp>
-      <p:sp>
-        <p:nvSpPr>
-          <p:cNvPr id="9" name="Text 7"/>
-          <p:cNvSpPr/>
-          <p:nvPr/>
-        </p:nvSpPr>
-        <p:spPr>
-          <a:xfrm>
-            <a:off x="2286000" y="6263640"/>
-            <a:ext cx="6492240" cy="256032"/>
-          </a:xfrm>
-          <a:prstGeom prst="rect">
-            <a:avLst/>
-          </a:prstGeom>
-          <a:noFill/>
-          <a:ln/>
-        </p:spPr>
-        <p:txBody>
-          <a:bodyPr wrap="square" rtlCol="0" anchor="ctr"/>
-          <a:lstStyle/>
-          <a:p>
-            <a:pPr algn="r" indent="0" marL="0">
+              <a:t>automática de</a:t>
+            </a:r>
+            <a:endParaRPr lang="en-US" sz="1300" dirty="0"/>
+          </a:p>
+          <a:p>
+            <a:pPr algn="ctr" indent="0" marL="0">
               <a:buNone/>
             </a:pPr>
             <a:r>
-              <a:rPr lang="en-US" sz="900" dirty="0">
+              <a:rPr lang="en-US" sz="1300" dirty="0">
                 <a:solidFill>
-                  <a:srgbClr val="94A3B8"/>
+                  <a:srgbClr val="2D3748"/>
                 </a:solidFill>
                 <a:latin typeface="Arial" pitchFamily="34" charset="0"/>
                 <a:ea typeface="Arial" pitchFamily="34" charset="-122"/>
                 <a:cs typeface="Arial" pitchFamily="34" charset="-120"/>
               </a:rPr>
-              <a:t>MVP operacional · No dispositivo médico · Datos ficticios</a:t>
-            </a:r>
-            <a:endParaRPr lang="en-US" sz="900" dirty="0"/>
+              <a:t>rondas atrasadas</a:t>
+            </a:r>
+            <a:endParaRPr lang="en-US" sz="1300" dirty="0"/>
           </a:p>
         </p:txBody>
       </p:sp>
       <p:sp>
         <p:nvSpPr>
-          <p:cNvPr id="10" name="Text 8"/>
+          <p:cNvPr id="12" name="Shape 10"/>
           <p:cNvSpPr/>
           <p:nvPr/>
         </p:nvSpPr>
         <p:spPr>
           <a:xfrm>
-            <a:off x="365760" y="6263640"/>
-            <a:ext cx="2743200" cy="256032"/>
+            <a:off x="3291840" y="2560320"/>
+            <a:ext cx="2606040" cy="2011680"/>
+          </a:xfrm>
+          <a:prstGeom prst="roundRect">
+            <a:avLst>
+              <a:gd name="adj" fmla="val 3636"/>
+            </a:avLst>
+          </a:prstGeom>
+          <a:solidFill>
+            <a:srgbClr val="F0EDE8"/>
+          </a:solidFill>
+          <a:ln w="6350">
+            <a:solidFill>
+              <a:srgbClr val="E2E8F0"/>
+            </a:solidFill>
+            <a:prstDash val="solid"/>
+          </a:ln>
+        </p:spPr>
+      </p:sp>
+      <p:sp>
+        <p:nvSpPr>
+          <p:cNvPr id="13" name="Text 11"/>
+          <p:cNvSpPr/>
+          <p:nvPr/>
+        </p:nvSpPr>
+        <p:spPr>
+          <a:xfrm>
+            <a:off x="3291840" y="2697480"/>
+            <a:ext cx="2606040" cy="548640"/>
           </a:xfrm>
           <a:prstGeom prst="rect">
             <a:avLst/>
@@ -1157,21 +1264,305 @@
           <a:bodyPr wrap="square" rtlCol="0" anchor="ctr"/>
           <a:lstStyle/>
           <a:p>
-            <a:pPr indent="0" marL="0">
+            <a:pPr algn="ctr" indent="0" marL="0">
               <a:buNone/>
             </a:pPr>
             <a:r>
-              <a:rPr lang="en-US" sz="900" dirty="0">
+              <a:rPr lang="en-US" sz="3000" dirty="0">
                 <a:solidFill>
-                  <a:srgbClr val="94A3B8"/>
+                  <a:srgbClr val="000000"/>
+                </a:solidFill>
+              </a:rPr>
+              <a:t>📋</a:t>
+            </a:r>
+            <a:endParaRPr lang="en-US" sz="3000" dirty="0"/>
+          </a:p>
+        </p:txBody>
+      </p:sp>
+      <p:sp>
+        <p:nvSpPr>
+          <p:cNvPr id="14" name="Text 12"/>
+          <p:cNvSpPr/>
+          <p:nvPr/>
+        </p:nvSpPr>
+        <p:spPr>
+          <a:xfrm>
+            <a:off x="3291840" y="3291840"/>
+            <a:ext cx="2606040" cy="1005840"/>
+          </a:xfrm>
+          <a:prstGeom prst="rect">
+            <a:avLst/>
+          </a:prstGeom>
+          <a:noFill/>
+          <a:ln/>
+        </p:spPr>
+        <p:txBody>
+          <a:bodyPr wrap="square" rtlCol="0" anchor="ctr"/>
+          <a:lstStyle/>
+          <a:p>
+            <a:pPr algn="ctr" indent="0" marL="0">
+              <a:buNone/>
+            </a:pPr>
+            <a:r>
+              <a:rPr lang="en-US" sz="1300" dirty="0">
+                <a:solidFill>
+                  <a:srgbClr val="2D3748"/>
                 </a:solidFill>
                 <a:latin typeface="Arial" pitchFamily="34" charset="0"/>
                 <a:ea typeface="Arial" pitchFamily="34" charset="-122"/>
                 <a:cs typeface="Arial" pitchFamily="34" charset="-120"/>
               </a:rPr>
-              <a:t>v0.1.0-workshop</a:t>
-            </a:r>
-            <a:endParaRPr lang="en-US" sz="900" dirty="0"/>
+              <a:t>Bitácora</a:t>
+            </a:r>
+            <a:endParaRPr lang="en-US" sz="1300" dirty="0"/>
+          </a:p>
+          <a:p>
+            <a:pPr algn="ctr" indent="0" marL="0">
+              <a:buNone/>
+            </a:pPr>
+            <a:r>
+              <a:rPr lang="en-US" sz="1300" dirty="0">
+                <a:solidFill>
+                  <a:srgbClr val="2D3748"/>
+                </a:solidFill>
+                <a:latin typeface="Arial" pitchFamily="34" charset="0"/>
+                <a:ea typeface="Arial" pitchFamily="34" charset="-122"/>
+                <a:cs typeface="Arial" pitchFamily="34" charset="-120"/>
+              </a:rPr>
+              <a:t>auditable</a:t>
+            </a:r>
+            <a:endParaRPr lang="en-US" sz="1300" dirty="0"/>
+          </a:p>
+          <a:p>
+            <a:pPr algn="ctr" indent="0" marL="0">
+              <a:buNone/>
+            </a:pPr>
+            <a:r>
+              <a:rPr lang="en-US" sz="1300" dirty="0">
+                <a:solidFill>
+                  <a:srgbClr val="2D3748"/>
+                </a:solidFill>
+                <a:latin typeface="Arial" pitchFamily="34" charset="0"/>
+                <a:ea typeface="Arial" pitchFamily="34" charset="-122"/>
+                <a:cs typeface="Arial" pitchFamily="34" charset="-120"/>
+              </a:rPr>
+              <a:t>e inmutable</a:t>
+            </a:r>
+            <a:endParaRPr lang="en-US" sz="1300" dirty="0"/>
+          </a:p>
+        </p:txBody>
+      </p:sp>
+      <p:sp>
+        <p:nvSpPr>
+          <p:cNvPr id="15" name="Shape 13"/>
+          <p:cNvSpPr/>
+          <p:nvPr/>
+        </p:nvSpPr>
+        <p:spPr>
+          <a:xfrm>
+            <a:off x="6126480" y="2560320"/>
+            <a:ext cx="2606040" cy="2011680"/>
+          </a:xfrm>
+          <a:prstGeom prst="roundRect">
+            <a:avLst>
+              <a:gd name="adj" fmla="val 3636"/>
+            </a:avLst>
+          </a:prstGeom>
+          <a:solidFill>
+            <a:srgbClr val="F0EDE8"/>
+          </a:solidFill>
+          <a:ln w="6350">
+            <a:solidFill>
+              <a:srgbClr val="E2E8F0"/>
+            </a:solidFill>
+            <a:prstDash val="solid"/>
+          </a:ln>
+        </p:spPr>
+      </p:sp>
+      <p:sp>
+        <p:nvSpPr>
+          <p:cNvPr id="16" name="Text 14"/>
+          <p:cNvSpPr/>
+          <p:nvPr/>
+        </p:nvSpPr>
+        <p:spPr>
+          <a:xfrm>
+            <a:off x="6126480" y="2697480"/>
+            <a:ext cx="2606040" cy="548640"/>
+          </a:xfrm>
+          <a:prstGeom prst="rect">
+            <a:avLst/>
+          </a:prstGeom>
+          <a:noFill/>
+          <a:ln/>
+        </p:spPr>
+        <p:txBody>
+          <a:bodyPr wrap="square" rtlCol="0" anchor="ctr"/>
+          <a:lstStyle/>
+          <a:p>
+            <a:pPr algn="ctr" indent="0" marL="0">
+              <a:buNone/>
+            </a:pPr>
+            <a:r>
+              <a:rPr lang="en-US" sz="3000" dirty="0">
+                <a:solidFill>
+                  <a:srgbClr val="000000"/>
+                </a:solidFill>
+              </a:rPr>
+              <a:t>🔔</a:t>
+            </a:r>
+            <a:endParaRPr lang="en-US" sz="3000" dirty="0"/>
+          </a:p>
+        </p:txBody>
+      </p:sp>
+      <p:sp>
+        <p:nvSpPr>
+          <p:cNvPr id="17" name="Text 15"/>
+          <p:cNvSpPr/>
+          <p:nvPr/>
+        </p:nvSpPr>
+        <p:spPr>
+          <a:xfrm>
+            <a:off x="6126480" y="3291840"/>
+            <a:ext cx="2606040" cy="1005840"/>
+          </a:xfrm>
+          <a:prstGeom prst="rect">
+            <a:avLst/>
+          </a:prstGeom>
+          <a:noFill/>
+          <a:ln/>
+        </p:spPr>
+        <p:txBody>
+          <a:bodyPr wrap="square" rtlCol="0" anchor="ctr"/>
+          <a:lstStyle/>
+          <a:p>
+            <a:pPr algn="ctr" indent="0" marL="0">
+              <a:buNone/>
+            </a:pPr>
+            <a:r>
+              <a:rPr lang="en-US" sz="1300" dirty="0">
+                <a:solidFill>
+                  <a:srgbClr val="2D3748"/>
+                </a:solidFill>
+                <a:latin typeface="Arial" pitchFamily="34" charset="0"/>
+                <a:ea typeface="Arial" pitchFamily="34" charset="-122"/>
+                <a:cs typeface="Arial" pitchFamily="34" charset="-120"/>
+              </a:rPr>
+              <a:t>Alertas en</a:t>
+            </a:r>
+            <a:endParaRPr lang="en-US" sz="1300" dirty="0"/>
+          </a:p>
+          <a:p>
+            <a:pPr algn="ctr" indent="0" marL="0">
+              <a:buNone/>
+            </a:pPr>
+            <a:r>
+              <a:rPr lang="en-US" sz="1300" dirty="0">
+                <a:solidFill>
+                  <a:srgbClr val="2D3748"/>
+                </a:solidFill>
+                <a:latin typeface="Arial" pitchFamily="34" charset="0"/>
+                <a:ea typeface="Arial" pitchFamily="34" charset="-122"/>
+                <a:cs typeface="Arial" pitchFamily="34" charset="-120"/>
+              </a:rPr>
+              <a:t>tiempo real</a:t>
+            </a:r>
+            <a:endParaRPr lang="en-US" sz="1300" dirty="0"/>
+          </a:p>
+          <a:p>
+            <a:pPr algn="ctr" indent="0" marL="0">
+              <a:buNone/>
+            </a:pPr>
+            <a:r>
+              <a:rPr lang="en-US" sz="1300" dirty="0">
+                <a:solidFill>
+                  <a:srgbClr val="2D3748"/>
+                </a:solidFill>
+                <a:latin typeface="Arial" pitchFamily="34" charset="0"/>
+                <a:ea typeface="Arial" pitchFamily="34" charset="-122"/>
+                <a:cs typeface="Arial" pitchFamily="34" charset="-120"/>
+              </a:rPr>
+              <a:t>al supervisor</a:t>
+            </a:r>
+            <a:endParaRPr lang="en-US" sz="1300" dirty="0"/>
+          </a:p>
+        </p:txBody>
+      </p:sp>
+      <p:sp>
+        <p:nvSpPr>
+          <p:cNvPr id="18" name="Text 16"/>
+          <p:cNvSpPr/>
+          <p:nvPr/>
+        </p:nvSpPr>
+        <p:spPr>
+          <a:xfrm>
+            <a:off x="457200" y="4892040"/>
+            <a:ext cx="8375904" cy="320040"/>
+          </a:xfrm>
+          <a:prstGeom prst="rect">
+            <a:avLst/>
+          </a:prstGeom>
+          <a:noFill/>
+          <a:ln/>
+        </p:spPr>
+        <p:txBody>
+          <a:bodyPr wrap="square" rtlCol="0" anchor="ctr"/>
+          <a:lstStyle/>
+          <a:p>
+            <a:pPr algn="ctr" indent="0" marL="0">
+              <a:buNone/>
+            </a:pPr>
+            <a:r>
+              <a:rPr lang="en-US" sz="1200" dirty="0">
+                <a:solidFill>
+                  <a:srgbClr val="718096"/>
+                </a:solidFill>
+                <a:latin typeface="Arial" pitchFamily="34" charset="0"/>
+                <a:ea typeface="Arial" pitchFamily="34" charset="-122"/>
+                <a:cs typeface="Arial" pitchFamily="34" charset="-120"/>
+              </a:rPr>
+              <a:t>Pitch · 4 minutos  |  WomenCISO 4 / MenCISO 1  |  Agosto 2026</a:t>
+            </a:r>
+            <a:endParaRPr lang="en-US" sz="1200" dirty="0"/>
+          </a:p>
+        </p:txBody>
+      </p:sp>
+      <p:sp>
+        <p:nvSpPr>
+          <p:cNvPr id="19" name="Text 17"/>
+          <p:cNvSpPr/>
+          <p:nvPr/>
+        </p:nvSpPr>
+        <p:spPr>
+          <a:xfrm>
+            <a:off x="457200" y="6172200"/>
+            <a:ext cx="8375904" cy="256032"/>
+          </a:xfrm>
+          <a:prstGeom prst="rect">
+            <a:avLst/>
+          </a:prstGeom>
+          <a:noFill/>
+          <a:ln/>
+        </p:spPr>
+        <p:txBody>
+          <a:bodyPr wrap="square" rtlCol="0" anchor="ctr"/>
+          <a:lstStyle/>
+          <a:p>
+            <a:pPr algn="ctr" indent="0" marL="0">
+              <a:buNone/>
+            </a:pPr>
+            <a:r>
+              <a:rPr lang="en-US" dirty="0">
+                <a:solidFill>
+                  <a:srgbClr val="718096"/>
+                </a:solidFill>
+                <a:latin typeface="Arial" pitchFamily="34" charset="0"/>
+                <a:ea typeface="Arial" pitchFamily="34" charset="-122"/>
+                <a:cs typeface="Arial" pitchFamily="34" charset="-120"/>
+              </a:rPr>
+              <a:t>v0.1.0-workshop  ·  MVP operacional  ·  No dispositivo médico  ·  Datos ficticios</a:t>
+            </a:r>
+            <a:endParaRPr lang="en-US" dirty="0"/>
           </a:p>
         </p:txBody>
       </p:sp>
@@ -1226,7 +1617,7 @@
     </a:clrScheme>
     <a:fontScheme name="Office">
       <a:majorFont>
-        <a:latin typeface="Arial"/>
+        <a:latin typeface="Calibri Light" panose="020F0302020204030204"/>
         <a:ea typeface=""/>
         <a:cs typeface=""/>
         <a:font script="Jpan" typeface="游ゴシック Light"/>
@@ -1278,7 +1669,7 @@
         <a:font script="Tfng" typeface="Ebrima"/>
       </a:majorFont>
       <a:minorFont>
-        <a:latin typeface="Arial"/>
+        <a:latin typeface="Calibri" panose="020F0502020204030204"/>
         <a:ea typeface=""/>
         <a:cs typeface=""/>
         <a:font script="Jpan" typeface="游ゴシック"/>

</xml_diff>

<commit_message>
E3: deck — sistema decoFondo con círculos, barras y trazos ejecutivos pastel
Co-Authored-By: Claude Sonnet 4.6 <noreply@anthropic.com>
</commit_message>
<xml_diff>
--- a/business/CareSignal_Pitch_Deck.pptx
+++ b/business/CareSignal_Pitch_Deck.pptx
@@ -901,8 +901,95 @@
         </p:nvSpPr>
         <p:spPr>
           <a:xfrm>
+            <a:off x="6583680" y="4389120"/>
+            <a:ext cx="3840480" cy="3840480"/>
+          </a:xfrm>
+          <a:prstGeom prst="ellipse">
+            <a:avLst/>
+          </a:prstGeom>
+          <a:solidFill>
+            <a:srgbClr val="A8C4DC">
+              <a:alpha val="18000"/>
+            </a:srgbClr>
+          </a:solidFill>
+          <a:ln w="12700">
+            <a:solidFill>
+              <a:srgbClr val="A8C4DC">
+                <a:alpha val="18000"/>
+              </a:srgbClr>
+            </a:solidFill>
+            <a:prstDash val="solid"/>
+          </a:ln>
+        </p:spPr>
+      </p:sp>
+      <p:sp>
+        <p:nvSpPr>
+          <p:cNvPr id="4" name="Shape 2"/>
+          <p:cNvSpPr/>
+          <p:nvPr/>
+        </p:nvSpPr>
+        <p:spPr>
+          <a:xfrm>
+            <a:off x="-1005840" y="-1097280"/>
+            <a:ext cx="2926080" cy="2926080"/>
+          </a:xfrm>
+          <a:prstGeom prst="ellipse">
+            <a:avLst/>
+          </a:prstGeom>
+          <a:solidFill>
+            <a:srgbClr val="C4786A">
+              <a:alpha val="12000"/>
+            </a:srgbClr>
+          </a:solidFill>
+          <a:ln w="12700">
+            <a:solidFill>
+              <a:srgbClr val="C4786A">
+                <a:alpha val="12000"/>
+              </a:srgbClr>
+            </a:solidFill>
+            <a:prstDash val="solid"/>
+          </a:ln>
+        </p:spPr>
+      </p:sp>
+      <p:sp>
+        <p:nvSpPr>
+          <p:cNvPr id="5" name="Shape 3"/>
+          <p:cNvSpPr/>
+          <p:nvPr/>
+        </p:nvSpPr>
+        <p:spPr>
+          <a:xfrm>
+            <a:off x="8778240" y="1645920"/>
+            <a:ext cx="54864" cy="2194560"/>
+          </a:xfrm>
+          <a:prstGeom prst="rect">
+            <a:avLst/>
+          </a:prstGeom>
+          <a:solidFill>
+            <a:srgbClr val="5B8DB8">
+              <a:alpha val="45000"/>
+            </a:srgbClr>
+          </a:solidFill>
+          <a:ln w="12700">
+            <a:solidFill>
+              <a:srgbClr val="5B8DB8">
+                <a:alpha val="45000"/>
+              </a:srgbClr>
+            </a:solidFill>
+            <a:prstDash val="solid"/>
+          </a:ln>
+        </p:spPr>
+      </p:sp>
+      <p:sp>
+        <p:nvSpPr>
+          <p:cNvPr id="6" name="Shape 4"/>
+          <p:cNvSpPr/>
+          <p:nvPr/>
+        </p:nvSpPr>
+        <p:spPr>
+          <a:xfrm>
             <a:off x="0" y="0"/>
-            <a:ext cx="12192000" cy="73152"/>
+            <a:ext cx="12192000" cy="54864"/>
           </a:xfrm>
           <a:prstGeom prst="rect">
             <a:avLst/>
@@ -920,14 +1007,14 @@
       </p:sp>
       <p:sp>
         <p:nvSpPr>
-          <p:cNvPr id="4" name="Shape 2"/>
-          <p:cNvSpPr/>
-          <p:nvPr/>
-        </p:nvSpPr>
-        <p:spPr>
-          <a:xfrm>
-            <a:off x="0" y="6510528"/>
-            <a:ext cx="12192000" cy="73152"/>
+          <p:cNvPr id="7" name="Shape 5"/>
+          <p:cNvSpPr/>
+          <p:nvPr/>
+        </p:nvSpPr>
+        <p:spPr>
+          <a:xfrm>
+            <a:off x="0" y="6528816"/>
+            <a:ext cx="12192000" cy="54864"/>
           </a:xfrm>
           <a:prstGeom prst="rect">
             <a:avLst/>
@@ -945,7 +1032,7 @@
       </p:sp>
       <p:sp>
         <p:nvSpPr>
-          <p:cNvPr id="5" name="Text 3"/>
+          <p:cNvPr id="8" name="Text 6"/>
           <p:cNvSpPr/>
           <p:nvPr/>
         </p:nvSpPr>
@@ -981,7 +1068,7 @@
       </p:sp>
       <p:sp>
         <p:nvSpPr>
-          <p:cNvPr id="6" name="Text 4"/>
+          <p:cNvPr id="9" name="Text 7"/>
           <p:cNvSpPr/>
           <p:nvPr/>
         </p:nvSpPr>
@@ -1020,7 +1107,7 @@
       </p:sp>
       <p:sp>
         <p:nvSpPr>
-          <p:cNvPr id="7" name="Text 5"/>
+          <p:cNvPr id="10" name="Text 8"/>
           <p:cNvSpPr/>
           <p:nvPr/>
         </p:nvSpPr>
@@ -1059,7 +1146,7 @@
       </p:sp>
       <p:sp>
         <p:nvSpPr>
-          <p:cNvPr id="8" name="Shape 6"/>
+          <p:cNvPr id="11" name="Shape 9"/>
           <p:cNvSpPr/>
           <p:nvPr/>
         </p:nvSpPr>
@@ -1082,7 +1169,7 @@
       </p:sp>
       <p:sp>
         <p:nvSpPr>
-          <p:cNvPr id="9" name="Shape 7"/>
+          <p:cNvPr id="12" name="Shape 10"/>
           <p:cNvSpPr/>
           <p:nvPr/>
         </p:nvSpPr>
@@ -1109,7 +1196,7 @@
       </p:sp>
       <p:sp>
         <p:nvSpPr>
-          <p:cNvPr id="10" name="Text 8"/>
+          <p:cNvPr id="13" name="Text 11"/>
           <p:cNvSpPr/>
           <p:nvPr/>
         </p:nvSpPr>
@@ -1145,7 +1232,7 @@
       </p:sp>
       <p:sp>
         <p:nvSpPr>
-          <p:cNvPr id="11" name="Text 9"/>
+          <p:cNvPr id="14" name="Text 12"/>
           <p:cNvSpPr/>
           <p:nvPr/>
         </p:nvSpPr>
@@ -1218,7 +1305,7 @@
       </p:sp>
       <p:sp>
         <p:nvSpPr>
-          <p:cNvPr id="12" name="Shape 10"/>
+          <p:cNvPr id="15" name="Shape 13"/>
           <p:cNvSpPr/>
           <p:nvPr/>
         </p:nvSpPr>
@@ -1245,7 +1332,7 @@
       </p:sp>
       <p:sp>
         <p:nvSpPr>
-          <p:cNvPr id="13" name="Text 11"/>
+          <p:cNvPr id="16" name="Text 14"/>
           <p:cNvSpPr/>
           <p:nvPr/>
         </p:nvSpPr>
@@ -1281,7 +1368,7 @@
       </p:sp>
       <p:sp>
         <p:nvSpPr>
-          <p:cNvPr id="14" name="Text 12"/>
+          <p:cNvPr id="17" name="Text 15"/>
           <p:cNvSpPr/>
           <p:nvPr/>
         </p:nvSpPr>
@@ -1354,7 +1441,7 @@
       </p:sp>
       <p:sp>
         <p:nvSpPr>
-          <p:cNvPr id="15" name="Shape 13"/>
+          <p:cNvPr id="18" name="Shape 16"/>
           <p:cNvSpPr/>
           <p:nvPr/>
         </p:nvSpPr>
@@ -1381,7 +1468,7 @@
       </p:sp>
       <p:sp>
         <p:nvSpPr>
-          <p:cNvPr id="16" name="Text 14"/>
+          <p:cNvPr id="19" name="Text 17"/>
           <p:cNvSpPr/>
           <p:nvPr/>
         </p:nvSpPr>
@@ -1417,7 +1504,7 @@
       </p:sp>
       <p:sp>
         <p:nvSpPr>
-          <p:cNvPr id="17" name="Text 15"/>
+          <p:cNvPr id="20" name="Text 18"/>
           <p:cNvSpPr/>
           <p:nvPr/>
         </p:nvSpPr>
@@ -1490,7 +1577,7 @@
       </p:sp>
       <p:sp>
         <p:nvSpPr>
-          <p:cNvPr id="18" name="Text 16"/>
+          <p:cNvPr id="21" name="Text 19"/>
           <p:cNvSpPr/>
           <p:nvPr/>
         </p:nvSpPr>
@@ -1529,7 +1616,7 @@
       </p:sp>
       <p:sp>
         <p:nvSpPr>
-          <p:cNvPr id="19" name="Text 17"/>
+          <p:cNvPr id="22" name="Text 20"/>
           <p:cNvSpPr/>
           <p:nvPr/>
         </p:nvSpPr>

</xml_diff>

<commit_message>
E3: deck slide 7 — solución dos columnas fallo operativo vs administrativo
Co-Authored-By: Claude Sonnet 4.6 <noreply@anthropic.com>
</commit_message>
<xml_diff>
--- a/business/CareSignal_Pitch_Deck.pptx
+++ b/business/CareSignal_Pitch_Deck.pptx
@@ -11,9 +11,10 @@
     <p:sldId id="259" r:id="rId5"/>
     <p:sldId id="260" r:id="rId6"/>
     <p:sldId id="261" r:id="rId7"/>
+    <p:sldId id="262" r:id="rId8"/>
   </p:sldIdLst>
   <p:notesMasterIdLst>
-    <p:notesMasterId r:id="rId8"/>
+    <p:notesMasterId r:id="rId9"/>
   </p:notesMasterIdLst>
   <p:sldSz cx="12192000" cy="6858000"/>
   <p:notesSz cx="6858000" cy="12192000"/>
@@ -989,6 +990,94 @@
 </p:notes>
 </file>
 
+<file path=ppt/notesSlides/notesSlide7.xml><?xml version="1.0" encoding="utf-8"?>
+<p:notes xmlns:a="http://schemas.openxmlformats.org/drawingml/2006/main" xmlns:r="http://schemas.openxmlformats.org/officeDocument/2006/relationships" xmlns:p="http://schemas.openxmlformats.org/presentationml/2006/main">
+  <p:cSld>
+    <p:spTree>
+      <p:nvGrpSpPr>
+        <p:cNvPr id="1" name=""/>
+        <p:cNvGrpSpPr/>
+        <p:nvPr/>
+      </p:nvGrpSpPr>
+      <p:grpSpPr>
+        <a:xfrm>
+          <a:off x="0" y="0"/>
+          <a:ext cx="0" cy="0"/>
+          <a:chOff x="0" y="0"/>
+          <a:chExt cx="0" cy="0"/>
+        </a:xfrm>
+      </p:grpSpPr>
+      <p:sp>
+        <p:nvSpPr>
+          <p:cNvPr id="2" name="Slide Image Placeholder 1"/>
+          <p:cNvSpPr>
+            <a:spLocks noGrp="1" noRot="1" noChangeAspect="1"/>
+          </p:cNvSpPr>
+          <p:nvPr>
+            <p:ph type="sldImg"/>
+          </p:nvPr>
+        </p:nvSpPr>
+        <p:spPr/>
+      </p:sp>
+      <p:sp>
+        <p:nvSpPr>
+          <p:cNvPr id="3" name="Notes Placeholder 2"/>
+          <p:cNvSpPr>
+            <a:spLocks noGrp="1"/>
+          </p:cNvSpPr>
+          <p:nvPr>
+            <p:ph type="body" idx="1"/>
+          </p:nvPr>
+        </p:nvSpPr>
+        <p:spPr/>
+        <p:txBody>
+          <a:bodyPr/>
+          <a:lstStyle/>
+          <a:p>
+            <a:r>
+              <a:rPr lang="en-US" dirty="0"/>
+              <a:t/>
+            </a:r>
+            <a:endParaRPr lang="en-US" dirty="0"/>
+          </a:p>
+        </p:txBody>
+      </p:sp>
+      <p:sp>
+        <p:nvSpPr>
+          <p:cNvPr id="4" name="Slide Number Placeholder 3"/>
+          <p:cNvSpPr>
+            <a:spLocks noGrp="1"/>
+          </p:cNvSpPr>
+          <p:nvPr>
+            <p:ph type="sldNum" sz="quarter" idx="10"/>
+          </p:nvPr>
+        </p:nvSpPr>
+        <p:spPr/>
+        <p:txBody>
+          <a:bodyPr/>
+          <a:lstStyle/>
+          <a:p>
+            <a:fld id="{F7021451-1387-4CA6-816F-3879F97B5CBC}" type="slidenum">
+              <a:rPr lang="en-US"/>
+              <a:t>7</a:t>
+            </a:fld>
+            <a:endParaRPr lang="en-US"/>
+          </a:p>
+        </p:txBody>
+      </p:sp>
+    </p:spTree>
+    <p:extLst>
+      <p:ext uri="{BB962C8B-B14F-4D97-AF65-F5344CB8AC3E}">
+        <p14:creationId xmlns:p14="http://schemas.microsoft.com/office/powerpoint/2010/main" val="1024086991"/>
+      </p:ext>
+    </p:extLst>
+  </p:cSld>
+  <p:clrMapOvr>
+    <a:masterClrMapping/>
+  </p:clrMapOvr>
+</p:notes>
+</file>
+
 <file path=ppt/slideLayouts/slideLayout1.xml><?xml version="1.0" encoding="utf-8"?>
 <p:sldLayout xmlns:a="http://schemas.openxmlformats.org/drawingml/2006/main" xmlns:r="http://schemas.openxmlformats.org/officeDocument/2006/relationships" xmlns:p="http://schemas.openxmlformats.org/presentationml/2006/main" preserve="1">
   <p:cSld name="DEFAULT">
@@ -6703,6 +6792,1217 @@
                 <a:cs typeface="Arial" pitchFamily="34" charset="-120"/>
               </a:rPr>
               <a:t>Fuentes: DOF · CNDH · Ley General de Salud Art. 419</a:t>
+            </a:r>
+            <a:endParaRPr lang="en-US" dirty="0"/>
+          </a:p>
+        </p:txBody>
+      </p:sp>
+    </p:spTree>
+  </p:cSld>
+  <p:clrMapOvr>
+    <a:masterClrMapping/>
+  </p:clrMapOvr>
+</p:sld>
+</file>
+
+<file path=ppt/slides/slide7.xml><?xml version="1.0" encoding="utf-8"?>
+<p:sld xmlns:a="http://schemas.openxmlformats.org/drawingml/2006/main" xmlns:r="http://schemas.openxmlformats.org/officeDocument/2006/relationships" xmlns:p="http://schemas.openxmlformats.org/presentationml/2006/main">
+  <p:cSld name="Slide 7">
+    <p:spTree>
+      <p:nvGrpSpPr>
+        <p:cNvPr id="1" name=""/>
+        <p:cNvGrpSpPr/>
+        <p:nvPr/>
+      </p:nvGrpSpPr>
+      <p:grpSpPr>
+        <a:xfrm>
+          <a:off x="0" y="0"/>
+          <a:ext cx="0" cy="0"/>
+          <a:chOff x="0" y="0"/>
+          <a:chExt cx="0" cy="0"/>
+        </a:xfrm>
+      </p:grpSpPr>
+      <p:sp>
+        <p:nvSpPr>
+          <p:cNvPr id="2" name="Shape 0"/>
+          <p:cNvSpPr/>
+          <p:nvPr/>
+        </p:nvSpPr>
+        <p:spPr>
+          <a:xfrm>
+            <a:off x="0" y="0"/>
+            <a:ext cx="12192000" cy="6858000"/>
+          </a:xfrm>
+          <a:prstGeom prst="rect">
+            <a:avLst/>
+          </a:prstGeom>
+          <a:solidFill>
+            <a:srgbClr val="FAFAF8"/>
+          </a:solidFill>
+          <a:ln w="12700">
+            <a:solidFill>
+              <a:srgbClr val="FAFAF8"/>
+            </a:solidFill>
+            <a:prstDash val="solid"/>
+          </a:ln>
+        </p:spPr>
+      </p:sp>
+      <p:sp>
+        <p:nvSpPr>
+          <p:cNvPr id="3" name="Shape 1"/>
+          <p:cNvSpPr/>
+          <p:nvPr/>
+        </p:nvSpPr>
+        <p:spPr>
+          <a:xfrm>
+            <a:off x="8138160" y="0"/>
+            <a:ext cx="694944" cy="6858000"/>
+          </a:xfrm>
+          <a:prstGeom prst="rect">
+            <a:avLst/>
+          </a:prstGeom>
+          <a:solidFill>
+            <a:srgbClr val="A8C4DC">
+              <a:alpha val="12000"/>
+            </a:srgbClr>
+          </a:solidFill>
+          <a:ln w="12700">
+            <a:solidFill>
+              <a:srgbClr val="A8C4DC">
+                <a:alpha val="12000"/>
+              </a:srgbClr>
+            </a:solidFill>
+            <a:prstDash val="solid"/>
+          </a:ln>
+        </p:spPr>
+      </p:sp>
+      <p:sp>
+        <p:nvSpPr>
+          <p:cNvPr id="4" name="Shape 2"/>
+          <p:cNvSpPr/>
+          <p:nvPr/>
+        </p:nvSpPr>
+        <p:spPr>
+          <a:xfrm>
+            <a:off x="3474720" y="5120640"/>
+            <a:ext cx="2377440" cy="2377440"/>
+          </a:xfrm>
+          <a:prstGeom prst="ellipse">
+            <a:avLst/>
+          </a:prstGeom>
+          <a:solidFill>
+            <a:srgbClr val="C4786A">
+              <a:alpha val="10000"/>
+            </a:srgbClr>
+          </a:solidFill>
+          <a:ln w="12700">
+            <a:solidFill>
+              <a:srgbClr val="C4786A">
+                <a:alpha val="10000"/>
+              </a:srgbClr>
+            </a:solidFill>
+            <a:prstDash val="solid"/>
+          </a:ln>
+        </p:spPr>
+      </p:sp>
+      <p:sp>
+        <p:nvSpPr>
+          <p:cNvPr id="5" name="Shape 3"/>
+          <p:cNvSpPr/>
+          <p:nvPr/>
+        </p:nvSpPr>
+        <p:spPr>
+          <a:xfrm>
+            <a:off x="0" y="0"/>
+            <a:ext cx="12192000" cy="54864"/>
+          </a:xfrm>
+          <a:prstGeom prst="rect">
+            <a:avLst/>
+          </a:prstGeom>
+          <a:solidFill>
+            <a:srgbClr val="5B8DB8"/>
+          </a:solidFill>
+          <a:ln w="12700">
+            <a:solidFill>
+              <a:srgbClr val="5B8DB8"/>
+            </a:solidFill>
+            <a:prstDash val="solid"/>
+          </a:ln>
+        </p:spPr>
+      </p:sp>
+      <p:sp>
+        <p:nvSpPr>
+          <p:cNvPr id="6" name="Shape 4"/>
+          <p:cNvSpPr/>
+          <p:nvPr/>
+        </p:nvSpPr>
+        <p:spPr>
+          <a:xfrm>
+            <a:off x="0" y="6528816"/>
+            <a:ext cx="12192000" cy="54864"/>
+          </a:xfrm>
+          <a:prstGeom prst="rect">
+            <a:avLst/>
+          </a:prstGeom>
+          <a:solidFill>
+            <a:srgbClr val="C4786A"/>
+          </a:solidFill>
+          <a:ln w="12700">
+            <a:solidFill>
+              <a:srgbClr val="C4786A"/>
+            </a:solidFill>
+            <a:prstDash val="solid"/>
+          </a:ln>
+        </p:spPr>
+      </p:sp>
+      <p:sp>
+        <p:nvSpPr>
+          <p:cNvPr id="7" name="Text 5"/>
+          <p:cNvSpPr/>
+          <p:nvPr/>
+        </p:nvSpPr>
+        <p:spPr>
+          <a:xfrm>
+            <a:off x="457200" y="228600"/>
+            <a:ext cx="8375904" cy="502920"/>
+          </a:xfrm>
+          <a:prstGeom prst="rect">
+            <a:avLst/>
+          </a:prstGeom>
+          <a:noFill/>
+          <a:ln/>
+        </p:spPr>
+        <p:txBody>
+          <a:bodyPr wrap="square" rtlCol="0" anchor="ctr"/>
+          <a:lstStyle/>
+          <a:p>
+            <a:pPr indent="0" marL="0">
+              <a:buNone/>
+            </a:pPr>
+            <a:r>
+              <a:rPr lang="en-US" b="1" dirty="0">
+                <a:solidFill>
+                  <a:srgbClr val="2D3748"/>
+                </a:solidFill>
+                <a:latin typeface="Arial" pitchFamily="34" charset="0"/>
+                <a:ea typeface="Arial" pitchFamily="34" charset="-122"/>
+                <a:cs typeface="Arial" pitchFamily="34" charset="-120"/>
+              </a:rPr>
+              <a:t>✅  CareSignal — la solución</a:t>
+            </a:r>
+            <a:endParaRPr lang="en-US" dirty="0"/>
+          </a:p>
+        </p:txBody>
+      </p:sp>
+      <p:sp>
+        <p:nvSpPr>
+          <p:cNvPr id="8" name="Text 6"/>
+          <p:cNvSpPr/>
+          <p:nvPr/>
+        </p:nvSpPr>
+        <p:spPr>
+          <a:xfrm>
+            <a:off x="457200" y="731520"/>
+            <a:ext cx="8375904" cy="320040"/>
+          </a:xfrm>
+          <a:prstGeom prst="rect">
+            <a:avLst/>
+          </a:prstGeom>
+          <a:noFill/>
+          <a:ln/>
+        </p:spPr>
+        <p:txBody>
+          <a:bodyPr wrap="square" rtlCol="0" anchor="ctr"/>
+          <a:lstStyle/>
+          <a:p>
+            <a:pPr indent="0" marL="0">
+              <a:buNone/>
+            </a:pPr>
+            <a:r>
+              <a:rPr lang="en-US" b="1" dirty="0">
+                <a:solidFill>
+                  <a:srgbClr val="5B8DB8"/>
+                </a:solidFill>
+                <a:latin typeface="Arial" pitchFamily="34" charset="0"/>
+                <a:ea typeface="Arial" pitchFamily="34" charset="-122"/>
+                <a:cs typeface="Arial" pitchFamily="34" charset="-120"/>
+              </a:rPr>
+              <a:t>Un sistema diseñado para resolver los dos fallos</a:t>
+            </a:r>
+            <a:endParaRPr lang="en-US" dirty="0"/>
+          </a:p>
+        </p:txBody>
+      </p:sp>
+      <p:sp>
+        <p:nvSpPr>
+          <p:cNvPr id="9" name="Shape 7"/>
+          <p:cNvSpPr/>
+          <p:nvPr/>
+        </p:nvSpPr>
+        <p:spPr>
+          <a:xfrm>
+            <a:off x="457200" y="1097280"/>
+            <a:ext cx="8375904" cy="0"/>
+          </a:xfrm>
+          <a:prstGeom prst="line">
+            <a:avLst/>
+          </a:prstGeom>
+          <a:noFill/>
+          <a:ln w="12700">
+            <a:solidFill>
+              <a:srgbClr val="E2E8F0"/>
+            </a:solidFill>
+            <a:prstDash val="solid"/>
+          </a:ln>
+        </p:spPr>
+      </p:sp>
+      <p:sp>
+        <p:nvSpPr>
+          <p:cNvPr id="10" name="Shape 8"/>
+          <p:cNvSpPr/>
+          <p:nvPr/>
+        </p:nvSpPr>
+        <p:spPr>
+          <a:xfrm>
+            <a:off x="457200" y="1261872"/>
+            <a:ext cx="3977640" cy="3474720"/>
+          </a:xfrm>
+          <a:prstGeom prst="roundRect">
+            <a:avLst>
+              <a:gd name="adj" fmla="val 2105"/>
+            </a:avLst>
+          </a:prstGeom>
+          <a:solidFill>
+            <a:srgbClr val="EFF6FF"/>
+          </a:solidFill>
+          <a:ln w="6350">
+            <a:solidFill>
+              <a:srgbClr val="E2E8F0"/>
+            </a:solidFill>
+            <a:prstDash val="solid"/>
+          </a:ln>
+        </p:spPr>
+      </p:sp>
+      <p:sp>
+        <p:nvSpPr>
+          <p:cNvPr id="11" name="Text 9"/>
+          <p:cNvSpPr/>
+          <p:nvPr/>
+        </p:nvSpPr>
+        <p:spPr>
+          <a:xfrm>
+            <a:off x="594360" y="1371600"/>
+            <a:ext cx="3703320" cy="384048"/>
+          </a:xfrm>
+          <a:prstGeom prst="rect">
+            <a:avLst/>
+          </a:prstGeom>
+          <a:noFill/>
+          <a:ln/>
+        </p:spPr>
+        <p:txBody>
+          <a:bodyPr wrap="square" rtlCol="0" anchor="ctr"/>
+          <a:lstStyle/>
+          <a:p>
+            <a:pPr indent="0" marL="0">
+              <a:buNone/>
+            </a:pPr>
+            <a:r>
+              <a:rPr lang="en-US" sz="1400" b="1" dirty="0">
+                <a:solidFill>
+                  <a:srgbClr val="C4786A"/>
+                </a:solidFill>
+                <a:latin typeface="Arial" pitchFamily="34" charset="0"/>
+                <a:ea typeface="Arial" pitchFamily="34" charset="-122"/>
+                <a:cs typeface="Arial" pitchFamily="34" charset="-120"/>
+              </a:rPr>
+              <a:t>⚠️  Fallo operativo</a:t>
+            </a:r>
+            <a:endParaRPr lang="en-US" sz="1400" dirty="0"/>
+          </a:p>
+        </p:txBody>
+      </p:sp>
+      <p:sp>
+        <p:nvSpPr>
+          <p:cNvPr id="12" name="Shape 10"/>
+          <p:cNvSpPr/>
+          <p:nvPr/>
+        </p:nvSpPr>
+        <p:spPr>
+          <a:xfrm>
+            <a:off x="594360" y="1783080"/>
+            <a:ext cx="3703320" cy="0"/>
+          </a:xfrm>
+          <a:prstGeom prst="line">
+            <a:avLst/>
+          </a:prstGeom>
+          <a:noFill/>
+          <a:ln w="9525">
+            <a:solidFill>
+              <a:srgbClr val="E2E8F0"/>
+            </a:solidFill>
+            <a:prstDash val="solid"/>
+          </a:ln>
+        </p:spPr>
+      </p:sp>
+      <p:sp>
+        <p:nvSpPr>
+          <p:cNvPr id="13" name="Text 11"/>
+          <p:cNvSpPr/>
+          <p:nvPr/>
+        </p:nvSpPr>
+        <p:spPr>
+          <a:xfrm>
+            <a:off x="594360" y="1874520"/>
+            <a:ext cx="3703320" cy="347472"/>
+          </a:xfrm>
+          <a:prstGeom prst="rect">
+            <a:avLst/>
+          </a:prstGeom>
+          <a:noFill/>
+          <a:ln/>
+        </p:spPr>
+        <p:txBody>
+          <a:bodyPr wrap="square" rtlCol="0" anchor="ctr"/>
+          <a:lstStyle/>
+          <a:p>
+            <a:pPr indent="0" marL="0">
+              <a:buNone/>
+            </a:pPr>
+            <a:r>
+              <a:rPr lang="en-US" sz="1200" i="1" dirty="0">
+                <a:solidFill>
+                  <a:srgbClr val="718096"/>
+                </a:solidFill>
+                <a:latin typeface="Arial" pitchFamily="34" charset="0"/>
+                <a:ea typeface="Arial" pitchFamily="34" charset="-122"/>
+                <a:cs typeface="Arial" pitchFamily="34" charset="-120"/>
+              </a:rPr>
+              <a:t>Ronda no ocurre y nadie lo detecta</a:t>
+            </a:r>
+            <a:endParaRPr lang="en-US" sz="1200" dirty="0"/>
+          </a:p>
+        </p:txBody>
+      </p:sp>
+      <p:sp>
+        <p:nvSpPr>
+          <p:cNvPr id="14" name="Text 12"/>
+          <p:cNvSpPr/>
+          <p:nvPr/>
+        </p:nvSpPr>
+        <p:spPr>
+          <a:xfrm>
+            <a:off x="640080" y="2331720"/>
+            <a:ext cx="548640" cy="457200"/>
+          </a:xfrm>
+          <a:prstGeom prst="rect">
+            <a:avLst/>
+          </a:prstGeom>
+          <a:noFill/>
+          <a:ln/>
+        </p:spPr>
+        <p:txBody>
+          <a:bodyPr wrap="square" rtlCol="0" anchor="ctr"/>
+          <a:lstStyle/>
+          <a:p>
+            <a:pPr algn="ctr" indent="0" marL="0">
+              <a:buNone/>
+            </a:pPr>
+            <a:r>
+              <a:rPr lang="en-US" sz="2200" dirty="0">
+                <a:solidFill>
+                  <a:srgbClr val="000000"/>
+                </a:solidFill>
+              </a:rPr>
+              <a:t>⏱️</a:t>
+            </a:r>
+            <a:endParaRPr lang="en-US" sz="2200" dirty="0"/>
+          </a:p>
+        </p:txBody>
+      </p:sp>
+      <p:sp>
+        <p:nvSpPr>
+          <p:cNvPr id="15" name="Text 13"/>
+          <p:cNvSpPr/>
+          <p:nvPr/>
+        </p:nvSpPr>
+        <p:spPr>
+          <a:xfrm>
+            <a:off x="1234440" y="2331720"/>
+            <a:ext cx="3063240" cy="594360"/>
+          </a:xfrm>
+          <a:prstGeom prst="rect">
+            <a:avLst/>
+          </a:prstGeom>
+          <a:noFill/>
+          <a:ln/>
+        </p:spPr>
+        <p:txBody>
+          <a:bodyPr wrap="square" rtlCol="0" anchor="ctr"/>
+          <a:lstStyle/>
+          <a:p>
+            <a:pPr indent="0" marL="0">
+              <a:buNone/>
+            </a:pPr>
+            <a:r>
+              <a:rPr lang="en-US" sz="1300" dirty="0">
+                <a:solidFill>
+                  <a:srgbClr val="2D3748"/>
+                </a:solidFill>
+                <a:latin typeface="Arial" pitchFamily="34" charset="0"/>
+                <a:ea typeface="Arial" pitchFamily="34" charset="-122"/>
+                <a:cs typeface="Arial" pitchFamily="34" charset="-120"/>
+              </a:rPr>
+              <a:t>Detecta automáticamente</a:t>
+            </a:r>
+            <a:endParaRPr lang="en-US" sz="1300" dirty="0"/>
+          </a:p>
+          <a:p>
+            <a:pPr indent="0" marL="0">
+              <a:buNone/>
+            </a:pPr>
+            <a:r>
+              <a:rPr lang="en-US" sz="1300" dirty="0">
+                <a:solidFill>
+                  <a:srgbClr val="2D3748"/>
+                </a:solidFill>
+                <a:latin typeface="Arial" pitchFamily="34" charset="0"/>
+                <a:ea typeface="Arial" pitchFamily="34" charset="-122"/>
+                <a:cs typeface="Arial" pitchFamily="34" charset="-120"/>
+              </a:rPr>
+              <a:t>cuando una ronda no ocurre</a:t>
+            </a:r>
+            <a:endParaRPr lang="en-US" sz="1300" dirty="0"/>
+          </a:p>
+        </p:txBody>
+      </p:sp>
+      <p:sp>
+        <p:nvSpPr>
+          <p:cNvPr id="16" name="Text 14"/>
+          <p:cNvSpPr/>
+          <p:nvPr/>
+        </p:nvSpPr>
+        <p:spPr>
+          <a:xfrm>
+            <a:off x="640080" y="3017520"/>
+            <a:ext cx="548640" cy="457200"/>
+          </a:xfrm>
+          <a:prstGeom prst="rect">
+            <a:avLst/>
+          </a:prstGeom>
+          <a:noFill/>
+          <a:ln/>
+        </p:spPr>
+        <p:txBody>
+          <a:bodyPr wrap="square" rtlCol="0" anchor="ctr"/>
+          <a:lstStyle/>
+          <a:p>
+            <a:pPr algn="ctr" indent="0" marL="0">
+              <a:buNone/>
+            </a:pPr>
+            <a:r>
+              <a:rPr lang="en-US" sz="2200" dirty="0">
+                <a:solidFill>
+                  <a:srgbClr val="000000"/>
+                </a:solidFill>
+              </a:rPr>
+              <a:t>🔔</a:t>
+            </a:r>
+            <a:endParaRPr lang="en-US" sz="2200" dirty="0"/>
+          </a:p>
+        </p:txBody>
+      </p:sp>
+      <p:sp>
+        <p:nvSpPr>
+          <p:cNvPr id="17" name="Text 15"/>
+          <p:cNvSpPr/>
+          <p:nvPr/>
+        </p:nvSpPr>
+        <p:spPr>
+          <a:xfrm>
+            <a:off x="1234440" y="3017520"/>
+            <a:ext cx="3063240" cy="594360"/>
+          </a:xfrm>
+          <a:prstGeom prst="rect">
+            <a:avLst/>
+          </a:prstGeom>
+          <a:noFill/>
+          <a:ln/>
+        </p:spPr>
+        <p:txBody>
+          <a:bodyPr wrap="square" rtlCol="0" anchor="ctr"/>
+          <a:lstStyle/>
+          <a:p>
+            <a:pPr indent="0" marL="0">
+              <a:buNone/>
+            </a:pPr>
+            <a:r>
+              <a:rPr lang="en-US" sz="1300" dirty="0">
+                <a:solidFill>
+                  <a:srgbClr val="2D3748"/>
+                </a:solidFill>
+                <a:latin typeface="Arial" pitchFamily="34" charset="0"/>
+                <a:ea typeface="Arial" pitchFamily="34" charset="-122"/>
+                <a:cs typeface="Arial" pitchFamily="34" charset="-120"/>
+              </a:rPr>
+              <a:t>Alerta al supervisor</a:t>
+            </a:r>
+            <a:endParaRPr lang="en-US" sz="1300" dirty="0"/>
+          </a:p>
+          <a:p>
+            <a:pPr indent="0" marL="0">
+              <a:buNone/>
+            </a:pPr>
+            <a:r>
+              <a:rPr lang="en-US" sz="1300" dirty="0">
+                <a:solidFill>
+                  <a:srgbClr val="2D3748"/>
+                </a:solidFill>
+                <a:latin typeface="Arial" pitchFamily="34" charset="0"/>
+                <a:ea typeface="Arial" pitchFamily="34" charset="-122"/>
+                <a:cs typeface="Arial" pitchFamily="34" charset="-120"/>
+              </a:rPr>
+              <a:t>en tiempo real</a:t>
+            </a:r>
+            <a:endParaRPr lang="en-US" sz="1300" dirty="0"/>
+          </a:p>
+        </p:txBody>
+      </p:sp>
+      <p:sp>
+        <p:nvSpPr>
+          <p:cNvPr id="18" name="Text 16"/>
+          <p:cNvSpPr/>
+          <p:nvPr/>
+        </p:nvSpPr>
+        <p:spPr>
+          <a:xfrm>
+            <a:off x="640080" y="3703320"/>
+            <a:ext cx="548640" cy="457200"/>
+          </a:xfrm>
+          <a:prstGeom prst="rect">
+            <a:avLst/>
+          </a:prstGeom>
+          <a:noFill/>
+          <a:ln/>
+        </p:spPr>
+        <p:txBody>
+          <a:bodyPr wrap="square" rtlCol="0" anchor="ctr"/>
+          <a:lstStyle/>
+          <a:p>
+            <a:pPr algn="ctr" indent="0" marL="0">
+              <a:buNone/>
+            </a:pPr>
+            <a:r>
+              <a:rPr lang="en-US" sz="2200" dirty="0">
+                <a:solidFill>
+                  <a:srgbClr val="000000"/>
+                </a:solidFill>
+              </a:rPr>
+              <a:t>👤</a:t>
+            </a:r>
+            <a:endParaRPr lang="en-US" sz="2200" dirty="0"/>
+          </a:p>
+        </p:txBody>
+      </p:sp>
+      <p:sp>
+        <p:nvSpPr>
+          <p:cNvPr id="19" name="Text 17"/>
+          <p:cNvSpPr/>
+          <p:nvPr/>
+        </p:nvSpPr>
+        <p:spPr>
+          <a:xfrm>
+            <a:off x="1234440" y="3703320"/>
+            <a:ext cx="3063240" cy="594360"/>
+          </a:xfrm>
+          <a:prstGeom prst="rect">
+            <a:avLst/>
+          </a:prstGeom>
+          <a:noFill/>
+          <a:ln/>
+        </p:spPr>
+        <p:txBody>
+          <a:bodyPr wrap="square" rtlCol="0" anchor="ctr"/>
+          <a:lstStyle/>
+          <a:p>
+            <a:pPr indent="0" marL="0">
+              <a:buNone/>
+            </a:pPr>
+            <a:r>
+              <a:rPr lang="en-US" sz="1300" dirty="0">
+                <a:solidFill>
+                  <a:srgbClr val="2D3748"/>
+                </a:solidFill>
+                <a:latin typeface="Arial" pitchFamily="34" charset="0"/>
+                <a:ea typeface="Arial" pitchFamily="34" charset="-122"/>
+                <a:cs typeface="Arial" pitchFamily="34" charset="-120"/>
+              </a:rPr>
+              <a:t>Asignación, escalación</a:t>
+            </a:r>
+            <a:endParaRPr lang="en-US" sz="1300" dirty="0"/>
+          </a:p>
+          <a:p>
+            <a:pPr indent="0" marL="0">
+              <a:buNone/>
+            </a:pPr>
+            <a:r>
+              <a:rPr lang="en-US" sz="1300" dirty="0">
+                <a:solidFill>
+                  <a:srgbClr val="2D3748"/>
+                </a:solidFill>
+                <a:latin typeface="Arial" pitchFamily="34" charset="0"/>
+                <a:ea typeface="Arial" pitchFamily="34" charset="-122"/>
+                <a:cs typeface="Arial" pitchFamily="34" charset="-120"/>
+              </a:rPr>
+              <a:t>y seguimiento del cuidador</a:t>
+            </a:r>
+            <a:endParaRPr lang="en-US" sz="1300" dirty="0"/>
+          </a:p>
+        </p:txBody>
+      </p:sp>
+      <p:sp>
+        <p:nvSpPr>
+          <p:cNvPr id="20" name="Shape 18"/>
+          <p:cNvSpPr/>
+          <p:nvPr/>
+        </p:nvSpPr>
+        <p:spPr>
+          <a:xfrm>
+            <a:off x="4846320" y="1261872"/>
+            <a:ext cx="3977640" cy="3474720"/>
+          </a:xfrm>
+          <a:prstGeom prst="roundRect">
+            <a:avLst>
+              <a:gd name="adj" fmla="val 2105"/>
+            </a:avLst>
+          </a:prstGeom>
+          <a:solidFill>
+            <a:srgbClr val="F0FDF4"/>
+          </a:solidFill>
+          <a:ln w="6350">
+            <a:solidFill>
+              <a:srgbClr val="E2E8F0"/>
+            </a:solidFill>
+            <a:prstDash val="solid"/>
+          </a:ln>
+        </p:spPr>
+      </p:sp>
+      <p:sp>
+        <p:nvSpPr>
+          <p:cNvPr id="21" name="Text 19"/>
+          <p:cNvSpPr/>
+          <p:nvPr/>
+        </p:nvSpPr>
+        <p:spPr>
+          <a:xfrm>
+            <a:off x="4983480" y="1371600"/>
+            <a:ext cx="3703320" cy="384048"/>
+          </a:xfrm>
+          <a:prstGeom prst="rect">
+            <a:avLst/>
+          </a:prstGeom>
+          <a:noFill/>
+          <a:ln/>
+        </p:spPr>
+        <p:txBody>
+          <a:bodyPr wrap="square" rtlCol="0" anchor="ctr"/>
+          <a:lstStyle/>
+          <a:p>
+            <a:pPr indent="0" marL="0">
+              <a:buNone/>
+            </a:pPr>
+            <a:r>
+              <a:rPr lang="en-US" sz="1400" b="1" dirty="0">
+                <a:solidFill>
+                  <a:srgbClr val="7BA68A"/>
+                </a:solidFill>
+                <a:latin typeface="Arial" pitchFamily="34" charset="0"/>
+                <a:ea typeface="Arial" pitchFamily="34" charset="-122"/>
+                <a:cs typeface="Arial" pitchFamily="34" charset="-120"/>
+              </a:rPr>
+              <a:t>🗂️  Fallo administrativo</a:t>
+            </a:r>
+            <a:endParaRPr lang="en-US" sz="1400" dirty="0"/>
+          </a:p>
+        </p:txBody>
+      </p:sp>
+      <p:sp>
+        <p:nvSpPr>
+          <p:cNvPr id="22" name="Shape 20"/>
+          <p:cNvSpPr/>
+          <p:nvPr/>
+        </p:nvSpPr>
+        <p:spPr>
+          <a:xfrm>
+            <a:off x="4983480" y="1783080"/>
+            <a:ext cx="3703320" cy="0"/>
+          </a:xfrm>
+          <a:prstGeom prst="line">
+            <a:avLst/>
+          </a:prstGeom>
+          <a:noFill/>
+          <a:ln w="9525">
+            <a:solidFill>
+              <a:srgbClr val="E2E8F0"/>
+            </a:solidFill>
+            <a:prstDash val="solid"/>
+          </a:ln>
+        </p:spPr>
+      </p:sp>
+      <p:sp>
+        <p:nvSpPr>
+          <p:cNvPr id="23" name="Text 21"/>
+          <p:cNvSpPr/>
+          <p:nvPr/>
+        </p:nvSpPr>
+        <p:spPr>
+          <a:xfrm>
+            <a:off x="4983480" y="1874520"/>
+            <a:ext cx="3703320" cy="347472"/>
+          </a:xfrm>
+          <a:prstGeom prst="rect">
+            <a:avLst/>
+          </a:prstGeom>
+          <a:noFill/>
+          <a:ln/>
+        </p:spPr>
+        <p:txBody>
+          <a:bodyPr wrap="square" rtlCol="0" anchor="ctr"/>
+          <a:lstStyle/>
+          <a:p>
+            <a:pPr indent="0" marL="0">
+              <a:buNone/>
+            </a:pPr>
+            <a:r>
+              <a:rPr lang="en-US" sz="1200" i="1" dirty="0">
+                <a:solidFill>
+                  <a:srgbClr val="718096"/>
+                </a:solidFill>
+                <a:latin typeface="Arial" pitchFamily="34" charset="0"/>
+                <a:ea typeface="Arial" pitchFamily="34" charset="-122"/>
+                <a:cs typeface="Arial" pitchFamily="34" charset="-120"/>
+              </a:rPr>
+              <a:t>Sin registro confiable ni evidencia auditable</a:t>
+            </a:r>
+            <a:endParaRPr lang="en-US" sz="1200" dirty="0"/>
+          </a:p>
+        </p:txBody>
+      </p:sp>
+      <p:sp>
+        <p:nvSpPr>
+          <p:cNvPr id="24" name="Text 22"/>
+          <p:cNvSpPr/>
+          <p:nvPr/>
+        </p:nvSpPr>
+        <p:spPr>
+          <a:xfrm>
+            <a:off x="5029200" y="2331720"/>
+            <a:ext cx="548640" cy="457200"/>
+          </a:xfrm>
+          <a:prstGeom prst="rect">
+            <a:avLst/>
+          </a:prstGeom>
+          <a:noFill/>
+          <a:ln/>
+        </p:spPr>
+        <p:txBody>
+          <a:bodyPr wrap="square" rtlCol="0" anchor="ctr"/>
+          <a:lstStyle/>
+          <a:p>
+            <a:pPr algn="ctr" indent="0" marL="0">
+              <a:buNone/>
+            </a:pPr>
+            <a:r>
+              <a:rPr lang="en-US" sz="2200" dirty="0">
+                <a:solidFill>
+                  <a:srgbClr val="000000"/>
+                </a:solidFill>
+              </a:rPr>
+              <a:t>📋</a:t>
+            </a:r>
+            <a:endParaRPr lang="en-US" sz="2200" dirty="0"/>
+          </a:p>
+        </p:txBody>
+      </p:sp>
+      <p:sp>
+        <p:nvSpPr>
+          <p:cNvPr id="25" name="Text 23"/>
+          <p:cNvSpPr/>
+          <p:nvPr/>
+        </p:nvSpPr>
+        <p:spPr>
+          <a:xfrm>
+            <a:off x="5623560" y="2331720"/>
+            <a:ext cx="3063240" cy="594360"/>
+          </a:xfrm>
+          <a:prstGeom prst="rect">
+            <a:avLst/>
+          </a:prstGeom>
+          <a:noFill/>
+          <a:ln/>
+        </p:spPr>
+        <p:txBody>
+          <a:bodyPr wrap="square" rtlCol="0" anchor="ctr"/>
+          <a:lstStyle/>
+          <a:p>
+            <a:pPr indent="0" marL="0">
+              <a:buNone/>
+            </a:pPr>
+            <a:r>
+              <a:rPr lang="en-US" sz="1300" dirty="0">
+                <a:solidFill>
+                  <a:srgbClr val="2D3748"/>
+                </a:solidFill>
+                <a:latin typeface="Arial" pitchFamily="34" charset="0"/>
+                <a:ea typeface="Arial" pitchFamily="34" charset="-122"/>
+                <a:cs typeface="Arial" pitchFamily="34" charset="-120"/>
+              </a:rPr>
+              <a:t>Bitácora inmutable:</a:t>
+            </a:r>
+            <a:endParaRPr lang="en-US" sz="1300" dirty="0"/>
+          </a:p>
+          <a:p>
+            <a:pPr indent="0" marL="0">
+              <a:buNone/>
+            </a:pPr>
+            <a:r>
+              <a:rPr lang="en-US" sz="1300" dirty="0">
+                <a:solidFill>
+                  <a:srgbClr val="2D3748"/>
+                </a:solidFill>
+                <a:latin typeface="Arial" pitchFamily="34" charset="0"/>
+                <a:ea typeface="Arial" pitchFamily="34" charset="-122"/>
+                <a:cs typeface="Arial" pitchFamily="34" charset="-120"/>
+              </a:rPr>
+              <a:t>quién, cuándo, qué resultado</a:t>
+            </a:r>
+            <a:endParaRPr lang="en-US" sz="1300" dirty="0"/>
+          </a:p>
+        </p:txBody>
+      </p:sp>
+      <p:sp>
+        <p:nvSpPr>
+          <p:cNvPr id="26" name="Text 24"/>
+          <p:cNvSpPr/>
+          <p:nvPr/>
+        </p:nvSpPr>
+        <p:spPr>
+          <a:xfrm>
+            <a:off x="5029200" y="3017520"/>
+            <a:ext cx="548640" cy="457200"/>
+          </a:xfrm>
+          <a:prstGeom prst="rect">
+            <a:avLst/>
+          </a:prstGeom>
+          <a:noFill/>
+          <a:ln/>
+        </p:spPr>
+        <p:txBody>
+          <a:bodyPr wrap="square" rtlCol="0" anchor="ctr"/>
+          <a:lstStyle/>
+          <a:p>
+            <a:pPr algn="ctr" indent="0" marL="0">
+              <a:buNone/>
+            </a:pPr>
+            <a:r>
+              <a:rPr lang="en-US" sz="2200" dirty="0">
+                <a:solidFill>
+                  <a:srgbClr val="000000"/>
+                </a:solidFill>
+              </a:rPr>
+              <a:t>📄</a:t>
+            </a:r>
+            <a:endParaRPr lang="en-US" sz="2200" dirty="0"/>
+          </a:p>
+        </p:txBody>
+      </p:sp>
+      <p:sp>
+        <p:nvSpPr>
+          <p:cNvPr id="27" name="Text 25"/>
+          <p:cNvSpPr/>
+          <p:nvPr/>
+        </p:nvSpPr>
+        <p:spPr>
+          <a:xfrm>
+            <a:off x="5623560" y="3017520"/>
+            <a:ext cx="3063240" cy="594360"/>
+          </a:xfrm>
+          <a:prstGeom prst="rect">
+            <a:avLst/>
+          </a:prstGeom>
+          <a:noFill/>
+          <a:ln/>
+        </p:spPr>
+        <p:txBody>
+          <a:bodyPr wrap="square" rtlCol="0" anchor="ctr"/>
+          <a:lstStyle/>
+          <a:p>
+            <a:pPr indent="0" marL="0">
+              <a:buNone/>
+            </a:pPr>
+            <a:r>
+              <a:rPr lang="en-US" sz="1300" dirty="0">
+                <a:solidFill>
+                  <a:srgbClr val="2D3748"/>
+                </a:solidFill>
+                <a:latin typeface="Arial" pitchFamily="34" charset="0"/>
+                <a:ea typeface="Arial" pitchFamily="34" charset="-122"/>
+                <a:cs typeface="Arial" pitchFamily="34" charset="-120"/>
+              </a:rPr>
+              <a:t>Sin papel, sin transcripción,</a:t>
+            </a:r>
+            <a:endParaRPr lang="en-US" sz="1300" dirty="0"/>
+          </a:p>
+          <a:p>
+            <a:pPr indent="0" marL="0">
+              <a:buNone/>
+            </a:pPr>
+            <a:r>
+              <a:rPr lang="en-US" sz="1300" dirty="0">
+                <a:solidFill>
+                  <a:srgbClr val="2D3748"/>
+                </a:solidFill>
+                <a:latin typeface="Arial" pitchFamily="34" charset="0"/>
+                <a:ea typeface="Arial" pitchFamily="34" charset="-122"/>
+                <a:cs typeface="Arial" pitchFamily="34" charset="-120"/>
+              </a:rPr>
+              <a:t>sin trabajo extra</a:t>
+            </a:r>
+            <a:endParaRPr lang="en-US" sz="1300" dirty="0"/>
+          </a:p>
+        </p:txBody>
+      </p:sp>
+      <p:sp>
+        <p:nvSpPr>
+          <p:cNvPr id="28" name="Text 26"/>
+          <p:cNvSpPr/>
+          <p:nvPr/>
+        </p:nvSpPr>
+        <p:spPr>
+          <a:xfrm>
+            <a:off x="5029200" y="3703320"/>
+            <a:ext cx="548640" cy="457200"/>
+          </a:xfrm>
+          <a:prstGeom prst="rect">
+            <a:avLst/>
+          </a:prstGeom>
+          <a:noFill/>
+          <a:ln/>
+        </p:spPr>
+        <p:txBody>
+          <a:bodyPr wrap="square" rtlCol="0" anchor="ctr"/>
+          <a:lstStyle/>
+          <a:p>
+            <a:pPr algn="ctr" indent="0" marL="0">
+              <a:buNone/>
+            </a:pPr>
+            <a:r>
+              <a:rPr lang="en-US" sz="2200" dirty="0">
+                <a:solidFill>
+                  <a:srgbClr val="000000"/>
+                </a:solidFill>
+              </a:rPr>
+              <a:t>🛡️</a:t>
+            </a:r>
+            <a:endParaRPr lang="en-US" sz="2200" dirty="0"/>
+          </a:p>
+        </p:txBody>
+      </p:sp>
+      <p:sp>
+        <p:nvSpPr>
+          <p:cNvPr id="29" name="Text 27"/>
+          <p:cNvSpPr/>
+          <p:nvPr/>
+        </p:nvSpPr>
+        <p:spPr>
+          <a:xfrm>
+            <a:off x="5623560" y="3703320"/>
+            <a:ext cx="3063240" cy="594360"/>
+          </a:xfrm>
+          <a:prstGeom prst="rect">
+            <a:avLst/>
+          </a:prstGeom>
+          <a:noFill/>
+          <a:ln/>
+        </p:spPr>
+        <p:txBody>
+          <a:bodyPr wrap="square" rtlCol="0" anchor="ctr"/>
+          <a:lstStyle/>
+          <a:p>
+            <a:pPr indent="0" marL="0">
+              <a:buNone/>
+            </a:pPr>
+            <a:r>
+              <a:rPr lang="en-US" sz="1300" dirty="0">
+                <a:solidFill>
+                  <a:srgbClr val="2D3748"/>
+                </a:solidFill>
+                <a:latin typeface="Arial" pitchFamily="34" charset="0"/>
+                <a:ea typeface="Arial" pitchFamily="34" charset="-122"/>
+                <a:cs typeface="Arial" pitchFamily="34" charset="-120"/>
+              </a:rPr>
+              <a:t>Evidencia lista ante cualquier</a:t>
+            </a:r>
+            <a:endParaRPr lang="en-US" sz="1300" dirty="0"/>
+          </a:p>
+          <a:p>
+            <a:pPr indent="0" marL="0">
+              <a:buNone/>
+            </a:pPr>
+            <a:r>
+              <a:rPr lang="en-US" sz="1300" dirty="0">
+                <a:solidFill>
+                  <a:srgbClr val="2D3748"/>
+                </a:solidFill>
+                <a:latin typeface="Arial" pitchFamily="34" charset="0"/>
+                <a:ea typeface="Arial" pitchFamily="34" charset="-122"/>
+                <a:cs typeface="Arial" pitchFamily="34" charset="-120"/>
+              </a:rPr>
+              <a:t>inspección, queja o demanda</a:t>
+            </a:r>
+            <a:endParaRPr lang="en-US" sz="1300" dirty="0"/>
+          </a:p>
+        </p:txBody>
+      </p:sp>
+      <p:sp>
+        <p:nvSpPr>
+          <p:cNvPr id="30" name="Text 28"/>
+          <p:cNvSpPr/>
+          <p:nvPr/>
+        </p:nvSpPr>
+        <p:spPr>
+          <a:xfrm>
+            <a:off x="4434840" y="2651760"/>
+            <a:ext cx="411480" cy="457200"/>
+          </a:xfrm>
+          <a:prstGeom prst="rect">
+            <a:avLst/>
+          </a:prstGeom>
+          <a:noFill/>
+          <a:ln/>
+        </p:spPr>
+        <p:txBody>
+          <a:bodyPr wrap="square" rtlCol="0" anchor="ctr"/>
+          <a:lstStyle/>
+          <a:p>
+            <a:pPr algn="ctr" indent="0" marL="0">
+              <a:buNone/>
+            </a:pPr>
+            <a:r>
+              <a:rPr lang="en-US" sz="2400" b="1" dirty="0">
+                <a:solidFill>
+                  <a:srgbClr val="5B8DB8"/>
+                </a:solidFill>
+                <a:latin typeface="Arial" pitchFamily="34" charset="0"/>
+                <a:ea typeface="Arial" pitchFamily="34" charset="-122"/>
+                <a:cs typeface="Arial" pitchFamily="34" charset="-120"/>
+              </a:rPr>
+              <a:t>→</a:t>
+            </a:r>
+            <a:endParaRPr lang="en-US" sz="2400" dirty="0"/>
+          </a:p>
+        </p:txBody>
+      </p:sp>
+      <p:sp>
+        <p:nvSpPr>
+          <p:cNvPr id="31" name="Shape 29"/>
+          <p:cNvSpPr/>
+          <p:nvPr/>
+        </p:nvSpPr>
+        <p:spPr>
+          <a:xfrm>
+            <a:off x="457200" y="4956048"/>
+            <a:ext cx="8375904" cy="685800"/>
+          </a:xfrm>
+          <a:prstGeom prst="roundRect">
+            <a:avLst>
+              <a:gd name="adj" fmla="val 10667"/>
+            </a:avLst>
+          </a:prstGeom>
+          <a:solidFill>
+            <a:srgbClr val="F0EDE8"/>
+          </a:solidFill>
+          <a:ln w="6350">
+            <a:solidFill>
+              <a:srgbClr val="E2E8F0"/>
+            </a:solidFill>
+            <a:prstDash val="solid"/>
+          </a:ln>
+        </p:spPr>
+      </p:sp>
+      <p:sp>
+        <p:nvSpPr>
+          <p:cNvPr id="32" name="Text 30"/>
+          <p:cNvSpPr/>
+          <p:nvPr/>
+        </p:nvSpPr>
+        <p:spPr>
+          <a:xfrm>
+            <a:off x="640080" y="5029200"/>
+            <a:ext cx="8010144" cy="502920"/>
+          </a:xfrm>
+          <a:prstGeom prst="rect">
+            <a:avLst/>
+          </a:prstGeom>
+          <a:noFill/>
+          <a:ln/>
+        </p:spPr>
+        <p:txBody>
+          <a:bodyPr wrap="square" rtlCol="0" anchor="ctr"/>
+          <a:lstStyle/>
+          <a:p>
+            <a:pPr algn="ctr" indent="0" marL="0">
+              <a:buNone/>
+            </a:pPr>
+            <a:r>
+              <a:rPr lang="en-US" sz="1300" b="1" dirty="0">
+                <a:solidFill>
+                  <a:srgbClr val="2D3748"/>
+                </a:solidFill>
+                <a:latin typeface="Arial" pitchFamily="34" charset="0"/>
+                <a:ea typeface="Arial" pitchFamily="34" charset="-122"/>
+                <a:cs typeface="Arial" pitchFamily="34" charset="-120"/>
+              </a:rPr>
+              <a:t>El director tiene evidencia lista ante cualquier inspección, queja o demanda — en todo momento.</a:t>
+            </a:r>
+            <a:endParaRPr lang="en-US" sz="1300" dirty="0"/>
+          </a:p>
+        </p:txBody>
+      </p:sp>
+      <p:sp>
+        <p:nvSpPr>
+          <p:cNvPr id="33" name="Text 31"/>
+          <p:cNvSpPr/>
+          <p:nvPr/>
+        </p:nvSpPr>
+        <p:spPr>
+          <a:xfrm>
+            <a:off x="457200" y="6291072"/>
+            <a:ext cx="8375904" cy="201168"/>
+          </a:xfrm>
+          <a:prstGeom prst="rect">
+            <a:avLst/>
+          </a:prstGeom>
+          <a:noFill/>
+          <a:ln/>
+        </p:spPr>
+        <p:txBody>
+          <a:bodyPr wrap="square" rtlCol="0" anchor="ctr"/>
+          <a:lstStyle/>
+          <a:p>
+            <a:pPr algn="ctr" indent="0" marL="0">
+              <a:buNone/>
+            </a:pPr>
+            <a:r>
+              <a:rPr lang="en-US" dirty="0">
+                <a:solidFill>
+                  <a:srgbClr val="718096"/>
+                </a:solidFill>
+                <a:latin typeface="Arial" pitchFamily="34" charset="0"/>
+                <a:ea typeface="Arial" pitchFamily="34" charset="-122"/>
+                <a:cs typeface="Arial" pitchFamily="34" charset="-120"/>
+              </a:rPr>
+              <a:t>MVP operacional · No dispositivo médico · Datos ficticios</a:t>
             </a:r>
             <a:endParaRPr lang="en-US" dirty="0"/>
           </a:p>

</xml_diff>

<commit_message>
E3: deck slides 8-9 — mercado TAM/SAM/SOM y tabla comparativa diferenciador
Co-Authored-By: Claude Sonnet 4.6 <noreply@anthropic.com>
</commit_message>
<xml_diff>
--- a/business/CareSignal_Pitch_Deck.pptx
+++ b/business/CareSignal_Pitch_Deck.pptx
@@ -12,9 +12,11 @@
     <p:sldId id="260" r:id="rId6"/>
     <p:sldId id="261" r:id="rId7"/>
     <p:sldId id="262" r:id="rId8"/>
+    <p:sldId id="263" r:id="rId9"/>
+    <p:sldId id="264" r:id="rId10"/>
   </p:sldIdLst>
   <p:notesMasterIdLst>
-    <p:notesMasterId r:id="rId9"/>
+    <p:notesMasterId r:id="rId11"/>
   </p:notesMasterIdLst>
   <p:sldSz cx="12192000" cy="6858000"/>
   <p:notesSz cx="6858000" cy="12192000"/>
@@ -1060,6 +1062,182 @@
             <a:fld id="{F7021451-1387-4CA6-816F-3879F97B5CBC}" type="slidenum">
               <a:rPr lang="en-US"/>
               <a:t>7</a:t>
+            </a:fld>
+            <a:endParaRPr lang="en-US"/>
+          </a:p>
+        </p:txBody>
+      </p:sp>
+    </p:spTree>
+    <p:extLst>
+      <p:ext uri="{BB962C8B-B14F-4D97-AF65-F5344CB8AC3E}">
+        <p14:creationId xmlns:p14="http://schemas.microsoft.com/office/powerpoint/2010/main" val="1024086991"/>
+      </p:ext>
+    </p:extLst>
+  </p:cSld>
+  <p:clrMapOvr>
+    <a:masterClrMapping/>
+  </p:clrMapOvr>
+</p:notes>
+</file>
+
+<file path=ppt/notesSlides/notesSlide8.xml><?xml version="1.0" encoding="utf-8"?>
+<p:notes xmlns:a="http://schemas.openxmlformats.org/drawingml/2006/main" xmlns:r="http://schemas.openxmlformats.org/officeDocument/2006/relationships" xmlns:p="http://schemas.openxmlformats.org/presentationml/2006/main">
+  <p:cSld>
+    <p:spTree>
+      <p:nvGrpSpPr>
+        <p:cNvPr id="1" name=""/>
+        <p:cNvGrpSpPr/>
+        <p:nvPr/>
+      </p:nvGrpSpPr>
+      <p:grpSpPr>
+        <a:xfrm>
+          <a:off x="0" y="0"/>
+          <a:ext cx="0" cy="0"/>
+          <a:chOff x="0" y="0"/>
+          <a:chExt cx="0" cy="0"/>
+        </a:xfrm>
+      </p:grpSpPr>
+      <p:sp>
+        <p:nvSpPr>
+          <p:cNvPr id="2" name="Slide Image Placeholder 1"/>
+          <p:cNvSpPr>
+            <a:spLocks noGrp="1" noRot="1" noChangeAspect="1"/>
+          </p:cNvSpPr>
+          <p:nvPr>
+            <p:ph type="sldImg"/>
+          </p:nvPr>
+        </p:nvSpPr>
+        <p:spPr/>
+      </p:sp>
+      <p:sp>
+        <p:nvSpPr>
+          <p:cNvPr id="3" name="Notes Placeholder 2"/>
+          <p:cNvSpPr>
+            <a:spLocks noGrp="1"/>
+          </p:cNvSpPr>
+          <p:nvPr>
+            <p:ph type="body" idx="1"/>
+          </p:nvPr>
+        </p:nvSpPr>
+        <p:spPr/>
+        <p:txBody>
+          <a:bodyPr/>
+          <a:lstStyle/>
+          <a:p>
+            <a:r>
+              <a:rPr lang="en-US" dirty="0"/>
+              <a:t/>
+            </a:r>
+            <a:endParaRPr lang="en-US" dirty="0"/>
+          </a:p>
+        </p:txBody>
+      </p:sp>
+      <p:sp>
+        <p:nvSpPr>
+          <p:cNvPr id="4" name="Slide Number Placeholder 3"/>
+          <p:cNvSpPr>
+            <a:spLocks noGrp="1"/>
+          </p:cNvSpPr>
+          <p:nvPr>
+            <p:ph type="sldNum" sz="quarter" idx="10"/>
+          </p:nvPr>
+        </p:nvSpPr>
+        <p:spPr/>
+        <p:txBody>
+          <a:bodyPr/>
+          <a:lstStyle/>
+          <a:p>
+            <a:fld id="{F7021451-1387-4CA6-816F-3879F97B5CBC}" type="slidenum">
+              <a:rPr lang="en-US"/>
+              <a:t>8</a:t>
+            </a:fld>
+            <a:endParaRPr lang="en-US"/>
+          </a:p>
+        </p:txBody>
+      </p:sp>
+    </p:spTree>
+    <p:extLst>
+      <p:ext uri="{BB962C8B-B14F-4D97-AF65-F5344CB8AC3E}">
+        <p14:creationId xmlns:p14="http://schemas.microsoft.com/office/powerpoint/2010/main" val="1024086991"/>
+      </p:ext>
+    </p:extLst>
+  </p:cSld>
+  <p:clrMapOvr>
+    <a:masterClrMapping/>
+  </p:clrMapOvr>
+</p:notes>
+</file>
+
+<file path=ppt/notesSlides/notesSlide9.xml><?xml version="1.0" encoding="utf-8"?>
+<p:notes xmlns:a="http://schemas.openxmlformats.org/drawingml/2006/main" xmlns:r="http://schemas.openxmlformats.org/officeDocument/2006/relationships" xmlns:p="http://schemas.openxmlformats.org/presentationml/2006/main">
+  <p:cSld>
+    <p:spTree>
+      <p:nvGrpSpPr>
+        <p:cNvPr id="1" name=""/>
+        <p:cNvGrpSpPr/>
+        <p:nvPr/>
+      </p:nvGrpSpPr>
+      <p:grpSpPr>
+        <a:xfrm>
+          <a:off x="0" y="0"/>
+          <a:ext cx="0" cy="0"/>
+          <a:chOff x="0" y="0"/>
+          <a:chExt cx="0" cy="0"/>
+        </a:xfrm>
+      </p:grpSpPr>
+      <p:sp>
+        <p:nvSpPr>
+          <p:cNvPr id="2" name="Slide Image Placeholder 1"/>
+          <p:cNvSpPr>
+            <a:spLocks noGrp="1" noRot="1" noChangeAspect="1"/>
+          </p:cNvSpPr>
+          <p:nvPr>
+            <p:ph type="sldImg"/>
+          </p:nvPr>
+        </p:nvSpPr>
+        <p:spPr/>
+      </p:sp>
+      <p:sp>
+        <p:nvSpPr>
+          <p:cNvPr id="3" name="Notes Placeholder 2"/>
+          <p:cNvSpPr>
+            <a:spLocks noGrp="1"/>
+          </p:cNvSpPr>
+          <p:nvPr>
+            <p:ph type="body" idx="1"/>
+          </p:nvPr>
+        </p:nvSpPr>
+        <p:spPr/>
+        <p:txBody>
+          <a:bodyPr/>
+          <a:lstStyle/>
+          <a:p>
+            <a:r>
+              <a:rPr lang="en-US" dirty="0"/>
+              <a:t/>
+            </a:r>
+            <a:endParaRPr lang="en-US" dirty="0"/>
+          </a:p>
+        </p:txBody>
+      </p:sp>
+      <p:sp>
+        <p:nvSpPr>
+          <p:cNvPr id="4" name="Slide Number Placeholder 3"/>
+          <p:cNvSpPr>
+            <a:spLocks noGrp="1"/>
+          </p:cNvSpPr>
+          <p:nvPr>
+            <p:ph type="sldNum" sz="quarter" idx="10"/>
+          </p:nvPr>
+        </p:nvSpPr>
+        <p:spPr/>
+        <p:txBody>
+          <a:bodyPr/>
+          <a:lstStyle/>
+          <a:p>
+            <a:fld id="{F7021451-1387-4CA6-816F-3879F97B5CBC}" type="slidenum">
+              <a:rPr lang="en-US"/>
+              <a:t>9</a:t>
             </a:fld>
             <a:endParaRPr lang="en-US"/>
           </a:p>
@@ -8016,6 +8194,2430 @@
 </p:sld>
 </file>
 
+<file path=ppt/slides/slide8.xml><?xml version="1.0" encoding="utf-8"?>
+<p:sld xmlns:a="http://schemas.openxmlformats.org/drawingml/2006/main" xmlns:r="http://schemas.openxmlformats.org/officeDocument/2006/relationships" xmlns:p="http://schemas.openxmlformats.org/presentationml/2006/main">
+  <p:cSld name="Slide 8">
+    <p:spTree>
+      <p:nvGrpSpPr>
+        <p:cNvPr id="1" name=""/>
+        <p:cNvGrpSpPr/>
+        <p:nvPr/>
+      </p:nvGrpSpPr>
+      <p:grpSpPr>
+        <a:xfrm>
+          <a:off x="0" y="0"/>
+          <a:ext cx="0" cy="0"/>
+          <a:chOff x="0" y="0"/>
+          <a:chExt cx="0" cy="0"/>
+        </a:xfrm>
+      </p:grpSpPr>
+      <p:sp>
+        <p:nvSpPr>
+          <p:cNvPr id="2" name="Shape 0"/>
+          <p:cNvSpPr/>
+          <p:nvPr/>
+        </p:nvSpPr>
+        <p:spPr>
+          <a:xfrm>
+            <a:off x="0" y="0"/>
+            <a:ext cx="12192000" cy="6858000"/>
+          </a:xfrm>
+          <a:prstGeom prst="rect">
+            <a:avLst/>
+          </a:prstGeom>
+          <a:solidFill>
+            <a:srgbClr val="FAFAF8"/>
+          </a:solidFill>
+          <a:ln w="12700">
+            <a:solidFill>
+              <a:srgbClr val="FAFAF8"/>
+            </a:solidFill>
+            <a:prstDash val="solid"/>
+          </a:ln>
+        </p:spPr>
+      </p:sp>
+      <p:sp>
+        <p:nvSpPr>
+          <p:cNvPr id="3" name="Shape 1"/>
+          <p:cNvSpPr/>
+          <p:nvPr/>
+        </p:nvSpPr>
+        <p:spPr>
+          <a:xfrm>
+            <a:off x="7132320" y="-1371600"/>
+            <a:ext cx="3474720" cy="3474720"/>
+          </a:xfrm>
+          <a:prstGeom prst="ellipse">
+            <a:avLst/>
+          </a:prstGeom>
+          <a:solidFill>
+            <a:srgbClr val="7BA68A">
+              <a:alpha val="16000"/>
+            </a:srgbClr>
+          </a:solidFill>
+          <a:ln w="12700">
+            <a:solidFill>
+              <a:srgbClr val="7BA68A">
+                <a:alpha val="16000"/>
+              </a:srgbClr>
+            </a:solidFill>
+            <a:prstDash val="solid"/>
+          </a:ln>
+        </p:spPr>
+      </p:sp>
+      <p:sp>
+        <p:nvSpPr>
+          <p:cNvPr id="4" name="Shape 2"/>
+          <p:cNvSpPr/>
+          <p:nvPr/>
+        </p:nvSpPr>
+        <p:spPr>
+          <a:xfrm>
+            <a:off x="-365760" y="5303520"/>
+            <a:ext cx="2011680" cy="2011680"/>
+          </a:xfrm>
+          <a:prstGeom prst="ellipse">
+            <a:avLst/>
+          </a:prstGeom>
+          <a:solidFill>
+            <a:srgbClr val="A8C4DC">
+              <a:alpha val="20000"/>
+            </a:srgbClr>
+          </a:solidFill>
+          <a:ln w="12700">
+            <a:solidFill>
+              <a:srgbClr val="A8C4DC">
+                <a:alpha val="20000"/>
+              </a:srgbClr>
+            </a:solidFill>
+            <a:prstDash val="solid"/>
+          </a:ln>
+        </p:spPr>
+      </p:sp>
+      <p:sp>
+        <p:nvSpPr>
+          <p:cNvPr id="5" name="Shape 3"/>
+          <p:cNvSpPr/>
+          <p:nvPr/>
+        </p:nvSpPr>
+        <p:spPr>
+          <a:xfrm rot="-1080000">
+            <a:off x="274320" y="5943600"/>
+            <a:ext cx="2286000" cy="0"/>
+          </a:xfrm>
+          <a:prstGeom prst="line">
+            <a:avLst/>
+          </a:prstGeom>
+          <a:noFill/>
+          <a:ln w="12700">
+            <a:solidFill>
+              <a:srgbClr val="E2E8F0"/>
+            </a:solidFill>
+            <a:prstDash val="solid"/>
+          </a:ln>
+        </p:spPr>
+      </p:sp>
+      <p:sp>
+        <p:nvSpPr>
+          <p:cNvPr id="6" name="Shape 4"/>
+          <p:cNvSpPr/>
+          <p:nvPr/>
+        </p:nvSpPr>
+        <p:spPr>
+          <a:xfrm>
+            <a:off x="0" y="0"/>
+            <a:ext cx="12192000" cy="54864"/>
+          </a:xfrm>
+          <a:prstGeom prst="rect">
+            <a:avLst/>
+          </a:prstGeom>
+          <a:solidFill>
+            <a:srgbClr val="5B8DB8"/>
+          </a:solidFill>
+          <a:ln w="12700">
+            <a:solidFill>
+              <a:srgbClr val="5B8DB8"/>
+            </a:solidFill>
+            <a:prstDash val="solid"/>
+          </a:ln>
+        </p:spPr>
+      </p:sp>
+      <p:sp>
+        <p:nvSpPr>
+          <p:cNvPr id="7" name="Shape 5"/>
+          <p:cNvSpPr/>
+          <p:nvPr/>
+        </p:nvSpPr>
+        <p:spPr>
+          <a:xfrm>
+            <a:off x="0" y="6528816"/>
+            <a:ext cx="12192000" cy="54864"/>
+          </a:xfrm>
+          <a:prstGeom prst="rect">
+            <a:avLst/>
+          </a:prstGeom>
+          <a:solidFill>
+            <a:srgbClr val="C4786A"/>
+          </a:solidFill>
+          <a:ln w="12700">
+            <a:solidFill>
+              <a:srgbClr val="C4786A"/>
+            </a:solidFill>
+            <a:prstDash val="solid"/>
+          </a:ln>
+        </p:spPr>
+      </p:sp>
+      <p:sp>
+        <p:nvSpPr>
+          <p:cNvPr id="8" name="Text 6"/>
+          <p:cNvSpPr/>
+          <p:nvPr/>
+        </p:nvSpPr>
+        <p:spPr>
+          <a:xfrm>
+            <a:off x="457200" y="228600"/>
+            <a:ext cx="8375904" cy="502920"/>
+          </a:xfrm>
+          <a:prstGeom prst="rect">
+            <a:avLst/>
+          </a:prstGeom>
+          <a:noFill/>
+          <a:ln/>
+        </p:spPr>
+        <p:txBody>
+          <a:bodyPr wrap="square" rtlCol="0" anchor="ctr"/>
+          <a:lstStyle/>
+          <a:p>
+            <a:pPr indent="0" marL="0">
+              <a:buNone/>
+            </a:pPr>
+            <a:r>
+              <a:rPr lang="en-US" b="1" dirty="0">
+                <a:solidFill>
+                  <a:srgbClr val="2D3748"/>
+                </a:solidFill>
+                <a:latin typeface="Arial" pitchFamily="34" charset="0"/>
+                <a:ea typeface="Arial" pitchFamily="34" charset="-122"/>
+                <a:cs typeface="Arial" pitchFamily="34" charset="-120"/>
+              </a:rPr>
+              <a:t>📊  Tamaño de mercado</a:t>
+            </a:r>
+            <a:endParaRPr lang="en-US" dirty="0"/>
+          </a:p>
+        </p:txBody>
+      </p:sp>
+      <p:sp>
+        <p:nvSpPr>
+          <p:cNvPr id="9" name="Text 7"/>
+          <p:cNvSpPr/>
+          <p:nvPr/>
+        </p:nvSpPr>
+        <p:spPr>
+          <a:xfrm>
+            <a:off x="457200" y="731520"/>
+            <a:ext cx="8375904" cy="320040"/>
+          </a:xfrm>
+          <a:prstGeom prst="rect">
+            <a:avLst/>
+          </a:prstGeom>
+          <a:noFill/>
+          <a:ln/>
+        </p:spPr>
+        <p:txBody>
+          <a:bodyPr wrap="square" rtlCol="0" anchor="ctr"/>
+          <a:lstStyle/>
+          <a:p>
+            <a:pPr indent="0" marL="0">
+              <a:buNone/>
+            </a:pPr>
+            <a:r>
+              <a:rPr lang="en-US" b="1" dirty="0">
+                <a:solidFill>
+                  <a:srgbClr val="5B8DB8"/>
+                </a:solidFill>
+                <a:latin typeface="Arial" pitchFamily="34" charset="0"/>
+                <a:ea typeface="Arial" pitchFamily="34" charset="-122"/>
+                <a:cs typeface="Arial" pitchFamily="34" charset="-120"/>
+              </a:rPr>
+              <a:t>México · SaaS B2B · por residencia / mes</a:t>
+            </a:r>
+            <a:endParaRPr lang="en-US" dirty="0"/>
+          </a:p>
+        </p:txBody>
+      </p:sp>
+      <p:sp>
+        <p:nvSpPr>
+          <p:cNvPr id="10" name="Shape 8"/>
+          <p:cNvSpPr/>
+          <p:nvPr/>
+        </p:nvSpPr>
+        <p:spPr>
+          <a:xfrm>
+            <a:off x="457200" y="1097280"/>
+            <a:ext cx="8375904" cy="0"/>
+          </a:xfrm>
+          <a:prstGeom prst="line">
+            <a:avLst/>
+          </a:prstGeom>
+          <a:noFill/>
+          <a:ln w="12700">
+            <a:solidFill>
+              <a:srgbClr val="E2E8F0"/>
+            </a:solidFill>
+            <a:prstDash val="solid"/>
+          </a:ln>
+        </p:spPr>
+      </p:sp>
+      <p:sp>
+        <p:nvSpPr>
+          <p:cNvPr id="11" name="Shape 9"/>
+          <p:cNvSpPr/>
+          <p:nvPr/>
+        </p:nvSpPr>
+        <p:spPr>
+          <a:xfrm>
+            <a:off x="457200" y="1261872"/>
+            <a:ext cx="8375904" cy="1371600"/>
+          </a:xfrm>
+          <a:prstGeom prst="roundRect">
+            <a:avLst>
+              <a:gd name="adj" fmla="val 6667"/>
+            </a:avLst>
+          </a:prstGeom>
+          <a:solidFill>
+            <a:srgbClr val="A8C4DC"/>
+          </a:solidFill>
+          <a:ln w="6350">
+            <a:solidFill>
+              <a:srgbClr val="E2E8F0"/>
+            </a:solidFill>
+            <a:prstDash val="solid"/>
+          </a:ln>
+        </p:spPr>
+      </p:sp>
+      <p:sp>
+        <p:nvSpPr>
+          <p:cNvPr id="12" name="Text 10"/>
+          <p:cNvSpPr/>
+          <p:nvPr/>
+        </p:nvSpPr>
+        <p:spPr>
+          <a:xfrm>
+            <a:off x="621792" y="1371600"/>
+            <a:ext cx="914400" cy="384048"/>
+          </a:xfrm>
+          <a:prstGeom prst="rect">
+            <a:avLst/>
+          </a:prstGeom>
+          <a:noFill/>
+          <a:ln/>
+        </p:spPr>
+        <p:txBody>
+          <a:bodyPr wrap="square" rtlCol="0" anchor="ctr"/>
+          <a:lstStyle/>
+          <a:p>
+            <a:pPr indent="0" marL="0">
+              <a:buNone/>
+            </a:pPr>
+            <a:r>
+              <a:rPr lang="en-US" sz="1500" b="1" dirty="0">
+                <a:solidFill>
+                  <a:srgbClr val="3A6B96"/>
+                </a:solidFill>
+                <a:latin typeface="Arial" pitchFamily="34" charset="0"/>
+                <a:ea typeface="Arial" pitchFamily="34" charset="-122"/>
+                <a:cs typeface="Arial" pitchFamily="34" charset="-120"/>
+              </a:rPr>
+              <a:t>TAM</a:t>
+            </a:r>
+            <a:endParaRPr lang="en-US" sz="1500" dirty="0"/>
+          </a:p>
+        </p:txBody>
+      </p:sp>
+      <p:sp>
+        <p:nvSpPr>
+          <p:cNvPr id="13" name="Text 11"/>
+          <p:cNvSpPr/>
+          <p:nvPr/>
+        </p:nvSpPr>
+        <p:spPr>
+          <a:xfrm>
+            <a:off x="1600200" y="1335024"/>
+            <a:ext cx="4114800" cy="685800"/>
+          </a:xfrm>
+          <a:prstGeom prst="rect">
+            <a:avLst/>
+          </a:prstGeom>
+          <a:noFill/>
+          <a:ln/>
+        </p:spPr>
+        <p:txBody>
+          <a:bodyPr wrap="square" rtlCol="0" anchor="ctr"/>
+          <a:lstStyle/>
+          <a:p>
+            <a:pPr indent="0" marL="0">
+              <a:buNone/>
+            </a:pPr>
+            <a:r>
+              <a:rPr lang="en-US" sz="1100" dirty="0">
+                <a:solidFill>
+                  <a:srgbClr val="2D3748"/>
+                </a:solidFill>
+                <a:latin typeface="Arial" pitchFamily="34" charset="0"/>
+                <a:ea typeface="Arial" pitchFamily="34" charset="-122"/>
+                <a:cs typeface="Arial" pitchFamily="34" charset="-120"/>
+              </a:rPr>
+              <a:t>Mercado total cuidados</a:t>
+            </a:r>
+            <a:endParaRPr lang="en-US" sz="1100" dirty="0"/>
+          </a:p>
+          <a:p>
+            <a:pPr indent="0" marL="0">
+              <a:buNone/>
+            </a:pPr>
+            <a:r>
+              <a:rPr lang="en-US" sz="1100" dirty="0">
+                <a:solidFill>
+                  <a:srgbClr val="2D3748"/>
+                </a:solidFill>
+                <a:latin typeface="Arial" pitchFamily="34" charset="0"/>
+                <a:ea typeface="Arial" pitchFamily="34" charset="-122"/>
+                <a:cs typeface="Arial" pitchFamily="34" charset="-120"/>
+              </a:rPr>
+              <a:t>geriátricos MX + LatAm</a:t>
+            </a:r>
+            <a:endParaRPr lang="en-US" sz="1100" dirty="0"/>
+          </a:p>
+        </p:txBody>
+      </p:sp>
+      <p:sp>
+        <p:nvSpPr>
+          <p:cNvPr id="14" name="Text 12"/>
+          <p:cNvSpPr/>
+          <p:nvPr/>
+        </p:nvSpPr>
+        <p:spPr>
+          <a:xfrm>
+            <a:off x="5760720" y="1490472"/>
+            <a:ext cx="2743200" cy="384048"/>
+          </a:xfrm>
+          <a:prstGeom prst="rect">
+            <a:avLst/>
+          </a:prstGeom>
+          <a:noFill/>
+          <a:ln/>
+        </p:spPr>
+        <p:txBody>
+          <a:bodyPr wrap="square" rtlCol="0" anchor="ctr"/>
+          <a:lstStyle/>
+          <a:p>
+            <a:pPr algn="r" indent="0" marL="0">
+              <a:buNone/>
+            </a:pPr>
+            <a:r>
+              <a:rPr lang="en-US" sz="1300" b="1" dirty="0">
+                <a:solidFill>
+                  <a:srgbClr val="3A6B96"/>
+                </a:solidFill>
+                <a:latin typeface="Arial" pitchFamily="34" charset="0"/>
+                <a:ea typeface="Arial" pitchFamily="34" charset="-122"/>
+                <a:cs typeface="Arial" pitchFamily="34" charset="-120"/>
+              </a:rPr>
+              <a:t>&gt; USD 25,000 M</a:t>
+            </a:r>
+            <a:endParaRPr lang="en-US" sz="1300" dirty="0"/>
+          </a:p>
+        </p:txBody>
+      </p:sp>
+      <p:sp>
+        <p:nvSpPr>
+          <p:cNvPr id="15" name="Shape 13"/>
+          <p:cNvSpPr/>
+          <p:nvPr/>
+        </p:nvSpPr>
+        <p:spPr>
+          <a:xfrm>
+            <a:off x="868680" y="2423160"/>
+            <a:ext cx="7552944" cy="1325880"/>
+          </a:xfrm>
+          <a:prstGeom prst="roundRect">
+            <a:avLst>
+              <a:gd name="adj" fmla="val 6897"/>
+            </a:avLst>
+          </a:prstGeom>
+          <a:solidFill>
+            <a:srgbClr val="D1E8F5"/>
+          </a:solidFill>
+          <a:ln w="6350">
+            <a:solidFill>
+              <a:srgbClr val="E2E8F0"/>
+            </a:solidFill>
+            <a:prstDash val="solid"/>
+          </a:ln>
+        </p:spPr>
+      </p:sp>
+      <p:sp>
+        <p:nvSpPr>
+          <p:cNvPr id="16" name="Text 14"/>
+          <p:cNvSpPr/>
+          <p:nvPr/>
+        </p:nvSpPr>
+        <p:spPr>
+          <a:xfrm>
+            <a:off x="1033272" y="2532888"/>
+            <a:ext cx="914400" cy="384048"/>
+          </a:xfrm>
+          <a:prstGeom prst="rect">
+            <a:avLst/>
+          </a:prstGeom>
+          <a:noFill/>
+          <a:ln/>
+        </p:spPr>
+        <p:txBody>
+          <a:bodyPr wrap="square" rtlCol="0" anchor="ctr"/>
+          <a:lstStyle/>
+          <a:p>
+            <a:pPr indent="0" marL="0">
+              <a:buNone/>
+            </a:pPr>
+            <a:r>
+              <a:rPr lang="en-US" sz="1500" b="1" dirty="0">
+                <a:solidFill>
+                  <a:srgbClr val="3A6B96"/>
+                </a:solidFill>
+                <a:latin typeface="Arial" pitchFamily="34" charset="0"/>
+                <a:ea typeface="Arial" pitchFamily="34" charset="-122"/>
+                <a:cs typeface="Arial" pitchFamily="34" charset="-120"/>
+              </a:rPr>
+              <a:t>SAM</a:t>
+            </a:r>
+            <a:endParaRPr lang="en-US" sz="1500" dirty="0"/>
+          </a:p>
+        </p:txBody>
+      </p:sp>
+      <p:sp>
+        <p:nvSpPr>
+          <p:cNvPr id="17" name="Text 15"/>
+          <p:cNvSpPr/>
+          <p:nvPr/>
+        </p:nvSpPr>
+        <p:spPr>
+          <a:xfrm>
+            <a:off x="2011680" y="2496312"/>
+            <a:ext cx="4114800" cy="685800"/>
+          </a:xfrm>
+          <a:prstGeom prst="rect">
+            <a:avLst/>
+          </a:prstGeom>
+          <a:noFill/>
+          <a:ln/>
+        </p:spPr>
+        <p:txBody>
+          <a:bodyPr wrap="square" rtlCol="0" anchor="ctr"/>
+          <a:lstStyle/>
+          <a:p>
+            <a:pPr indent="0" marL="0">
+              <a:buNone/>
+            </a:pPr>
+            <a:r>
+              <a:rPr lang="en-US" sz="1100" dirty="0">
+                <a:solidFill>
+                  <a:srgbClr val="2D3748"/>
+                </a:solidFill>
+                <a:latin typeface="Arial" pitchFamily="34" charset="0"/>
+                <a:ea typeface="Arial" pitchFamily="34" charset="-122"/>
+                <a:cs typeface="Arial" pitchFamily="34" charset="-120"/>
+              </a:rPr>
+              <a:t>~1,100–1,300 residencias</a:t>
+            </a:r>
+            <a:endParaRPr lang="en-US" sz="1100" dirty="0"/>
+          </a:p>
+          <a:p>
+            <a:pPr indent="0" marL="0">
+              <a:buNone/>
+            </a:pPr>
+            <a:r>
+              <a:rPr lang="en-US" sz="1100" dirty="0">
+                <a:solidFill>
+                  <a:srgbClr val="2D3748"/>
+                </a:solidFill>
+                <a:latin typeface="Arial" pitchFamily="34" charset="0"/>
+                <a:ea typeface="Arial" pitchFamily="34" charset="-122"/>
+                <a:cs typeface="Arial" pitchFamily="34" charset="-120"/>
+              </a:rPr>
+              <a:t>privadas formales en MX</a:t>
+            </a:r>
+            <a:endParaRPr lang="en-US" sz="1100" dirty="0"/>
+          </a:p>
+        </p:txBody>
+      </p:sp>
+      <p:sp>
+        <p:nvSpPr>
+          <p:cNvPr id="18" name="Text 16"/>
+          <p:cNvSpPr/>
+          <p:nvPr/>
+        </p:nvSpPr>
+        <p:spPr>
+          <a:xfrm>
+            <a:off x="6172200" y="2651760"/>
+            <a:ext cx="2743200" cy="384048"/>
+          </a:xfrm>
+          <a:prstGeom prst="rect">
+            <a:avLst/>
+          </a:prstGeom>
+          <a:noFill/>
+          <a:ln/>
+        </p:spPr>
+        <p:txBody>
+          <a:bodyPr wrap="square" rtlCol="0" anchor="ctr"/>
+          <a:lstStyle/>
+          <a:p>
+            <a:pPr algn="r" indent="0" marL="0">
+              <a:buNone/>
+            </a:pPr>
+            <a:r>
+              <a:rPr lang="en-US" sz="1300" b="1" dirty="0">
+                <a:solidFill>
+                  <a:srgbClr val="3A6B96"/>
+                </a:solidFill>
+                <a:latin typeface="Arial" pitchFamily="34" charset="0"/>
+                <a:ea typeface="Arial" pitchFamily="34" charset="-122"/>
+                <a:cs typeface="Arial" pitchFamily="34" charset="-120"/>
+              </a:rPr>
+              <a:t>DENUE 2025 · +18 % anual</a:t>
+            </a:r>
+            <a:endParaRPr lang="en-US" sz="1300" dirty="0"/>
+          </a:p>
+        </p:txBody>
+      </p:sp>
+      <p:sp>
+        <p:nvSpPr>
+          <p:cNvPr id="19" name="Shape 17"/>
+          <p:cNvSpPr/>
+          <p:nvPr/>
+        </p:nvSpPr>
+        <p:spPr>
+          <a:xfrm>
+            <a:off x="1280160" y="3547872"/>
+            <a:ext cx="6729984" cy="1325880"/>
+          </a:xfrm>
+          <a:prstGeom prst="roundRect">
+            <a:avLst>
+              <a:gd name="adj" fmla="val 6897"/>
+            </a:avLst>
+          </a:prstGeom>
+          <a:solidFill>
+            <a:srgbClr val="F0EDE8"/>
+          </a:solidFill>
+          <a:ln w="6350">
+            <a:solidFill>
+              <a:srgbClr val="E2E8F0"/>
+            </a:solidFill>
+            <a:prstDash val="solid"/>
+          </a:ln>
+        </p:spPr>
+      </p:sp>
+      <p:sp>
+        <p:nvSpPr>
+          <p:cNvPr id="20" name="Text 18"/>
+          <p:cNvSpPr/>
+          <p:nvPr/>
+        </p:nvSpPr>
+        <p:spPr>
+          <a:xfrm>
+            <a:off x="1444752" y="3657600"/>
+            <a:ext cx="914400" cy="384048"/>
+          </a:xfrm>
+          <a:prstGeom prst="rect">
+            <a:avLst/>
+          </a:prstGeom>
+          <a:noFill/>
+          <a:ln/>
+        </p:spPr>
+        <p:txBody>
+          <a:bodyPr wrap="square" rtlCol="0" anchor="ctr"/>
+          <a:lstStyle/>
+          <a:p>
+            <a:pPr indent="0" marL="0">
+              <a:buNone/>
+            </a:pPr>
+            <a:r>
+              <a:rPr lang="en-US" sz="1500" b="1" dirty="0">
+                <a:solidFill>
+                  <a:srgbClr val="3A6B96"/>
+                </a:solidFill>
+                <a:latin typeface="Arial" pitchFamily="34" charset="0"/>
+                <a:ea typeface="Arial" pitchFamily="34" charset="-122"/>
+                <a:cs typeface="Arial" pitchFamily="34" charset="-120"/>
+              </a:rPr>
+              <a:t>SOM</a:t>
+            </a:r>
+            <a:endParaRPr lang="en-US" sz="1500" dirty="0"/>
+          </a:p>
+        </p:txBody>
+      </p:sp>
+      <p:sp>
+        <p:nvSpPr>
+          <p:cNvPr id="21" name="Text 19"/>
+          <p:cNvSpPr/>
+          <p:nvPr/>
+        </p:nvSpPr>
+        <p:spPr>
+          <a:xfrm>
+            <a:off x="2423160" y="3621024"/>
+            <a:ext cx="4114800" cy="685800"/>
+          </a:xfrm>
+          <a:prstGeom prst="rect">
+            <a:avLst/>
+          </a:prstGeom>
+          <a:noFill/>
+          <a:ln/>
+        </p:spPr>
+        <p:txBody>
+          <a:bodyPr wrap="square" rtlCol="0" anchor="ctr"/>
+          <a:lstStyle/>
+          <a:p>
+            <a:pPr indent="0" marL="0">
+              <a:buNone/>
+            </a:pPr>
+            <a:r>
+              <a:rPr lang="en-US" sz="1100" dirty="0">
+                <a:solidFill>
+                  <a:srgbClr val="2D3748"/>
+                </a:solidFill>
+                <a:latin typeface="Arial" pitchFamily="34" charset="0"/>
+                <a:ea typeface="Arial" pitchFamily="34" charset="-122"/>
+                <a:cs typeface="Arial" pitchFamily="34" charset="-120"/>
+              </a:rPr>
+              <a:t>Objetivo 3–5 años:</a:t>
+            </a:r>
+            <a:endParaRPr lang="en-US" sz="1100" dirty="0"/>
+          </a:p>
+          <a:p>
+            <a:pPr indent="0" marL="0">
+              <a:buNone/>
+            </a:pPr>
+            <a:r>
+              <a:rPr lang="en-US" sz="1100" dirty="0">
+                <a:solidFill>
+                  <a:srgbClr val="2D3748"/>
+                </a:solidFill>
+                <a:latin typeface="Arial" pitchFamily="34" charset="0"/>
+                <a:ea typeface="Arial" pitchFamily="34" charset="-122"/>
+                <a:cs typeface="Arial" pitchFamily="34" charset="-120"/>
+              </a:rPr>
+              <a:t>50–200 residencias piloto</a:t>
+            </a:r>
+            <a:endParaRPr lang="en-US" sz="1100" dirty="0"/>
+          </a:p>
+        </p:txBody>
+      </p:sp>
+      <p:sp>
+        <p:nvSpPr>
+          <p:cNvPr id="22" name="Text 20"/>
+          <p:cNvSpPr/>
+          <p:nvPr/>
+        </p:nvSpPr>
+        <p:spPr>
+          <a:xfrm>
+            <a:off x="6583680" y="3776472"/>
+            <a:ext cx="2743200" cy="384048"/>
+          </a:xfrm>
+          <a:prstGeom prst="rect">
+            <a:avLst/>
+          </a:prstGeom>
+          <a:noFill/>
+          <a:ln/>
+        </p:spPr>
+        <p:txBody>
+          <a:bodyPr wrap="square" rtlCol="0" anchor="ctr"/>
+          <a:lstStyle/>
+          <a:p>
+            <a:pPr algn="r" indent="0" marL="0">
+              <a:buNone/>
+            </a:pPr>
+            <a:r>
+              <a:rPr lang="en-US" sz="1300" b="1" dirty="0">
+                <a:solidFill>
+                  <a:srgbClr val="3A6B96"/>
+                </a:solidFill>
+                <a:latin typeface="Arial" pitchFamily="34" charset="0"/>
+                <a:ea typeface="Arial" pitchFamily="34" charset="-122"/>
+                <a:cs typeface="Arial" pitchFamily="34" charset="-120"/>
+              </a:rPr>
+              <a:t>$175K – $700K MXN/mes</a:t>
+            </a:r>
+            <a:endParaRPr lang="en-US" sz="1300" dirty="0"/>
+          </a:p>
+        </p:txBody>
+      </p:sp>
+      <p:sp>
+        <p:nvSpPr>
+          <p:cNvPr id="23" name="Shape 21"/>
+          <p:cNvSpPr/>
+          <p:nvPr/>
+        </p:nvSpPr>
+        <p:spPr>
+          <a:xfrm>
+            <a:off x="457200" y="5047488"/>
+            <a:ext cx="8375904" cy="594360"/>
+          </a:xfrm>
+          <a:prstGeom prst="roundRect">
+            <a:avLst>
+              <a:gd name="adj" fmla="val 12308"/>
+            </a:avLst>
+          </a:prstGeom>
+          <a:solidFill>
+            <a:srgbClr val="F0EDE8"/>
+          </a:solidFill>
+          <a:ln w="6350">
+            <a:solidFill>
+              <a:srgbClr val="E2E8F0"/>
+            </a:solidFill>
+            <a:prstDash val="solid"/>
+          </a:ln>
+        </p:spPr>
+      </p:sp>
+      <p:sp>
+        <p:nvSpPr>
+          <p:cNvPr id="24" name="Text 22"/>
+          <p:cNvSpPr/>
+          <p:nvPr/>
+        </p:nvSpPr>
+        <p:spPr>
+          <a:xfrm>
+            <a:off x="640080" y="5120640"/>
+            <a:ext cx="8010144" cy="438912"/>
+          </a:xfrm>
+          <a:prstGeom prst="rect">
+            <a:avLst/>
+          </a:prstGeom>
+          <a:noFill/>
+          <a:ln/>
+        </p:spPr>
+        <p:txBody>
+          <a:bodyPr wrap="square" rtlCol="0" anchor="ctr"/>
+          <a:lstStyle/>
+          <a:p>
+            <a:pPr indent="0" marL="0">
+              <a:buNone/>
+            </a:pPr>
+            <a:r>
+              <a:rPr lang="en-US" sz="1200" dirty="0">
+                <a:solidFill>
+                  <a:srgbClr val="2D3748"/>
+                </a:solidFill>
+                <a:latin typeface="Arial" pitchFamily="34" charset="0"/>
+                <a:ea typeface="Arial" pitchFamily="34" charset="-122"/>
+                <a:cs typeface="Arial" pitchFamily="34" charset="-120"/>
+              </a:rPr>
+              <a:t>📈  El registro del sector creció +18 % en un año (DENUE 2024→2025) — mercado en expansión activa.</a:t>
+            </a:r>
+            <a:endParaRPr lang="en-US" sz="1200" dirty="0"/>
+          </a:p>
+        </p:txBody>
+      </p:sp>
+      <p:sp>
+        <p:nvSpPr>
+          <p:cNvPr id="25" name="Text 23"/>
+          <p:cNvSpPr/>
+          <p:nvPr/>
+        </p:nvSpPr>
+        <p:spPr>
+          <a:xfrm>
+            <a:off x="457200" y="6291072"/>
+            <a:ext cx="8375904" cy="201168"/>
+          </a:xfrm>
+          <a:prstGeom prst="rect">
+            <a:avLst/>
+          </a:prstGeom>
+          <a:noFill/>
+          <a:ln/>
+        </p:spPr>
+        <p:txBody>
+          <a:bodyPr wrap="square" rtlCol="0" anchor="ctr"/>
+          <a:lstStyle/>
+          <a:p>
+            <a:pPr algn="l" indent="0" marL="0">
+              <a:buNone/>
+            </a:pPr>
+            <a:r>
+              <a:rPr lang="en-US" dirty="0">
+                <a:solidFill>
+                  <a:srgbClr val="718096"/>
+                </a:solidFill>
+                <a:latin typeface="Arial" pitchFamily="34" charset="0"/>
+                <a:ea typeface="Arial" pitchFamily="34" charset="-122"/>
+                <a:cs typeface="Arial" pitchFamily="34" charset="-120"/>
+              </a:rPr>
+              <a:t>Fuentes: DENUE 2025 · IMARC Group · Grand View Research  ·  Precios de referencia, no validados con clientes</a:t>
+            </a:r>
+            <a:endParaRPr lang="en-US" dirty="0"/>
+          </a:p>
+        </p:txBody>
+      </p:sp>
+    </p:spTree>
+  </p:cSld>
+  <p:clrMapOvr>
+    <a:masterClrMapping/>
+  </p:clrMapOvr>
+</p:sld>
+</file>
+
+<file path=ppt/slides/slide9.xml><?xml version="1.0" encoding="utf-8"?>
+<p:sld xmlns:a="http://schemas.openxmlformats.org/drawingml/2006/main" xmlns:r="http://schemas.openxmlformats.org/officeDocument/2006/relationships" xmlns:p="http://schemas.openxmlformats.org/presentationml/2006/main">
+  <p:cSld name="Slide 9">
+    <p:spTree>
+      <p:nvGrpSpPr>
+        <p:cNvPr id="1" name=""/>
+        <p:cNvGrpSpPr/>
+        <p:nvPr/>
+      </p:nvGrpSpPr>
+      <p:grpSpPr>
+        <a:xfrm>
+          <a:off x="0" y="0"/>
+          <a:ext cx="0" cy="0"/>
+          <a:chOff x="0" y="0"/>
+          <a:chExt cx="0" cy="0"/>
+        </a:xfrm>
+      </p:grpSpPr>
+      <p:sp>
+        <p:nvSpPr>
+          <p:cNvPr id="2" name="Shape 0"/>
+          <p:cNvSpPr/>
+          <p:nvPr/>
+        </p:nvSpPr>
+        <p:spPr>
+          <a:xfrm>
+            <a:off x="0" y="0"/>
+            <a:ext cx="12192000" cy="6858000"/>
+          </a:xfrm>
+          <a:prstGeom prst="rect">
+            <a:avLst/>
+          </a:prstGeom>
+          <a:solidFill>
+            <a:srgbClr val="FAFAF8"/>
+          </a:solidFill>
+          <a:ln w="12700">
+            <a:solidFill>
+              <a:srgbClr val="FAFAF8"/>
+            </a:solidFill>
+            <a:prstDash val="solid"/>
+          </a:ln>
+        </p:spPr>
+      </p:sp>
+      <p:sp>
+        <p:nvSpPr>
+          <p:cNvPr id="3" name="Shape 1"/>
+          <p:cNvSpPr/>
+          <p:nvPr/>
+        </p:nvSpPr>
+        <p:spPr>
+          <a:xfrm>
+            <a:off x="6583680" y="4389120"/>
+            <a:ext cx="3840480" cy="3840480"/>
+          </a:xfrm>
+          <a:prstGeom prst="ellipse">
+            <a:avLst/>
+          </a:prstGeom>
+          <a:solidFill>
+            <a:srgbClr val="A8C4DC">
+              <a:alpha val="18000"/>
+            </a:srgbClr>
+          </a:solidFill>
+          <a:ln w="12700">
+            <a:solidFill>
+              <a:srgbClr val="A8C4DC">
+                <a:alpha val="18000"/>
+              </a:srgbClr>
+            </a:solidFill>
+            <a:prstDash val="solid"/>
+          </a:ln>
+        </p:spPr>
+      </p:sp>
+      <p:sp>
+        <p:nvSpPr>
+          <p:cNvPr id="4" name="Shape 2"/>
+          <p:cNvSpPr/>
+          <p:nvPr/>
+        </p:nvSpPr>
+        <p:spPr>
+          <a:xfrm>
+            <a:off x="-1005840" y="-1097280"/>
+            <a:ext cx="2926080" cy="2926080"/>
+          </a:xfrm>
+          <a:prstGeom prst="ellipse">
+            <a:avLst/>
+          </a:prstGeom>
+          <a:solidFill>
+            <a:srgbClr val="C4786A">
+              <a:alpha val="12000"/>
+            </a:srgbClr>
+          </a:solidFill>
+          <a:ln w="12700">
+            <a:solidFill>
+              <a:srgbClr val="C4786A">
+                <a:alpha val="12000"/>
+              </a:srgbClr>
+            </a:solidFill>
+            <a:prstDash val="solid"/>
+          </a:ln>
+        </p:spPr>
+      </p:sp>
+      <p:sp>
+        <p:nvSpPr>
+          <p:cNvPr id="5" name="Shape 3"/>
+          <p:cNvSpPr/>
+          <p:nvPr/>
+        </p:nvSpPr>
+        <p:spPr>
+          <a:xfrm>
+            <a:off x="8778240" y="1645920"/>
+            <a:ext cx="54864" cy="2194560"/>
+          </a:xfrm>
+          <a:prstGeom prst="rect">
+            <a:avLst/>
+          </a:prstGeom>
+          <a:solidFill>
+            <a:srgbClr val="5B8DB8">
+              <a:alpha val="45000"/>
+            </a:srgbClr>
+          </a:solidFill>
+          <a:ln w="12700">
+            <a:solidFill>
+              <a:srgbClr val="5B8DB8">
+                <a:alpha val="45000"/>
+              </a:srgbClr>
+            </a:solidFill>
+            <a:prstDash val="solid"/>
+          </a:ln>
+        </p:spPr>
+      </p:sp>
+      <p:sp>
+        <p:nvSpPr>
+          <p:cNvPr id="6" name="Shape 4"/>
+          <p:cNvSpPr/>
+          <p:nvPr/>
+        </p:nvSpPr>
+        <p:spPr>
+          <a:xfrm>
+            <a:off x="0" y="0"/>
+            <a:ext cx="12192000" cy="54864"/>
+          </a:xfrm>
+          <a:prstGeom prst="rect">
+            <a:avLst/>
+          </a:prstGeom>
+          <a:solidFill>
+            <a:srgbClr val="5B8DB8"/>
+          </a:solidFill>
+          <a:ln w="12700">
+            <a:solidFill>
+              <a:srgbClr val="5B8DB8"/>
+            </a:solidFill>
+            <a:prstDash val="solid"/>
+          </a:ln>
+        </p:spPr>
+      </p:sp>
+      <p:sp>
+        <p:nvSpPr>
+          <p:cNvPr id="7" name="Shape 5"/>
+          <p:cNvSpPr/>
+          <p:nvPr/>
+        </p:nvSpPr>
+        <p:spPr>
+          <a:xfrm>
+            <a:off x="0" y="6528816"/>
+            <a:ext cx="12192000" cy="54864"/>
+          </a:xfrm>
+          <a:prstGeom prst="rect">
+            <a:avLst/>
+          </a:prstGeom>
+          <a:solidFill>
+            <a:srgbClr val="C4786A"/>
+          </a:solidFill>
+          <a:ln w="12700">
+            <a:solidFill>
+              <a:srgbClr val="C4786A"/>
+            </a:solidFill>
+            <a:prstDash val="solid"/>
+          </a:ln>
+        </p:spPr>
+      </p:sp>
+      <p:sp>
+        <p:nvSpPr>
+          <p:cNvPr id="8" name="Text 6"/>
+          <p:cNvSpPr/>
+          <p:nvPr/>
+        </p:nvSpPr>
+        <p:spPr>
+          <a:xfrm>
+            <a:off x="457200" y="228600"/>
+            <a:ext cx="8375904" cy="502920"/>
+          </a:xfrm>
+          <a:prstGeom prst="rect">
+            <a:avLst/>
+          </a:prstGeom>
+          <a:noFill/>
+          <a:ln/>
+        </p:spPr>
+        <p:txBody>
+          <a:bodyPr wrap="square" rtlCol="0" anchor="ctr"/>
+          <a:lstStyle/>
+          <a:p>
+            <a:pPr indent="0" marL="0">
+              <a:buNone/>
+            </a:pPr>
+            <a:r>
+              <a:rPr lang="en-US" b="1" dirty="0">
+                <a:solidFill>
+                  <a:srgbClr val="2D3748"/>
+                </a:solidFill>
+                <a:latin typeface="Arial" pitchFamily="34" charset="0"/>
+                <a:ea typeface="Arial" pitchFamily="34" charset="-122"/>
+                <a:cs typeface="Arial" pitchFamily="34" charset="-120"/>
+              </a:rPr>
+              <a:t>🏆  ¿Por qué CareSignal?</a:t>
+            </a:r>
+            <a:endParaRPr lang="en-US" dirty="0"/>
+          </a:p>
+        </p:txBody>
+      </p:sp>
+      <p:sp>
+        <p:nvSpPr>
+          <p:cNvPr id="9" name="Text 7"/>
+          <p:cNvSpPr/>
+          <p:nvPr/>
+        </p:nvSpPr>
+        <p:spPr>
+          <a:xfrm>
+            <a:off x="457200" y="731520"/>
+            <a:ext cx="8375904" cy="320040"/>
+          </a:xfrm>
+          <a:prstGeom prst="rect">
+            <a:avLst/>
+          </a:prstGeom>
+          <a:noFill/>
+          <a:ln/>
+        </p:spPr>
+        <p:txBody>
+          <a:bodyPr wrap="square" rtlCol="0" anchor="ctr"/>
+          <a:lstStyle/>
+          <a:p>
+            <a:pPr indent="0" marL="0">
+              <a:buNone/>
+            </a:pPr>
+            <a:r>
+              <a:rPr lang="en-US" b="1" dirty="0">
+                <a:solidFill>
+                  <a:srgbClr val="5B8DB8"/>
+                </a:solidFill>
+                <a:latin typeface="Arial" pitchFamily="34" charset="0"/>
+                <a:ea typeface="Arial" pitchFamily="34" charset="-122"/>
+                <a:cs typeface="Arial" pitchFamily="34" charset="-120"/>
+              </a:rPr>
+              <a:t>Nadie más modela el ciclo operativo de la ronda</a:t>
+            </a:r>
+            <a:endParaRPr lang="en-US" dirty="0"/>
+          </a:p>
+        </p:txBody>
+      </p:sp>
+      <p:sp>
+        <p:nvSpPr>
+          <p:cNvPr id="10" name="Shape 8"/>
+          <p:cNvSpPr/>
+          <p:nvPr/>
+        </p:nvSpPr>
+        <p:spPr>
+          <a:xfrm>
+            <a:off x="457200" y="1097280"/>
+            <a:ext cx="8375904" cy="0"/>
+          </a:xfrm>
+          <a:prstGeom prst="line">
+            <a:avLst/>
+          </a:prstGeom>
+          <a:noFill/>
+          <a:ln w="12700">
+            <a:solidFill>
+              <a:srgbClr val="E2E8F0"/>
+            </a:solidFill>
+            <a:prstDash val="solid"/>
+          </a:ln>
+        </p:spPr>
+      </p:sp>
+      <p:sp>
+        <p:nvSpPr>
+          <p:cNvPr id="11" name="Shape 9"/>
+          <p:cNvSpPr/>
+          <p:nvPr/>
+        </p:nvSpPr>
+        <p:spPr>
+          <a:xfrm>
+            <a:off x="457200" y="1188720"/>
+            <a:ext cx="8375904" cy="457200"/>
+          </a:xfrm>
+          <a:prstGeom prst="roundRect">
+            <a:avLst>
+              <a:gd name="adj" fmla="val 10000"/>
+            </a:avLst>
+          </a:prstGeom>
+          <a:solidFill>
+            <a:srgbClr val="5B8DB8"/>
+          </a:solidFill>
+          <a:ln w="12700">
+            <a:solidFill>
+              <a:srgbClr val="5B8DB8"/>
+            </a:solidFill>
+            <a:prstDash val="solid"/>
+          </a:ln>
+        </p:spPr>
+      </p:sp>
+      <p:sp>
+        <p:nvSpPr>
+          <p:cNvPr id="12" name="Text 10"/>
+          <p:cNvSpPr/>
+          <p:nvPr/>
+        </p:nvSpPr>
+        <p:spPr>
+          <a:xfrm>
+            <a:off x="548640" y="1234440"/>
+            <a:ext cx="2651760" cy="365760"/>
+          </a:xfrm>
+          <a:prstGeom prst="rect">
+            <a:avLst/>
+          </a:prstGeom>
+          <a:noFill/>
+          <a:ln/>
+        </p:spPr>
+        <p:txBody>
+          <a:bodyPr wrap="square" rtlCol="0" anchor="ctr"/>
+          <a:lstStyle/>
+          <a:p>
+            <a:pPr indent="0" marL="0">
+              <a:buNone/>
+            </a:pPr>
+            <a:r>
+              <a:rPr lang="en-US" sz="1200" b="1" dirty="0">
+                <a:solidFill>
+                  <a:srgbClr val="FFFFFF"/>
+                </a:solidFill>
+                <a:latin typeface="Arial" pitchFamily="34" charset="0"/>
+                <a:ea typeface="Arial" pitchFamily="34" charset="-122"/>
+                <a:cs typeface="Arial" pitchFamily="34" charset="-120"/>
+              </a:rPr>
+              <a:t>Capacidad</a:t>
+            </a:r>
+            <a:endParaRPr lang="en-US" sz="1200" dirty="0"/>
+          </a:p>
+        </p:txBody>
+      </p:sp>
+      <p:sp>
+        <p:nvSpPr>
+          <p:cNvPr id="13" name="Text 11"/>
+          <p:cNvSpPr/>
+          <p:nvPr/>
+        </p:nvSpPr>
+        <p:spPr>
+          <a:xfrm>
+            <a:off x="3337560" y="1234440"/>
+            <a:ext cx="1600200" cy="365760"/>
+          </a:xfrm>
+          <a:prstGeom prst="rect">
+            <a:avLst/>
+          </a:prstGeom>
+          <a:noFill/>
+          <a:ln/>
+        </p:spPr>
+        <p:txBody>
+          <a:bodyPr wrap="square" rtlCol="0" anchor="ctr"/>
+          <a:lstStyle/>
+          <a:p>
+            <a:pPr indent="0" marL="0">
+              <a:buNone/>
+            </a:pPr>
+            <a:r>
+              <a:rPr lang="en-US" sz="1200" b="1" dirty="0">
+                <a:solidFill>
+                  <a:srgbClr val="FFFFFF"/>
+                </a:solidFill>
+                <a:latin typeface="Arial" pitchFamily="34" charset="0"/>
+                <a:ea typeface="Arial" pitchFamily="34" charset="-122"/>
+                <a:cs typeface="Arial" pitchFamily="34" charset="-120"/>
+              </a:rPr>
+              <a:t>CareSignal</a:t>
+            </a:r>
+            <a:endParaRPr lang="en-US" sz="1200" dirty="0"/>
+          </a:p>
+        </p:txBody>
+      </p:sp>
+      <p:sp>
+        <p:nvSpPr>
+          <p:cNvPr id="14" name="Text 12"/>
+          <p:cNvSpPr/>
+          <p:nvPr/>
+        </p:nvSpPr>
+        <p:spPr>
+          <a:xfrm>
+            <a:off x="5074920" y="1234440"/>
+            <a:ext cx="1600200" cy="365760"/>
+          </a:xfrm>
+          <a:prstGeom prst="rect">
+            <a:avLst/>
+          </a:prstGeom>
+          <a:noFill/>
+          <a:ln/>
+        </p:spPr>
+        <p:txBody>
+          <a:bodyPr wrap="square" rtlCol="0" anchor="ctr"/>
+          <a:lstStyle/>
+          <a:p>
+            <a:pPr indent="0" marL="0">
+              <a:buNone/>
+            </a:pPr>
+            <a:r>
+              <a:rPr lang="en-US" sz="1200" b="1" dirty="0">
+                <a:solidFill>
+                  <a:srgbClr val="FFFFFF"/>
+                </a:solidFill>
+                <a:latin typeface="Arial" pitchFamily="34" charset="0"/>
+                <a:ea typeface="Arial" pitchFamily="34" charset="-122"/>
+                <a:cs typeface="Arial" pitchFamily="34" charset="-120"/>
+              </a:rPr>
+              <a:t>Cronos Care</a:t>
+            </a:r>
+            <a:endParaRPr lang="en-US" sz="1200" dirty="0"/>
+          </a:p>
+        </p:txBody>
+      </p:sp>
+      <p:sp>
+        <p:nvSpPr>
+          <p:cNvPr id="15" name="Text 13"/>
+          <p:cNvSpPr/>
+          <p:nvPr/>
+        </p:nvSpPr>
+        <p:spPr>
+          <a:xfrm>
+            <a:off x="6812280" y="1234440"/>
+            <a:ext cx="1600200" cy="365760"/>
+          </a:xfrm>
+          <a:prstGeom prst="rect">
+            <a:avLst/>
+          </a:prstGeom>
+          <a:noFill/>
+          <a:ln/>
+        </p:spPr>
+        <p:txBody>
+          <a:bodyPr wrap="square" rtlCol="0" anchor="ctr"/>
+          <a:lstStyle/>
+          <a:p>
+            <a:pPr indent="0" marL="0">
+              <a:buNone/>
+            </a:pPr>
+            <a:r>
+              <a:rPr lang="en-US" sz="1200" b="1" dirty="0">
+                <a:solidFill>
+                  <a:srgbClr val="FFFFFF"/>
+                </a:solidFill>
+                <a:latin typeface="Arial" pitchFamily="34" charset="0"/>
+                <a:ea typeface="Arial" pitchFamily="34" charset="-122"/>
+                <a:cs typeface="Arial" pitchFamily="34" charset="-120"/>
+              </a:rPr>
+              <a:t>GERIGES</a:t>
+            </a:r>
+            <a:endParaRPr lang="en-US" sz="1200" dirty="0"/>
+          </a:p>
+        </p:txBody>
+      </p:sp>
+      <p:sp>
+        <p:nvSpPr>
+          <p:cNvPr id="16" name="Shape 14"/>
+          <p:cNvSpPr/>
+          <p:nvPr/>
+        </p:nvSpPr>
+        <p:spPr>
+          <a:xfrm>
+            <a:off x="457200" y="1645920"/>
+            <a:ext cx="8375904" cy="530352"/>
+          </a:xfrm>
+          <a:prstGeom prst="roundRect">
+            <a:avLst>
+              <a:gd name="adj" fmla="val 6897"/>
+            </a:avLst>
+          </a:prstGeom>
+          <a:solidFill>
+            <a:srgbClr val="F0EDE8"/>
+          </a:solidFill>
+          <a:ln w="5080">
+            <a:solidFill>
+              <a:srgbClr val="E2E8F0"/>
+            </a:solidFill>
+            <a:prstDash val="solid"/>
+          </a:ln>
+        </p:spPr>
+      </p:sp>
+      <p:sp>
+        <p:nvSpPr>
+          <p:cNvPr id="17" name="Text 15"/>
+          <p:cNvSpPr/>
+          <p:nvPr/>
+        </p:nvSpPr>
+        <p:spPr>
+          <a:xfrm>
+            <a:off x="548640" y="1719072"/>
+            <a:ext cx="2606040" cy="384048"/>
+          </a:xfrm>
+          <a:prstGeom prst="rect">
+            <a:avLst/>
+          </a:prstGeom>
+          <a:noFill/>
+          <a:ln/>
+        </p:spPr>
+        <p:txBody>
+          <a:bodyPr wrap="square" rtlCol="0" anchor="ctr"/>
+          <a:lstStyle/>
+          <a:p>
+            <a:pPr indent="0" marL="0">
+              <a:buNone/>
+            </a:pPr>
+            <a:r>
+              <a:rPr lang="en-US" sz="1150" dirty="0">
+                <a:solidFill>
+                  <a:srgbClr val="2D3748"/>
+                </a:solidFill>
+                <a:latin typeface="Arial" pitchFamily="34" charset="0"/>
+                <a:ea typeface="Arial" pitchFamily="34" charset="-122"/>
+                <a:cs typeface="Arial" pitchFamily="34" charset="-120"/>
+              </a:rPr>
+              <a:t>Detección de ronda atrasada</a:t>
+            </a:r>
+            <a:endParaRPr lang="en-US" sz="1150" dirty="0"/>
+          </a:p>
+        </p:txBody>
+      </p:sp>
+      <p:sp>
+        <p:nvSpPr>
+          <p:cNvPr id="18" name="Text 16"/>
+          <p:cNvSpPr/>
+          <p:nvPr/>
+        </p:nvSpPr>
+        <p:spPr>
+          <a:xfrm>
+            <a:off x="3246120" y="1691640"/>
+            <a:ext cx="1691640" cy="438912"/>
+          </a:xfrm>
+          <a:prstGeom prst="rect">
+            <a:avLst/>
+          </a:prstGeom>
+          <a:noFill/>
+          <a:ln/>
+        </p:spPr>
+        <p:txBody>
+          <a:bodyPr wrap="square" rtlCol="0" anchor="ctr"/>
+          <a:lstStyle/>
+          <a:p>
+            <a:pPr algn="ctr" indent="0" marL="0">
+              <a:buNone/>
+            </a:pPr>
+            <a:r>
+              <a:rPr lang="en-US" sz="1800" dirty="0">
+                <a:solidFill>
+                  <a:srgbClr val="000000"/>
+                </a:solidFill>
+              </a:rPr>
+              <a:t>✅</a:t>
+            </a:r>
+            <a:endParaRPr lang="en-US" sz="1800" dirty="0"/>
+          </a:p>
+        </p:txBody>
+      </p:sp>
+      <p:sp>
+        <p:nvSpPr>
+          <p:cNvPr id="19" name="Text 17"/>
+          <p:cNvSpPr/>
+          <p:nvPr/>
+        </p:nvSpPr>
+        <p:spPr>
+          <a:xfrm>
+            <a:off x="4983480" y="1691640"/>
+            <a:ext cx="1691640" cy="438912"/>
+          </a:xfrm>
+          <a:prstGeom prst="rect">
+            <a:avLst/>
+          </a:prstGeom>
+          <a:noFill/>
+          <a:ln/>
+        </p:spPr>
+        <p:txBody>
+          <a:bodyPr wrap="square" rtlCol="0" anchor="ctr"/>
+          <a:lstStyle/>
+          <a:p>
+            <a:pPr algn="ctr" indent="0" marL="0">
+              <a:buNone/>
+            </a:pPr>
+            <a:r>
+              <a:rPr lang="en-US" sz="1800" dirty="0">
+                <a:solidFill>
+                  <a:srgbClr val="000000"/>
+                </a:solidFill>
+              </a:rPr>
+              <a:t>❌</a:t>
+            </a:r>
+            <a:endParaRPr lang="en-US" sz="1800" dirty="0"/>
+          </a:p>
+        </p:txBody>
+      </p:sp>
+      <p:sp>
+        <p:nvSpPr>
+          <p:cNvPr id="20" name="Text 18"/>
+          <p:cNvSpPr/>
+          <p:nvPr/>
+        </p:nvSpPr>
+        <p:spPr>
+          <a:xfrm>
+            <a:off x="6720840" y="1691640"/>
+            <a:ext cx="1691640" cy="438912"/>
+          </a:xfrm>
+          <a:prstGeom prst="rect">
+            <a:avLst/>
+          </a:prstGeom>
+          <a:noFill/>
+          <a:ln/>
+        </p:spPr>
+        <p:txBody>
+          <a:bodyPr wrap="square" rtlCol="0" anchor="ctr"/>
+          <a:lstStyle/>
+          <a:p>
+            <a:pPr algn="ctr" indent="0" marL="0">
+              <a:buNone/>
+            </a:pPr>
+            <a:r>
+              <a:rPr lang="en-US" sz="1800" dirty="0">
+                <a:solidFill>
+                  <a:srgbClr val="000000"/>
+                </a:solidFill>
+              </a:rPr>
+              <a:t>❌</a:t>
+            </a:r>
+            <a:endParaRPr lang="en-US" sz="1800" dirty="0"/>
+          </a:p>
+        </p:txBody>
+      </p:sp>
+      <p:sp>
+        <p:nvSpPr>
+          <p:cNvPr id="21" name="Shape 19"/>
+          <p:cNvSpPr/>
+          <p:nvPr/>
+        </p:nvSpPr>
+        <p:spPr>
+          <a:xfrm>
+            <a:off x="457200" y="2240280"/>
+            <a:ext cx="8375904" cy="530352"/>
+          </a:xfrm>
+          <a:prstGeom prst="roundRect">
+            <a:avLst>
+              <a:gd name="adj" fmla="val 6897"/>
+            </a:avLst>
+          </a:prstGeom>
+          <a:solidFill>
+            <a:srgbClr val="FFFFFF"/>
+          </a:solidFill>
+          <a:ln w="5080">
+            <a:solidFill>
+              <a:srgbClr val="E2E8F0"/>
+            </a:solidFill>
+            <a:prstDash val="solid"/>
+          </a:ln>
+        </p:spPr>
+      </p:sp>
+      <p:sp>
+        <p:nvSpPr>
+          <p:cNvPr id="22" name="Text 20"/>
+          <p:cNvSpPr/>
+          <p:nvPr/>
+        </p:nvSpPr>
+        <p:spPr>
+          <a:xfrm>
+            <a:off x="548640" y="2313432"/>
+            <a:ext cx="2606040" cy="384048"/>
+          </a:xfrm>
+          <a:prstGeom prst="rect">
+            <a:avLst/>
+          </a:prstGeom>
+          <a:noFill/>
+          <a:ln/>
+        </p:spPr>
+        <p:txBody>
+          <a:bodyPr wrap="square" rtlCol="0" anchor="ctr"/>
+          <a:lstStyle/>
+          <a:p>
+            <a:pPr indent="0" marL="0">
+              <a:buNone/>
+            </a:pPr>
+            <a:r>
+              <a:rPr lang="en-US" sz="1150" dirty="0">
+                <a:solidFill>
+                  <a:srgbClr val="2D3748"/>
+                </a:solidFill>
+                <a:latin typeface="Arial" pitchFamily="34" charset="0"/>
+                <a:ea typeface="Arial" pitchFamily="34" charset="-122"/>
+                <a:cs typeface="Arial" pitchFamily="34" charset="-120"/>
+              </a:rPr>
+              <a:t>Alerta automática al supervisor</a:t>
+            </a:r>
+            <a:endParaRPr lang="en-US" sz="1150" dirty="0"/>
+          </a:p>
+        </p:txBody>
+      </p:sp>
+      <p:sp>
+        <p:nvSpPr>
+          <p:cNvPr id="23" name="Text 21"/>
+          <p:cNvSpPr/>
+          <p:nvPr/>
+        </p:nvSpPr>
+        <p:spPr>
+          <a:xfrm>
+            <a:off x="3246120" y="2286000"/>
+            <a:ext cx="1691640" cy="438912"/>
+          </a:xfrm>
+          <a:prstGeom prst="rect">
+            <a:avLst/>
+          </a:prstGeom>
+          <a:noFill/>
+          <a:ln/>
+        </p:spPr>
+        <p:txBody>
+          <a:bodyPr wrap="square" rtlCol="0" anchor="ctr"/>
+          <a:lstStyle/>
+          <a:p>
+            <a:pPr algn="ctr" indent="0" marL="0">
+              <a:buNone/>
+            </a:pPr>
+            <a:r>
+              <a:rPr lang="en-US" sz="1800" dirty="0">
+                <a:solidFill>
+                  <a:srgbClr val="000000"/>
+                </a:solidFill>
+              </a:rPr>
+              <a:t>✅</a:t>
+            </a:r>
+            <a:endParaRPr lang="en-US" sz="1800" dirty="0"/>
+          </a:p>
+        </p:txBody>
+      </p:sp>
+      <p:sp>
+        <p:nvSpPr>
+          <p:cNvPr id="24" name="Text 22"/>
+          <p:cNvSpPr/>
+          <p:nvPr/>
+        </p:nvSpPr>
+        <p:spPr>
+          <a:xfrm>
+            <a:off x="4983480" y="2286000"/>
+            <a:ext cx="1691640" cy="438912"/>
+          </a:xfrm>
+          <a:prstGeom prst="rect">
+            <a:avLst/>
+          </a:prstGeom>
+          <a:noFill/>
+          <a:ln/>
+        </p:spPr>
+        <p:txBody>
+          <a:bodyPr wrap="square" rtlCol="0" anchor="ctr"/>
+          <a:lstStyle/>
+          <a:p>
+            <a:pPr algn="ctr" indent="0" marL="0">
+              <a:buNone/>
+            </a:pPr>
+            <a:r>
+              <a:rPr lang="en-US" sz="1800" dirty="0">
+                <a:solidFill>
+                  <a:srgbClr val="000000"/>
+                </a:solidFill>
+              </a:rPr>
+              <a:t>❌</a:t>
+            </a:r>
+            <a:endParaRPr lang="en-US" sz="1800" dirty="0"/>
+          </a:p>
+        </p:txBody>
+      </p:sp>
+      <p:sp>
+        <p:nvSpPr>
+          <p:cNvPr id="25" name="Text 23"/>
+          <p:cNvSpPr/>
+          <p:nvPr/>
+        </p:nvSpPr>
+        <p:spPr>
+          <a:xfrm>
+            <a:off x="6720840" y="2286000"/>
+            <a:ext cx="1691640" cy="438912"/>
+          </a:xfrm>
+          <a:prstGeom prst="rect">
+            <a:avLst/>
+          </a:prstGeom>
+          <a:noFill/>
+          <a:ln/>
+        </p:spPr>
+        <p:txBody>
+          <a:bodyPr wrap="square" rtlCol="0" anchor="ctr"/>
+          <a:lstStyle/>
+          <a:p>
+            <a:pPr algn="ctr" indent="0" marL="0">
+              <a:buNone/>
+            </a:pPr>
+            <a:r>
+              <a:rPr lang="en-US" sz="1800" dirty="0">
+                <a:solidFill>
+                  <a:srgbClr val="000000"/>
+                </a:solidFill>
+              </a:rPr>
+              <a:t>❌</a:t>
+            </a:r>
+            <a:endParaRPr lang="en-US" sz="1800" dirty="0"/>
+          </a:p>
+        </p:txBody>
+      </p:sp>
+      <p:sp>
+        <p:nvSpPr>
+          <p:cNvPr id="26" name="Shape 24"/>
+          <p:cNvSpPr/>
+          <p:nvPr/>
+        </p:nvSpPr>
+        <p:spPr>
+          <a:xfrm>
+            <a:off x="457200" y="2834640"/>
+            <a:ext cx="8375904" cy="530352"/>
+          </a:xfrm>
+          <a:prstGeom prst="roundRect">
+            <a:avLst>
+              <a:gd name="adj" fmla="val 6897"/>
+            </a:avLst>
+          </a:prstGeom>
+          <a:solidFill>
+            <a:srgbClr val="F0EDE8"/>
+          </a:solidFill>
+          <a:ln w="5080">
+            <a:solidFill>
+              <a:srgbClr val="E2E8F0"/>
+            </a:solidFill>
+            <a:prstDash val="solid"/>
+          </a:ln>
+        </p:spPr>
+      </p:sp>
+      <p:sp>
+        <p:nvSpPr>
+          <p:cNvPr id="27" name="Text 25"/>
+          <p:cNvSpPr/>
+          <p:nvPr/>
+        </p:nvSpPr>
+        <p:spPr>
+          <a:xfrm>
+            <a:off x="548640" y="2907792"/>
+            <a:ext cx="2606040" cy="384048"/>
+          </a:xfrm>
+          <a:prstGeom prst="rect">
+            <a:avLst/>
+          </a:prstGeom>
+          <a:noFill/>
+          <a:ln/>
+        </p:spPr>
+        <p:txBody>
+          <a:bodyPr wrap="square" rtlCol="0" anchor="ctr"/>
+          <a:lstStyle/>
+          <a:p>
+            <a:pPr indent="0" marL="0">
+              <a:buNone/>
+            </a:pPr>
+            <a:r>
+              <a:rPr lang="en-US" sz="1150" dirty="0">
+                <a:solidFill>
+                  <a:srgbClr val="2D3748"/>
+                </a:solidFill>
+                <a:latin typeface="Arial" pitchFamily="34" charset="0"/>
+                <a:ea typeface="Arial" pitchFamily="34" charset="-122"/>
+                <a:cs typeface="Arial" pitchFamily="34" charset="-120"/>
+              </a:rPr>
+              <a:t>Bitácora de auditoría inmutable</a:t>
+            </a:r>
+            <a:endParaRPr lang="en-US" sz="1150" dirty="0"/>
+          </a:p>
+        </p:txBody>
+      </p:sp>
+      <p:sp>
+        <p:nvSpPr>
+          <p:cNvPr id="28" name="Text 26"/>
+          <p:cNvSpPr/>
+          <p:nvPr/>
+        </p:nvSpPr>
+        <p:spPr>
+          <a:xfrm>
+            <a:off x="3246120" y="2880360"/>
+            <a:ext cx="1691640" cy="438912"/>
+          </a:xfrm>
+          <a:prstGeom prst="rect">
+            <a:avLst/>
+          </a:prstGeom>
+          <a:noFill/>
+          <a:ln/>
+        </p:spPr>
+        <p:txBody>
+          <a:bodyPr wrap="square" rtlCol="0" anchor="ctr"/>
+          <a:lstStyle/>
+          <a:p>
+            <a:pPr algn="ctr" indent="0" marL="0">
+              <a:buNone/>
+            </a:pPr>
+            <a:r>
+              <a:rPr lang="en-US" sz="1800" dirty="0">
+                <a:solidFill>
+                  <a:srgbClr val="000000"/>
+                </a:solidFill>
+              </a:rPr>
+              <a:t>✅</a:t>
+            </a:r>
+            <a:endParaRPr lang="en-US" sz="1800" dirty="0"/>
+          </a:p>
+        </p:txBody>
+      </p:sp>
+      <p:sp>
+        <p:nvSpPr>
+          <p:cNvPr id="29" name="Text 27"/>
+          <p:cNvSpPr/>
+          <p:nvPr/>
+        </p:nvSpPr>
+        <p:spPr>
+          <a:xfrm>
+            <a:off x="4983480" y="2880360"/>
+            <a:ext cx="1691640" cy="438912"/>
+          </a:xfrm>
+          <a:prstGeom prst="rect">
+            <a:avLst/>
+          </a:prstGeom>
+          <a:noFill/>
+          <a:ln/>
+        </p:spPr>
+        <p:txBody>
+          <a:bodyPr wrap="square" rtlCol="0" anchor="ctr"/>
+          <a:lstStyle/>
+          <a:p>
+            <a:pPr algn="ctr" indent="0" marL="0">
+              <a:buNone/>
+            </a:pPr>
+            <a:r>
+              <a:rPr lang="en-US" sz="1800" dirty="0">
+                <a:solidFill>
+                  <a:srgbClr val="000000"/>
+                </a:solidFill>
+              </a:rPr>
+              <a:t>⚠️</a:t>
+            </a:r>
+            <a:endParaRPr lang="en-US" sz="1800" dirty="0"/>
+          </a:p>
+        </p:txBody>
+      </p:sp>
+      <p:sp>
+        <p:nvSpPr>
+          <p:cNvPr id="30" name="Text 28"/>
+          <p:cNvSpPr/>
+          <p:nvPr/>
+        </p:nvSpPr>
+        <p:spPr>
+          <a:xfrm>
+            <a:off x="6720840" y="2880360"/>
+            <a:ext cx="1691640" cy="438912"/>
+          </a:xfrm>
+          <a:prstGeom prst="rect">
+            <a:avLst/>
+          </a:prstGeom>
+          <a:noFill/>
+          <a:ln/>
+        </p:spPr>
+        <p:txBody>
+          <a:bodyPr wrap="square" rtlCol="0" anchor="ctr"/>
+          <a:lstStyle/>
+          <a:p>
+            <a:pPr algn="ctr" indent="0" marL="0">
+              <a:buNone/>
+            </a:pPr>
+            <a:r>
+              <a:rPr lang="en-US" sz="1800" dirty="0">
+                <a:solidFill>
+                  <a:srgbClr val="000000"/>
+                </a:solidFill>
+              </a:rPr>
+              <a:t>⚠️</a:t>
+            </a:r>
+            <a:endParaRPr lang="en-US" sz="1800" dirty="0"/>
+          </a:p>
+        </p:txBody>
+      </p:sp>
+      <p:sp>
+        <p:nvSpPr>
+          <p:cNvPr id="31" name="Shape 29"/>
+          <p:cNvSpPr/>
+          <p:nvPr/>
+        </p:nvSpPr>
+        <p:spPr>
+          <a:xfrm>
+            <a:off x="457200" y="3429000"/>
+            <a:ext cx="8375904" cy="530352"/>
+          </a:xfrm>
+          <a:prstGeom prst="roundRect">
+            <a:avLst>
+              <a:gd name="adj" fmla="val 6897"/>
+            </a:avLst>
+          </a:prstGeom>
+          <a:solidFill>
+            <a:srgbClr val="FFFFFF"/>
+          </a:solidFill>
+          <a:ln w="5080">
+            <a:solidFill>
+              <a:srgbClr val="E2E8F0"/>
+            </a:solidFill>
+            <a:prstDash val="solid"/>
+          </a:ln>
+        </p:spPr>
+      </p:sp>
+      <p:sp>
+        <p:nvSpPr>
+          <p:cNvPr id="32" name="Text 30"/>
+          <p:cNvSpPr/>
+          <p:nvPr/>
+        </p:nvSpPr>
+        <p:spPr>
+          <a:xfrm>
+            <a:off x="548640" y="3502152"/>
+            <a:ext cx="2606040" cy="384048"/>
+          </a:xfrm>
+          <a:prstGeom prst="rect">
+            <a:avLst/>
+          </a:prstGeom>
+          <a:noFill/>
+          <a:ln/>
+        </p:spPr>
+        <p:txBody>
+          <a:bodyPr wrap="square" rtlCol="0" anchor="ctr"/>
+          <a:lstStyle/>
+          <a:p>
+            <a:pPr indent="0" marL="0">
+              <a:buNone/>
+            </a:pPr>
+            <a:r>
+              <a:rPr lang="en-US" sz="1150" dirty="0">
+                <a:solidFill>
+                  <a:srgbClr val="2D3748"/>
+                </a:solidFill>
+                <a:latin typeface="Arial" pitchFamily="34" charset="0"/>
+                <a:ea typeface="Arial" pitchFamily="34" charset="-122"/>
+                <a:cs typeface="Arial" pitchFamily="34" charset="-120"/>
+              </a:rPr>
+              <a:t>Ciclo completo alerta→cierre</a:t>
+            </a:r>
+            <a:endParaRPr lang="en-US" sz="1150" dirty="0"/>
+          </a:p>
+        </p:txBody>
+      </p:sp>
+      <p:sp>
+        <p:nvSpPr>
+          <p:cNvPr id="33" name="Text 31"/>
+          <p:cNvSpPr/>
+          <p:nvPr/>
+        </p:nvSpPr>
+        <p:spPr>
+          <a:xfrm>
+            <a:off x="3246120" y="3474720"/>
+            <a:ext cx="1691640" cy="438912"/>
+          </a:xfrm>
+          <a:prstGeom prst="rect">
+            <a:avLst/>
+          </a:prstGeom>
+          <a:noFill/>
+          <a:ln/>
+        </p:spPr>
+        <p:txBody>
+          <a:bodyPr wrap="square" rtlCol="0" anchor="ctr"/>
+          <a:lstStyle/>
+          <a:p>
+            <a:pPr algn="ctr" indent="0" marL="0">
+              <a:buNone/>
+            </a:pPr>
+            <a:r>
+              <a:rPr lang="en-US" sz="1800" dirty="0">
+                <a:solidFill>
+                  <a:srgbClr val="000000"/>
+                </a:solidFill>
+              </a:rPr>
+              <a:t>✅</a:t>
+            </a:r>
+            <a:endParaRPr lang="en-US" sz="1800" dirty="0"/>
+          </a:p>
+        </p:txBody>
+      </p:sp>
+      <p:sp>
+        <p:nvSpPr>
+          <p:cNvPr id="34" name="Text 32"/>
+          <p:cNvSpPr/>
+          <p:nvPr/>
+        </p:nvSpPr>
+        <p:spPr>
+          <a:xfrm>
+            <a:off x="4983480" y="3474720"/>
+            <a:ext cx="1691640" cy="438912"/>
+          </a:xfrm>
+          <a:prstGeom prst="rect">
+            <a:avLst/>
+          </a:prstGeom>
+          <a:noFill/>
+          <a:ln/>
+        </p:spPr>
+        <p:txBody>
+          <a:bodyPr wrap="square" rtlCol="0" anchor="ctr"/>
+          <a:lstStyle/>
+          <a:p>
+            <a:pPr algn="ctr" indent="0" marL="0">
+              <a:buNone/>
+            </a:pPr>
+            <a:r>
+              <a:rPr lang="en-US" sz="1800" dirty="0">
+                <a:solidFill>
+                  <a:srgbClr val="000000"/>
+                </a:solidFill>
+              </a:rPr>
+              <a:t>❌</a:t>
+            </a:r>
+            <a:endParaRPr lang="en-US" sz="1800" dirty="0"/>
+          </a:p>
+        </p:txBody>
+      </p:sp>
+      <p:sp>
+        <p:nvSpPr>
+          <p:cNvPr id="35" name="Text 33"/>
+          <p:cNvSpPr/>
+          <p:nvPr/>
+        </p:nvSpPr>
+        <p:spPr>
+          <a:xfrm>
+            <a:off x="6720840" y="3474720"/>
+            <a:ext cx="1691640" cy="438912"/>
+          </a:xfrm>
+          <a:prstGeom prst="rect">
+            <a:avLst/>
+          </a:prstGeom>
+          <a:noFill/>
+          <a:ln/>
+        </p:spPr>
+        <p:txBody>
+          <a:bodyPr wrap="square" rtlCol="0" anchor="ctr"/>
+          <a:lstStyle/>
+          <a:p>
+            <a:pPr algn="ctr" indent="0" marL="0">
+              <a:buNone/>
+            </a:pPr>
+            <a:r>
+              <a:rPr lang="en-US" sz="1800" dirty="0">
+                <a:solidFill>
+                  <a:srgbClr val="000000"/>
+                </a:solidFill>
+              </a:rPr>
+              <a:t>❌</a:t>
+            </a:r>
+            <a:endParaRPr lang="en-US" sz="1800" dirty="0"/>
+          </a:p>
+        </p:txBody>
+      </p:sp>
+      <p:sp>
+        <p:nvSpPr>
+          <p:cNvPr id="36" name="Shape 34"/>
+          <p:cNvSpPr/>
+          <p:nvPr/>
+        </p:nvSpPr>
+        <p:spPr>
+          <a:xfrm>
+            <a:off x="457200" y="4023360"/>
+            <a:ext cx="8375904" cy="530352"/>
+          </a:xfrm>
+          <a:prstGeom prst="roundRect">
+            <a:avLst>
+              <a:gd name="adj" fmla="val 6897"/>
+            </a:avLst>
+          </a:prstGeom>
+          <a:solidFill>
+            <a:srgbClr val="F0EDE8"/>
+          </a:solidFill>
+          <a:ln w="5080">
+            <a:solidFill>
+              <a:srgbClr val="E2E8F0"/>
+            </a:solidFill>
+            <a:prstDash val="solid"/>
+          </a:ln>
+        </p:spPr>
+      </p:sp>
+      <p:sp>
+        <p:nvSpPr>
+          <p:cNvPr id="37" name="Text 35"/>
+          <p:cNvSpPr/>
+          <p:nvPr/>
+        </p:nvSpPr>
+        <p:spPr>
+          <a:xfrm>
+            <a:off x="548640" y="4096512"/>
+            <a:ext cx="2606040" cy="384048"/>
+          </a:xfrm>
+          <a:prstGeom prst="rect">
+            <a:avLst/>
+          </a:prstGeom>
+          <a:noFill/>
+          <a:ln/>
+        </p:spPr>
+        <p:txBody>
+          <a:bodyPr wrap="square" rtlCol="0" anchor="ctr"/>
+          <a:lstStyle/>
+          <a:p>
+            <a:pPr indent="0" marL="0">
+              <a:buNone/>
+            </a:pPr>
+            <a:r>
+              <a:rPr lang="en-US" sz="1150" dirty="0">
+                <a:solidFill>
+                  <a:srgbClr val="2D3748"/>
+                </a:solidFill>
+                <a:latin typeface="Arial" pitchFamily="34" charset="0"/>
+                <a:ea typeface="Arial" pitchFamily="34" charset="-122"/>
+                <a:cs typeface="Arial" pitchFamily="34" charset="-120"/>
+              </a:rPr>
+              <a:t>Precio publicado</a:t>
+            </a:r>
+            <a:endParaRPr lang="en-US" sz="1150" dirty="0"/>
+          </a:p>
+        </p:txBody>
+      </p:sp>
+      <p:sp>
+        <p:nvSpPr>
+          <p:cNvPr id="38" name="Text 36"/>
+          <p:cNvSpPr/>
+          <p:nvPr/>
+        </p:nvSpPr>
+        <p:spPr>
+          <a:xfrm>
+            <a:off x="3246120" y="4069080"/>
+            <a:ext cx="1691640" cy="438912"/>
+          </a:xfrm>
+          <a:prstGeom prst="rect">
+            <a:avLst/>
+          </a:prstGeom>
+          <a:noFill/>
+          <a:ln/>
+        </p:spPr>
+        <p:txBody>
+          <a:bodyPr wrap="square" rtlCol="0" anchor="ctr"/>
+          <a:lstStyle/>
+          <a:p>
+            <a:pPr algn="ctr" indent="0" marL="0">
+              <a:buNone/>
+            </a:pPr>
+            <a:r>
+              <a:rPr lang="en-US" sz="1800" dirty="0">
+                <a:solidFill>
+                  <a:srgbClr val="000000"/>
+                </a:solidFill>
+              </a:rPr>
+              <a:t>✅</a:t>
+            </a:r>
+            <a:endParaRPr lang="en-US" sz="1800" dirty="0"/>
+          </a:p>
+        </p:txBody>
+      </p:sp>
+      <p:sp>
+        <p:nvSpPr>
+          <p:cNvPr id="39" name="Text 37"/>
+          <p:cNvSpPr/>
+          <p:nvPr/>
+        </p:nvSpPr>
+        <p:spPr>
+          <a:xfrm>
+            <a:off x="4983480" y="4069080"/>
+            <a:ext cx="1691640" cy="438912"/>
+          </a:xfrm>
+          <a:prstGeom prst="rect">
+            <a:avLst/>
+          </a:prstGeom>
+          <a:noFill/>
+          <a:ln/>
+        </p:spPr>
+        <p:txBody>
+          <a:bodyPr wrap="square" rtlCol="0" anchor="ctr"/>
+          <a:lstStyle/>
+          <a:p>
+            <a:pPr algn="ctr" indent="0" marL="0">
+              <a:buNone/>
+            </a:pPr>
+            <a:r>
+              <a:rPr lang="en-US" sz="1800" dirty="0">
+                <a:solidFill>
+                  <a:srgbClr val="000000"/>
+                </a:solidFill>
+              </a:rPr>
+              <a:t>❌</a:t>
+            </a:r>
+            <a:endParaRPr lang="en-US" sz="1800" dirty="0"/>
+          </a:p>
+        </p:txBody>
+      </p:sp>
+      <p:sp>
+        <p:nvSpPr>
+          <p:cNvPr id="40" name="Text 38"/>
+          <p:cNvSpPr/>
+          <p:nvPr/>
+        </p:nvSpPr>
+        <p:spPr>
+          <a:xfrm>
+            <a:off x="6720840" y="4069080"/>
+            <a:ext cx="1691640" cy="438912"/>
+          </a:xfrm>
+          <a:prstGeom prst="rect">
+            <a:avLst/>
+          </a:prstGeom>
+          <a:noFill/>
+          <a:ln/>
+        </p:spPr>
+        <p:txBody>
+          <a:bodyPr wrap="square" rtlCol="0" anchor="ctr"/>
+          <a:lstStyle/>
+          <a:p>
+            <a:pPr algn="ctr" indent="0" marL="0">
+              <a:buNone/>
+            </a:pPr>
+            <a:r>
+              <a:rPr lang="en-US" sz="1800" dirty="0">
+                <a:solidFill>
+                  <a:srgbClr val="000000"/>
+                </a:solidFill>
+              </a:rPr>
+              <a:t>❌</a:t>
+            </a:r>
+            <a:endParaRPr lang="en-US" sz="1800" dirty="0"/>
+          </a:p>
+        </p:txBody>
+      </p:sp>
+      <p:sp>
+        <p:nvSpPr>
+          <p:cNvPr id="41" name="Shape 39"/>
+          <p:cNvSpPr/>
+          <p:nvPr/>
+        </p:nvSpPr>
+        <p:spPr>
+          <a:xfrm>
+            <a:off x="457200" y="4617720"/>
+            <a:ext cx="8375904" cy="530352"/>
+          </a:xfrm>
+          <a:prstGeom prst="roundRect">
+            <a:avLst>
+              <a:gd name="adj" fmla="val 6897"/>
+            </a:avLst>
+          </a:prstGeom>
+          <a:solidFill>
+            <a:srgbClr val="FFFFFF"/>
+          </a:solidFill>
+          <a:ln w="5080">
+            <a:solidFill>
+              <a:srgbClr val="E2E8F0"/>
+            </a:solidFill>
+            <a:prstDash val="solid"/>
+          </a:ln>
+        </p:spPr>
+      </p:sp>
+      <p:sp>
+        <p:nvSpPr>
+          <p:cNvPr id="42" name="Text 40"/>
+          <p:cNvSpPr/>
+          <p:nvPr/>
+        </p:nvSpPr>
+        <p:spPr>
+          <a:xfrm>
+            <a:off x="548640" y="4690872"/>
+            <a:ext cx="2606040" cy="384048"/>
+          </a:xfrm>
+          <a:prstGeom prst="rect">
+            <a:avLst/>
+          </a:prstGeom>
+          <a:noFill/>
+          <a:ln/>
+        </p:spPr>
+        <p:txBody>
+          <a:bodyPr wrap="square" rtlCol="0" anchor="ctr"/>
+          <a:lstStyle/>
+          <a:p>
+            <a:pPr indent="0" marL="0">
+              <a:buNone/>
+            </a:pPr>
+            <a:r>
+              <a:rPr lang="en-US" sz="1150" dirty="0">
+                <a:solidFill>
+                  <a:srgbClr val="2D3748"/>
+                </a:solidFill>
+                <a:latin typeface="Arial" pitchFamily="34" charset="0"/>
+                <a:ea typeface="Arial" pitchFamily="34" charset="-122"/>
+                <a:cs typeface="Arial" pitchFamily="34" charset="-120"/>
+              </a:rPr>
+              <a:t>Expediente / historial residente</a:t>
+            </a:r>
+            <a:endParaRPr lang="en-US" sz="1150" dirty="0"/>
+          </a:p>
+        </p:txBody>
+      </p:sp>
+      <p:sp>
+        <p:nvSpPr>
+          <p:cNvPr id="43" name="Text 41"/>
+          <p:cNvSpPr/>
+          <p:nvPr/>
+        </p:nvSpPr>
+        <p:spPr>
+          <a:xfrm>
+            <a:off x="3246120" y="4663440"/>
+            <a:ext cx="1691640" cy="438912"/>
+          </a:xfrm>
+          <a:prstGeom prst="rect">
+            <a:avLst/>
+          </a:prstGeom>
+          <a:noFill/>
+          <a:ln/>
+        </p:spPr>
+        <p:txBody>
+          <a:bodyPr wrap="square" rtlCol="0" anchor="ctr"/>
+          <a:lstStyle/>
+          <a:p>
+            <a:pPr algn="ctr" indent="0" marL="0">
+              <a:buNone/>
+            </a:pPr>
+            <a:r>
+              <a:rPr lang="en-US" sz="1800" dirty="0">
+                <a:solidFill>
+                  <a:srgbClr val="000000"/>
+                </a:solidFill>
+              </a:rPr>
+              <a:t>⚠️</a:t>
+            </a:r>
+            <a:endParaRPr lang="en-US" sz="1800" dirty="0"/>
+          </a:p>
+        </p:txBody>
+      </p:sp>
+      <p:sp>
+        <p:nvSpPr>
+          <p:cNvPr id="44" name="Text 42"/>
+          <p:cNvSpPr/>
+          <p:nvPr/>
+        </p:nvSpPr>
+        <p:spPr>
+          <a:xfrm>
+            <a:off x="4983480" y="4663440"/>
+            <a:ext cx="1691640" cy="438912"/>
+          </a:xfrm>
+          <a:prstGeom prst="rect">
+            <a:avLst/>
+          </a:prstGeom>
+          <a:noFill/>
+          <a:ln/>
+        </p:spPr>
+        <p:txBody>
+          <a:bodyPr wrap="square" rtlCol="0" anchor="ctr"/>
+          <a:lstStyle/>
+          <a:p>
+            <a:pPr algn="ctr" indent="0" marL="0">
+              <a:buNone/>
+            </a:pPr>
+            <a:r>
+              <a:rPr lang="en-US" sz="1800" dirty="0">
+                <a:solidFill>
+                  <a:srgbClr val="000000"/>
+                </a:solidFill>
+              </a:rPr>
+              <a:t>✅</a:t>
+            </a:r>
+            <a:endParaRPr lang="en-US" sz="1800" dirty="0"/>
+          </a:p>
+        </p:txBody>
+      </p:sp>
+      <p:sp>
+        <p:nvSpPr>
+          <p:cNvPr id="45" name="Text 43"/>
+          <p:cNvSpPr/>
+          <p:nvPr/>
+        </p:nvSpPr>
+        <p:spPr>
+          <a:xfrm>
+            <a:off x="6720840" y="4663440"/>
+            <a:ext cx="1691640" cy="438912"/>
+          </a:xfrm>
+          <a:prstGeom prst="rect">
+            <a:avLst/>
+          </a:prstGeom>
+          <a:noFill/>
+          <a:ln/>
+        </p:spPr>
+        <p:txBody>
+          <a:bodyPr wrap="square" rtlCol="0" anchor="ctr"/>
+          <a:lstStyle/>
+          <a:p>
+            <a:pPr algn="ctr" indent="0" marL="0">
+              <a:buNone/>
+            </a:pPr>
+            <a:r>
+              <a:rPr lang="en-US" sz="1800" dirty="0">
+                <a:solidFill>
+                  <a:srgbClr val="000000"/>
+                </a:solidFill>
+              </a:rPr>
+              <a:t>✅</a:t>
+            </a:r>
+            <a:endParaRPr lang="en-US" sz="1800" dirty="0"/>
+          </a:p>
+        </p:txBody>
+      </p:sp>
+      <p:sp>
+        <p:nvSpPr>
+          <p:cNvPr id="46" name="Text 44"/>
+          <p:cNvSpPr/>
+          <p:nvPr/>
+        </p:nvSpPr>
+        <p:spPr>
+          <a:xfrm>
+            <a:off x="457200" y="6291072"/>
+            <a:ext cx="8375904" cy="201168"/>
+          </a:xfrm>
+          <a:prstGeom prst="rect">
+            <a:avLst/>
+          </a:prstGeom>
+          <a:noFill/>
+          <a:ln/>
+        </p:spPr>
+        <p:txBody>
+          <a:bodyPr wrap="square" rtlCol="0" anchor="ctr"/>
+          <a:lstStyle/>
+          <a:p>
+            <a:pPr algn="l" indent="0" marL="0">
+              <a:buNone/>
+            </a:pPr>
+            <a:r>
+              <a:rPr lang="en-US" dirty="0">
+                <a:solidFill>
+                  <a:srgbClr val="718096"/>
+                </a:solidFill>
+                <a:latin typeface="Arial" pitchFamily="34" charset="0"/>
+                <a:ea typeface="Arial" pitchFamily="34" charset="-122"/>
+                <a:cs typeface="Arial" pitchFamily="34" charset="-120"/>
+              </a:rPr>
+              <a:t>⚠️ = funcionalidad parcial o no confirmada  ·  Fuente: investigación pública agosto 2026</a:t>
+            </a:r>
+            <a:endParaRPr lang="en-US" dirty="0"/>
+          </a:p>
+        </p:txBody>
+      </p:sp>
+    </p:spTree>
+  </p:cSld>
+  <p:clrMapOvr>
+    <a:masterClrMapping/>
+  </p:clrMapOvr>
+</p:sld>
+</file>
+
 <file path=ppt/theme/theme1.xml><?xml version="1.0" encoding="utf-8"?>
 <a:theme xmlns:a="http://schemas.openxmlformats.org/drawingml/2006/main" name="Office Theme">
   <a:themeElements>

</xml_diff>

<commit_message>
E3: deck slides 10-11 — tracción MVP y modelo de negocio tres planes
Co-Authored-By: Claude Sonnet 4.6 <noreply@anthropic.com>
</commit_message>
<xml_diff>
--- a/business/CareSignal_Pitch_Deck.pptx
+++ b/business/CareSignal_Pitch_Deck.pptx
@@ -14,9 +14,11 @@
     <p:sldId id="262" r:id="rId8"/>
     <p:sldId id="263" r:id="rId9"/>
     <p:sldId id="264" r:id="rId10"/>
+    <p:sldId id="265" r:id="rId11"/>
+    <p:sldId id="266" r:id="rId12"/>
   </p:sldIdLst>
   <p:notesMasterIdLst>
-    <p:notesMasterId r:id="rId11"/>
+    <p:notesMasterId r:id="rId13"/>
   </p:notesMasterIdLst>
   <p:sldSz cx="12192000" cy="6858000"/>
   <p:notesSz cx="6858000" cy="12192000"/>
@@ -534,6 +536,182 @@
             <a:fld id="{F7021451-1387-4CA6-816F-3879F97B5CBC}" type="slidenum">
               <a:rPr lang="en-US"/>
               <a:t>1</a:t>
+            </a:fld>
+            <a:endParaRPr lang="en-US"/>
+          </a:p>
+        </p:txBody>
+      </p:sp>
+    </p:spTree>
+    <p:extLst>
+      <p:ext uri="{BB962C8B-B14F-4D97-AF65-F5344CB8AC3E}">
+        <p14:creationId xmlns:p14="http://schemas.microsoft.com/office/powerpoint/2010/main" val="1024086991"/>
+      </p:ext>
+    </p:extLst>
+  </p:cSld>
+  <p:clrMapOvr>
+    <a:masterClrMapping/>
+  </p:clrMapOvr>
+</p:notes>
+</file>
+
+<file path=ppt/notesSlides/notesSlide10.xml><?xml version="1.0" encoding="utf-8"?>
+<p:notes xmlns:a="http://schemas.openxmlformats.org/drawingml/2006/main" xmlns:r="http://schemas.openxmlformats.org/officeDocument/2006/relationships" xmlns:p="http://schemas.openxmlformats.org/presentationml/2006/main">
+  <p:cSld>
+    <p:spTree>
+      <p:nvGrpSpPr>
+        <p:cNvPr id="1" name=""/>
+        <p:cNvGrpSpPr/>
+        <p:nvPr/>
+      </p:nvGrpSpPr>
+      <p:grpSpPr>
+        <a:xfrm>
+          <a:off x="0" y="0"/>
+          <a:ext cx="0" cy="0"/>
+          <a:chOff x="0" y="0"/>
+          <a:chExt cx="0" cy="0"/>
+        </a:xfrm>
+      </p:grpSpPr>
+      <p:sp>
+        <p:nvSpPr>
+          <p:cNvPr id="2" name="Slide Image Placeholder 1"/>
+          <p:cNvSpPr>
+            <a:spLocks noGrp="1" noRot="1" noChangeAspect="1"/>
+          </p:cNvSpPr>
+          <p:nvPr>
+            <p:ph type="sldImg"/>
+          </p:nvPr>
+        </p:nvSpPr>
+        <p:spPr/>
+      </p:sp>
+      <p:sp>
+        <p:nvSpPr>
+          <p:cNvPr id="3" name="Notes Placeholder 2"/>
+          <p:cNvSpPr>
+            <a:spLocks noGrp="1"/>
+          </p:cNvSpPr>
+          <p:nvPr>
+            <p:ph type="body" idx="1"/>
+          </p:nvPr>
+        </p:nvSpPr>
+        <p:spPr/>
+        <p:txBody>
+          <a:bodyPr/>
+          <a:lstStyle/>
+          <a:p>
+            <a:r>
+              <a:rPr lang="en-US" dirty="0"/>
+              <a:t/>
+            </a:r>
+            <a:endParaRPr lang="en-US" dirty="0"/>
+          </a:p>
+        </p:txBody>
+      </p:sp>
+      <p:sp>
+        <p:nvSpPr>
+          <p:cNvPr id="4" name="Slide Number Placeholder 3"/>
+          <p:cNvSpPr>
+            <a:spLocks noGrp="1"/>
+          </p:cNvSpPr>
+          <p:nvPr>
+            <p:ph type="sldNum" sz="quarter" idx="10"/>
+          </p:nvPr>
+        </p:nvSpPr>
+        <p:spPr/>
+        <p:txBody>
+          <a:bodyPr/>
+          <a:lstStyle/>
+          <a:p>
+            <a:fld id="{F7021451-1387-4CA6-816F-3879F97B5CBC}" type="slidenum">
+              <a:rPr lang="en-US"/>
+              <a:t>10</a:t>
+            </a:fld>
+            <a:endParaRPr lang="en-US"/>
+          </a:p>
+        </p:txBody>
+      </p:sp>
+    </p:spTree>
+    <p:extLst>
+      <p:ext uri="{BB962C8B-B14F-4D97-AF65-F5344CB8AC3E}">
+        <p14:creationId xmlns:p14="http://schemas.microsoft.com/office/powerpoint/2010/main" val="1024086991"/>
+      </p:ext>
+    </p:extLst>
+  </p:cSld>
+  <p:clrMapOvr>
+    <a:masterClrMapping/>
+  </p:clrMapOvr>
+</p:notes>
+</file>
+
+<file path=ppt/notesSlides/notesSlide11.xml><?xml version="1.0" encoding="utf-8"?>
+<p:notes xmlns:a="http://schemas.openxmlformats.org/drawingml/2006/main" xmlns:r="http://schemas.openxmlformats.org/officeDocument/2006/relationships" xmlns:p="http://schemas.openxmlformats.org/presentationml/2006/main">
+  <p:cSld>
+    <p:spTree>
+      <p:nvGrpSpPr>
+        <p:cNvPr id="1" name=""/>
+        <p:cNvGrpSpPr/>
+        <p:nvPr/>
+      </p:nvGrpSpPr>
+      <p:grpSpPr>
+        <a:xfrm>
+          <a:off x="0" y="0"/>
+          <a:ext cx="0" cy="0"/>
+          <a:chOff x="0" y="0"/>
+          <a:chExt cx="0" cy="0"/>
+        </a:xfrm>
+      </p:grpSpPr>
+      <p:sp>
+        <p:nvSpPr>
+          <p:cNvPr id="2" name="Slide Image Placeholder 1"/>
+          <p:cNvSpPr>
+            <a:spLocks noGrp="1" noRot="1" noChangeAspect="1"/>
+          </p:cNvSpPr>
+          <p:nvPr>
+            <p:ph type="sldImg"/>
+          </p:nvPr>
+        </p:nvSpPr>
+        <p:spPr/>
+      </p:sp>
+      <p:sp>
+        <p:nvSpPr>
+          <p:cNvPr id="3" name="Notes Placeholder 2"/>
+          <p:cNvSpPr>
+            <a:spLocks noGrp="1"/>
+          </p:cNvSpPr>
+          <p:nvPr>
+            <p:ph type="body" idx="1"/>
+          </p:nvPr>
+        </p:nvSpPr>
+        <p:spPr/>
+        <p:txBody>
+          <a:bodyPr/>
+          <a:lstStyle/>
+          <a:p>
+            <a:r>
+              <a:rPr lang="en-US" dirty="0"/>
+              <a:t/>
+            </a:r>
+            <a:endParaRPr lang="en-US" dirty="0"/>
+          </a:p>
+        </p:txBody>
+      </p:sp>
+      <p:sp>
+        <p:nvSpPr>
+          <p:cNvPr id="4" name="Slide Number Placeholder 3"/>
+          <p:cNvSpPr>
+            <a:spLocks noGrp="1"/>
+          </p:cNvSpPr>
+          <p:nvPr>
+            <p:ph type="sldNum" sz="quarter" idx="10"/>
+          </p:nvPr>
+        </p:nvSpPr>
+        <p:spPr/>
+        <p:txBody>
+          <a:bodyPr/>
+          <a:lstStyle/>
+          <a:p>
+            <a:fld id="{F7021451-1387-4CA6-816F-3879F97B5CBC}" type="slidenum">
+              <a:rPr lang="en-US"/>
+              <a:t>11</a:t>
             </a:fld>
             <a:endParaRPr lang="en-US"/>
           </a:p>
@@ -2373,6 +2551,2924 @@
 </p:sld>
 </file>
 
+<file path=ppt/slides/slide10.xml><?xml version="1.0" encoding="utf-8"?>
+<p:sld xmlns:a="http://schemas.openxmlformats.org/drawingml/2006/main" xmlns:r="http://schemas.openxmlformats.org/officeDocument/2006/relationships" xmlns:p="http://schemas.openxmlformats.org/presentationml/2006/main">
+  <p:cSld name="Slide 10">
+    <p:spTree>
+      <p:nvGrpSpPr>
+        <p:cNvPr id="1" name=""/>
+        <p:cNvGrpSpPr/>
+        <p:nvPr/>
+      </p:nvGrpSpPr>
+      <p:grpSpPr>
+        <a:xfrm>
+          <a:off x="0" y="0"/>
+          <a:ext cx="0" cy="0"/>
+          <a:chOff x="0" y="0"/>
+          <a:chExt cx="0" cy="0"/>
+        </a:xfrm>
+      </p:grpSpPr>
+      <p:sp>
+        <p:nvSpPr>
+          <p:cNvPr id="2" name="Shape 0"/>
+          <p:cNvSpPr/>
+          <p:nvPr/>
+        </p:nvSpPr>
+        <p:spPr>
+          <a:xfrm>
+            <a:off x="0" y="0"/>
+            <a:ext cx="12192000" cy="6858000"/>
+          </a:xfrm>
+          <a:prstGeom prst="rect">
+            <a:avLst/>
+          </a:prstGeom>
+          <a:solidFill>
+            <a:srgbClr val="FAFAF8"/>
+          </a:solidFill>
+          <a:ln w="12700">
+            <a:solidFill>
+              <a:srgbClr val="FAFAF8"/>
+            </a:solidFill>
+            <a:prstDash val="solid"/>
+          </a:ln>
+        </p:spPr>
+      </p:sp>
+      <p:sp>
+        <p:nvSpPr>
+          <p:cNvPr id="3" name="Shape 1"/>
+          <p:cNvSpPr/>
+          <p:nvPr/>
+        </p:nvSpPr>
+        <p:spPr>
+          <a:xfrm>
+            <a:off x="8138160" y="0"/>
+            <a:ext cx="694944" cy="6858000"/>
+          </a:xfrm>
+          <a:prstGeom prst="rect">
+            <a:avLst/>
+          </a:prstGeom>
+          <a:solidFill>
+            <a:srgbClr val="A8C4DC">
+              <a:alpha val="12000"/>
+            </a:srgbClr>
+          </a:solidFill>
+          <a:ln w="12700">
+            <a:solidFill>
+              <a:srgbClr val="A8C4DC">
+                <a:alpha val="12000"/>
+              </a:srgbClr>
+            </a:solidFill>
+            <a:prstDash val="solid"/>
+          </a:ln>
+        </p:spPr>
+      </p:sp>
+      <p:sp>
+        <p:nvSpPr>
+          <p:cNvPr id="4" name="Shape 2"/>
+          <p:cNvSpPr/>
+          <p:nvPr/>
+        </p:nvSpPr>
+        <p:spPr>
+          <a:xfrm>
+            <a:off x="3474720" y="5120640"/>
+            <a:ext cx="2377440" cy="2377440"/>
+          </a:xfrm>
+          <a:prstGeom prst="ellipse">
+            <a:avLst/>
+          </a:prstGeom>
+          <a:solidFill>
+            <a:srgbClr val="C4786A">
+              <a:alpha val="10000"/>
+            </a:srgbClr>
+          </a:solidFill>
+          <a:ln w="12700">
+            <a:solidFill>
+              <a:srgbClr val="C4786A">
+                <a:alpha val="10000"/>
+              </a:srgbClr>
+            </a:solidFill>
+            <a:prstDash val="solid"/>
+          </a:ln>
+        </p:spPr>
+      </p:sp>
+      <p:sp>
+        <p:nvSpPr>
+          <p:cNvPr id="5" name="Shape 3"/>
+          <p:cNvSpPr/>
+          <p:nvPr/>
+        </p:nvSpPr>
+        <p:spPr>
+          <a:xfrm>
+            <a:off x="0" y="0"/>
+            <a:ext cx="12192000" cy="54864"/>
+          </a:xfrm>
+          <a:prstGeom prst="rect">
+            <a:avLst/>
+          </a:prstGeom>
+          <a:solidFill>
+            <a:srgbClr val="5B8DB8"/>
+          </a:solidFill>
+          <a:ln w="12700">
+            <a:solidFill>
+              <a:srgbClr val="5B8DB8"/>
+            </a:solidFill>
+            <a:prstDash val="solid"/>
+          </a:ln>
+        </p:spPr>
+      </p:sp>
+      <p:sp>
+        <p:nvSpPr>
+          <p:cNvPr id="6" name="Shape 4"/>
+          <p:cNvSpPr/>
+          <p:nvPr/>
+        </p:nvSpPr>
+        <p:spPr>
+          <a:xfrm>
+            <a:off x="0" y="6528816"/>
+            <a:ext cx="12192000" cy="54864"/>
+          </a:xfrm>
+          <a:prstGeom prst="rect">
+            <a:avLst/>
+          </a:prstGeom>
+          <a:solidFill>
+            <a:srgbClr val="C4786A"/>
+          </a:solidFill>
+          <a:ln w="12700">
+            <a:solidFill>
+              <a:srgbClr val="C4786A"/>
+            </a:solidFill>
+            <a:prstDash val="solid"/>
+          </a:ln>
+        </p:spPr>
+      </p:sp>
+      <p:sp>
+        <p:nvSpPr>
+          <p:cNvPr id="7" name="Text 5"/>
+          <p:cNvSpPr/>
+          <p:nvPr/>
+        </p:nvSpPr>
+        <p:spPr>
+          <a:xfrm>
+            <a:off x="457200" y="228600"/>
+            <a:ext cx="8375904" cy="502920"/>
+          </a:xfrm>
+          <a:prstGeom prst="rect">
+            <a:avLst/>
+          </a:prstGeom>
+          <a:noFill/>
+          <a:ln/>
+        </p:spPr>
+        <p:txBody>
+          <a:bodyPr wrap="square" rtlCol="0" anchor="ctr"/>
+          <a:lstStyle/>
+          <a:p>
+            <a:pPr indent="0" marL="0">
+              <a:buNone/>
+            </a:pPr>
+            <a:r>
+              <a:rPr lang="en-US" b="1" dirty="0">
+                <a:solidFill>
+                  <a:srgbClr val="2D3748"/>
+                </a:solidFill>
+                <a:latin typeface="Arial" pitchFamily="34" charset="0"/>
+                <a:ea typeface="Arial" pitchFamily="34" charset="-122"/>
+                <a:cs typeface="Arial" pitchFamily="34" charset="-120"/>
+              </a:rPr>
+              <a:t>🏅  Tracción — producto terminado hoy</a:t>
+            </a:r>
+            <a:endParaRPr lang="en-US" dirty="0"/>
+          </a:p>
+        </p:txBody>
+      </p:sp>
+      <p:sp>
+        <p:nvSpPr>
+          <p:cNvPr id="8" name="Text 6"/>
+          <p:cNvSpPr/>
+          <p:nvPr/>
+        </p:nvSpPr>
+        <p:spPr>
+          <a:xfrm>
+            <a:off x="457200" y="731520"/>
+            <a:ext cx="8375904" cy="320040"/>
+          </a:xfrm>
+          <a:prstGeom prst="rect">
+            <a:avLst/>
+          </a:prstGeom>
+          <a:noFill/>
+          <a:ln/>
+        </p:spPr>
+        <p:txBody>
+          <a:bodyPr wrap="square" rtlCol="0" anchor="ctr"/>
+          <a:lstStyle/>
+          <a:p>
+            <a:pPr indent="0" marL="0">
+              <a:buNone/>
+            </a:pPr>
+            <a:r>
+              <a:rPr lang="en-US" b="1" dirty="0">
+                <a:solidFill>
+                  <a:srgbClr val="5B8DB8"/>
+                </a:solidFill>
+                <a:latin typeface="Arial" pitchFamily="34" charset="0"/>
+                <a:ea typeface="Arial" pitchFamily="34" charset="-122"/>
+                <a:cs typeface="Arial" pitchFamily="34" charset="-120"/>
+              </a:rPr>
+              <a:t>8 fases con gate review humano · Auditoría QA: PASS</a:t>
+            </a:r>
+            <a:endParaRPr lang="en-US" dirty="0"/>
+          </a:p>
+        </p:txBody>
+      </p:sp>
+      <p:sp>
+        <p:nvSpPr>
+          <p:cNvPr id="9" name="Shape 7"/>
+          <p:cNvSpPr/>
+          <p:nvPr/>
+        </p:nvSpPr>
+        <p:spPr>
+          <a:xfrm>
+            <a:off x="457200" y="1097280"/>
+            <a:ext cx="8375904" cy="0"/>
+          </a:xfrm>
+          <a:prstGeom prst="line">
+            <a:avLst/>
+          </a:prstGeom>
+          <a:noFill/>
+          <a:ln w="12700">
+            <a:solidFill>
+              <a:srgbClr val="E2E8F0"/>
+            </a:solidFill>
+            <a:prstDash val="solid"/>
+          </a:ln>
+        </p:spPr>
+      </p:sp>
+      <p:sp>
+        <p:nvSpPr>
+          <p:cNvPr id="10" name="Shape 8"/>
+          <p:cNvSpPr/>
+          <p:nvPr/>
+        </p:nvSpPr>
+        <p:spPr>
+          <a:xfrm>
+            <a:off x="457200" y="1261872"/>
+            <a:ext cx="1828800" cy="1965960"/>
+          </a:xfrm>
+          <a:prstGeom prst="roundRect">
+            <a:avLst>
+              <a:gd name="adj" fmla="val 4000"/>
+            </a:avLst>
+          </a:prstGeom>
+          <a:solidFill>
+            <a:srgbClr val="F0FDF4"/>
+          </a:solidFill>
+          <a:ln w="6350">
+            <a:solidFill>
+              <a:srgbClr val="E2E8F0"/>
+            </a:solidFill>
+            <a:prstDash val="solid"/>
+          </a:ln>
+        </p:spPr>
+      </p:sp>
+      <p:sp>
+        <p:nvSpPr>
+          <p:cNvPr id="11" name="Text 9"/>
+          <p:cNvSpPr/>
+          <p:nvPr/>
+        </p:nvSpPr>
+        <p:spPr>
+          <a:xfrm>
+            <a:off x="457200" y="1371600"/>
+            <a:ext cx="1828800" cy="502920"/>
+          </a:xfrm>
+          <a:prstGeom prst="rect">
+            <a:avLst/>
+          </a:prstGeom>
+          <a:noFill/>
+          <a:ln/>
+        </p:spPr>
+        <p:txBody>
+          <a:bodyPr wrap="square" rtlCol="0" anchor="ctr"/>
+          <a:lstStyle/>
+          <a:p>
+            <a:pPr algn="ctr" indent="0" marL="0">
+              <a:buNone/>
+            </a:pPr>
+            <a:r>
+              <a:rPr lang="en-US" sz="2600" dirty="0">
+                <a:solidFill>
+                  <a:srgbClr val="000000"/>
+                </a:solidFill>
+              </a:rPr>
+              <a:t>✅</a:t>
+            </a:r>
+            <a:endParaRPr lang="en-US" sz="2600" dirty="0"/>
+          </a:p>
+        </p:txBody>
+      </p:sp>
+      <p:sp>
+        <p:nvSpPr>
+          <p:cNvPr id="12" name="Text 10"/>
+          <p:cNvSpPr/>
+          <p:nvPr/>
+        </p:nvSpPr>
+        <p:spPr>
+          <a:xfrm>
+            <a:off x="457200" y="1920240"/>
+            <a:ext cx="1828800" cy="594360"/>
+          </a:xfrm>
+          <a:prstGeom prst="rect">
+            <a:avLst/>
+          </a:prstGeom>
+          <a:noFill/>
+          <a:ln/>
+        </p:spPr>
+        <p:txBody>
+          <a:bodyPr wrap="square" rtlCol="0" anchor="ctr"/>
+          <a:lstStyle/>
+          <a:p>
+            <a:pPr algn="ctr" indent="0" marL="0">
+              <a:buNone/>
+            </a:pPr>
+            <a:r>
+              <a:rPr lang="en-US" sz="3000" b="1" dirty="0">
+                <a:solidFill>
+                  <a:srgbClr val="3A6B96"/>
+                </a:solidFill>
+                <a:latin typeface="Arial" pitchFamily="34" charset="0"/>
+                <a:ea typeface="Arial" pitchFamily="34" charset="-122"/>
+                <a:cs typeface="Arial" pitchFamily="34" charset="-120"/>
+              </a:rPr>
+              <a:t>8 / 8</a:t>
+            </a:r>
+            <a:endParaRPr lang="en-US" sz="3000" dirty="0"/>
+          </a:p>
+        </p:txBody>
+      </p:sp>
+      <p:sp>
+        <p:nvSpPr>
+          <p:cNvPr id="13" name="Text 11"/>
+          <p:cNvSpPr/>
+          <p:nvPr/>
+        </p:nvSpPr>
+        <p:spPr>
+          <a:xfrm>
+            <a:off x="457200" y="2514600"/>
+            <a:ext cx="1828800" cy="548640"/>
+          </a:xfrm>
+          <a:prstGeom prst="rect">
+            <a:avLst/>
+          </a:prstGeom>
+          <a:noFill/>
+          <a:ln/>
+        </p:spPr>
+        <p:txBody>
+          <a:bodyPr wrap="square" rtlCol="0" anchor="ctr"/>
+          <a:lstStyle/>
+          <a:p>
+            <a:pPr algn="ctr" indent="0" marL="0">
+              <a:buNone/>
+            </a:pPr>
+            <a:r>
+              <a:rPr lang="en-US" sz="1050" dirty="0">
+                <a:solidFill>
+                  <a:srgbClr val="718096"/>
+                </a:solidFill>
+                <a:latin typeface="Arial" pitchFamily="34" charset="0"/>
+                <a:ea typeface="Arial" pitchFamily="34" charset="-122"/>
+                <a:cs typeface="Arial" pitchFamily="34" charset="-120"/>
+              </a:rPr>
+              <a:t>Fases aprobadas</a:t>
+            </a:r>
+            <a:endParaRPr lang="en-US" sz="1050" dirty="0"/>
+          </a:p>
+          <a:p>
+            <a:pPr algn="ctr" indent="0" marL="0">
+              <a:buNone/>
+            </a:pPr>
+            <a:r>
+              <a:rPr lang="en-US" sz="1050" dirty="0">
+                <a:solidFill>
+                  <a:srgbClr val="718096"/>
+                </a:solidFill>
+                <a:latin typeface="Arial" pitchFamily="34" charset="0"/>
+                <a:ea typeface="Arial" pitchFamily="34" charset="-122"/>
+                <a:cs typeface="Arial" pitchFamily="34" charset="-120"/>
+              </a:rPr>
+              <a:t>con gate review</a:t>
+            </a:r>
+            <a:endParaRPr lang="en-US" sz="1050" dirty="0"/>
+          </a:p>
+        </p:txBody>
+      </p:sp>
+      <p:sp>
+        <p:nvSpPr>
+          <p:cNvPr id="14" name="Shape 12"/>
+          <p:cNvSpPr/>
+          <p:nvPr/>
+        </p:nvSpPr>
+        <p:spPr>
+          <a:xfrm>
+            <a:off x="2578608" y="1261872"/>
+            <a:ext cx="1828800" cy="1965960"/>
+          </a:xfrm>
+          <a:prstGeom prst="roundRect">
+            <a:avLst>
+              <a:gd name="adj" fmla="val 4000"/>
+            </a:avLst>
+          </a:prstGeom>
+          <a:solidFill>
+            <a:srgbClr val="EFF6FF"/>
+          </a:solidFill>
+          <a:ln w="6350">
+            <a:solidFill>
+              <a:srgbClr val="E2E8F0"/>
+            </a:solidFill>
+            <a:prstDash val="solid"/>
+          </a:ln>
+        </p:spPr>
+      </p:sp>
+      <p:sp>
+        <p:nvSpPr>
+          <p:cNvPr id="15" name="Text 13"/>
+          <p:cNvSpPr/>
+          <p:nvPr/>
+        </p:nvSpPr>
+        <p:spPr>
+          <a:xfrm>
+            <a:off x="2578608" y="1371600"/>
+            <a:ext cx="1828800" cy="502920"/>
+          </a:xfrm>
+          <a:prstGeom prst="rect">
+            <a:avLst/>
+          </a:prstGeom>
+          <a:noFill/>
+          <a:ln/>
+        </p:spPr>
+        <p:txBody>
+          <a:bodyPr wrap="square" rtlCol="0" anchor="ctr"/>
+          <a:lstStyle/>
+          <a:p>
+            <a:pPr algn="ctr" indent="0" marL="0">
+              <a:buNone/>
+            </a:pPr>
+            <a:r>
+              <a:rPr lang="en-US" sz="2600" dirty="0">
+                <a:solidFill>
+                  <a:srgbClr val="000000"/>
+                </a:solidFill>
+              </a:rPr>
+              <a:t>🧪</a:t>
+            </a:r>
+            <a:endParaRPr lang="en-US" sz="2600" dirty="0"/>
+          </a:p>
+        </p:txBody>
+      </p:sp>
+      <p:sp>
+        <p:nvSpPr>
+          <p:cNvPr id="16" name="Text 14"/>
+          <p:cNvSpPr/>
+          <p:nvPr/>
+        </p:nvSpPr>
+        <p:spPr>
+          <a:xfrm>
+            <a:off x="2578608" y="1920240"/>
+            <a:ext cx="1828800" cy="594360"/>
+          </a:xfrm>
+          <a:prstGeom prst="rect">
+            <a:avLst/>
+          </a:prstGeom>
+          <a:noFill/>
+          <a:ln/>
+        </p:spPr>
+        <p:txBody>
+          <a:bodyPr wrap="square" rtlCol="0" anchor="ctr"/>
+          <a:lstStyle/>
+          <a:p>
+            <a:pPr algn="ctr" indent="0" marL="0">
+              <a:buNone/>
+            </a:pPr>
+            <a:r>
+              <a:rPr lang="en-US" sz="3000" b="1" dirty="0">
+                <a:solidFill>
+                  <a:srgbClr val="3A6B96"/>
+                </a:solidFill>
+                <a:latin typeface="Arial" pitchFamily="34" charset="0"/>
+                <a:ea typeface="Arial" pitchFamily="34" charset="-122"/>
+                <a:cs typeface="Arial" pitchFamily="34" charset="-120"/>
+              </a:rPr>
+              <a:t>38</a:t>
+            </a:r>
+            <a:endParaRPr lang="en-US" sz="3000" dirty="0"/>
+          </a:p>
+        </p:txBody>
+      </p:sp>
+      <p:sp>
+        <p:nvSpPr>
+          <p:cNvPr id="17" name="Text 15"/>
+          <p:cNvSpPr/>
+          <p:nvPr/>
+        </p:nvSpPr>
+        <p:spPr>
+          <a:xfrm>
+            <a:off x="2578608" y="2514600"/>
+            <a:ext cx="1828800" cy="548640"/>
+          </a:xfrm>
+          <a:prstGeom prst="rect">
+            <a:avLst/>
+          </a:prstGeom>
+          <a:noFill/>
+          <a:ln/>
+        </p:spPr>
+        <p:txBody>
+          <a:bodyPr wrap="square" rtlCol="0" anchor="ctr"/>
+          <a:lstStyle/>
+          <a:p>
+            <a:pPr algn="ctr" indent="0" marL="0">
+              <a:buNone/>
+            </a:pPr>
+            <a:r>
+              <a:rPr lang="en-US" sz="1050" dirty="0">
+                <a:solidFill>
+                  <a:srgbClr val="718096"/>
+                </a:solidFill>
+                <a:latin typeface="Arial" pitchFamily="34" charset="0"/>
+                <a:ea typeface="Arial" pitchFamily="34" charset="-122"/>
+                <a:cs typeface="Arial" pitchFamily="34" charset="-120"/>
+              </a:rPr>
+              <a:t>Pruebas</a:t>
+            </a:r>
+            <a:endParaRPr lang="en-US" sz="1050" dirty="0"/>
+          </a:p>
+          <a:p>
+            <a:pPr algn="ctr" indent="0" marL="0">
+              <a:buNone/>
+            </a:pPr>
+            <a:r>
+              <a:rPr lang="en-US" sz="1050" dirty="0">
+                <a:solidFill>
+                  <a:srgbClr val="718096"/>
+                </a:solidFill>
+                <a:latin typeface="Arial" pitchFamily="34" charset="0"/>
+                <a:ea typeface="Arial" pitchFamily="34" charset="-122"/>
+                <a:cs typeface="Arial" pitchFamily="34" charset="-120"/>
+              </a:rPr>
+              <a:t>automatizadas</a:t>
+            </a:r>
+            <a:endParaRPr lang="en-US" sz="1050" dirty="0"/>
+          </a:p>
+        </p:txBody>
+      </p:sp>
+      <p:sp>
+        <p:nvSpPr>
+          <p:cNvPr id="18" name="Shape 16"/>
+          <p:cNvSpPr/>
+          <p:nvPr/>
+        </p:nvSpPr>
+        <p:spPr>
+          <a:xfrm>
+            <a:off x="4700016" y="1261872"/>
+            <a:ext cx="1828800" cy="1965960"/>
+          </a:xfrm>
+          <a:prstGeom prst="roundRect">
+            <a:avLst>
+              <a:gd name="adj" fmla="val 4000"/>
+            </a:avLst>
+          </a:prstGeom>
+          <a:solidFill>
+            <a:srgbClr val="EFF6FF"/>
+          </a:solidFill>
+          <a:ln w="6350">
+            <a:solidFill>
+              <a:srgbClr val="E2E8F0"/>
+            </a:solidFill>
+            <a:prstDash val="solid"/>
+          </a:ln>
+        </p:spPr>
+      </p:sp>
+      <p:sp>
+        <p:nvSpPr>
+          <p:cNvPr id="19" name="Text 17"/>
+          <p:cNvSpPr/>
+          <p:nvPr/>
+        </p:nvSpPr>
+        <p:spPr>
+          <a:xfrm>
+            <a:off x="4700016" y="1371600"/>
+            <a:ext cx="1828800" cy="502920"/>
+          </a:xfrm>
+          <a:prstGeom prst="rect">
+            <a:avLst/>
+          </a:prstGeom>
+          <a:noFill/>
+          <a:ln/>
+        </p:spPr>
+        <p:txBody>
+          <a:bodyPr wrap="square" rtlCol="0" anchor="ctr"/>
+          <a:lstStyle/>
+          <a:p>
+            <a:pPr algn="ctr" indent="0" marL="0">
+              <a:buNone/>
+            </a:pPr>
+            <a:r>
+              <a:rPr lang="en-US" sz="2600" dirty="0">
+                <a:solidFill>
+                  <a:srgbClr val="000000"/>
+                </a:solidFill>
+              </a:rPr>
+              <a:t>📋</a:t>
+            </a:r>
+            <a:endParaRPr lang="en-US" sz="2600" dirty="0"/>
+          </a:p>
+        </p:txBody>
+      </p:sp>
+      <p:sp>
+        <p:nvSpPr>
+          <p:cNvPr id="20" name="Text 18"/>
+          <p:cNvSpPr/>
+          <p:nvPr/>
+        </p:nvSpPr>
+        <p:spPr>
+          <a:xfrm>
+            <a:off x="4700016" y="1920240"/>
+            <a:ext cx="1828800" cy="594360"/>
+          </a:xfrm>
+          <a:prstGeom prst="rect">
+            <a:avLst/>
+          </a:prstGeom>
+          <a:noFill/>
+          <a:ln/>
+        </p:spPr>
+        <p:txBody>
+          <a:bodyPr wrap="square" rtlCol="0" anchor="ctr"/>
+          <a:lstStyle/>
+          <a:p>
+            <a:pPr algn="ctr" indent="0" marL="0">
+              <a:buNone/>
+            </a:pPr>
+            <a:r>
+              <a:rPr lang="en-US" sz="3000" b="1" dirty="0">
+                <a:solidFill>
+                  <a:srgbClr val="3A6B96"/>
+                </a:solidFill>
+                <a:latin typeface="Arial" pitchFamily="34" charset="0"/>
+                <a:ea typeface="Arial" pitchFamily="34" charset="-122"/>
+                <a:cs typeface="Arial" pitchFamily="34" charset="-120"/>
+              </a:rPr>
+              <a:t>20</a:t>
+            </a:r>
+            <a:endParaRPr lang="en-US" sz="3000" dirty="0"/>
+          </a:p>
+        </p:txBody>
+      </p:sp>
+      <p:sp>
+        <p:nvSpPr>
+          <p:cNvPr id="21" name="Text 19"/>
+          <p:cNvSpPr/>
+          <p:nvPr/>
+        </p:nvSpPr>
+        <p:spPr>
+          <a:xfrm>
+            <a:off x="4700016" y="2514600"/>
+            <a:ext cx="1828800" cy="548640"/>
+          </a:xfrm>
+          <a:prstGeom prst="rect">
+            <a:avLst/>
+          </a:prstGeom>
+          <a:noFill/>
+          <a:ln/>
+        </p:spPr>
+        <p:txBody>
+          <a:bodyPr wrap="square" rtlCol="0" anchor="ctr"/>
+          <a:lstStyle/>
+          <a:p>
+            <a:pPr algn="ctr" indent="0" marL="0">
+              <a:buNone/>
+            </a:pPr>
+            <a:r>
+              <a:rPr lang="en-US" sz="1050" dirty="0">
+                <a:solidFill>
+                  <a:srgbClr val="718096"/>
+                </a:solidFill>
+                <a:latin typeface="Arial" pitchFamily="34" charset="0"/>
+                <a:ea typeface="Arial" pitchFamily="34" charset="-122"/>
+                <a:cs typeface="Arial" pitchFamily="34" charset="-120"/>
+              </a:rPr>
+              <a:t>Aceptación</a:t>
+            </a:r>
+            <a:endParaRPr lang="en-US" sz="1050" dirty="0"/>
+          </a:p>
+          <a:p>
+            <a:pPr algn="ctr" indent="0" marL="0">
+              <a:buNone/>
+            </a:pPr>
+            <a:r>
+              <a:rPr lang="en-US" sz="1050" dirty="0">
+                <a:solidFill>
+                  <a:srgbClr val="718096"/>
+                </a:solidFill>
+                <a:latin typeface="Arial" pitchFamily="34" charset="0"/>
+                <a:ea typeface="Arial" pitchFamily="34" charset="-122"/>
+                <a:cs typeface="Arial" pitchFamily="34" charset="-120"/>
+              </a:rPr>
+              <a:t>del contrato</a:t>
+            </a:r>
+            <a:endParaRPr lang="en-US" sz="1050" dirty="0"/>
+          </a:p>
+        </p:txBody>
+      </p:sp>
+      <p:sp>
+        <p:nvSpPr>
+          <p:cNvPr id="22" name="Shape 20"/>
+          <p:cNvSpPr/>
+          <p:nvPr/>
+        </p:nvSpPr>
+        <p:spPr>
+          <a:xfrm>
+            <a:off x="6821424" y="1261872"/>
+            <a:ext cx="1828800" cy="1965960"/>
+          </a:xfrm>
+          <a:prstGeom prst="roundRect">
+            <a:avLst>
+              <a:gd name="adj" fmla="val 4000"/>
+            </a:avLst>
+          </a:prstGeom>
+          <a:solidFill>
+            <a:srgbClr val="FFF7ED"/>
+          </a:solidFill>
+          <a:ln w="6350">
+            <a:solidFill>
+              <a:srgbClr val="E2E8F0"/>
+            </a:solidFill>
+            <a:prstDash val="solid"/>
+          </a:ln>
+        </p:spPr>
+      </p:sp>
+      <p:sp>
+        <p:nvSpPr>
+          <p:cNvPr id="23" name="Text 21"/>
+          <p:cNvSpPr/>
+          <p:nvPr/>
+        </p:nvSpPr>
+        <p:spPr>
+          <a:xfrm>
+            <a:off x="6821424" y="1371600"/>
+            <a:ext cx="1828800" cy="502920"/>
+          </a:xfrm>
+          <a:prstGeom prst="rect">
+            <a:avLst/>
+          </a:prstGeom>
+          <a:noFill/>
+          <a:ln/>
+        </p:spPr>
+        <p:txBody>
+          <a:bodyPr wrap="square" rtlCol="0" anchor="ctr"/>
+          <a:lstStyle/>
+          <a:p>
+            <a:pPr algn="ctr" indent="0" marL="0">
+              <a:buNone/>
+            </a:pPr>
+            <a:r>
+              <a:rPr lang="en-US" sz="2600" dirty="0">
+                <a:solidFill>
+                  <a:srgbClr val="000000"/>
+                </a:solidFill>
+              </a:rPr>
+              <a:t>🚫</a:t>
+            </a:r>
+            <a:endParaRPr lang="en-US" sz="2600" dirty="0"/>
+          </a:p>
+        </p:txBody>
+      </p:sp>
+      <p:sp>
+        <p:nvSpPr>
+          <p:cNvPr id="24" name="Text 22"/>
+          <p:cNvSpPr/>
+          <p:nvPr/>
+        </p:nvSpPr>
+        <p:spPr>
+          <a:xfrm>
+            <a:off x="6821424" y="1920240"/>
+            <a:ext cx="1828800" cy="594360"/>
+          </a:xfrm>
+          <a:prstGeom prst="rect">
+            <a:avLst/>
+          </a:prstGeom>
+          <a:noFill/>
+          <a:ln/>
+        </p:spPr>
+        <p:txBody>
+          <a:bodyPr wrap="square" rtlCol="0" anchor="ctr"/>
+          <a:lstStyle/>
+          <a:p>
+            <a:pPr algn="ctr" indent="0" marL="0">
+              <a:buNone/>
+            </a:pPr>
+            <a:r>
+              <a:rPr lang="en-US" sz="3000" b="1" dirty="0">
+                <a:solidFill>
+                  <a:srgbClr val="3A6B96"/>
+                </a:solidFill>
+                <a:latin typeface="Arial" pitchFamily="34" charset="0"/>
+                <a:ea typeface="Arial" pitchFamily="34" charset="-122"/>
+                <a:cs typeface="Arial" pitchFamily="34" charset="-120"/>
+              </a:rPr>
+              <a:t>0</a:t>
+            </a:r>
+            <a:endParaRPr lang="en-US" sz="3000" dirty="0"/>
+          </a:p>
+        </p:txBody>
+      </p:sp>
+      <p:sp>
+        <p:nvSpPr>
+          <p:cNvPr id="25" name="Text 23"/>
+          <p:cNvSpPr/>
+          <p:nvPr/>
+        </p:nvSpPr>
+        <p:spPr>
+          <a:xfrm>
+            <a:off x="6821424" y="2514600"/>
+            <a:ext cx="1828800" cy="548640"/>
+          </a:xfrm>
+          <a:prstGeom prst="rect">
+            <a:avLst/>
+          </a:prstGeom>
+          <a:noFill/>
+          <a:ln/>
+        </p:spPr>
+        <p:txBody>
+          <a:bodyPr wrap="square" rtlCol="0" anchor="ctr"/>
+          <a:lstStyle/>
+          <a:p>
+            <a:pPr algn="ctr" indent="0" marL="0">
+              <a:buNone/>
+            </a:pPr>
+            <a:r>
+              <a:rPr lang="en-US" sz="1050" dirty="0">
+                <a:solidFill>
+                  <a:srgbClr val="718096"/>
+                </a:solidFill>
+                <a:latin typeface="Arial" pitchFamily="34" charset="0"/>
+                <a:ea typeface="Arial" pitchFamily="34" charset="-122"/>
+                <a:cs typeface="Arial" pitchFamily="34" charset="-120"/>
+              </a:rPr>
+              <a:t>Hallazgos</a:t>
+            </a:r>
+            <a:endParaRPr lang="en-US" sz="1050" dirty="0"/>
+          </a:p>
+          <a:p>
+            <a:pPr algn="ctr" indent="0" marL="0">
+              <a:buNone/>
+            </a:pPr>
+            <a:r>
+              <a:rPr lang="en-US" sz="1050" dirty="0">
+                <a:solidFill>
+                  <a:srgbClr val="718096"/>
+                </a:solidFill>
+                <a:latin typeface="Arial" pitchFamily="34" charset="0"/>
+                <a:ea typeface="Arial" pitchFamily="34" charset="-122"/>
+                <a:cs typeface="Arial" pitchFamily="34" charset="-120"/>
+              </a:rPr>
+              <a:t>bloqueantes</a:t>
+            </a:r>
+            <a:endParaRPr lang="en-US" sz="1050" dirty="0"/>
+          </a:p>
+        </p:txBody>
+      </p:sp>
+      <p:sp>
+        <p:nvSpPr>
+          <p:cNvPr id="26" name="Shape 24"/>
+          <p:cNvSpPr/>
+          <p:nvPr/>
+        </p:nvSpPr>
+        <p:spPr>
+          <a:xfrm>
+            <a:off x="457200" y="3429000"/>
+            <a:ext cx="1828800" cy="1691640"/>
+          </a:xfrm>
+          <a:prstGeom prst="roundRect">
+            <a:avLst>
+              <a:gd name="adj" fmla="val 4324"/>
+            </a:avLst>
+          </a:prstGeom>
+          <a:solidFill>
+            <a:srgbClr val="F0EDE8"/>
+          </a:solidFill>
+          <a:ln w="6350">
+            <a:solidFill>
+              <a:srgbClr val="E2E8F0"/>
+            </a:solidFill>
+            <a:prstDash val="solid"/>
+          </a:ln>
+        </p:spPr>
+      </p:sp>
+      <p:sp>
+        <p:nvSpPr>
+          <p:cNvPr id="27" name="Text 25"/>
+          <p:cNvSpPr/>
+          <p:nvPr/>
+        </p:nvSpPr>
+        <p:spPr>
+          <a:xfrm>
+            <a:off x="457200" y="3520440"/>
+            <a:ext cx="1828800" cy="457200"/>
+          </a:xfrm>
+          <a:prstGeom prst="rect">
+            <a:avLst/>
+          </a:prstGeom>
+          <a:noFill/>
+          <a:ln/>
+        </p:spPr>
+        <p:txBody>
+          <a:bodyPr wrap="square" rtlCol="0" anchor="ctr"/>
+          <a:lstStyle/>
+          <a:p>
+            <a:pPr algn="ctr" indent="0" marL="0">
+              <a:buNone/>
+            </a:pPr>
+            <a:r>
+              <a:rPr lang="en-US" sz="2200" dirty="0">
+                <a:solidFill>
+                  <a:srgbClr val="000000"/>
+                </a:solidFill>
+              </a:rPr>
+              <a:t>📊</a:t>
+            </a:r>
+            <a:endParaRPr lang="en-US" sz="2200" dirty="0"/>
+          </a:p>
+        </p:txBody>
+      </p:sp>
+      <p:sp>
+        <p:nvSpPr>
+          <p:cNvPr id="28" name="Text 26"/>
+          <p:cNvSpPr/>
+          <p:nvPr/>
+        </p:nvSpPr>
+        <p:spPr>
+          <a:xfrm>
+            <a:off x="457200" y="4005072"/>
+            <a:ext cx="1828800" cy="502920"/>
+          </a:xfrm>
+          <a:prstGeom prst="rect">
+            <a:avLst/>
+          </a:prstGeom>
+          <a:noFill/>
+          <a:ln/>
+        </p:spPr>
+        <p:txBody>
+          <a:bodyPr wrap="square" rtlCol="0" anchor="ctr"/>
+          <a:lstStyle/>
+          <a:p>
+            <a:pPr algn="ctr" indent="0" marL="0">
+              <a:buNone/>
+            </a:pPr>
+            <a:r>
+              <a:rPr lang="en-US" sz="2400" b="1" dirty="0">
+                <a:solidFill>
+                  <a:srgbClr val="5B8DB8"/>
+                </a:solidFill>
+                <a:latin typeface="Arial" pitchFamily="34" charset="0"/>
+                <a:ea typeface="Arial" pitchFamily="34" charset="-122"/>
+                <a:cs typeface="Arial" pitchFamily="34" charset="-120"/>
+              </a:rPr>
+              <a:t>20</a:t>
+            </a:r>
+            <a:endParaRPr lang="en-US" sz="2400" dirty="0"/>
+          </a:p>
+        </p:txBody>
+      </p:sp>
+      <p:sp>
+        <p:nvSpPr>
+          <p:cNvPr id="29" name="Text 27"/>
+          <p:cNvSpPr/>
+          <p:nvPr/>
+        </p:nvSpPr>
+        <p:spPr>
+          <a:xfrm>
+            <a:off x="457200" y="4526280"/>
+            <a:ext cx="1828800" cy="457200"/>
+          </a:xfrm>
+          <a:prstGeom prst="rect">
+            <a:avLst/>
+          </a:prstGeom>
+          <a:noFill/>
+          <a:ln/>
+        </p:spPr>
+        <p:txBody>
+          <a:bodyPr wrap="square" rtlCol="0" anchor="ctr"/>
+          <a:lstStyle/>
+          <a:p>
+            <a:pPr algn="ctr" indent="0" marL="0">
+              <a:buNone/>
+            </a:pPr>
+            <a:r>
+              <a:rPr lang="en-US" sz="1000" dirty="0">
+                <a:solidFill>
+                  <a:srgbClr val="718096"/>
+                </a:solidFill>
+                <a:latin typeface="Arial" pitchFamily="34" charset="0"/>
+                <a:ea typeface="Arial" pitchFamily="34" charset="-122"/>
+                <a:cs typeface="Arial" pitchFamily="34" charset="-120"/>
+              </a:rPr>
+              <a:t>Tipos de evento</a:t>
+            </a:r>
+            <a:endParaRPr lang="en-US" sz="1000" dirty="0"/>
+          </a:p>
+          <a:p>
+            <a:pPr algn="ctr" indent="0" marL="0">
+              <a:buNone/>
+            </a:pPr>
+            <a:r>
+              <a:rPr lang="en-US" sz="1000" dirty="0">
+                <a:solidFill>
+                  <a:srgbClr val="718096"/>
+                </a:solidFill>
+                <a:latin typeface="Arial" pitchFamily="34" charset="0"/>
+                <a:ea typeface="Arial" pitchFamily="34" charset="-122"/>
+                <a:cs typeface="Arial" pitchFamily="34" charset="-120"/>
+              </a:rPr>
+              <a:t>de auditoría</a:t>
+            </a:r>
+            <a:endParaRPr lang="en-US" sz="1000" dirty="0"/>
+          </a:p>
+        </p:txBody>
+      </p:sp>
+      <p:sp>
+        <p:nvSpPr>
+          <p:cNvPr id="30" name="Shape 28"/>
+          <p:cNvSpPr/>
+          <p:nvPr/>
+        </p:nvSpPr>
+        <p:spPr>
+          <a:xfrm>
+            <a:off x="2578608" y="3429000"/>
+            <a:ext cx="1828800" cy="1691640"/>
+          </a:xfrm>
+          <a:prstGeom prst="roundRect">
+            <a:avLst>
+              <a:gd name="adj" fmla="val 4324"/>
+            </a:avLst>
+          </a:prstGeom>
+          <a:solidFill>
+            <a:srgbClr val="F0EDE8"/>
+          </a:solidFill>
+          <a:ln w="6350">
+            <a:solidFill>
+              <a:srgbClr val="E2E8F0"/>
+            </a:solidFill>
+            <a:prstDash val="solid"/>
+          </a:ln>
+        </p:spPr>
+      </p:sp>
+      <p:sp>
+        <p:nvSpPr>
+          <p:cNvPr id="31" name="Text 29"/>
+          <p:cNvSpPr/>
+          <p:nvPr/>
+        </p:nvSpPr>
+        <p:spPr>
+          <a:xfrm>
+            <a:off x="2578608" y="3520440"/>
+            <a:ext cx="1828800" cy="457200"/>
+          </a:xfrm>
+          <a:prstGeom prst="rect">
+            <a:avLst/>
+          </a:prstGeom>
+          <a:noFill/>
+          <a:ln/>
+        </p:spPr>
+        <p:txBody>
+          <a:bodyPr wrap="square" rtlCol="0" anchor="ctr"/>
+          <a:lstStyle/>
+          <a:p>
+            <a:pPr algn="ctr" indent="0" marL="0">
+              <a:buNone/>
+            </a:pPr>
+            <a:r>
+              <a:rPr lang="en-US" sz="2200" dirty="0">
+                <a:solidFill>
+                  <a:srgbClr val="000000"/>
+                </a:solidFill>
+              </a:rPr>
+              <a:t>⚙️</a:t>
+            </a:r>
+            <a:endParaRPr lang="en-US" sz="2200" dirty="0"/>
+          </a:p>
+        </p:txBody>
+      </p:sp>
+      <p:sp>
+        <p:nvSpPr>
+          <p:cNvPr id="32" name="Text 30"/>
+          <p:cNvSpPr/>
+          <p:nvPr/>
+        </p:nvSpPr>
+        <p:spPr>
+          <a:xfrm>
+            <a:off x="2578608" y="4005072"/>
+            <a:ext cx="1828800" cy="502920"/>
+          </a:xfrm>
+          <a:prstGeom prst="rect">
+            <a:avLst/>
+          </a:prstGeom>
+          <a:noFill/>
+          <a:ln/>
+        </p:spPr>
+        <p:txBody>
+          <a:bodyPr wrap="square" rtlCol="0" anchor="ctr"/>
+          <a:lstStyle/>
+          <a:p>
+            <a:pPr algn="ctr" indent="0" marL="0">
+              <a:buNone/>
+            </a:pPr>
+            <a:r>
+              <a:rPr lang="en-US" sz="2400" b="1" dirty="0">
+                <a:solidFill>
+                  <a:srgbClr val="5B8DB8"/>
+                </a:solidFill>
+                <a:latin typeface="Arial" pitchFamily="34" charset="0"/>
+                <a:ea typeface="Arial" pitchFamily="34" charset="-122"/>
+                <a:cs typeface="Arial" pitchFamily="34" charset="-120"/>
+              </a:rPr>
+              <a:t>8</a:t>
+            </a:r>
+            <a:endParaRPr lang="en-US" sz="2400" dirty="0"/>
+          </a:p>
+        </p:txBody>
+      </p:sp>
+      <p:sp>
+        <p:nvSpPr>
+          <p:cNvPr id="33" name="Text 31"/>
+          <p:cNvSpPr/>
+          <p:nvPr/>
+        </p:nvSpPr>
+        <p:spPr>
+          <a:xfrm>
+            <a:off x="2578608" y="4526280"/>
+            <a:ext cx="1828800" cy="457200"/>
+          </a:xfrm>
+          <a:prstGeom prst="rect">
+            <a:avLst/>
+          </a:prstGeom>
+          <a:noFill/>
+          <a:ln/>
+        </p:spPr>
+        <p:txBody>
+          <a:bodyPr wrap="square" rtlCol="0" anchor="ctr"/>
+          <a:lstStyle/>
+          <a:p>
+            <a:pPr algn="ctr" indent="0" marL="0">
+              <a:buNone/>
+            </a:pPr>
+            <a:r>
+              <a:rPr lang="en-US" sz="1000" dirty="0">
+                <a:solidFill>
+                  <a:srgbClr val="718096"/>
+                </a:solidFill>
+                <a:latin typeface="Arial" pitchFamily="34" charset="0"/>
+                <a:ea typeface="Arial" pitchFamily="34" charset="-122"/>
+                <a:cs typeface="Arial" pitchFamily="34" charset="-120"/>
+              </a:rPr>
+              <a:t>Políticas del</a:t>
+            </a:r>
+            <a:endParaRPr lang="en-US" sz="1000" dirty="0"/>
+          </a:p>
+          <a:p>
+            <a:pPr algn="ctr" indent="0" marL="0">
+              <a:buNone/>
+            </a:pPr>
+            <a:r>
+              <a:rPr lang="en-US" sz="1000" dirty="0">
+                <a:solidFill>
+                  <a:srgbClr val="718096"/>
+                </a:solidFill>
+                <a:latin typeface="Arial" pitchFamily="34" charset="0"/>
+                <a:ea typeface="Arial" pitchFamily="34" charset="-122"/>
+                <a:cs typeface="Arial" pitchFamily="34" charset="-120"/>
+              </a:rPr>
+              <a:t>motor temporal</a:t>
+            </a:r>
+            <a:endParaRPr lang="en-US" sz="1000" dirty="0"/>
+          </a:p>
+        </p:txBody>
+      </p:sp>
+      <p:sp>
+        <p:nvSpPr>
+          <p:cNvPr id="34" name="Shape 32"/>
+          <p:cNvSpPr/>
+          <p:nvPr/>
+        </p:nvSpPr>
+        <p:spPr>
+          <a:xfrm>
+            <a:off x="4700016" y="3429000"/>
+            <a:ext cx="1828800" cy="1691640"/>
+          </a:xfrm>
+          <a:prstGeom prst="roundRect">
+            <a:avLst>
+              <a:gd name="adj" fmla="val 4324"/>
+            </a:avLst>
+          </a:prstGeom>
+          <a:solidFill>
+            <a:srgbClr val="F0EDE8"/>
+          </a:solidFill>
+          <a:ln w="6350">
+            <a:solidFill>
+              <a:srgbClr val="E2E8F0"/>
+            </a:solidFill>
+            <a:prstDash val="solid"/>
+          </a:ln>
+        </p:spPr>
+      </p:sp>
+      <p:sp>
+        <p:nvSpPr>
+          <p:cNvPr id="35" name="Text 33"/>
+          <p:cNvSpPr/>
+          <p:nvPr/>
+        </p:nvSpPr>
+        <p:spPr>
+          <a:xfrm>
+            <a:off x="4700016" y="3520440"/>
+            <a:ext cx="1828800" cy="457200"/>
+          </a:xfrm>
+          <a:prstGeom prst="rect">
+            <a:avLst/>
+          </a:prstGeom>
+          <a:noFill/>
+          <a:ln/>
+        </p:spPr>
+        <p:txBody>
+          <a:bodyPr wrap="square" rtlCol="0" anchor="ctr"/>
+          <a:lstStyle/>
+          <a:p>
+            <a:pPr algn="ctr" indent="0" marL="0">
+              <a:buNone/>
+            </a:pPr>
+            <a:r>
+              <a:rPr lang="en-US" sz="2200" dirty="0">
+                <a:solidFill>
+                  <a:srgbClr val="000000"/>
+                </a:solidFill>
+              </a:rPr>
+              <a:t>👆</a:t>
+            </a:r>
+            <a:endParaRPr lang="en-US" sz="2200" dirty="0"/>
+          </a:p>
+        </p:txBody>
+      </p:sp>
+      <p:sp>
+        <p:nvSpPr>
+          <p:cNvPr id="36" name="Text 34"/>
+          <p:cNvSpPr/>
+          <p:nvPr/>
+        </p:nvSpPr>
+        <p:spPr>
+          <a:xfrm>
+            <a:off x="4700016" y="4005072"/>
+            <a:ext cx="1828800" cy="502920"/>
+          </a:xfrm>
+          <a:prstGeom prst="rect">
+            <a:avLst/>
+          </a:prstGeom>
+          <a:noFill/>
+          <a:ln/>
+        </p:spPr>
+        <p:txBody>
+          <a:bodyPr wrap="square" rtlCol="0" anchor="ctr"/>
+          <a:lstStyle/>
+          <a:p>
+            <a:pPr algn="ctr" indent="0" marL="0">
+              <a:buNone/>
+            </a:pPr>
+            <a:r>
+              <a:rPr lang="en-US" sz="2400" b="1" dirty="0">
+                <a:solidFill>
+                  <a:srgbClr val="5B8DB8"/>
+                </a:solidFill>
+                <a:latin typeface="Arial" pitchFamily="34" charset="0"/>
+                <a:ea typeface="Arial" pitchFamily="34" charset="-122"/>
+                <a:cs typeface="Arial" pitchFamily="34" charset="-120"/>
+              </a:rPr>
+              <a:t>≤ 3</a:t>
+            </a:r>
+            <a:endParaRPr lang="en-US" sz="2400" dirty="0"/>
+          </a:p>
+        </p:txBody>
+      </p:sp>
+      <p:sp>
+        <p:nvSpPr>
+          <p:cNvPr id="37" name="Text 35"/>
+          <p:cNvSpPr/>
+          <p:nvPr/>
+        </p:nvSpPr>
+        <p:spPr>
+          <a:xfrm>
+            <a:off x="4700016" y="4526280"/>
+            <a:ext cx="1828800" cy="457200"/>
+          </a:xfrm>
+          <a:prstGeom prst="rect">
+            <a:avLst/>
+          </a:prstGeom>
+          <a:noFill/>
+          <a:ln/>
+        </p:spPr>
+        <p:txBody>
+          <a:bodyPr wrap="square" rtlCol="0" anchor="ctr"/>
+          <a:lstStyle/>
+          <a:p>
+            <a:pPr algn="ctr" indent="0" marL="0">
+              <a:buNone/>
+            </a:pPr>
+            <a:r>
+              <a:rPr lang="en-US" sz="1000" dirty="0">
+                <a:solidFill>
+                  <a:srgbClr val="718096"/>
+                </a:solidFill>
+                <a:latin typeface="Arial" pitchFamily="34" charset="0"/>
+                <a:ea typeface="Arial" pitchFamily="34" charset="-122"/>
+                <a:cs typeface="Arial" pitchFamily="34" charset="-120"/>
+              </a:rPr>
+              <a:t>Acciones para</a:t>
+            </a:r>
+            <a:endParaRPr lang="en-US" sz="1000" dirty="0"/>
+          </a:p>
+          <a:p>
+            <a:pPr algn="ctr" indent="0" marL="0">
+              <a:buNone/>
+            </a:pPr>
+            <a:r>
+              <a:rPr lang="en-US" sz="1000" dirty="0">
+                <a:solidFill>
+                  <a:srgbClr val="718096"/>
+                </a:solidFill>
+                <a:latin typeface="Arial" pitchFamily="34" charset="0"/>
+                <a:ea typeface="Arial" pitchFamily="34" charset="-122"/>
+                <a:cs typeface="Arial" pitchFamily="34" charset="-120"/>
+              </a:rPr>
+              <a:t>completar una ronda</a:t>
+            </a:r>
+            <a:endParaRPr lang="en-US" sz="1000" dirty="0"/>
+          </a:p>
+        </p:txBody>
+      </p:sp>
+      <p:sp>
+        <p:nvSpPr>
+          <p:cNvPr id="38" name="Shape 36"/>
+          <p:cNvSpPr/>
+          <p:nvPr/>
+        </p:nvSpPr>
+        <p:spPr>
+          <a:xfrm>
+            <a:off x="6821424" y="3429000"/>
+            <a:ext cx="1828800" cy="1691640"/>
+          </a:xfrm>
+          <a:prstGeom prst="roundRect">
+            <a:avLst>
+              <a:gd name="adj" fmla="val 4324"/>
+            </a:avLst>
+          </a:prstGeom>
+          <a:solidFill>
+            <a:srgbClr val="F0EDE8"/>
+          </a:solidFill>
+          <a:ln w="6350">
+            <a:solidFill>
+              <a:srgbClr val="E2E8F0"/>
+            </a:solidFill>
+            <a:prstDash val="solid"/>
+          </a:ln>
+        </p:spPr>
+      </p:sp>
+      <p:sp>
+        <p:nvSpPr>
+          <p:cNvPr id="39" name="Text 37"/>
+          <p:cNvSpPr/>
+          <p:nvPr/>
+        </p:nvSpPr>
+        <p:spPr>
+          <a:xfrm>
+            <a:off x="6821424" y="3520440"/>
+            <a:ext cx="1828800" cy="457200"/>
+          </a:xfrm>
+          <a:prstGeom prst="rect">
+            <a:avLst/>
+          </a:prstGeom>
+          <a:noFill/>
+          <a:ln/>
+        </p:spPr>
+        <p:txBody>
+          <a:bodyPr wrap="square" rtlCol="0" anchor="ctr"/>
+          <a:lstStyle/>
+          <a:p>
+            <a:pPr algn="ctr" indent="0" marL="0">
+              <a:buNone/>
+            </a:pPr>
+            <a:r>
+              <a:rPr lang="en-US" sz="2200" dirty="0">
+                <a:solidFill>
+                  <a:srgbClr val="000000"/>
+                </a:solidFill>
+              </a:rPr>
+              <a:t>📦</a:t>
+            </a:r>
+            <a:endParaRPr lang="en-US" sz="2200" dirty="0"/>
+          </a:p>
+        </p:txBody>
+      </p:sp>
+      <p:sp>
+        <p:nvSpPr>
+          <p:cNvPr id="40" name="Text 38"/>
+          <p:cNvSpPr/>
+          <p:nvPr/>
+        </p:nvSpPr>
+        <p:spPr>
+          <a:xfrm>
+            <a:off x="6821424" y="4005072"/>
+            <a:ext cx="1828800" cy="502920"/>
+          </a:xfrm>
+          <a:prstGeom prst="rect">
+            <a:avLst/>
+          </a:prstGeom>
+          <a:noFill/>
+          <a:ln/>
+        </p:spPr>
+        <p:txBody>
+          <a:bodyPr wrap="square" rtlCol="0" anchor="ctr"/>
+          <a:lstStyle/>
+          <a:p>
+            <a:pPr algn="ctr" indent="0" marL="0">
+              <a:buNone/>
+            </a:pPr>
+            <a:r>
+              <a:rPr lang="en-US" sz="2400" b="1" dirty="0">
+                <a:solidFill>
+                  <a:srgbClr val="5B8DB8"/>
+                </a:solidFill>
+                <a:latin typeface="Arial" pitchFamily="34" charset="0"/>
+                <a:ea typeface="Arial" pitchFamily="34" charset="-122"/>
+                <a:cs typeface="Arial" pitchFamily="34" charset="-120"/>
+              </a:rPr>
+              <a:t>~68 KB</a:t>
+            </a:r>
+            <a:endParaRPr lang="en-US" sz="2400" dirty="0"/>
+          </a:p>
+        </p:txBody>
+      </p:sp>
+      <p:sp>
+        <p:nvSpPr>
+          <p:cNvPr id="41" name="Text 39"/>
+          <p:cNvSpPr/>
+          <p:nvPr/>
+        </p:nvSpPr>
+        <p:spPr>
+          <a:xfrm>
+            <a:off x="6821424" y="4526280"/>
+            <a:ext cx="1828800" cy="457200"/>
+          </a:xfrm>
+          <a:prstGeom prst="rect">
+            <a:avLst/>
+          </a:prstGeom>
+          <a:noFill/>
+          <a:ln/>
+        </p:spPr>
+        <p:txBody>
+          <a:bodyPr wrap="square" rtlCol="0" anchor="ctr"/>
+          <a:lstStyle/>
+          <a:p>
+            <a:pPr algn="ctr" indent="0" marL="0">
+              <a:buNone/>
+            </a:pPr>
+            <a:r>
+              <a:rPr lang="en-US" sz="1000" dirty="0">
+                <a:solidFill>
+                  <a:srgbClr val="718096"/>
+                </a:solidFill>
+                <a:latin typeface="Arial" pitchFamily="34" charset="0"/>
+                <a:ea typeface="Arial" pitchFamily="34" charset="-122"/>
+                <a:cs typeface="Arial" pitchFamily="34" charset="-120"/>
+              </a:rPr>
+              <a:t>Bundle comprimido</a:t>
+            </a:r>
+            <a:endParaRPr lang="en-US" sz="1000" dirty="0"/>
+          </a:p>
+          <a:p>
+            <a:pPr algn="ctr" indent="0" marL="0">
+              <a:buNone/>
+            </a:pPr>
+            <a:r>
+              <a:rPr lang="en-US" sz="1000" dirty="0">
+                <a:solidFill>
+                  <a:srgbClr val="718096"/>
+                </a:solidFill>
+                <a:latin typeface="Arial" pitchFamily="34" charset="0"/>
+                <a:ea typeface="Arial" pitchFamily="34" charset="-122"/>
+                <a:cs typeface="Arial" pitchFamily="34" charset="-120"/>
+              </a:rPr>
+              <a:t>de producción</a:t>
+            </a:r>
+            <a:endParaRPr lang="en-US" sz="1000" dirty="0"/>
+          </a:p>
+        </p:txBody>
+      </p:sp>
+      <p:sp>
+        <p:nvSpPr>
+          <p:cNvPr id="42" name="Text 40"/>
+          <p:cNvSpPr/>
+          <p:nvPr/>
+        </p:nvSpPr>
+        <p:spPr>
+          <a:xfrm>
+            <a:off x="457200" y="6291072"/>
+            <a:ext cx="8375904" cy="201168"/>
+          </a:xfrm>
+          <a:prstGeom prst="rect">
+            <a:avLst/>
+          </a:prstGeom>
+          <a:noFill/>
+          <a:ln/>
+        </p:spPr>
+        <p:txBody>
+          <a:bodyPr wrap="square" rtlCol="0" anchor="ctr"/>
+          <a:lstStyle/>
+          <a:p>
+            <a:pPr algn="ctr" indent="0" marL="0">
+              <a:buNone/>
+            </a:pPr>
+            <a:r>
+              <a:rPr lang="en-US" dirty="0">
+                <a:solidFill>
+                  <a:srgbClr val="718096"/>
+                </a:solidFill>
+                <a:latin typeface="Arial" pitchFamily="34" charset="0"/>
+                <a:ea typeface="Arial" pitchFamily="34" charset="-122"/>
+                <a:cs typeface="Arial" pitchFamily="34" charset="-120"/>
+              </a:rPr>
+              <a:t>MVP operacional · No dispositivo médico · Datos ficticios</a:t>
+            </a:r>
+            <a:endParaRPr lang="en-US" dirty="0"/>
+          </a:p>
+        </p:txBody>
+      </p:sp>
+    </p:spTree>
+  </p:cSld>
+  <p:clrMapOvr>
+    <a:masterClrMapping/>
+  </p:clrMapOvr>
+</p:sld>
+</file>
+
+<file path=ppt/slides/slide11.xml><?xml version="1.0" encoding="utf-8"?>
+<p:sld xmlns:a="http://schemas.openxmlformats.org/drawingml/2006/main" xmlns:r="http://schemas.openxmlformats.org/officeDocument/2006/relationships" xmlns:p="http://schemas.openxmlformats.org/presentationml/2006/main">
+  <p:cSld name="Slide 11">
+    <p:spTree>
+      <p:nvGrpSpPr>
+        <p:cNvPr id="1" name=""/>
+        <p:cNvGrpSpPr/>
+        <p:nvPr/>
+      </p:nvGrpSpPr>
+      <p:grpSpPr>
+        <a:xfrm>
+          <a:off x="0" y="0"/>
+          <a:ext cx="0" cy="0"/>
+          <a:chOff x="0" y="0"/>
+          <a:chExt cx="0" cy="0"/>
+        </a:xfrm>
+      </p:grpSpPr>
+      <p:sp>
+        <p:nvSpPr>
+          <p:cNvPr id="2" name="Shape 0"/>
+          <p:cNvSpPr/>
+          <p:nvPr/>
+        </p:nvSpPr>
+        <p:spPr>
+          <a:xfrm>
+            <a:off x="0" y="0"/>
+            <a:ext cx="12192000" cy="6858000"/>
+          </a:xfrm>
+          <a:prstGeom prst="rect">
+            <a:avLst/>
+          </a:prstGeom>
+          <a:solidFill>
+            <a:srgbClr val="FAFAF8"/>
+          </a:solidFill>
+          <a:ln w="12700">
+            <a:solidFill>
+              <a:srgbClr val="FAFAF8"/>
+            </a:solidFill>
+            <a:prstDash val="solid"/>
+          </a:ln>
+        </p:spPr>
+      </p:sp>
+      <p:sp>
+        <p:nvSpPr>
+          <p:cNvPr id="3" name="Shape 1"/>
+          <p:cNvSpPr/>
+          <p:nvPr/>
+        </p:nvSpPr>
+        <p:spPr>
+          <a:xfrm>
+            <a:off x="7132320" y="-1371600"/>
+            <a:ext cx="3474720" cy="3474720"/>
+          </a:xfrm>
+          <a:prstGeom prst="ellipse">
+            <a:avLst/>
+          </a:prstGeom>
+          <a:solidFill>
+            <a:srgbClr val="7BA68A">
+              <a:alpha val="16000"/>
+            </a:srgbClr>
+          </a:solidFill>
+          <a:ln w="12700">
+            <a:solidFill>
+              <a:srgbClr val="7BA68A">
+                <a:alpha val="16000"/>
+              </a:srgbClr>
+            </a:solidFill>
+            <a:prstDash val="solid"/>
+          </a:ln>
+        </p:spPr>
+      </p:sp>
+      <p:sp>
+        <p:nvSpPr>
+          <p:cNvPr id="4" name="Shape 2"/>
+          <p:cNvSpPr/>
+          <p:nvPr/>
+        </p:nvSpPr>
+        <p:spPr>
+          <a:xfrm>
+            <a:off x="-365760" y="5303520"/>
+            <a:ext cx="2011680" cy="2011680"/>
+          </a:xfrm>
+          <a:prstGeom prst="ellipse">
+            <a:avLst/>
+          </a:prstGeom>
+          <a:solidFill>
+            <a:srgbClr val="A8C4DC">
+              <a:alpha val="20000"/>
+            </a:srgbClr>
+          </a:solidFill>
+          <a:ln w="12700">
+            <a:solidFill>
+              <a:srgbClr val="A8C4DC">
+                <a:alpha val="20000"/>
+              </a:srgbClr>
+            </a:solidFill>
+            <a:prstDash val="solid"/>
+          </a:ln>
+        </p:spPr>
+      </p:sp>
+      <p:sp>
+        <p:nvSpPr>
+          <p:cNvPr id="5" name="Shape 3"/>
+          <p:cNvSpPr/>
+          <p:nvPr/>
+        </p:nvSpPr>
+        <p:spPr>
+          <a:xfrm rot="-1080000">
+            <a:off x="274320" y="5943600"/>
+            <a:ext cx="2286000" cy="0"/>
+          </a:xfrm>
+          <a:prstGeom prst="line">
+            <a:avLst/>
+          </a:prstGeom>
+          <a:noFill/>
+          <a:ln w="12700">
+            <a:solidFill>
+              <a:srgbClr val="E2E8F0"/>
+            </a:solidFill>
+            <a:prstDash val="solid"/>
+          </a:ln>
+        </p:spPr>
+      </p:sp>
+      <p:sp>
+        <p:nvSpPr>
+          <p:cNvPr id="6" name="Shape 4"/>
+          <p:cNvSpPr/>
+          <p:nvPr/>
+        </p:nvSpPr>
+        <p:spPr>
+          <a:xfrm>
+            <a:off x="0" y="0"/>
+            <a:ext cx="12192000" cy="54864"/>
+          </a:xfrm>
+          <a:prstGeom prst="rect">
+            <a:avLst/>
+          </a:prstGeom>
+          <a:solidFill>
+            <a:srgbClr val="5B8DB8"/>
+          </a:solidFill>
+          <a:ln w="12700">
+            <a:solidFill>
+              <a:srgbClr val="5B8DB8"/>
+            </a:solidFill>
+            <a:prstDash val="solid"/>
+          </a:ln>
+        </p:spPr>
+      </p:sp>
+      <p:sp>
+        <p:nvSpPr>
+          <p:cNvPr id="7" name="Shape 5"/>
+          <p:cNvSpPr/>
+          <p:nvPr/>
+        </p:nvSpPr>
+        <p:spPr>
+          <a:xfrm>
+            <a:off x="0" y="6528816"/>
+            <a:ext cx="12192000" cy="54864"/>
+          </a:xfrm>
+          <a:prstGeom prst="rect">
+            <a:avLst/>
+          </a:prstGeom>
+          <a:solidFill>
+            <a:srgbClr val="C4786A"/>
+          </a:solidFill>
+          <a:ln w="12700">
+            <a:solidFill>
+              <a:srgbClr val="C4786A"/>
+            </a:solidFill>
+            <a:prstDash val="solid"/>
+          </a:ln>
+        </p:spPr>
+      </p:sp>
+      <p:sp>
+        <p:nvSpPr>
+          <p:cNvPr id="8" name="Text 6"/>
+          <p:cNvSpPr/>
+          <p:nvPr/>
+        </p:nvSpPr>
+        <p:spPr>
+          <a:xfrm>
+            <a:off x="457200" y="228600"/>
+            <a:ext cx="8375904" cy="502920"/>
+          </a:xfrm>
+          <a:prstGeom prst="rect">
+            <a:avLst/>
+          </a:prstGeom>
+          <a:noFill/>
+          <a:ln/>
+        </p:spPr>
+        <p:txBody>
+          <a:bodyPr wrap="square" rtlCol="0" anchor="ctr"/>
+          <a:lstStyle/>
+          <a:p>
+            <a:pPr indent="0" marL="0">
+              <a:buNone/>
+            </a:pPr>
+            <a:r>
+              <a:rPr lang="en-US" b="1" dirty="0">
+                <a:solidFill>
+                  <a:srgbClr val="2D3748"/>
+                </a:solidFill>
+                <a:latin typeface="Arial" pitchFamily="34" charset="0"/>
+                <a:ea typeface="Arial" pitchFamily="34" charset="-122"/>
+                <a:cs typeface="Arial" pitchFamily="34" charset="-120"/>
+              </a:rPr>
+              <a:t>💰  Modelo de negocio</a:t>
+            </a:r>
+            <a:endParaRPr lang="en-US" dirty="0"/>
+          </a:p>
+        </p:txBody>
+      </p:sp>
+      <p:sp>
+        <p:nvSpPr>
+          <p:cNvPr id="9" name="Text 7"/>
+          <p:cNvSpPr/>
+          <p:nvPr/>
+        </p:nvSpPr>
+        <p:spPr>
+          <a:xfrm>
+            <a:off x="457200" y="731520"/>
+            <a:ext cx="8375904" cy="320040"/>
+          </a:xfrm>
+          <a:prstGeom prst="rect">
+            <a:avLst/>
+          </a:prstGeom>
+          <a:noFill/>
+          <a:ln/>
+        </p:spPr>
+        <p:txBody>
+          <a:bodyPr wrap="square" rtlCol="0" anchor="ctr"/>
+          <a:lstStyle/>
+          <a:p>
+            <a:pPr indent="0" marL="0">
+              <a:buNone/>
+            </a:pPr>
+            <a:r>
+              <a:rPr lang="en-US" b="1" dirty="0">
+                <a:solidFill>
+                  <a:srgbClr val="5B8DB8"/>
+                </a:solidFill>
+                <a:latin typeface="Arial" pitchFamily="34" charset="0"/>
+                <a:ea typeface="Arial" pitchFamily="34" charset="-122"/>
+                <a:cs typeface="Arial" pitchFamily="34" charset="-120"/>
+              </a:rPr>
+              <a:t>SaaS B2B · por residencia / mes · margen bruto &gt; 97 %</a:t>
+            </a:r>
+            <a:endParaRPr lang="en-US" dirty="0"/>
+          </a:p>
+        </p:txBody>
+      </p:sp>
+      <p:sp>
+        <p:nvSpPr>
+          <p:cNvPr id="10" name="Shape 8"/>
+          <p:cNvSpPr/>
+          <p:nvPr/>
+        </p:nvSpPr>
+        <p:spPr>
+          <a:xfrm>
+            <a:off x="457200" y="1097280"/>
+            <a:ext cx="8375904" cy="0"/>
+          </a:xfrm>
+          <a:prstGeom prst="line">
+            <a:avLst/>
+          </a:prstGeom>
+          <a:noFill/>
+          <a:ln w="12700">
+            <a:solidFill>
+              <a:srgbClr val="E2E8F0"/>
+            </a:solidFill>
+            <a:prstDash val="solid"/>
+          </a:ln>
+        </p:spPr>
+      </p:sp>
+      <p:sp>
+        <p:nvSpPr>
+          <p:cNvPr id="11" name="Shape 9"/>
+          <p:cNvSpPr/>
+          <p:nvPr/>
+        </p:nvSpPr>
+        <p:spPr>
+          <a:xfrm>
+            <a:off x="457200" y="1261872"/>
+            <a:ext cx="2633472" cy="4206240"/>
+          </a:xfrm>
+          <a:prstGeom prst="roundRect">
+            <a:avLst>
+              <a:gd name="adj" fmla="val 4167"/>
+            </a:avLst>
+          </a:prstGeom>
+          <a:solidFill>
+            <a:srgbClr val="F0EDE8"/>
+          </a:solidFill>
+          <a:ln w="6350">
+            <a:solidFill>
+              <a:srgbClr val="E2E8F0"/>
+            </a:solidFill>
+            <a:prstDash val="solid"/>
+          </a:ln>
+        </p:spPr>
+      </p:sp>
+      <p:sp>
+        <p:nvSpPr>
+          <p:cNvPr id="12" name="Text 10"/>
+          <p:cNvSpPr/>
+          <p:nvPr/>
+        </p:nvSpPr>
+        <p:spPr>
+          <a:xfrm>
+            <a:off x="457200" y="1417320"/>
+            <a:ext cx="2633472" cy="365760"/>
+          </a:xfrm>
+          <a:prstGeom prst="rect">
+            <a:avLst/>
+          </a:prstGeom>
+          <a:noFill/>
+          <a:ln/>
+        </p:spPr>
+        <p:txBody>
+          <a:bodyPr wrap="square" rtlCol="0" anchor="ctr"/>
+          <a:lstStyle/>
+          <a:p>
+            <a:pPr algn="ctr" indent="0" marL="0">
+              <a:buNone/>
+            </a:pPr>
+            <a:r>
+              <a:rPr lang="en-US" sz="1500" b="1" dirty="0">
+                <a:solidFill>
+                  <a:srgbClr val="2D3748"/>
+                </a:solidFill>
+                <a:latin typeface="Arial" pitchFamily="34" charset="0"/>
+                <a:ea typeface="Arial" pitchFamily="34" charset="-122"/>
+                <a:cs typeface="Arial" pitchFamily="34" charset="-120"/>
+              </a:rPr>
+              <a:t>Esencial</a:t>
+            </a:r>
+            <a:endParaRPr lang="en-US" sz="1500" dirty="0"/>
+          </a:p>
+        </p:txBody>
+      </p:sp>
+      <p:sp>
+        <p:nvSpPr>
+          <p:cNvPr id="13" name="Text 11"/>
+          <p:cNvSpPr/>
+          <p:nvPr/>
+        </p:nvSpPr>
+        <p:spPr>
+          <a:xfrm>
+            <a:off x="457200" y="1828800"/>
+            <a:ext cx="2633472" cy="640080"/>
+          </a:xfrm>
+          <a:prstGeom prst="rect">
+            <a:avLst/>
+          </a:prstGeom>
+          <a:noFill/>
+          <a:ln/>
+        </p:spPr>
+        <p:txBody>
+          <a:bodyPr wrap="square" rtlCol="0" anchor="ctr"/>
+          <a:lstStyle/>
+          <a:p>
+            <a:pPr algn="ctr" indent="0" marL="0">
+              <a:buNone/>
+            </a:pPr>
+            <a:r>
+              <a:rPr lang="en-US" sz="3200" b="1" dirty="0">
+                <a:solidFill>
+                  <a:srgbClr val="5B8DB8"/>
+                </a:solidFill>
+                <a:latin typeface="Arial" pitchFamily="34" charset="0"/>
+                <a:ea typeface="Arial" pitchFamily="34" charset="-122"/>
+                <a:cs typeface="Arial" pitchFamily="34" charset="-120"/>
+              </a:rPr>
+              <a:t>$1,490</a:t>
+            </a:r>
+            <a:endParaRPr lang="en-US" sz="3200" dirty="0"/>
+          </a:p>
+        </p:txBody>
+      </p:sp>
+      <p:sp>
+        <p:nvSpPr>
+          <p:cNvPr id="14" name="Text 12"/>
+          <p:cNvSpPr/>
+          <p:nvPr/>
+        </p:nvSpPr>
+        <p:spPr>
+          <a:xfrm>
+            <a:off x="457200" y="2487168"/>
+            <a:ext cx="2633472" cy="274320"/>
+          </a:xfrm>
+          <a:prstGeom prst="rect">
+            <a:avLst/>
+          </a:prstGeom>
+          <a:noFill/>
+          <a:ln/>
+        </p:spPr>
+        <p:txBody>
+          <a:bodyPr wrap="square" rtlCol="0" anchor="ctr"/>
+          <a:lstStyle/>
+          <a:p>
+            <a:pPr algn="ctr" indent="0" marL="0">
+              <a:buNone/>
+            </a:pPr>
+            <a:r>
+              <a:rPr lang="en-US" sz="1100" dirty="0">
+                <a:solidFill>
+                  <a:srgbClr val="718096"/>
+                </a:solidFill>
+                <a:latin typeface="Arial" pitchFamily="34" charset="0"/>
+                <a:ea typeface="Arial" pitchFamily="34" charset="-122"/>
+                <a:cs typeface="Arial" pitchFamily="34" charset="-120"/>
+              </a:rPr>
+              <a:t>MXN / mes</a:t>
+            </a:r>
+            <a:endParaRPr lang="en-US" sz="1100" dirty="0"/>
+          </a:p>
+        </p:txBody>
+      </p:sp>
+      <p:sp>
+        <p:nvSpPr>
+          <p:cNvPr id="15" name="Shape 13"/>
+          <p:cNvSpPr/>
+          <p:nvPr/>
+        </p:nvSpPr>
+        <p:spPr>
+          <a:xfrm>
+            <a:off x="640080" y="2834640"/>
+            <a:ext cx="2267712" cy="0"/>
+          </a:xfrm>
+          <a:prstGeom prst="line">
+            <a:avLst/>
+          </a:prstGeom>
+          <a:noFill/>
+          <a:ln w="6350">
+            <a:solidFill>
+              <a:srgbClr val="E2E8F0"/>
+            </a:solidFill>
+            <a:prstDash val="solid"/>
+          </a:ln>
+        </p:spPr>
+      </p:sp>
+      <p:sp>
+        <p:nvSpPr>
+          <p:cNvPr id="16" name="Text 14"/>
+          <p:cNvSpPr/>
+          <p:nvPr/>
+        </p:nvSpPr>
+        <p:spPr>
+          <a:xfrm>
+            <a:off x="594360" y="2944368"/>
+            <a:ext cx="2359152" cy="420624"/>
+          </a:xfrm>
+          <a:prstGeom prst="rect">
+            <a:avLst/>
+          </a:prstGeom>
+          <a:noFill/>
+          <a:ln/>
+        </p:spPr>
+        <p:txBody>
+          <a:bodyPr wrap="square" rtlCol="0" anchor="ctr"/>
+          <a:lstStyle/>
+          <a:p>
+            <a:pPr algn="ctr" indent="0" marL="0">
+              <a:buNone/>
+            </a:pPr>
+            <a:r>
+              <a:rPr lang="en-US" sz="1150" dirty="0">
+                <a:solidFill>
+                  <a:srgbClr val="2D3748"/>
+                </a:solidFill>
+                <a:latin typeface="Arial" pitchFamily="34" charset="0"/>
+                <a:ea typeface="Arial" pitchFamily="34" charset="-122"/>
+                <a:cs typeface="Arial" pitchFamily="34" charset="-120"/>
+              </a:rPr>
+              <a:t>Hasta 25 residentes</a:t>
+            </a:r>
+            <a:endParaRPr lang="en-US" sz="1150" dirty="0"/>
+          </a:p>
+        </p:txBody>
+      </p:sp>
+      <p:sp>
+        <p:nvSpPr>
+          <p:cNvPr id="17" name="Text 15"/>
+          <p:cNvSpPr/>
+          <p:nvPr/>
+        </p:nvSpPr>
+        <p:spPr>
+          <a:xfrm>
+            <a:off x="594360" y="3438144"/>
+            <a:ext cx="2359152" cy="420624"/>
+          </a:xfrm>
+          <a:prstGeom prst="rect">
+            <a:avLst/>
+          </a:prstGeom>
+          <a:noFill/>
+          <a:ln/>
+        </p:spPr>
+        <p:txBody>
+          <a:bodyPr wrap="square" rtlCol="0" anchor="ctr"/>
+          <a:lstStyle/>
+          <a:p>
+            <a:pPr algn="ctr" indent="0" marL="0">
+              <a:buNone/>
+            </a:pPr>
+            <a:r>
+              <a:rPr lang="en-US" sz="1150" dirty="0">
+                <a:solidFill>
+                  <a:srgbClr val="2D3748"/>
+                </a:solidFill>
+                <a:latin typeface="Arial" pitchFamily="34" charset="0"/>
+                <a:ea typeface="Arial" pitchFamily="34" charset="-122"/>
+                <a:cs typeface="Arial" pitchFamily="34" charset="-120"/>
+              </a:rPr>
+              <a:t>1 supervisor</a:t>
+            </a:r>
+            <a:endParaRPr lang="en-US" sz="1150" dirty="0"/>
+          </a:p>
+        </p:txBody>
+      </p:sp>
+      <p:sp>
+        <p:nvSpPr>
+          <p:cNvPr id="18" name="Text 16"/>
+          <p:cNvSpPr/>
+          <p:nvPr/>
+        </p:nvSpPr>
+        <p:spPr>
+          <a:xfrm>
+            <a:off x="594360" y="3931920"/>
+            <a:ext cx="2359152" cy="420624"/>
+          </a:xfrm>
+          <a:prstGeom prst="rect">
+            <a:avLst/>
+          </a:prstGeom>
+          <a:noFill/>
+          <a:ln/>
+        </p:spPr>
+        <p:txBody>
+          <a:bodyPr wrap="square" rtlCol="0" anchor="ctr"/>
+          <a:lstStyle/>
+          <a:p>
+            <a:pPr algn="ctr" indent="0" marL="0">
+              <a:buNone/>
+            </a:pPr>
+            <a:r>
+              <a:rPr lang="en-US" sz="1150" dirty="0">
+                <a:solidFill>
+                  <a:srgbClr val="2D3748"/>
+                </a:solidFill>
+                <a:latin typeface="Arial" pitchFamily="34" charset="0"/>
+                <a:ea typeface="Arial" pitchFamily="34" charset="-122"/>
+                <a:cs typeface="Arial" pitchFamily="34" charset="-120"/>
+              </a:rPr>
+              <a:t>Hasta 5 cuidadores</a:t>
+            </a:r>
+            <a:endParaRPr lang="en-US" sz="1150" dirty="0"/>
+          </a:p>
+        </p:txBody>
+      </p:sp>
+      <p:sp>
+        <p:nvSpPr>
+          <p:cNvPr id="19" name="Text 17"/>
+          <p:cNvSpPr/>
+          <p:nvPr/>
+        </p:nvSpPr>
+        <p:spPr>
+          <a:xfrm>
+            <a:off x="594360" y="4425696"/>
+            <a:ext cx="2359152" cy="420624"/>
+          </a:xfrm>
+          <a:prstGeom prst="rect">
+            <a:avLst/>
+          </a:prstGeom>
+          <a:noFill/>
+          <a:ln/>
+        </p:spPr>
+        <p:txBody>
+          <a:bodyPr wrap="square" rtlCol="0" anchor="ctr"/>
+          <a:lstStyle/>
+          <a:p>
+            <a:pPr algn="ctr" indent="0" marL="0">
+              <a:buNone/>
+            </a:pPr>
+            <a:r>
+              <a:rPr lang="en-US" sz="1150" b="1" dirty="0">
+                <a:solidFill>
+                  <a:srgbClr val="5B8DB8"/>
+                </a:solidFill>
+                <a:latin typeface="Arial" pitchFamily="34" charset="0"/>
+                <a:ea typeface="Arial" pitchFamily="34" charset="-122"/>
+                <a:cs typeface="Arial" pitchFamily="34" charset="-120"/>
+              </a:rPr>
+              <a:t>Residencias pequeñas</a:t>
+            </a:r>
+            <a:endParaRPr lang="en-US" sz="1150" dirty="0"/>
+          </a:p>
+        </p:txBody>
+      </p:sp>
+      <p:sp>
+        <p:nvSpPr>
+          <p:cNvPr id="20" name="Shape 18"/>
+          <p:cNvSpPr/>
+          <p:nvPr/>
+        </p:nvSpPr>
+        <p:spPr>
+          <a:xfrm>
+            <a:off x="3273552" y="1261872"/>
+            <a:ext cx="2633472" cy="4206240"/>
+          </a:xfrm>
+          <a:prstGeom prst="roundRect">
+            <a:avLst>
+              <a:gd name="adj" fmla="val 4167"/>
+            </a:avLst>
+          </a:prstGeom>
+          <a:solidFill>
+            <a:srgbClr val="EFF6FF"/>
+          </a:solidFill>
+          <a:ln w="19050">
+            <a:solidFill>
+              <a:srgbClr val="5B8DB8"/>
+            </a:solidFill>
+            <a:prstDash val="solid"/>
+          </a:ln>
+        </p:spPr>
+      </p:sp>
+      <p:sp>
+        <p:nvSpPr>
+          <p:cNvPr id="21" name="Shape 19"/>
+          <p:cNvSpPr/>
+          <p:nvPr/>
+        </p:nvSpPr>
+        <p:spPr>
+          <a:xfrm>
+            <a:off x="3639312" y="1188720"/>
+            <a:ext cx="1874520" cy="292608"/>
+          </a:xfrm>
+          <a:prstGeom prst="roundRect">
+            <a:avLst>
+              <a:gd name="adj" fmla="val 18750"/>
+            </a:avLst>
+          </a:prstGeom>
+          <a:solidFill>
+            <a:srgbClr val="5B8DB8"/>
+          </a:solidFill>
+          <a:ln w="12700">
+            <a:solidFill>
+              <a:srgbClr val="5B8DB8"/>
+            </a:solidFill>
+            <a:prstDash val="solid"/>
+          </a:ln>
+        </p:spPr>
+      </p:sp>
+      <p:sp>
+        <p:nvSpPr>
+          <p:cNvPr id="22" name="Text 20"/>
+          <p:cNvSpPr/>
+          <p:nvPr/>
+        </p:nvSpPr>
+        <p:spPr>
+          <a:xfrm>
+            <a:off x="3639312" y="1188720"/>
+            <a:ext cx="1874520" cy="292608"/>
+          </a:xfrm>
+          <a:prstGeom prst="rect">
+            <a:avLst/>
+          </a:prstGeom>
+          <a:noFill/>
+          <a:ln/>
+        </p:spPr>
+        <p:txBody>
+          <a:bodyPr wrap="square" rtlCol="0" anchor="ctr"/>
+          <a:lstStyle/>
+          <a:p>
+            <a:pPr algn="ctr" indent="0" marL="0">
+              <a:buNone/>
+            </a:pPr>
+            <a:r>
+              <a:rPr lang="en-US" sz="900" b="1" dirty="0">
+                <a:solidFill>
+                  <a:srgbClr val="FFFFFF"/>
+                </a:solidFill>
+                <a:latin typeface="Arial" pitchFamily="34" charset="0"/>
+                <a:ea typeface="Arial" pitchFamily="34" charset="-122"/>
+                <a:cs typeface="Arial" pitchFamily="34" charset="-120"/>
+              </a:rPr>
+              <a:t>Más popular</a:t>
+            </a:r>
+            <a:endParaRPr lang="en-US" sz="900" dirty="0"/>
+          </a:p>
+        </p:txBody>
+      </p:sp>
+      <p:sp>
+        <p:nvSpPr>
+          <p:cNvPr id="23" name="Text 21"/>
+          <p:cNvSpPr/>
+          <p:nvPr/>
+        </p:nvSpPr>
+        <p:spPr>
+          <a:xfrm>
+            <a:off x="3273552" y="1417320"/>
+            <a:ext cx="2633472" cy="365760"/>
+          </a:xfrm>
+          <a:prstGeom prst="rect">
+            <a:avLst/>
+          </a:prstGeom>
+          <a:noFill/>
+          <a:ln/>
+        </p:spPr>
+        <p:txBody>
+          <a:bodyPr wrap="square" rtlCol="0" anchor="ctr"/>
+          <a:lstStyle/>
+          <a:p>
+            <a:pPr algn="ctr" indent="0" marL="0">
+              <a:buNone/>
+            </a:pPr>
+            <a:r>
+              <a:rPr lang="en-US" sz="1500" b="1" dirty="0">
+                <a:solidFill>
+                  <a:srgbClr val="2D3748"/>
+                </a:solidFill>
+                <a:latin typeface="Arial" pitchFamily="34" charset="0"/>
+                <a:ea typeface="Arial" pitchFamily="34" charset="-122"/>
+                <a:cs typeface="Arial" pitchFamily="34" charset="-120"/>
+              </a:rPr>
+              <a:t>Profesional</a:t>
+            </a:r>
+            <a:endParaRPr lang="en-US" sz="1500" dirty="0"/>
+          </a:p>
+        </p:txBody>
+      </p:sp>
+      <p:sp>
+        <p:nvSpPr>
+          <p:cNvPr id="24" name="Text 22"/>
+          <p:cNvSpPr/>
+          <p:nvPr/>
+        </p:nvSpPr>
+        <p:spPr>
+          <a:xfrm>
+            <a:off x="3273552" y="1828800"/>
+            <a:ext cx="2633472" cy="640080"/>
+          </a:xfrm>
+          <a:prstGeom prst="rect">
+            <a:avLst/>
+          </a:prstGeom>
+          <a:noFill/>
+          <a:ln/>
+        </p:spPr>
+        <p:txBody>
+          <a:bodyPr wrap="square" rtlCol="0" anchor="ctr"/>
+          <a:lstStyle/>
+          <a:p>
+            <a:pPr algn="ctr" indent="0" marL="0">
+              <a:buNone/>
+            </a:pPr>
+            <a:r>
+              <a:rPr lang="en-US" sz="3200" b="1" dirty="0">
+                <a:solidFill>
+                  <a:srgbClr val="3A6B96"/>
+                </a:solidFill>
+                <a:latin typeface="Arial" pitchFamily="34" charset="0"/>
+                <a:ea typeface="Arial" pitchFamily="34" charset="-122"/>
+                <a:cs typeface="Arial" pitchFamily="34" charset="-120"/>
+              </a:rPr>
+              <a:t>$3,490</a:t>
+            </a:r>
+            <a:endParaRPr lang="en-US" sz="3200" dirty="0"/>
+          </a:p>
+        </p:txBody>
+      </p:sp>
+      <p:sp>
+        <p:nvSpPr>
+          <p:cNvPr id="25" name="Text 23"/>
+          <p:cNvSpPr/>
+          <p:nvPr/>
+        </p:nvSpPr>
+        <p:spPr>
+          <a:xfrm>
+            <a:off x="3273552" y="2487168"/>
+            <a:ext cx="2633472" cy="274320"/>
+          </a:xfrm>
+          <a:prstGeom prst="rect">
+            <a:avLst/>
+          </a:prstGeom>
+          <a:noFill/>
+          <a:ln/>
+        </p:spPr>
+        <p:txBody>
+          <a:bodyPr wrap="square" rtlCol="0" anchor="ctr"/>
+          <a:lstStyle/>
+          <a:p>
+            <a:pPr algn="ctr" indent="0" marL="0">
+              <a:buNone/>
+            </a:pPr>
+            <a:r>
+              <a:rPr lang="en-US" sz="1100" dirty="0">
+                <a:solidFill>
+                  <a:srgbClr val="718096"/>
+                </a:solidFill>
+                <a:latin typeface="Arial" pitchFamily="34" charset="0"/>
+                <a:ea typeface="Arial" pitchFamily="34" charset="-122"/>
+                <a:cs typeface="Arial" pitchFamily="34" charset="-120"/>
+              </a:rPr>
+              <a:t>MXN / mes</a:t>
+            </a:r>
+            <a:endParaRPr lang="en-US" sz="1100" dirty="0"/>
+          </a:p>
+        </p:txBody>
+      </p:sp>
+      <p:sp>
+        <p:nvSpPr>
+          <p:cNvPr id="26" name="Shape 24"/>
+          <p:cNvSpPr/>
+          <p:nvPr/>
+        </p:nvSpPr>
+        <p:spPr>
+          <a:xfrm>
+            <a:off x="3456432" y="2834640"/>
+            <a:ext cx="2267712" cy="0"/>
+          </a:xfrm>
+          <a:prstGeom prst="line">
+            <a:avLst/>
+          </a:prstGeom>
+          <a:noFill/>
+          <a:ln w="6350">
+            <a:solidFill>
+              <a:srgbClr val="E2E8F0"/>
+            </a:solidFill>
+            <a:prstDash val="solid"/>
+          </a:ln>
+        </p:spPr>
+      </p:sp>
+      <p:sp>
+        <p:nvSpPr>
+          <p:cNvPr id="27" name="Text 25"/>
+          <p:cNvSpPr/>
+          <p:nvPr/>
+        </p:nvSpPr>
+        <p:spPr>
+          <a:xfrm>
+            <a:off x="3410712" y="2944368"/>
+            <a:ext cx="2359152" cy="420624"/>
+          </a:xfrm>
+          <a:prstGeom prst="rect">
+            <a:avLst/>
+          </a:prstGeom>
+          <a:noFill/>
+          <a:ln/>
+        </p:spPr>
+        <p:txBody>
+          <a:bodyPr wrap="square" rtlCol="0" anchor="ctr"/>
+          <a:lstStyle/>
+          <a:p>
+            <a:pPr algn="ctr" indent="0" marL="0">
+              <a:buNone/>
+            </a:pPr>
+            <a:r>
+              <a:rPr lang="en-US" sz="1150" dirty="0">
+                <a:solidFill>
+                  <a:srgbClr val="2D3748"/>
+                </a:solidFill>
+                <a:latin typeface="Arial" pitchFamily="34" charset="0"/>
+                <a:ea typeface="Arial" pitchFamily="34" charset="-122"/>
+                <a:cs typeface="Arial" pitchFamily="34" charset="-120"/>
+              </a:rPr>
+              <a:t>Hasta 75 residentes</a:t>
+            </a:r>
+            <a:endParaRPr lang="en-US" sz="1150" dirty="0"/>
+          </a:p>
+        </p:txBody>
+      </p:sp>
+      <p:sp>
+        <p:nvSpPr>
+          <p:cNvPr id="28" name="Text 26"/>
+          <p:cNvSpPr/>
+          <p:nvPr/>
+        </p:nvSpPr>
+        <p:spPr>
+          <a:xfrm>
+            <a:off x="3410712" y="3438144"/>
+            <a:ext cx="2359152" cy="420624"/>
+          </a:xfrm>
+          <a:prstGeom prst="rect">
+            <a:avLst/>
+          </a:prstGeom>
+          <a:noFill/>
+          <a:ln/>
+        </p:spPr>
+        <p:txBody>
+          <a:bodyPr wrap="square" rtlCol="0" anchor="ctr"/>
+          <a:lstStyle/>
+          <a:p>
+            <a:pPr algn="ctr" indent="0" marL="0">
+              <a:buNone/>
+            </a:pPr>
+            <a:r>
+              <a:rPr lang="en-US" sz="1150" dirty="0">
+                <a:solidFill>
+                  <a:srgbClr val="2D3748"/>
+                </a:solidFill>
+                <a:latin typeface="Arial" pitchFamily="34" charset="0"/>
+                <a:ea typeface="Arial" pitchFamily="34" charset="-122"/>
+                <a:cs typeface="Arial" pitchFamily="34" charset="-120"/>
+              </a:rPr>
+              <a:t>Hasta 3 supervisores</a:t>
+            </a:r>
+            <a:endParaRPr lang="en-US" sz="1150" dirty="0"/>
+          </a:p>
+        </p:txBody>
+      </p:sp>
+      <p:sp>
+        <p:nvSpPr>
+          <p:cNvPr id="29" name="Text 27"/>
+          <p:cNvSpPr/>
+          <p:nvPr/>
+        </p:nvSpPr>
+        <p:spPr>
+          <a:xfrm>
+            <a:off x="3410712" y="3931920"/>
+            <a:ext cx="2359152" cy="420624"/>
+          </a:xfrm>
+          <a:prstGeom prst="rect">
+            <a:avLst/>
+          </a:prstGeom>
+          <a:noFill/>
+          <a:ln/>
+        </p:spPr>
+        <p:txBody>
+          <a:bodyPr wrap="square" rtlCol="0" anchor="ctr"/>
+          <a:lstStyle/>
+          <a:p>
+            <a:pPr algn="ctr" indent="0" marL="0">
+              <a:buNone/>
+            </a:pPr>
+            <a:r>
+              <a:rPr lang="en-US" sz="1150" dirty="0">
+                <a:solidFill>
+                  <a:srgbClr val="2D3748"/>
+                </a:solidFill>
+                <a:latin typeface="Arial" pitchFamily="34" charset="0"/>
+                <a:ea typeface="Arial" pitchFamily="34" charset="-122"/>
+                <a:cs typeface="Arial" pitchFamily="34" charset="-120"/>
+              </a:rPr>
+              <a:t>Hasta 15 cuidadores</a:t>
+            </a:r>
+            <a:endParaRPr lang="en-US" sz="1150" dirty="0"/>
+          </a:p>
+        </p:txBody>
+      </p:sp>
+      <p:sp>
+        <p:nvSpPr>
+          <p:cNvPr id="30" name="Text 28"/>
+          <p:cNvSpPr/>
+          <p:nvPr/>
+        </p:nvSpPr>
+        <p:spPr>
+          <a:xfrm>
+            <a:off x="3410712" y="4425696"/>
+            <a:ext cx="2359152" cy="420624"/>
+          </a:xfrm>
+          <a:prstGeom prst="rect">
+            <a:avLst/>
+          </a:prstGeom>
+          <a:noFill/>
+          <a:ln/>
+        </p:spPr>
+        <p:txBody>
+          <a:bodyPr wrap="square" rtlCol="0" anchor="ctr"/>
+          <a:lstStyle/>
+          <a:p>
+            <a:pPr algn="ctr" indent="0" marL="0">
+              <a:buNone/>
+            </a:pPr>
+            <a:r>
+              <a:rPr lang="en-US" sz="1150" b="1" dirty="0">
+                <a:solidFill>
+                  <a:srgbClr val="5B8DB8"/>
+                </a:solidFill>
+                <a:latin typeface="Arial" pitchFamily="34" charset="0"/>
+                <a:ea typeface="Arial" pitchFamily="34" charset="-122"/>
+                <a:cs typeface="Arial" pitchFamily="34" charset="-120"/>
+              </a:rPr>
+              <a:t>Residencias medianas</a:t>
+            </a:r>
+            <a:endParaRPr lang="en-US" sz="1150" dirty="0"/>
+          </a:p>
+        </p:txBody>
+      </p:sp>
+      <p:sp>
+        <p:nvSpPr>
+          <p:cNvPr id="31" name="Shape 29"/>
+          <p:cNvSpPr/>
+          <p:nvPr/>
+        </p:nvSpPr>
+        <p:spPr>
+          <a:xfrm>
+            <a:off x="6089904" y="1261872"/>
+            <a:ext cx="2633472" cy="4206240"/>
+          </a:xfrm>
+          <a:prstGeom prst="roundRect">
+            <a:avLst>
+              <a:gd name="adj" fmla="val 4167"/>
+            </a:avLst>
+          </a:prstGeom>
+          <a:solidFill>
+            <a:srgbClr val="F0EDE8"/>
+          </a:solidFill>
+          <a:ln w="6350">
+            <a:solidFill>
+              <a:srgbClr val="E2E8F0"/>
+            </a:solidFill>
+            <a:prstDash val="solid"/>
+          </a:ln>
+        </p:spPr>
+      </p:sp>
+      <p:sp>
+        <p:nvSpPr>
+          <p:cNvPr id="32" name="Text 30"/>
+          <p:cNvSpPr/>
+          <p:nvPr/>
+        </p:nvSpPr>
+        <p:spPr>
+          <a:xfrm>
+            <a:off x="6089904" y="1417320"/>
+            <a:ext cx="2633472" cy="365760"/>
+          </a:xfrm>
+          <a:prstGeom prst="rect">
+            <a:avLst/>
+          </a:prstGeom>
+          <a:noFill/>
+          <a:ln/>
+        </p:spPr>
+        <p:txBody>
+          <a:bodyPr wrap="square" rtlCol="0" anchor="ctr"/>
+          <a:lstStyle/>
+          <a:p>
+            <a:pPr algn="ctr" indent="0" marL="0">
+              <a:buNone/>
+            </a:pPr>
+            <a:r>
+              <a:rPr lang="en-US" sz="1500" b="1" dirty="0">
+                <a:solidFill>
+                  <a:srgbClr val="2D3748"/>
+                </a:solidFill>
+                <a:latin typeface="Arial" pitchFamily="34" charset="0"/>
+                <a:ea typeface="Arial" pitchFamily="34" charset="-122"/>
+                <a:cs typeface="Arial" pitchFamily="34" charset="-120"/>
+              </a:rPr>
+              <a:t>Institucional</a:t>
+            </a:r>
+            <a:endParaRPr lang="en-US" sz="1500" dirty="0"/>
+          </a:p>
+        </p:txBody>
+      </p:sp>
+      <p:sp>
+        <p:nvSpPr>
+          <p:cNvPr id="33" name="Text 31"/>
+          <p:cNvSpPr/>
+          <p:nvPr/>
+        </p:nvSpPr>
+        <p:spPr>
+          <a:xfrm>
+            <a:off x="6089904" y="1828800"/>
+            <a:ext cx="2633472" cy="640080"/>
+          </a:xfrm>
+          <a:prstGeom prst="rect">
+            <a:avLst/>
+          </a:prstGeom>
+          <a:noFill/>
+          <a:ln/>
+        </p:spPr>
+        <p:txBody>
+          <a:bodyPr wrap="square" rtlCol="0" anchor="ctr"/>
+          <a:lstStyle/>
+          <a:p>
+            <a:pPr algn="ctr" indent="0" marL="0">
+              <a:buNone/>
+            </a:pPr>
+            <a:r>
+              <a:rPr lang="en-US" sz="3200" b="1" dirty="0">
+                <a:solidFill>
+                  <a:srgbClr val="5B8DB8"/>
+                </a:solidFill>
+                <a:latin typeface="Arial" pitchFamily="34" charset="0"/>
+                <a:ea typeface="Arial" pitchFamily="34" charset="-122"/>
+                <a:cs typeface="Arial" pitchFamily="34" charset="-120"/>
+              </a:rPr>
+              <a:t>$6,990</a:t>
+            </a:r>
+            <a:endParaRPr lang="en-US" sz="3200" dirty="0"/>
+          </a:p>
+        </p:txBody>
+      </p:sp>
+      <p:sp>
+        <p:nvSpPr>
+          <p:cNvPr id="34" name="Text 32"/>
+          <p:cNvSpPr/>
+          <p:nvPr/>
+        </p:nvSpPr>
+        <p:spPr>
+          <a:xfrm>
+            <a:off x="6089904" y="2487168"/>
+            <a:ext cx="2633472" cy="274320"/>
+          </a:xfrm>
+          <a:prstGeom prst="rect">
+            <a:avLst/>
+          </a:prstGeom>
+          <a:noFill/>
+          <a:ln/>
+        </p:spPr>
+        <p:txBody>
+          <a:bodyPr wrap="square" rtlCol="0" anchor="ctr"/>
+          <a:lstStyle/>
+          <a:p>
+            <a:pPr algn="ctr" indent="0" marL="0">
+              <a:buNone/>
+            </a:pPr>
+            <a:r>
+              <a:rPr lang="en-US" sz="1100" dirty="0">
+                <a:solidFill>
+                  <a:srgbClr val="718096"/>
+                </a:solidFill>
+                <a:latin typeface="Arial" pitchFamily="34" charset="0"/>
+                <a:ea typeface="Arial" pitchFamily="34" charset="-122"/>
+                <a:cs typeface="Arial" pitchFamily="34" charset="-120"/>
+              </a:rPr>
+              <a:t>MXN / mes</a:t>
+            </a:r>
+            <a:endParaRPr lang="en-US" sz="1100" dirty="0"/>
+          </a:p>
+        </p:txBody>
+      </p:sp>
+      <p:sp>
+        <p:nvSpPr>
+          <p:cNvPr id="35" name="Shape 33"/>
+          <p:cNvSpPr/>
+          <p:nvPr/>
+        </p:nvSpPr>
+        <p:spPr>
+          <a:xfrm>
+            <a:off x="6272784" y="2834640"/>
+            <a:ext cx="2267712" cy="0"/>
+          </a:xfrm>
+          <a:prstGeom prst="line">
+            <a:avLst/>
+          </a:prstGeom>
+          <a:noFill/>
+          <a:ln w="6350">
+            <a:solidFill>
+              <a:srgbClr val="E2E8F0"/>
+            </a:solidFill>
+            <a:prstDash val="solid"/>
+          </a:ln>
+        </p:spPr>
+      </p:sp>
+      <p:sp>
+        <p:nvSpPr>
+          <p:cNvPr id="36" name="Text 34"/>
+          <p:cNvSpPr/>
+          <p:nvPr/>
+        </p:nvSpPr>
+        <p:spPr>
+          <a:xfrm>
+            <a:off x="6227064" y="2944368"/>
+            <a:ext cx="2359152" cy="420624"/>
+          </a:xfrm>
+          <a:prstGeom prst="rect">
+            <a:avLst/>
+          </a:prstGeom>
+          <a:noFill/>
+          <a:ln/>
+        </p:spPr>
+        <p:txBody>
+          <a:bodyPr wrap="square" rtlCol="0" anchor="ctr"/>
+          <a:lstStyle/>
+          <a:p>
+            <a:pPr algn="ctr" indent="0" marL="0">
+              <a:buNone/>
+            </a:pPr>
+            <a:r>
+              <a:rPr lang="en-US" sz="1150" dirty="0">
+                <a:solidFill>
+                  <a:srgbClr val="2D3748"/>
+                </a:solidFill>
+                <a:latin typeface="Arial" pitchFamily="34" charset="0"/>
+                <a:ea typeface="Arial" pitchFamily="34" charset="-122"/>
+                <a:cs typeface="Arial" pitchFamily="34" charset="-120"/>
+              </a:rPr>
+              <a:t>Sin límite</a:t>
+            </a:r>
+            <a:endParaRPr lang="en-US" sz="1150" dirty="0"/>
+          </a:p>
+        </p:txBody>
+      </p:sp>
+      <p:sp>
+        <p:nvSpPr>
+          <p:cNvPr id="37" name="Text 35"/>
+          <p:cNvSpPr/>
+          <p:nvPr/>
+        </p:nvSpPr>
+        <p:spPr>
+          <a:xfrm>
+            <a:off x="6227064" y="3438144"/>
+            <a:ext cx="2359152" cy="420624"/>
+          </a:xfrm>
+          <a:prstGeom prst="rect">
+            <a:avLst/>
+          </a:prstGeom>
+          <a:noFill/>
+          <a:ln/>
+        </p:spPr>
+        <p:txBody>
+          <a:bodyPr wrap="square" rtlCol="0" anchor="ctr"/>
+          <a:lstStyle/>
+          <a:p>
+            <a:pPr algn="ctr" indent="0" marL="0">
+              <a:buNone/>
+            </a:pPr>
+            <a:r>
+              <a:rPr lang="en-US" sz="1150" dirty="0">
+                <a:solidFill>
+                  <a:srgbClr val="2D3748"/>
+                </a:solidFill>
+                <a:latin typeface="Arial" pitchFamily="34" charset="0"/>
+                <a:ea typeface="Arial" pitchFamily="34" charset="-122"/>
+                <a:cs typeface="Arial" pitchFamily="34" charset="-120"/>
+              </a:rPr>
+              <a:t>Sin límite</a:t>
+            </a:r>
+            <a:endParaRPr lang="en-US" sz="1150" dirty="0"/>
+          </a:p>
+        </p:txBody>
+      </p:sp>
+      <p:sp>
+        <p:nvSpPr>
+          <p:cNvPr id="38" name="Text 36"/>
+          <p:cNvSpPr/>
+          <p:nvPr/>
+        </p:nvSpPr>
+        <p:spPr>
+          <a:xfrm>
+            <a:off x="6227064" y="3931920"/>
+            <a:ext cx="2359152" cy="420624"/>
+          </a:xfrm>
+          <a:prstGeom prst="rect">
+            <a:avLst/>
+          </a:prstGeom>
+          <a:noFill/>
+          <a:ln/>
+        </p:spPr>
+        <p:txBody>
+          <a:bodyPr wrap="square" rtlCol="0" anchor="ctr"/>
+          <a:lstStyle/>
+          <a:p>
+            <a:pPr algn="ctr" indent="0" marL="0">
+              <a:buNone/>
+            </a:pPr>
+            <a:r>
+              <a:rPr lang="en-US" sz="1150" dirty="0">
+                <a:solidFill>
+                  <a:srgbClr val="2D3748"/>
+                </a:solidFill>
+                <a:latin typeface="Arial" pitchFamily="34" charset="0"/>
+                <a:ea typeface="Arial" pitchFamily="34" charset="-122"/>
+                <a:cs typeface="Arial" pitchFamily="34" charset="-120"/>
+              </a:rPr>
+              <a:t>Sin límite</a:t>
+            </a:r>
+            <a:endParaRPr lang="en-US" sz="1150" dirty="0"/>
+          </a:p>
+        </p:txBody>
+      </p:sp>
+      <p:sp>
+        <p:nvSpPr>
+          <p:cNvPr id="39" name="Text 37"/>
+          <p:cNvSpPr/>
+          <p:nvPr/>
+        </p:nvSpPr>
+        <p:spPr>
+          <a:xfrm>
+            <a:off x="6227064" y="4425696"/>
+            <a:ext cx="2359152" cy="420624"/>
+          </a:xfrm>
+          <a:prstGeom prst="rect">
+            <a:avLst/>
+          </a:prstGeom>
+          <a:noFill/>
+          <a:ln/>
+        </p:spPr>
+        <p:txBody>
+          <a:bodyPr wrap="square" rtlCol="0" anchor="ctr"/>
+          <a:lstStyle/>
+          <a:p>
+            <a:pPr algn="ctr" indent="0" marL="0">
+              <a:buNone/>
+            </a:pPr>
+            <a:r>
+              <a:rPr lang="en-US" sz="1150" b="1" dirty="0">
+                <a:solidFill>
+                  <a:srgbClr val="5B8DB8"/>
+                </a:solidFill>
+                <a:latin typeface="Arial" pitchFamily="34" charset="0"/>
+                <a:ea typeface="Arial" pitchFamily="34" charset="-122"/>
+                <a:cs typeface="Arial" pitchFamily="34" charset="-120"/>
+              </a:rPr>
+              <a:t>Cadenas · soporte prioritario</a:t>
+            </a:r>
+            <a:endParaRPr lang="en-US" sz="1150" dirty="0"/>
+          </a:p>
+        </p:txBody>
+      </p:sp>
+      <p:sp>
+        <p:nvSpPr>
+          <p:cNvPr id="40" name="Text 38"/>
+          <p:cNvSpPr/>
+          <p:nvPr/>
+        </p:nvSpPr>
+        <p:spPr>
+          <a:xfrm>
+            <a:off x="457200" y="6291072"/>
+            <a:ext cx="8375904" cy="201168"/>
+          </a:xfrm>
+          <a:prstGeom prst="rect">
+            <a:avLst/>
+          </a:prstGeom>
+          <a:noFill/>
+          <a:ln/>
+        </p:spPr>
+        <p:txBody>
+          <a:bodyPr wrap="square" rtlCol="0" anchor="ctr"/>
+          <a:lstStyle/>
+          <a:p>
+            <a:pPr algn="l" indent="0" marL="0">
+              <a:buNone/>
+            </a:pPr>
+            <a:r>
+              <a:rPr lang="en-US" dirty="0">
+                <a:solidFill>
+                  <a:srgbClr val="718096"/>
+                </a:solidFill>
+                <a:latin typeface="Arial" pitchFamily="34" charset="0"/>
+                <a:ea typeface="Arial" pitchFamily="34" charset="-122"/>
+                <a:cs typeface="Arial" pitchFamily="34" charset="-120"/>
+              </a:rPr>
+              <a:t>⚠️ Precios de referencia — no validados con clientes. Declarar ante jueces.</a:t>
+            </a:r>
+            <a:endParaRPr lang="en-US" dirty="0"/>
+          </a:p>
+        </p:txBody>
+      </p:sp>
+    </p:spTree>
+  </p:cSld>
+  <p:clrMapOvr>
+    <a:masterClrMapping/>
+  </p:clrMapOvr>
+</p:sld>
+</file>
+
 <file path=ppt/slides/slide2.xml><?xml version="1.0" encoding="utf-8"?>
 <p:sld xmlns:a="http://schemas.openxmlformats.org/drawingml/2006/main" xmlns:r="http://schemas.openxmlformats.org/officeDocument/2006/relationships" xmlns:p="http://schemas.openxmlformats.org/presentationml/2006/main">
   <p:cSld name="Slide 2">

</xml_diff>

<commit_message>
E3: deck slide 12 — IA operativa y ciberseguridad GCP + Gemini API
Co-Authored-By: Claude Sonnet 4.6 <noreply@anthropic.com>
</commit_message>
<xml_diff>
--- a/business/CareSignal_Pitch_Deck.pptx
+++ b/business/CareSignal_Pitch_Deck.pptx
@@ -16,9 +16,10 @@
     <p:sldId id="264" r:id="rId10"/>
     <p:sldId id="265" r:id="rId11"/>
     <p:sldId id="266" r:id="rId12"/>
+    <p:sldId id="267" r:id="rId13"/>
   </p:sldIdLst>
   <p:notesMasterIdLst>
-    <p:notesMasterId r:id="rId13"/>
+    <p:notesMasterId r:id="rId14"/>
   </p:notesMasterIdLst>
   <p:sldSz cx="12192000" cy="6858000"/>
   <p:notesSz cx="6858000" cy="12192000"/>
@@ -712,6 +713,94 @@
             <a:fld id="{F7021451-1387-4CA6-816F-3879F97B5CBC}" type="slidenum">
               <a:rPr lang="en-US"/>
               <a:t>11</a:t>
+            </a:fld>
+            <a:endParaRPr lang="en-US"/>
+          </a:p>
+        </p:txBody>
+      </p:sp>
+    </p:spTree>
+    <p:extLst>
+      <p:ext uri="{BB962C8B-B14F-4D97-AF65-F5344CB8AC3E}">
+        <p14:creationId xmlns:p14="http://schemas.microsoft.com/office/powerpoint/2010/main" val="1024086991"/>
+      </p:ext>
+    </p:extLst>
+  </p:cSld>
+  <p:clrMapOvr>
+    <a:masterClrMapping/>
+  </p:clrMapOvr>
+</p:notes>
+</file>
+
+<file path=ppt/notesSlides/notesSlide12.xml><?xml version="1.0" encoding="utf-8"?>
+<p:notes xmlns:a="http://schemas.openxmlformats.org/drawingml/2006/main" xmlns:r="http://schemas.openxmlformats.org/officeDocument/2006/relationships" xmlns:p="http://schemas.openxmlformats.org/presentationml/2006/main">
+  <p:cSld>
+    <p:spTree>
+      <p:nvGrpSpPr>
+        <p:cNvPr id="1" name=""/>
+        <p:cNvGrpSpPr/>
+        <p:nvPr/>
+      </p:nvGrpSpPr>
+      <p:grpSpPr>
+        <a:xfrm>
+          <a:off x="0" y="0"/>
+          <a:ext cx="0" cy="0"/>
+          <a:chOff x="0" y="0"/>
+          <a:chExt cx="0" cy="0"/>
+        </a:xfrm>
+      </p:grpSpPr>
+      <p:sp>
+        <p:nvSpPr>
+          <p:cNvPr id="2" name="Slide Image Placeholder 1"/>
+          <p:cNvSpPr>
+            <a:spLocks noGrp="1" noRot="1" noChangeAspect="1"/>
+          </p:cNvSpPr>
+          <p:nvPr>
+            <p:ph type="sldImg"/>
+          </p:nvPr>
+        </p:nvSpPr>
+        <p:spPr/>
+      </p:sp>
+      <p:sp>
+        <p:nvSpPr>
+          <p:cNvPr id="3" name="Notes Placeholder 2"/>
+          <p:cNvSpPr>
+            <a:spLocks noGrp="1"/>
+          </p:cNvSpPr>
+          <p:nvPr>
+            <p:ph type="body" idx="1"/>
+          </p:nvPr>
+        </p:nvSpPr>
+        <p:spPr/>
+        <p:txBody>
+          <a:bodyPr/>
+          <a:lstStyle/>
+          <a:p>
+            <a:r>
+              <a:rPr lang="en-US" dirty="0"/>
+              <a:t/>
+            </a:r>
+            <a:endParaRPr lang="en-US" dirty="0"/>
+          </a:p>
+        </p:txBody>
+      </p:sp>
+      <p:sp>
+        <p:nvSpPr>
+          <p:cNvPr id="4" name="Slide Number Placeholder 3"/>
+          <p:cNvSpPr>
+            <a:spLocks noGrp="1"/>
+          </p:cNvSpPr>
+          <p:nvPr>
+            <p:ph type="sldNum" sz="quarter" idx="10"/>
+          </p:nvPr>
+        </p:nvSpPr>
+        <p:spPr/>
+        <p:txBody>
+          <a:bodyPr/>
+          <a:lstStyle/>
+          <a:p>
+            <a:fld id="{F7021451-1387-4CA6-816F-3879F97B5CBC}" type="slidenum">
+              <a:rPr lang="en-US"/>
+              <a:t>12</a:t>
             </a:fld>
             <a:endParaRPr lang="en-US"/>
           </a:p>
@@ -5469,6 +5558,1399 @@
 </p:sld>
 </file>
 
+<file path=ppt/slides/slide12.xml><?xml version="1.0" encoding="utf-8"?>
+<p:sld xmlns:a="http://schemas.openxmlformats.org/drawingml/2006/main" xmlns:r="http://schemas.openxmlformats.org/officeDocument/2006/relationships" xmlns:p="http://schemas.openxmlformats.org/presentationml/2006/main">
+  <p:cSld name="Slide 12">
+    <p:spTree>
+      <p:nvGrpSpPr>
+        <p:cNvPr id="1" name=""/>
+        <p:cNvGrpSpPr/>
+        <p:nvPr/>
+      </p:nvGrpSpPr>
+      <p:grpSpPr>
+        <a:xfrm>
+          <a:off x="0" y="0"/>
+          <a:ext cx="0" cy="0"/>
+          <a:chOff x="0" y="0"/>
+          <a:chExt cx="0" cy="0"/>
+        </a:xfrm>
+      </p:grpSpPr>
+      <p:sp>
+        <p:nvSpPr>
+          <p:cNvPr id="2" name="Shape 0"/>
+          <p:cNvSpPr/>
+          <p:nvPr/>
+        </p:nvSpPr>
+        <p:spPr>
+          <a:xfrm>
+            <a:off x="0" y="0"/>
+            <a:ext cx="12192000" cy="6858000"/>
+          </a:xfrm>
+          <a:prstGeom prst="rect">
+            <a:avLst/>
+          </a:prstGeom>
+          <a:solidFill>
+            <a:srgbClr val="FAFAF8"/>
+          </a:solidFill>
+          <a:ln w="12700">
+            <a:solidFill>
+              <a:srgbClr val="FAFAF8"/>
+            </a:solidFill>
+            <a:prstDash val="solid"/>
+          </a:ln>
+        </p:spPr>
+      </p:sp>
+      <p:sp>
+        <p:nvSpPr>
+          <p:cNvPr id="3" name="Shape 1"/>
+          <p:cNvSpPr/>
+          <p:nvPr/>
+        </p:nvSpPr>
+        <p:spPr>
+          <a:xfrm>
+            <a:off x="8138160" y="0"/>
+            <a:ext cx="694944" cy="6858000"/>
+          </a:xfrm>
+          <a:prstGeom prst="rect">
+            <a:avLst/>
+          </a:prstGeom>
+          <a:solidFill>
+            <a:srgbClr val="A8C4DC">
+              <a:alpha val="12000"/>
+            </a:srgbClr>
+          </a:solidFill>
+          <a:ln w="12700">
+            <a:solidFill>
+              <a:srgbClr val="A8C4DC">
+                <a:alpha val="12000"/>
+              </a:srgbClr>
+            </a:solidFill>
+            <a:prstDash val="solid"/>
+          </a:ln>
+        </p:spPr>
+      </p:sp>
+      <p:sp>
+        <p:nvSpPr>
+          <p:cNvPr id="4" name="Shape 2"/>
+          <p:cNvSpPr/>
+          <p:nvPr/>
+        </p:nvSpPr>
+        <p:spPr>
+          <a:xfrm>
+            <a:off x="3474720" y="5120640"/>
+            <a:ext cx="2377440" cy="2377440"/>
+          </a:xfrm>
+          <a:prstGeom prst="ellipse">
+            <a:avLst/>
+          </a:prstGeom>
+          <a:solidFill>
+            <a:srgbClr val="C4786A">
+              <a:alpha val="10000"/>
+            </a:srgbClr>
+          </a:solidFill>
+          <a:ln w="12700">
+            <a:solidFill>
+              <a:srgbClr val="C4786A">
+                <a:alpha val="10000"/>
+              </a:srgbClr>
+            </a:solidFill>
+            <a:prstDash val="solid"/>
+          </a:ln>
+        </p:spPr>
+      </p:sp>
+      <p:sp>
+        <p:nvSpPr>
+          <p:cNvPr id="5" name="Shape 3"/>
+          <p:cNvSpPr/>
+          <p:nvPr/>
+        </p:nvSpPr>
+        <p:spPr>
+          <a:xfrm>
+            <a:off x="0" y="0"/>
+            <a:ext cx="12192000" cy="54864"/>
+          </a:xfrm>
+          <a:prstGeom prst="rect">
+            <a:avLst/>
+          </a:prstGeom>
+          <a:solidFill>
+            <a:srgbClr val="5B8DB8"/>
+          </a:solidFill>
+          <a:ln w="12700">
+            <a:solidFill>
+              <a:srgbClr val="5B8DB8"/>
+            </a:solidFill>
+            <a:prstDash val="solid"/>
+          </a:ln>
+        </p:spPr>
+      </p:sp>
+      <p:sp>
+        <p:nvSpPr>
+          <p:cNvPr id="6" name="Shape 4"/>
+          <p:cNvSpPr/>
+          <p:nvPr/>
+        </p:nvSpPr>
+        <p:spPr>
+          <a:xfrm>
+            <a:off x="0" y="6528816"/>
+            <a:ext cx="12192000" cy="54864"/>
+          </a:xfrm>
+          <a:prstGeom prst="rect">
+            <a:avLst/>
+          </a:prstGeom>
+          <a:solidFill>
+            <a:srgbClr val="C4786A"/>
+          </a:solidFill>
+          <a:ln w="12700">
+            <a:solidFill>
+              <a:srgbClr val="C4786A"/>
+            </a:solidFill>
+            <a:prstDash val="solid"/>
+          </a:ln>
+        </p:spPr>
+      </p:sp>
+      <p:sp>
+        <p:nvSpPr>
+          <p:cNvPr id="7" name="Text 5"/>
+          <p:cNvSpPr/>
+          <p:nvPr/>
+        </p:nvSpPr>
+        <p:spPr>
+          <a:xfrm>
+            <a:off x="457200" y="228600"/>
+            <a:ext cx="8375904" cy="502920"/>
+          </a:xfrm>
+          <a:prstGeom prst="rect">
+            <a:avLst/>
+          </a:prstGeom>
+          <a:noFill/>
+          <a:ln/>
+        </p:spPr>
+        <p:txBody>
+          <a:bodyPr wrap="square" rtlCol="0" anchor="ctr"/>
+          <a:lstStyle/>
+          <a:p>
+            <a:pPr indent="0" marL="0">
+              <a:buNone/>
+            </a:pPr>
+            <a:r>
+              <a:rPr lang="en-US" b="1" dirty="0">
+                <a:solidFill>
+                  <a:srgbClr val="2D3748"/>
+                </a:solidFill>
+                <a:latin typeface="Arial" pitchFamily="34" charset="0"/>
+                <a:ea typeface="Arial" pitchFamily="34" charset="-122"/>
+                <a:cs typeface="Arial" pitchFamily="34" charset="-120"/>
+              </a:rPr>
+              <a:t>🔐  IA y Ciberseguridad</a:t>
+            </a:r>
+            <a:endParaRPr lang="en-US" dirty="0"/>
+          </a:p>
+        </p:txBody>
+      </p:sp>
+      <p:sp>
+        <p:nvSpPr>
+          <p:cNvPr id="8" name="Text 6"/>
+          <p:cNvSpPr/>
+          <p:nvPr/>
+        </p:nvSpPr>
+        <p:spPr>
+          <a:xfrm>
+            <a:off x="457200" y="731520"/>
+            <a:ext cx="8375904" cy="320040"/>
+          </a:xfrm>
+          <a:prstGeom prst="rect">
+            <a:avLst/>
+          </a:prstGeom>
+          <a:noFill/>
+          <a:ln/>
+        </p:spPr>
+        <p:txBody>
+          <a:bodyPr wrap="square" rtlCol="0" anchor="ctr"/>
+          <a:lstStyle/>
+          <a:p>
+            <a:pPr indent="0" marL="0">
+              <a:buNone/>
+            </a:pPr>
+            <a:r>
+              <a:rPr lang="en-US" b="1" dirty="0">
+                <a:solidFill>
+                  <a:srgbClr val="5B8DB8"/>
+                </a:solidFill>
+                <a:latin typeface="Arial" pitchFamily="34" charset="0"/>
+                <a:ea typeface="Arial" pitchFamily="34" charset="-122"/>
+                <a:cs typeface="Arial" pitchFamily="34" charset="-120"/>
+              </a:rPr>
+              <a:t>Datos sensibles por ley · arquitectura en GCP · roadmap de IA operativa</a:t>
+            </a:r>
+            <a:endParaRPr lang="en-US" dirty="0"/>
+          </a:p>
+        </p:txBody>
+      </p:sp>
+      <p:sp>
+        <p:nvSpPr>
+          <p:cNvPr id="9" name="Shape 7"/>
+          <p:cNvSpPr/>
+          <p:nvPr/>
+        </p:nvSpPr>
+        <p:spPr>
+          <a:xfrm>
+            <a:off x="457200" y="1097280"/>
+            <a:ext cx="8375904" cy="0"/>
+          </a:xfrm>
+          <a:prstGeom prst="line">
+            <a:avLst/>
+          </a:prstGeom>
+          <a:noFill/>
+          <a:ln w="12700">
+            <a:solidFill>
+              <a:srgbClr val="E2E8F0"/>
+            </a:solidFill>
+            <a:prstDash val="solid"/>
+          </a:ln>
+        </p:spPr>
+      </p:sp>
+      <p:sp>
+        <p:nvSpPr>
+          <p:cNvPr id="10" name="Shape 8"/>
+          <p:cNvSpPr/>
+          <p:nvPr/>
+        </p:nvSpPr>
+        <p:spPr>
+          <a:xfrm>
+            <a:off x="457200" y="1261872"/>
+            <a:ext cx="3977640" cy="3200400"/>
+          </a:xfrm>
+          <a:prstGeom prst="roundRect">
+            <a:avLst>
+              <a:gd name="adj" fmla="val 2286"/>
+            </a:avLst>
+          </a:prstGeom>
+          <a:solidFill>
+            <a:srgbClr val="FFF7ED"/>
+          </a:solidFill>
+          <a:ln w="6350">
+            <a:solidFill>
+              <a:srgbClr val="E2E8F0"/>
+            </a:solidFill>
+            <a:prstDash val="solid"/>
+          </a:ln>
+        </p:spPr>
+      </p:sp>
+      <p:sp>
+        <p:nvSpPr>
+          <p:cNvPr id="11" name="Text 9"/>
+          <p:cNvSpPr/>
+          <p:nvPr/>
+        </p:nvSpPr>
+        <p:spPr>
+          <a:xfrm>
+            <a:off x="594360" y="1371600"/>
+            <a:ext cx="3703320" cy="384048"/>
+          </a:xfrm>
+          <a:prstGeom prst="rect">
+            <a:avLst/>
+          </a:prstGeom>
+          <a:noFill/>
+          <a:ln/>
+        </p:spPr>
+        <p:txBody>
+          <a:bodyPr wrap="square" rtlCol="0" anchor="ctr"/>
+          <a:lstStyle/>
+          <a:p>
+            <a:pPr indent="0" marL="0">
+              <a:buNone/>
+            </a:pPr>
+            <a:r>
+              <a:rPr lang="en-US" sz="1400" b="1" dirty="0">
+                <a:solidFill>
+                  <a:srgbClr val="C4786A"/>
+                </a:solidFill>
+                <a:latin typeface="Arial" pitchFamily="34" charset="0"/>
+                <a:ea typeface="Arial" pitchFamily="34" charset="-122"/>
+                <a:cs typeface="Arial" pitchFamily="34" charset="-120"/>
+              </a:rPr>
+              <a:t>🛡️  Ciberseguridad</a:t>
+            </a:r>
+            <a:endParaRPr lang="en-US" sz="1400" dirty="0"/>
+          </a:p>
+        </p:txBody>
+      </p:sp>
+      <p:sp>
+        <p:nvSpPr>
+          <p:cNvPr id="12" name="Shape 10"/>
+          <p:cNvSpPr/>
+          <p:nvPr/>
+        </p:nvSpPr>
+        <p:spPr>
+          <a:xfrm>
+            <a:off x="594360" y="1783080"/>
+            <a:ext cx="3703320" cy="0"/>
+          </a:xfrm>
+          <a:prstGeom prst="line">
+            <a:avLst/>
+          </a:prstGeom>
+          <a:noFill/>
+          <a:ln w="7620">
+            <a:solidFill>
+              <a:srgbClr val="E2E8F0"/>
+            </a:solidFill>
+            <a:prstDash val="solid"/>
+          </a:ln>
+        </p:spPr>
+      </p:sp>
+      <p:sp>
+        <p:nvSpPr>
+          <p:cNvPr id="13" name="Text 11"/>
+          <p:cNvSpPr/>
+          <p:nvPr/>
+        </p:nvSpPr>
+        <p:spPr>
+          <a:xfrm>
+            <a:off x="594360" y="1920240"/>
+            <a:ext cx="548640" cy="530352"/>
+          </a:xfrm>
+          <a:prstGeom prst="rect">
+            <a:avLst/>
+          </a:prstGeom>
+          <a:noFill/>
+          <a:ln/>
+        </p:spPr>
+        <p:txBody>
+          <a:bodyPr wrap="square" rtlCol="0" anchor="ctr"/>
+          <a:lstStyle/>
+          <a:p>
+            <a:pPr algn="ctr" indent="0" marL="0">
+              <a:buNone/>
+            </a:pPr>
+            <a:r>
+              <a:rPr lang="en-US" sz="2000" dirty="0">
+                <a:solidFill>
+                  <a:srgbClr val="000000"/>
+                </a:solidFill>
+              </a:rPr>
+              <a:t>📜</a:t>
+            </a:r>
+            <a:endParaRPr lang="en-US" sz="2000" dirty="0"/>
+          </a:p>
+        </p:txBody>
+      </p:sp>
+      <p:sp>
+        <p:nvSpPr>
+          <p:cNvPr id="14" name="Text 12"/>
+          <p:cNvSpPr/>
+          <p:nvPr/>
+        </p:nvSpPr>
+        <p:spPr>
+          <a:xfrm>
+            <a:off x="1188720" y="1920240"/>
+            <a:ext cx="3063240" cy="530352"/>
+          </a:xfrm>
+          <a:prstGeom prst="rect">
+            <a:avLst/>
+          </a:prstGeom>
+          <a:noFill/>
+          <a:ln/>
+        </p:spPr>
+        <p:txBody>
+          <a:bodyPr wrap="square" rtlCol="0" anchor="ctr"/>
+          <a:lstStyle/>
+          <a:p>
+            <a:pPr indent="0" marL="0">
+              <a:buNone/>
+            </a:pPr>
+            <a:r>
+              <a:rPr lang="en-US" sz="1150" dirty="0">
+                <a:solidFill>
+                  <a:srgbClr val="2D3748"/>
+                </a:solidFill>
+                <a:latin typeface="Arial" pitchFamily="34" charset="0"/>
+                <a:ea typeface="Arial" pitchFamily="34" charset="-122"/>
+                <a:cs typeface="Arial" pitchFamily="34" charset="-120"/>
+              </a:rPr>
+              <a:t>LFPDPPP — datos de adultos</a:t>
+            </a:r>
+            <a:endParaRPr lang="en-US" sz="1150" dirty="0"/>
+          </a:p>
+          <a:p>
+            <a:pPr indent="0" marL="0">
+              <a:buNone/>
+            </a:pPr>
+            <a:r>
+              <a:rPr lang="en-US" sz="1150" dirty="0">
+                <a:solidFill>
+                  <a:srgbClr val="2D3748"/>
+                </a:solidFill>
+                <a:latin typeface="Arial" pitchFamily="34" charset="0"/>
+                <a:ea typeface="Arial" pitchFamily="34" charset="-122"/>
+                <a:cs typeface="Arial" pitchFamily="34" charset="-120"/>
+              </a:rPr>
+              <a:t>mayores son datos sensibles por ley</a:t>
+            </a:r>
+            <a:endParaRPr lang="en-US" sz="1150" dirty="0"/>
+          </a:p>
+        </p:txBody>
+      </p:sp>
+      <p:sp>
+        <p:nvSpPr>
+          <p:cNvPr id="15" name="Text 13"/>
+          <p:cNvSpPr/>
+          <p:nvPr/>
+        </p:nvSpPr>
+        <p:spPr>
+          <a:xfrm>
+            <a:off x="594360" y="2578608"/>
+            <a:ext cx="548640" cy="530352"/>
+          </a:xfrm>
+          <a:prstGeom prst="rect">
+            <a:avLst/>
+          </a:prstGeom>
+          <a:noFill/>
+          <a:ln/>
+        </p:spPr>
+        <p:txBody>
+          <a:bodyPr wrap="square" rtlCol="0" anchor="ctr"/>
+          <a:lstStyle/>
+          <a:p>
+            <a:pPr algn="ctr" indent="0" marL="0">
+              <a:buNone/>
+            </a:pPr>
+            <a:r>
+              <a:rPr lang="en-US" sz="2000" dirty="0">
+                <a:solidFill>
+                  <a:srgbClr val="000000"/>
+                </a:solidFill>
+              </a:rPr>
+              <a:t>☁️</a:t>
+            </a:r>
+            <a:endParaRPr lang="en-US" sz="2000" dirty="0"/>
+          </a:p>
+        </p:txBody>
+      </p:sp>
+      <p:sp>
+        <p:nvSpPr>
+          <p:cNvPr id="16" name="Text 14"/>
+          <p:cNvSpPr/>
+          <p:nvPr/>
+        </p:nvSpPr>
+        <p:spPr>
+          <a:xfrm>
+            <a:off x="1188720" y="2578608"/>
+            <a:ext cx="3063240" cy="530352"/>
+          </a:xfrm>
+          <a:prstGeom prst="rect">
+            <a:avLst/>
+          </a:prstGeom>
+          <a:noFill/>
+          <a:ln/>
+        </p:spPr>
+        <p:txBody>
+          <a:bodyPr wrap="square" rtlCol="0" anchor="ctr"/>
+          <a:lstStyle/>
+          <a:p>
+            <a:pPr indent="0" marL="0">
+              <a:buNone/>
+            </a:pPr>
+            <a:r>
+              <a:rPr lang="en-US" sz="1150" dirty="0">
+                <a:solidFill>
+                  <a:srgbClr val="2D3748"/>
+                </a:solidFill>
+                <a:latin typeface="Arial" pitchFamily="34" charset="0"/>
+                <a:ea typeface="Arial" pitchFamily="34" charset="-122"/>
+                <a:cs typeface="Arial" pitchFamily="34" charset="-120"/>
+              </a:rPr>
+              <a:t>Google Cloud Run + Firebase</a:t>
+            </a:r>
+            <a:endParaRPr lang="en-US" sz="1150" dirty="0"/>
+          </a:p>
+          <a:p>
+            <a:pPr indent="0" marL="0">
+              <a:buNone/>
+            </a:pPr>
+            <a:r>
+              <a:rPr lang="en-US" sz="1150" dirty="0">
+                <a:solidFill>
+                  <a:srgbClr val="2D3748"/>
+                </a:solidFill>
+                <a:latin typeface="Arial" pitchFamily="34" charset="0"/>
+                <a:ea typeface="Arial" pitchFamily="34" charset="-122"/>
+                <a:cs typeface="Arial" pitchFamily="34" charset="-120"/>
+              </a:rPr>
+              <a:t>con cifrado extremo a extremo</a:t>
+            </a:r>
+            <a:endParaRPr lang="en-US" sz="1150" dirty="0"/>
+          </a:p>
+        </p:txBody>
+      </p:sp>
+      <p:sp>
+        <p:nvSpPr>
+          <p:cNvPr id="17" name="Text 15"/>
+          <p:cNvSpPr/>
+          <p:nvPr/>
+        </p:nvSpPr>
+        <p:spPr>
+          <a:xfrm>
+            <a:off x="594360" y="3236976"/>
+            <a:ext cx="548640" cy="530352"/>
+          </a:xfrm>
+          <a:prstGeom prst="rect">
+            <a:avLst/>
+          </a:prstGeom>
+          <a:noFill/>
+          <a:ln/>
+        </p:spPr>
+        <p:txBody>
+          <a:bodyPr wrap="square" rtlCol="0" anchor="ctr"/>
+          <a:lstStyle/>
+          <a:p>
+            <a:pPr algn="ctr" indent="0" marL="0">
+              <a:buNone/>
+            </a:pPr>
+            <a:r>
+              <a:rPr lang="en-US" sz="2000" dirty="0">
+                <a:solidFill>
+                  <a:srgbClr val="000000"/>
+                </a:solidFill>
+              </a:rPr>
+              <a:t>🔒</a:t>
+            </a:r>
+            <a:endParaRPr lang="en-US" sz="2000" dirty="0"/>
+          </a:p>
+        </p:txBody>
+      </p:sp>
+      <p:sp>
+        <p:nvSpPr>
+          <p:cNvPr id="18" name="Text 16"/>
+          <p:cNvSpPr/>
+          <p:nvPr/>
+        </p:nvSpPr>
+        <p:spPr>
+          <a:xfrm>
+            <a:off x="1188720" y="3236976"/>
+            <a:ext cx="3063240" cy="530352"/>
+          </a:xfrm>
+          <a:prstGeom prst="rect">
+            <a:avLst/>
+          </a:prstGeom>
+          <a:noFill/>
+          <a:ln/>
+        </p:spPr>
+        <p:txBody>
+          <a:bodyPr wrap="square" rtlCol="0" anchor="ctr"/>
+          <a:lstStyle/>
+          <a:p>
+            <a:pPr indent="0" marL="0">
+              <a:buNone/>
+            </a:pPr>
+            <a:r>
+              <a:rPr lang="en-US" sz="1150" dirty="0">
+                <a:solidFill>
+                  <a:srgbClr val="2D3748"/>
+                </a:solidFill>
+                <a:latin typeface="Arial" pitchFamily="34" charset="0"/>
+                <a:ea typeface="Arial" pitchFamily="34" charset="-122"/>
+                <a:cs typeface="Arial" pitchFamily="34" charset="-120"/>
+              </a:rPr>
+              <a:t>Ningún dato de residente</a:t>
+            </a:r>
+            <a:endParaRPr lang="en-US" sz="1150" dirty="0"/>
+          </a:p>
+          <a:p>
+            <a:pPr indent="0" marL="0">
+              <a:buNone/>
+            </a:pPr>
+            <a:r>
+              <a:rPr lang="en-US" sz="1150" dirty="0">
+                <a:solidFill>
+                  <a:srgbClr val="2D3748"/>
+                </a:solidFill>
+                <a:latin typeface="Arial" pitchFamily="34" charset="0"/>
+                <a:ea typeface="Arial" pitchFamily="34" charset="-122"/>
+                <a:cs typeface="Arial" pitchFamily="34" charset="-120"/>
+              </a:rPr>
+              <a:t>sale del dispositivo — privacidad por diseño</a:t>
+            </a:r>
+            <a:endParaRPr lang="en-US" sz="1150" dirty="0"/>
+          </a:p>
+        </p:txBody>
+      </p:sp>
+      <p:sp>
+        <p:nvSpPr>
+          <p:cNvPr id="19" name="Text 17"/>
+          <p:cNvSpPr/>
+          <p:nvPr/>
+        </p:nvSpPr>
+        <p:spPr>
+          <a:xfrm>
+            <a:off x="594360" y="3895344"/>
+            <a:ext cx="548640" cy="530352"/>
+          </a:xfrm>
+          <a:prstGeom prst="rect">
+            <a:avLst/>
+          </a:prstGeom>
+          <a:noFill/>
+          <a:ln/>
+        </p:spPr>
+        <p:txBody>
+          <a:bodyPr wrap="square" rtlCol="0" anchor="ctr"/>
+          <a:lstStyle/>
+          <a:p>
+            <a:pPr algn="ctr" indent="0" marL="0">
+              <a:buNone/>
+            </a:pPr>
+            <a:r>
+              <a:rPr lang="en-US" sz="2000" dirty="0">
+                <a:solidFill>
+                  <a:srgbClr val="000000"/>
+                </a:solidFill>
+              </a:rPr>
+              <a:t>👮</a:t>
+            </a:r>
+            <a:endParaRPr lang="en-US" sz="2000" dirty="0"/>
+          </a:p>
+        </p:txBody>
+      </p:sp>
+      <p:sp>
+        <p:nvSpPr>
+          <p:cNvPr id="20" name="Text 18"/>
+          <p:cNvSpPr/>
+          <p:nvPr/>
+        </p:nvSpPr>
+        <p:spPr>
+          <a:xfrm>
+            <a:off x="1188720" y="3895344"/>
+            <a:ext cx="3063240" cy="530352"/>
+          </a:xfrm>
+          <a:prstGeom prst="rect">
+            <a:avLst/>
+          </a:prstGeom>
+          <a:noFill/>
+          <a:ln/>
+        </p:spPr>
+        <p:txBody>
+          <a:bodyPr wrap="square" rtlCol="0" anchor="ctr"/>
+          <a:lstStyle/>
+          <a:p>
+            <a:pPr indent="0" marL="0">
+              <a:buNone/>
+            </a:pPr>
+            <a:r>
+              <a:rPr lang="en-US" sz="1150" dirty="0">
+                <a:solidFill>
+                  <a:srgbClr val="2D3748"/>
+                </a:solidFill>
+                <a:latin typeface="Arial" pitchFamily="34" charset="0"/>
+                <a:ea typeface="Arial" pitchFamily="34" charset="-122"/>
+                <a:cs typeface="Arial" pitchFamily="34" charset="-120"/>
+              </a:rPr>
+              <a:t>Agente de ciberseguridad</a:t>
+            </a:r>
+            <a:endParaRPr lang="en-US" sz="1150" dirty="0"/>
+          </a:p>
+          <a:p>
+            <a:pPr indent="0" marL="0">
+              <a:buNone/>
+            </a:pPr>
+            <a:r>
+              <a:rPr lang="en-US" sz="1150" dirty="0">
+                <a:solidFill>
+                  <a:srgbClr val="2D3748"/>
+                </a:solidFill>
+                <a:latin typeface="Arial" pitchFamily="34" charset="0"/>
+                <a:ea typeface="Arial" pitchFamily="34" charset="-122"/>
+                <a:cs typeface="Arial" pitchFamily="34" charset="-120"/>
+              </a:rPr>
+              <a:t>activo 24 h sobre Gemini API</a:t>
+            </a:r>
+            <a:endParaRPr lang="en-US" sz="1150" dirty="0"/>
+          </a:p>
+        </p:txBody>
+      </p:sp>
+      <p:sp>
+        <p:nvSpPr>
+          <p:cNvPr id="21" name="Shape 19"/>
+          <p:cNvSpPr/>
+          <p:nvPr/>
+        </p:nvSpPr>
+        <p:spPr>
+          <a:xfrm>
+            <a:off x="4846320" y="1261872"/>
+            <a:ext cx="3977640" cy="3200400"/>
+          </a:xfrm>
+          <a:prstGeom prst="roundRect">
+            <a:avLst>
+              <a:gd name="adj" fmla="val 2286"/>
+            </a:avLst>
+          </a:prstGeom>
+          <a:solidFill>
+            <a:srgbClr val="EFF6FF"/>
+          </a:solidFill>
+          <a:ln w="6350">
+            <a:solidFill>
+              <a:srgbClr val="E2E8F0"/>
+            </a:solidFill>
+            <a:prstDash val="solid"/>
+          </a:ln>
+        </p:spPr>
+      </p:sp>
+      <p:sp>
+        <p:nvSpPr>
+          <p:cNvPr id="22" name="Text 20"/>
+          <p:cNvSpPr/>
+          <p:nvPr/>
+        </p:nvSpPr>
+        <p:spPr>
+          <a:xfrm>
+            <a:off x="4983480" y="1371600"/>
+            <a:ext cx="3703320" cy="384048"/>
+          </a:xfrm>
+          <a:prstGeom prst="rect">
+            <a:avLst/>
+          </a:prstGeom>
+          <a:noFill/>
+          <a:ln/>
+        </p:spPr>
+        <p:txBody>
+          <a:bodyPr wrap="square" rtlCol="0" anchor="ctr"/>
+          <a:lstStyle/>
+          <a:p>
+            <a:pPr indent="0" marL="0">
+              <a:buNone/>
+            </a:pPr>
+            <a:r>
+              <a:rPr lang="en-US" sz="1400" b="1" dirty="0">
+                <a:solidFill>
+                  <a:srgbClr val="3A6B96"/>
+                </a:solidFill>
+                <a:latin typeface="Arial" pitchFamily="34" charset="0"/>
+                <a:ea typeface="Arial" pitchFamily="34" charset="-122"/>
+                <a:cs typeface="Arial" pitchFamily="34" charset="-120"/>
+              </a:rPr>
+              <a:t>🤖  IA Operativa — roadmap v0.2</a:t>
+            </a:r>
+            <a:endParaRPr lang="en-US" sz="1400" dirty="0"/>
+          </a:p>
+        </p:txBody>
+      </p:sp>
+      <p:sp>
+        <p:nvSpPr>
+          <p:cNvPr id="23" name="Shape 21"/>
+          <p:cNvSpPr/>
+          <p:nvPr/>
+        </p:nvSpPr>
+        <p:spPr>
+          <a:xfrm>
+            <a:off x="4983480" y="1783080"/>
+            <a:ext cx="3703320" cy="0"/>
+          </a:xfrm>
+          <a:prstGeom prst="line">
+            <a:avLst/>
+          </a:prstGeom>
+          <a:noFill/>
+          <a:ln w="7620">
+            <a:solidFill>
+              <a:srgbClr val="E2E8F0"/>
+            </a:solidFill>
+            <a:prstDash val="solid"/>
+          </a:ln>
+        </p:spPr>
+      </p:sp>
+      <p:sp>
+        <p:nvSpPr>
+          <p:cNvPr id="24" name="Text 22"/>
+          <p:cNvSpPr/>
+          <p:nvPr/>
+        </p:nvSpPr>
+        <p:spPr>
+          <a:xfrm>
+            <a:off x="4983480" y="1920240"/>
+            <a:ext cx="548640" cy="530352"/>
+          </a:xfrm>
+          <a:prstGeom prst="rect">
+            <a:avLst/>
+          </a:prstGeom>
+          <a:noFill/>
+          <a:ln/>
+        </p:spPr>
+        <p:txBody>
+          <a:bodyPr wrap="square" rtlCol="0" anchor="ctr"/>
+          <a:lstStyle/>
+          <a:p>
+            <a:pPr algn="ctr" indent="0" marL="0">
+              <a:buNone/>
+            </a:pPr>
+            <a:r>
+              <a:rPr lang="en-US" sz="2000" dirty="0">
+                <a:solidFill>
+                  <a:srgbClr val="000000"/>
+                </a:solidFill>
+              </a:rPr>
+              <a:t>📈</a:t>
+            </a:r>
+            <a:endParaRPr lang="en-US" sz="2000" dirty="0"/>
+          </a:p>
+        </p:txBody>
+      </p:sp>
+      <p:sp>
+        <p:nvSpPr>
+          <p:cNvPr id="25" name="Text 23"/>
+          <p:cNvSpPr/>
+          <p:nvPr/>
+        </p:nvSpPr>
+        <p:spPr>
+          <a:xfrm>
+            <a:off x="5577840" y="1920240"/>
+            <a:ext cx="3108960" cy="530352"/>
+          </a:xfrm>
+          <a:prstGeom prst="rect">
+            <a:avLst/>
+          </a:prstGeom>
+          <a:noFill/>
+          <a:ln/>
+        </p:spPr>
+        <p:txBody>
+          <a:bodyPr wrap="square" rtlCol="0" anchor="ctr"/>
+          <a:lstStyle/>
+          <a:p>
+            <a:pPr indent="0" marL="0">
+              <a:buNone/>
+            </a:pPr>
+            <a:r>
+              <a:rPr lang="en-US" sz="1150" dirty="0">
+                <a:solidFill>
+                  <a:srgbClr val="2D3748"/>
+                </a:solidFill>
+                <a:latin typeface="Arial" pitchFamily="34" charset="0"/>
+                <a:ea typeface="Arial" pitchFamily="34" charset="-122"/>
+                <a:cs typeface="Arial" pitchFamily="34" charset="-120"/>
+              </a:rPr>
+              <a:t>Alertas predictivas</a:t>
+            </a:r>
+            <a:endParaRPr lang="en-US" sz="1150" dirty="0"/>
+          </a:p>
+          <a:p>
+            <a:pPr indent="0" marL="0">
+              <a:buNone/>
+            </a:pPr>
+            <a:r>
+              <a:rPr lang="en-US" sz="1150" dirty="0">
+                <a:solidFill>
+                  <a:srgbClr val="2D3748"/>
+                </a:solidFill>
+                <a:latin typeface="Arial" pitchFamily="34" charset="0"/>
+                <a:ea typeface="Arial" pitchFamily="34" charset="-122"/>
+                <a:cs typeface="Arial" pitchFamily="34" charset="-120"/>
+              </a:rPr>
+              <a:t>sobre histórico de tiempos de ronda</a:t>
+            </a:r>
+            <a:endParaRPr lang="en-US" sz="1150" dirty="0"/>
+          </a:p>
+        </p:txBody>
+      </p:sp>
+      <p:sp>
+        <p:nvSpPr>
+          <p:cNvPr id="26" name="Text 24"/>
+          <p:cNvSpPr/>
+          <p:nvPr/>
+        </p:nvSpPr>
+        <p:spPr>
+          <a:xfrm>
+            <a:off x="4983480" y="2578608"/>
+            <a:ext cx="548640" cy="530352"/>
+          </a:xfrm>
+          <a:prstGeom prst="rect">
+            <a:avLst/>
+          </a:prstGeom>
+          <a:noFill/>
+          <a:ln/>
+        </p:spPr>
+        <p:txBody>
+          <a:bodyPr wrap="square" rtlCol="0" anchor="ctr"/>
+          <a:lstStyle/>
+          <a:p>
+            <a:pPr algn="ctr" indent="0" marL="0">
+              <a:buNone/>
+            </a:pPr>
+            <a:r>
+              <a:rPr lang="en-US" sz="2000" dirty="0">
+                <a:solidFill>
+                  <a:srgbClr val="000000"/>
+                </a:solidFill>
+              </a:rPr>
+              <a:t>🔍</a:t>
+            </a:r>
+            <a:endParaRPr lang="en-US" sz="2000" dirty="0"/>
+          </a:p>
+        </p:txBody>
+      </p:sp>
+      <p:sp>
+        <p:nvSpPr>
+          <p:cNvPr id="27" name="Text 25"/>
+          <p:cNvSpPr/>
+          <p:nvPr/>
+        </p:nvSpPr>
+        <p:spPr>
+          <a:xfrm>
+            <a:off x="5577840" y="2578608"/>
+            <a:ext cx="3108960" cy="530352"/>
+          </a:xfrm>
+          <a:prstGeom prst="rect">
+            <a:avLst/>
+          </a:prstGeom>
+          <a:noFill/>
+          <a:ln/>
+        </p:spPr>
+        <p:txBody>
+          <a:bodyPr wrap="square" rtlCol="0" anchor="ctr"/>
+          <a:lstStyle/>
+          <a:p>
+            <a:pPr indent="0" marL="0">
+              <a:buNone/>
+            </a:pPr>
+            <a:r>
+              <a:rPr lang="en-US" sz="1150" dirty="0">
+                <a:solidFill>
+                  <a:srgbClr val="2D3748"/>
+                </a:solidFill>
+                <a:latin typeface="Arial" pitchFamily="34" charset="0"/>
+                <a:ea typeface="Arial" pitchFamily="34" charset="-122"/>
+                <a:cs typeface="Arial" pitchFamily="34" charset="-120"/>
+              </a:rPr>
+              <a:t>Detección de anomalías</a:t>
+            </a:r>
+            <a:endParaRPr lang="en-US" sz="1150" dirty="0"/>
+          </a:p>
+          <a:p>
+            <a:pPr indent="0" marL="0">
+              <a:buNone/>
+            </a:pPr>
+            <a:r>
+              <a:rPr lang="en-US" sz="1150" dirty="0">
+                <a:solidFill>
+                  <a:srgbClr val="2D3748"/>
+                </a:solidFill>
+                <a:latin typeface="Arial" pitchFamily="34" charset="0"/>
+                <a:ea typeface="Arial" pitchFamily="34" charset="-122"/>
+                <a:cs typeface="Arial" pitchFamily="34" charset="-120"/>
+              </a:rPr>
+              <a:t>en la bitácora de auditoría</a:t>
+            </a:r>
+            <a:endParaRPr lang="en-US" sz="1150" dirty="0"/>
+          </a:p>
+        </p:txBody>
+      </p:sp>
+      <p:sp>
+        <p:nvSpPr>
+          <p:cNvPr id="28" name="Text 26"/>
+          <p:cNvSpPr/>
+          <p:nvPr/>
+        </p:nvSpPr>
+        <p:spPr>
+          <a:xfrm>
+            <a:off x="4983480" y="3236976"/>
+            <a:ext cx="548640" cy="530352"/>
+          </a:xfrm>
+          <a:prstGeom prst="rect">
+            <a:avLst/>
+          </a:prstGeom>
+          <a:noFill/>
+          <a:ln/>
+        </p:spPr>
+        <p:txBody>
+          <a:bodyPr wrap="square" rtlCol="0" anchor="ctr"/>
+          <a:lstStyle/>
+          <a:p>
+            <a:pPr algn="ctr" indent="0" marL="0">
+              <a:buNone/>
+            </a:pPr>
+            <a:r>
+              <a:rPr lang="en-US" sz="2000" dirty="0">
+                <a:solidFill>
+                  <a:srgbClr val="000000"/>
+                </a:solidFill>
+              </a:rPr>
+              <a:t>📅</a:t>
+            </a:r>
+            <a:endParaRPr lang="en-US" sz="2000" dirty="0"/>
+          </a:p>
+        </p:txBody>
+      </p:sp>
+      <p:sp>
+        <p:nvSpPr>
+          <p:cNvPr id="29" name="Text 27"/>
+          <p:cNvSpPr/>
+          <p:nvPr/>
+        </p:nvSpPr>
+        <p:spPr>
+          <a:xfrm>
+            <a:off x="5577840" y="3236976"/>
+            <a:ext cx="3108960" cy="530352"/>
+          </a:xfrm>
+          <a:prstGeom prst="rect">
+            <a:avLst/>
+          </a:prstGeom>
+          <a:noFill/>
+          <a:ln/>
+        </p:spPr>
+        <p:txBody>
+          <a:bodyPr wrap="square" rtlCol="0" anchor="ctr"/>
+          <a:lstStyle/>
+          <a:p>
+            <a:pPr indent="0" marL="0">
+              <a:buNone/>
+            </a:pPr>
+            <a:r>
+              <a:rPr lang="en-US" sz="1150" dirty="0">
+                <a:solidFill>
+                  <a:srgbClr val="2D3748"/>
+                </a:solidFill>
+                <a:latin typeface="Arial" pitchFamily="34" charset="0"/>
+                <a:ea typeface="Arial" pitchFamily="34" charset="-122"/>
+                <a:cs typeface="Arial" pitchFamily="34" charset="-120"/>
+              </a:rPr>
+              <a:t>Optimización de asignación</a:t>
+            </a:r>
+            <a:endParaRPr lang="en-US" sz="1150" dirty="0"/>
+          </a:p>
+          <a:p>
+            <a:pPr indent="0" marL="0">
+              <a:buNone/>
+            </a:pPr>
+            <a:r>
+              <a:rPr lang="en-US" sz="1150" dirty="0">
+                <a:solidFill>
+                  <a:srgbClr val="2D3748"/>
+                </a:solidFill>
+                <a:latin typeface="Arial" pitchFamily="34" charset="0"/>
+                <a:ea typeface="Arial" pitchFamily="34" charset="-122"/>
+                <a:cs typeface="Arial" pitchFamily="34" charset="-120"/>
+              </a:rPr>
+              <a:t>de cuidadores por turno</a:t>
+            </a:r>
+            <a:endParaRPr lang="en-US" sz="1150" dirty="0"/>
+          </a:p>
+        </p:txBody>
+      </p:sp>
+      <p:sp>
+        <p:nvSpPr>
+          <p:cNvPr id="30" name="Text 28"/>
+          <p:cNvSpPr/>
+          <p:nvPr/>
+        </p:nvSpPr>
+        <p:spPr>
+          <a:xfrm>
+            <a:off x="4983480" y="3895344"/>
+            <a:ext cx="548640" cy="530352"/>
+          </a:xfrm>
+          <a:prstGeom prst="rect">
+            <a:avLst/>
+          </a:prstGeom>
+          <a:noFill/>
+          <a:ln/>
+        </p:spPr>
+        <p:txBody>
+          <a:bodyPr wrap="square" rtlCol="0" anchor="ctr"/>
+          <a:lstStyle/>
+          <a:p>
+            <a:pPr algn="ctr" indent="0" marL="0">
+              <a:buNone/>
+            </a:pPr>
+            <a:r>
+              <a:rPr lang="en-US" sz="2000" dirty="0">
+                <a:solidFill>
+                  <a:srgbClr val="000000"/>
+                </a:solidFill>
+              </a:rPr>
+              <a:t>📝</a:t>
+            </a:r>
+            <a:endParaRPr lang="en-US" sz="2000" dirty="0"/>
+          </a:p>
+        </p:txBody>
+      </p:sp>
+      <p:sp>
+        <p:nvSpPr>
+          <p:cNvPr id="31" name="Text 29"/>
+          <p:cNvSpPr/>
+          <p:nvPr/>
+        </p:nvSpPr>
+        <p:spPr>
+          <a:xfrm>
+            <a:off x="5577840" y="3895344"/>
+            <a:ext cx="3108960" cy="530352"/>
+          </a:xfrm>
+          <a:prstGeom prst="rect">
+            <a:avLst/>
+          </a:prstGeom>
+          <a:noFill/>
+          <a:ln/>
+        </p:spPr>
+        <p:txBody>
+          <a:bodyPr wrap="square" rtlCol="0" anchor="ctr"/>
+          <a:lstStyle/>
+          <a:p>
+            <a:pPr indent="0" marL="0">
+              <a:buNone/>
+            </a:pPr>
+            <a:r>
+              <a:rPr lang="en-US" sz="1150" dirty="0">
+                <a:solidFill>
+                  <a:srgbClr val="2D3748"/>
+                </a:solidFill>
+                <a:latin typeface="Arial" pitchFamily="34" charset="0"/>
+                <a:ea typeface="Arial" pitchFamily="34" charset="-122"/>
+                <a:cs typeface="Arial" pitchFamily="34" charset="-120"/>
+              </a:rPr>
+              <a:t>Resumen ejecutivo automático</a:t>
+            </a:r>
+            <a:endParaRPr lang="en-US" sz="1150" dirty="0"/>
+          </a:p>
+          <a:p>
+            <a:pPr indent="0" marL="0">
+              <a:buNone/>
+            </a:pPr>
+            <a:r>
+              <a:rPr lang="en-US" sz="1150" dirty="0">
+                <a:solidFill>
+                  <a:srgbClr val="2D3748"/>
+                </a:solidFill>
+                <a:latin typeface="Arial" pitchFamily="34" charset="0"/>
+                <a:ea typeface="Arial" pitchFamily="34" charset="-122"/>
+                <a:cs typeface="Arial" pitchFamily="34" charset="-120"/>
+              </a:rPr>
+              <a:t>del turno — sin transcripción manual</a:t>
+            </a:r>
+            <a:endParaRPr lang="en-US" sz="1150" dirty="0"/>
+          </a:p>
+        </p:txBody>
+      </p:sp>
+      <p:sp>
+        <p:nvSpPr>
+          <p:cNvPr id="32" name="Shape 30"/>
+          <p:cNvSpPr/>
+          <p:nvPr/>
+        </p:nvSpPr>
+        <p:spPr>
+          <a:xfrm>
+            <a:off x="4434840" y="1417320"/>
+            <a:ext cx="0" cy="2926080"/>
+          </a:xfrm>
+          <a:prstGeom prst="line">
+            <a:avLst/>
+          </a:prstGeom>
+          <a:noFill/>
+          <a:ln w="12700">
+            <a:solidFill>
+              <a:srgbClr val="E2E8F0"/>
+            </a:solidFill>
+            <a:prstDash val="solid"/>
+          </a:ln>
+        </p:spPr>
+      </p:sp>
+      <p:sp>
+        <p:nvSpPr>
+          <p:cNvPr id="33" name="Text 31"/>
+          <p:cNvSpPr/>
+          <p:nvPr/>
+        </p:nvSpPr>
+        <p:spPr>
+          <a:xfrm>
+            <a:off x="4315968" y="2606040"/>
+            <a:ext cx="411480" cy="365760"/>
+          </a:xfrm>
+          <a:prstGeom prst="rect">
+            <a:avLst/>
+          </a:prstGeom>
+          <a:noFill/>
+          <a:ln/>
+        </p:spPr>
+        <p:txBody>
+          <a:bodyPr wrap="square" rtlCol="0" anchor="ctr"/>
+          <a:lstStyle/>
+          <a:p>
+            <a:pPr algn="ctr" indent="0" marL="0">
+              <a:buNone/>
+            </a:pPr>
+            <a:r>
+              <a:rPr lang="en-US" sz="1800" dirty="0">
+                <a:solidFill>
+                  <a:srgbClr val="5B8DB8"/>
+                </a:solidFill>
+                <a:latin typeface="Arial" pitchFamily="34" charset="0"/>
+                <a:ea typeface="Arial" pitchFamily="34" charset="-122"/>
+                <a:cs typeface="Arial" pitchFamily="34" charset="-120"/>
+              </a:rPr>
+              <a:t>→</a:t>
+            </a:r>
+            <a:endParaRPr lang="en-US" sz="1800" dirty="0"/>
+          </a:p>
+        </p:txBody>
+      </p:sp>
+      <p:sp>
+        <p:nvSpPr>
+          <p:cNvPr id="34" name="Shape 32"/>
+          <p:cNvSpPr/>
+          <p:nvPr/>
+        </p:nvSpPr>
+        <p:spPr>
+          <a:xfrm>
+            <a:off x="457200" y="4663440"/>
+            <a:ext cx="8375904" cy="749808"/>
+          </a:xfrm>
+          <a:prstGeom prst="roundRect">
+            <a:avLst>
+              <a:gd name="adj" fmla="val 9756"/>
+            </a:avLst>
+          </a:prstGeom>
+          <a:solidFill>
+            <a:srgbClr val="F0EDE8"/>
+          </a:solidFill>
+          <a:ln w="6350">
+            <a:solidFill>
+              <a:srgbClr val="E2E8F0"/>
+            </a:solidFill>
+            <a:prstDash val="solid"/>
+          </a:ln>
+        </p:spPr>
+      </p:sp>
+      <p:sp>
+        <p:nvSpPr>
+          <p:cNvPr id="35" name="Text 33"/>
+          <p:cNvSpPr/>
+          <p:nvPr/>
+        </p:nvSpPr>
+        <p:spPr>
+          <a:xfrm>
+            <a:off x="566928" y="4773168"/>
+            <a:ext cx="640080" cy="548640"/>
+          </a:xfrm>
+          <a:prstGeom prst="rect">
+            <a:avLst/>
+          </a:prstGeom>
+          <a:noFill/>
+          <a:ln/>
+        </p:spPr>
+        <p:txBody>
+          <a:bodyPr wrap="square" rtlCol="0" anchor="ctr"/>
+          <a:lstStyle/>
+          <a:p>
+            <a:pPr algn="ctr" indent="0" marL="0">
+              <a:buNone/>
+            </a:pPr>
+            <a:r>
+              <a:rPr lang="en-US" sz="2400" dirty="0">
+                <a:solidFill>
+                  <a:srgbClr val="000000"/>
+                </a:solidFill>
+              </a:rPr>
+              <a:t>📊</a:t>
+            </a:r>
+            <a:endParaRPr lang="en-US" sz="2400" dirty="0"/>
+          </a:p>
+        </p:txBody>
+      </p:sp>
+      <p:sp>
+        <p:nvSpPr>
+          <p:cNvPr id="36" name="Text 34"/>
+          <p:cNvSpPr/>
+          <p:nvPr/>
+        </p:nvSpPr>
+        <p:spPr>
+          <a:xfrm>
+            <a:off x="1280160" y="4736592"/>
+            <a:ext cx="7406640" cy="603504"/>
+          </a:xfrm>
+          <a:prstGeom prst="rect">
+            <a:avLst/>
+          </a:prstGeom>
+          <a:noFill/>
+          <a:ln/>
+        </p:spPr>
+        <p:txBody>
+          <a:bodyPr wrap="square" rtlCol="0" anchor="ctr"/>
+          <a:lstStyle/>
+          <a:p>
+            <a:pPr indent="0" marL="0">
+              <a:buNone/>
+            </a:pPr>
+            <a:r>
+              <a:rPr lang="en-US" sz="1200" dirty="0">
+                <a:solidFill>
+                  <a:srgbClr val="2D3748"/>
+                </a:solidFill>
+                <a:latin typeface="Arial" pitchFamily="34" charset="0"/>
+                <a:ea typeface="Arial" pitchFamily="34" charset="-122"/>
+                <a:cs typeface="Arial" pitchFamily="34" charset="-120"/>
+              </a:rPr>
+              <a:t>La bitácora de 20 tipos de evento por turno es el insumo nativo para toda la IA operativa —</a:t>
+            </a:r>
+            <a:endParaRPr lang="en-US" sz="1200" dirty="0"/>
+          </a:p>
+          <a:p>
+            <a:pPr indent="0" marL="0">
+              <a:buNone/>
+            </a:pPr>
+            <a:r>
+              <a:rPr lang="en-US" sz="1200" dirty="0">
+                <a:solidFill>
+                  <a:srgbClr val="2D3748"/>
+                </a:solidFill>
+                <a:latin typeface="Arial" pitchFamily="34" charset="0"/>
+                <a:ea typeface="Arial" pitchFamily="34" charset="-122"/>
+                <a:cs typeface="Arial" pitchFamily="34" charset="-120"/>
+              </a:rPr>
+              <a:t>sin integración externa, sin datos sintéticos.</a:t>
+            </a:r>
+            <a:endParaRPr lang="en-US" sz="1200" dirty="0"/>
+          </a:p>
+        </p:txBody>
+      </p:sp>
+      <p:sp>
+        <p:nvSpPr>
+          <p:cNvPr id="37" name="Text 35"/>
+          <p:cNvSpPr/>
+          <p:nvPr/>
+        </p:nvSpPr>
+        <p:spPr>
+          <a:xfrm>
+            <a:off x="457200" y="6291072"/>
+            <a:ext cx="8375904" cy="201168"/>
+          </a:xfrm>
+          <a:prstGeom prst="rect">
+            <a:avLst/>
+          </a:prstGeom>
+          <a:noFill/>
+          <a:ln/>
+        </p:spPr>
+        <p:txBody>
+          <a:bodyPr wrap="square" rtlCol="0" anchor="ctr"/>
+          <a:lstStyle/>
+          <a:p>
+            <a:pPr algn="l" indent="0" marL="0">
+              <a:buNone/>
+            </a:pPr>
+            <a:r>
+              <a:rPr lang="en-US" dirty="0">
+                <a:solidFill>
+                  <a:srgbClr val="718096"/>
+                </a:solidFill>
+                <a:latin typeface="Arial" pitchFamily="34" charset="0"/>
+                <a:ea typeface="Arial" pitchFamily="34" charset="-122"/>
+                <a:cs typeface="Arial" pitchFamily="34" charset="-120"/>
+              </a:rPr>
+              <a:t>Criterios 1 y 11 del concurso: IA aplicada · ciberseguridad activa</a:t>
+            </a:r>
+            <a:endParaRPr lang="en-US" dirty="0"/>
+          </a:p>
+        </p:txBody>
+      </p:sp>
+    </p:spTree>
+  </p:cSld>
+  <p:clrMapOvr>
+    <a:masterClrMapping/>
+  </p:clrMapOvr>
+</p:sld>
+</file>
+
 <file path=ppt/slides/slide2.xml><?xml version="1.0" encoding="utf-8"?>
 <p:sld xmlns:a="http://schemas.openxmlformats.org/drawingml/2006/main" xmlns:r="http://schemas.openxmlformats.org/officeDocument/2006/relationships" xmlns:p="http://schemas.openxmlformats.org/presentationml/2006/main">
   <p:cSld name="Slide 2">

</xml_diff>

<commit_message>
E3: deck completo 14 slides — cierre, llamada a la acción y Q&A backup
Co-Authored-By: Claude Sonnet 4.6 <noreply@anthropic.com>
</commit_message>
<xml_diff>
--- a/business/CareSignal_Pitch_Deck.pptx
+++ b/business/CareSignal_Pitch_Deck.pptx
@@ -17,9 +17,11 @@
     <p:sldId id="265" r:id="rId11"/>
     <p:sldId id="266" r:id="rId12"/>
     <p:sldId id="267" r:id="rId13"/>
+    <p:sldId id="268" r:id="rId14"/>
+    <p:sldId id="269" r:id="rId15"/>
   </p:sldIdLst>
   <p:notesMasterIdLst>
-    <p:notesMasterId r:id="rId14"/>
+    <p:notesMasterId r:id="rId16"/>
   </p:notesMasterIdLst>
   <p:sldSz cx="12192000" cy="6858000"/>
   <p:notesSz cx="6858000" cy="12192000"/>
@@ -801,6 +803,182 @@
             <a:fld id="{F7021451-1387-4CA6-816F-3879F97B5CBC}" type="slidenum">
               <a:rPr lang="en-US"/>
               <a:t>12</a:t>
+            </a:fld>
+            <a:endParaRPr lang="en-US"/>
+          </a:p>
+        </p:txBody>
+      </p:sp>
+    </p:spTree>
+    <p:extLst>
+      <p:ext uri="{BB962C8B-B14F-4D97-AF65-F5344CB8AC3E}">
+        <p14:creationId xmlns:p14="http://schemas.microsoft.com/office/powerpoint/2010/main" val="1024086991"/>
+      </p:ext>
+    </p:extLst>
+  </p:cSld>
+  <p:clrMapOvr>
+    <a:masterClrMapping/>
+  </p:clrMapOvr>
+</p:notes>
+</file>
+
+<file path=ppt/notesSlides/notesSlide13.xml><?xml version="1.0" encoding="utf-8"?>
+<p:notes xmlns:a="http://schemas.openxmlformats.org/drawingml/2006/main" xmlns:r="http://schemas.openxmlformats.org/officeDocument/2006/relationships" xmlns:p="http://schemas.openxmlformats.org/presentationml/2006/main">
+  <p:cSld>
+    <p:spTree>
+      <p:nvGrpSpPr>
+        <p:cNvPr id="1" name=""/>
+        <p:cNvGrpSpPr/>
+        <p:nvPr/>
+      </p:nvGrpSpPr>
+      <p:grpSpPr>
+        <a:xfrm>
+          <a:off x="0" y="0"/>
+          <a:ext cx="0" cy="0"/>
+          <a:chOff x="0" y="0"/>
+          <a:chExt cx="0" cy="0"/>
+        </a:xfrm>
+      </p:grpSpPr>
+      <p:sp>
+        <p:nvSpPr>
+          <p:cNvPr id="2" name="Slide Image Placeholder 1"/>
+          <p:cNvSpPr>
+            <a:spLocks noGrp="1" noRot="1" noChangeAspect="1"/>
+          </p:cNvSpPr>
+          <p:nvPr>
+            <p:ph type="sldImg"/>
+          </p:nvPr>
+        </p:nvSpPr>
+        <p:spPr/>
+      </p:sp>
+      <p:sp>
+        <p:nvSpPr>
+          <p:cNvPr id="3" name="Notes Placeholder 2"/>
+          <p:cNvSpPr>
+            <a:spLocks noGrp="1"/>
+          </p:cNvSpPr>
+          <p:nvPr>
+            <p:ph type="body" idx="1"/>
+          </p:nvPr>
+        </p:nvSpPr>
+        <p:spPr/>
+        <p:txBody>
+          <a:bodyPr/>
+          <a:lstStyle/>
+          <a:p>
+            <a:r>
+              <a:rPr lang="en-US" dirty="0"/>
+              <a:t/>
+            </a:r>
+            <a:endParaRPr lang="en-US" dirty="0"/>
+          </a:p>
+        </p:txBody>
+      </p:sp>
+      <p:sp>
+        <p:nvSpPr>
+          <p:cNvPr id="4" name="Slide Number Placeholder 3"/>
+          <p:cNvSpPr>
+            <a:spLocks noGrp="1"/>
+          </p:cNvSpPr>
+          <p:nvPr>
+            <p:ph type="sldNum" sz="quarter" idx="10"/>
+          </p:nvPr>
+        </p:nvSpPr>
+        <p:spPr/>
+        <p:txBody>
+          <a:bodyPr/>
+          <a:lstStyle/>
+          <a:p>
+            <a:fld id="{F7021451-1387-4CA6-816F-3879F97B5CBC}" type="slidenum">
+              <a:rPr lang="en-US"/>
+              <a:t>13</a:t>
+            </a:fld>
+            <a:endParaRPr lang="en-US"/>
+          </a:p>
+        </p:txBody>
+      </p:sp>
+    </p:spTree>
+    <p:extLst>
+      <p:ext uri="{BB962C8B-B14F-4D97-AF65-F5344CB8AC3E}">
+        <p14:creationId xmlns:p14="http://schemas.microsoft.com/office/powerpoint/2010/main" val="1024086991"/>
+      </p:ext>
+    </p:extLst>
+  </p:cSld>
+  <p:clrMapOvr>
+    <a:masterClrMapping/>
+  </p:clrMapOvr>
+</p:notes>
+</file>
+
+<file path=ppt/notesSlides/notesSlide14.xml><?xml version="1.0" encoding="utf-8"?>
+<p:notes xmlns:a="http://schemas.openxmlformats.org/drawingml/2006/main" xmlns:r="http://schemas.openxmlformats.org/officeDocument/2006/relationships" xmlns:p="http://schemas.openxmlformats.org/presentationml/2006/main">
+  <p:cSld>
+    <p:spTree>
+      <p:nvGrpSpPr>
+        <p:cNvPr id="1" name=""/>
+        <p:cNvGrpSpPr/>
+        <p:nvPr/>
+      </p:nvGrpSpPr>
+      <p:grpSpPr>
+        <a:xfrm>
+          <a:off x="0" y="0"/>
+          <a:ext cx="0" cy="0"/>
+          <a:chOff x="0" y="0"/>
+          <a:chExt cx="0" cy="0"/>
+        </a:xfrm>
+      </p:grpSpPr>
+      <p:sp>
+        <p:nvSpPr>
+          <p:cNvPr id="2" name="Slide Image Placeholder 1"/>
+          <p:cNvSpPr>
+            <a:spLocks noGrp="1" noRot="1" noChangeAspect="1"/>
+          </p:cNvSpPr>
+          <p:nvPr>
+            <p:ph type="sldImg"/>
+          </p:nvPr>
+        </p:nvSpPr>
+        <p:spPr/>
+      </p:sp>
+      <p:sp>
+        <p:nvSpPr>
+          <p:cNvPr id="3" name="Notes Placeholder 2"/>
+          <p:cNvSpPr>
+            <a:spLocks noGrp="1"/>
+          </p:cNvSpPr>
+          <p:nvPr>
+            <p:ph type="body" idx="1"/>
+          </p:nvPr>
+        </p:nvSpPr>
+        <p:spPr/>
+        <p:txBody>
+          <a:bodyPr/>
+          <a:lstStyle/>
+          <a:p>
+            <a:r>
+              <a:rPr lang="en-US" dirty="0"/>
+              <a:t/>
+            </a:r>
+            <a:endParaRPr lang="en-US" dirty="0"/>
+          </a:p>
+        </p:txBody>
+      </p:sp>
+      <p:sp>
+        <p:nvSpPr>
+          <p:cNvPr id="4" name="Slide Number Placeholder 3"/>
+          <p:cNvSpPr>
+            <a:spLocks noGrp="1"/>
+          </p:cNvSpPr>
+          <p:nvPr>
+            <p:ph type="sldNum" sz="quarter" idx="10"/>
+          </p:nvPr>
+        </p:nvSpPr>
+        <p:spPr/>
+        <p:txBody>
+          <a:bodyPr/>
+          <a:lstStyle/>
+          <a:p>
+            <a:fld id="{F7021451-1387-4CA6-816F-3879F97B5CBC}" type="slidenum">
+              <a:rPr lang="en-US"/>
+              <a:t>14</a:t>
             </a:fld>
             <a:endParaRPr lang="en-US"/>
           </a:p>
@@ -6951,6 +7129,1736 @@
 </p:sld>
 </file>
 
+<file path=ppt/slides/slide13.xml><?xml version="1.0" encoding="utf-8"?>
+<p:sld xmlns:a="http://schemas.openxmlformats.org/drawingml/2006/main" xmlns:r="http://schemas.openxmlformats.org/officeDocument/2006/relationships" xmlns:p="http://schemas.openxmlformats.org/presentationml/2006/main">
+  <p:cSld name="Slide 13">
+    <p:spTree>
+      <p:nvGrpSpPr>
+        <p:cNvPr id="1" name=""/>
+        <p:cNvGrpSpPr/>
+        <p:nvPr/>
+      </p:nvGrpSpPr>
+      <p:grpSpPr>
+        <a:xfrm>
+          <a:off x="0" y="0"/>
+          <a:ext cx="0" cy="0"/>
+          <a:chOff x="0" y="0"/>
+          <a:chExt cx="0" cy="0"/>
+        </a:xfrm>
+      </p:grpSpPr>
+      <p:sp>
+        <p:nvSpPr>
+          <p:cNvPr id="2" name="Shape 0"/>
+          <p:cNvSpPr/>
+          <p:nvPr/>
+        </p:nvSpPr>
+        <p:spPr>
+          <a:xfrm>
+            <a:off x="0" y="0"/>
+            <a:ext cx="12192000" cy="6858000"/>
+          </a:xfrm>
+          <a:prstGeom prst="rect">
+            <a:avLst/>
+          </a:prstGeom>
+          <a:solidFill>
+            <a:srgbClr val="FAFAF8"/>
+          </a:solidFill>
+          <a:ln w="12700">
+            <a:solidFill>
+              <a:srgbClr val="FAFAF8"/>
+            </a:solidFill>
+            <a:prstDash val="solid"/>
+          </a:ln>
+        </p:spPr>
+      </p:sp>
+      <p:sp>
+        <p:nvSpPr>
+          <p:cNvPr id="3" name="Shape 1"/>
+          <p:cNvSpPr/>
+          <p:nvPr/>
+        </p:nvSpPr>
+        <p:spPr>
+          <a:xfrm>
+            <a:off x="6583680" y="4389120"/>
+            <a:ext cx="3840480" cy="3840480"/>
+          </a:xfrm>
+          <a:prstGeom prst="ellipse">
+            <a:avLst/>
+          </a:prstGeom>
+          <a:solidFill>
+            <a:srgbClr val="A8C4DC">
+              <a:alpha val="18000"/>
+            </a:srgbClr>
+          </a:solidFill>
+          <a:ln w="12700">
+            <a:solidFill>
+              <a:srgbClr val="A8C4DC">
+                <a:alpha val="18000"/>
+              </a:srgbClr>
+            </a:solidFill>
+            <a:prstDash val="solid"/>
+          </a:ln>
+        </p:spPr>
+      </p:sp>
+      <p:sp>
+        <p:nvSpPr>
+          <p:cNvPr id="4" name="Shape 2"/>
+          <p:cNvSpPr/>
+          <p:nvPr/>
+        </p:nvSpPr>
+        <p:spPr>
+          <a:xfrm>
+            <a:off x="-1005840" y="-1097280"/>
+            <a:ext cx="2926080" cy="2926080"/>
+          </a:xfrm>
+          <a:prstGeom prst="ellipse">
+            <a:avLst/>
+          </a:prstGeom>
+          <a:solidFill>
+            <a:srgbClr val="C4786A">
+              <a:alpha val="12000"/>
+            </a:srgbClr>
+          </a:solidFill>
+          <a:ln w="12700">
+            <a:solidFill>
+              <a:srgbClr val="C4786A">
+                <a:alpha val="12000"/>
+              </a:srgbClr>
+            </a:solidFill>
+            <a:prstDash val="solid"/>
+          </a:ln>
+        </p:spPr>
+      </p:sp>
+      <p:sp>
+        <p:nvSpPr>
+          <p:cNvPr id="5" name="Shape 3"/>
+          <p:cNvSpPr/>
+          <p:nvPr/>
+        </p:nvSpPr>
+        <p:spPr>
+          <a:xfrm>
+            <a:off x="8778240" y="1645920"/>
+            <a:ext cx="54864" cy="2194560"/>
+          </a:xfrm>
+          <a:prstGeom prst="rect">
+            <a:avLst/>
+          </a:prstGeom>
+          <a:solidFill>
+            <a:srgbClr val="5B8DB8">
+              <a:alpha val="45000"/>
+            </a:srgbClr>
+          </a:solidFill>
+          <a:ln w="12700">
+            <a:solidFill>
+              <a:srgbClr val="5B8DB8">
+                <a:alpha val="45000"/>
+              </a:srgbClr>
+            </a:solidFill>
+            <a:prstDash val="solid"/>
+          </a:ln>
+        </p:spPr>
+      </p:sp>
+      <p:sp>
+        <p:nvSpPr>
+          <p:cNvPr id="6" name="Shape 4"/>
+          <p:cNvSpPr/>
+          <p:nvPr/>
+        </p:nvSpPr>
+        <p:spPr>
+          <a:xfrm>
+            <a:off x="0" y="0"/>
+            <a:ext cx="12192000" cy="54864"/>
+          </a:xfrm>
+          <a:prstGeom prst="rect">
+            <a:avLst/>
+          </a:prstGeom>
+          <a:solidFill>
+            <a:srgbClr val="5B8DB8"/>
+          </a:solidFill>
+          <a:ln w="12700">
+            <a:solidFill>
+              <a:srgbClr val="5B8DB8"/>
+            </a:solidFill>
+            <a:prstDash val="solid"/>
+          </a:ln>
+        </p:spPr>
+      </p:sp>
+      <p:sp>
+        <p:nvSpPr>
+          <p:cNvPr id="7" name="Shape 5"/>
+          <p:cNvSpPr/>
+          <p:nvPr/>
+        </p:nvSpPr>
+        <p:spPr>
+          <a:xfrm>
+            <a:off x="0" y="6528816"/>
+            <a:ext cx="12192000" cy="54864"/>
+          </a:xfrm>
+          <a:prstGeom prst="rect">
+            <a:avLst/>
+          </a:prstGeom>
+          <a:solidFill>
+            <a:srgbClr val="C4786A"/>
+          </a:solidFill>
+          <a:ln w="12700">
+            <a:solidFill>
+              <a:srgbClr val="C4786A"/>
+            </a:solidFill>
+            <a:prstDash val="solid"/>
+          </a:ln>
+        </p:spPr>
+      </p:sp>
+      <p:sp>
+        <p:nvSpPr>
+          <p:cNvPr id="8" name="Text 6"/>
+          <p:cNvSpPr/>
+          <p:nvPr/>
+        </p:nvSpPr>
+        <p:spPr>
+          <a:xfrm>
+            <a:off x="457200" y="228600"/>
+            <a:ext cx="8375904" cy="502920"/>
+          </a:xfrm>
+          <a:prstGeom prst="rect">
+            <a:avLst/>
+          </a:prstGeom>
+          <a:noFill/>
+          <a:ln/>
+        </p:spPr>
+        <p:txBody>
+          <a:bodyPr wrap="square" rtlCol="0" anchor="ctr"/>
+          <a:lstStyle/>
+          <a:p>
+            <a:pPr indent="0" marL="0">
+              <a:buNone/>
+            </a:pPr>
+            <a:r>
+              <a:rPr lang="en-US" b="1" dirty="0">
+                <a:solidFill>
+                  <a:srgbClr val="2D3748"/>
+                </a:solidFill>
+                <a:latin typeface="Arial" pitchFamily="34" charset="0"/>
+                <a:ea typeface="Arial" pitchFamily="34" charset="-122"/>
+                <a:cs typeface="Arial" pitchFamily="34" charset="-120"/>
+              </a:rPr>
+              <a:t>🚀  La oportunidad</a:t>
+            </a:r>
+            <a:endParaRPr lang="en-US" dirty="0"/>
+          </a:p>
+        </p:txBody>
+      </p:sp>
+      <p:sp>
+        <p:nvSpPr>
+          <p:cNvPr id="9" name="Shape 7"/>
+          <p:cNvSpPr/>
+          <p:nvPr/>
+        </p:nvSpPr>
+        <p:spPr>
+          <a:xfrm>
+            <a:off x="457200" y="804672"/>
+            <a:ext cx="8375904" cy="0"/>
+          </a:xfrm>
+          <a:prstGeom prst="line">
+            <a:avLst/>
+          </a:prstGeom>
+          <a:noFill/>
+          <a:ln w="12700">
+            <a:solidFill>
+              <a:srgbClr val="E2E8F0"/>
+            </a:solidFill>
+            <a:prstDash val="solid"/>
+          </a:ln>
+        </p:spPr>
+      </p:sp>
+      <p:sp>
+        <p:nvSpPr>
+          <p:cNvPr id="10" name="Shape 8"/>
+          <p:cNvSpPr/>
+          <p:nvPr/>
+        </p:nvSpPr>
+        <p:spPr>
+          <a:xfrm>
+            <a:off x="457200" y="960120"/>
+            <a:ext cx="2633472" cy="2331720"/>
+          </a:xfrm>
+          <a:prstGeom prst="roundRect">
+            <a:avLst>
+              <a:gd name="adj" fmla="val 4706"/>
+            </a:avLst>
+          </a:prstGeom>
+          <a:solidFill>
+            <a:srgbClr val="F0EDE8"/>
+          </a:solidFill>
+          <a:ln w="6350">
+            <a:solidFill>
+              <a:srgbClr val="E2E8F0"/>
+            </a:solidFill>
+            <a:prstDash val="solid"/>
+          </a:ln>
+        </p:spPr>
+      </p:sp>
+      <p:sp>
+        <p:nvSpPr>
+          <p:cNvPr id="11" name="Text 9"/>
+          <p:cNvSpPr/>
+          <p:nvPr/>
+        </p:nvSpPr>
+        <p:spPr>
+          <a:xfrm>
+            <a:off x="457200" y="1078992"/>
+            <a:ext cx="2633472" cy="640080"/>
+          </a:xfrm>
+          <a:prstGeom prst="rect">
+            <a:avLst/>
+          </a:prstGeom>
+          <a:noFill/>
+          <a:ln/>
+        </p:spPr>
+        <p:txBody>
+          <a:bodyPr wrap="square" rtlCol="0" anchor="ctr"/>
+          <a:lstStyle/>
+          <a:p>
+            <a:pPr algn="ctr" indent="0" marL="0">
+              <a:buNone/>
+            </a:pPr>
+            <a:r>
+              <a:rPr lang="en-US" sz="3200" dirty="0">
+                <a:solidFill>
+                  <a:srgbClr val="000000"/>
+                </a:solidFill>
+              </a:rPr>
+              <a:t>📈</a:t>
+            </a:r>
+            <a:endParaRPr lang="en-US" sz="3200" dirty="0"/>
+          </a:p>
+        </p:txBody>
+      </p:sp>
+      <p:sp>
+        <p:nvSpPr>
+          <p:cNvPr id="12" name="Text 10"/>
+          <p:cNvSpPr/>
+          <p:nvPr/>
+        </p:nvSpPr>
+        <p:spPr>
+          <a:xfrm>
+            <a:off x="457200" y="1755648"/>
+            <a:ext cx="2633472" cy="804672"/>
+          </a:xfrm>
+          <a:prstGeom prst="rect">
+            <a:avLst/>
+          </a:prstGeom>
+          <a:noFill/>
+          <a:ln/>
+        </p:spPr>
+        <p:txBody>
+          <a:bodyPr wrap="square" rtlCol="0" anchor="ctr"/>
+          <a:lstStyle/>
+          <a:p>
+            <a:pPr algn="ctr" indent="0" marL="0">
+              <a:buNone/>
+            </a:pPr>
+            <a:r>
+              <a:rPr lang="en-US" sz="1500" b="1" dirty="0">
+                <a:solidFill>
+                  <a:srgbClr val="2D3748"/>
+                </a:solidFill>
+                <a:latin typeface="Arial" pitchFamily="34" charset="0"/>
+                <a:ea typeface="Arial" pitchFamily="34" charset="-122"/>
+                <a:cs typeface="Arial" pitchFamily="34" charset="-120"/>
+              </a:rPr>
+              <a:t>El sector crece al</a:t>
+            </a:r>
+            <a:endParaRPr lang="en-US" sz="1500" dirty="0"/>
+          </a:p>
+          <a:p>
+            <a:pPr algn="ctr" indent="0" marL="0">
+              <a:buNone/>
+            </a:pPr>
+            <a:r>
+              <a:rPr lang="en-US" sz="1500" b="1" dirty="0">
+                <a:solidFill>
+                  <a:srgbClr val="2D3748"/>
+                </a:solidFill>
+                <a:latin typeface="Arial" pitchFamily="34" charset="0"/>
+                <a:ea typeface="Arial" pitchFamily="34" charset="-122"/>
+                <a:cs typeface="Arial" pitchFamily="34" charset="-120"/>
+              </a:rPr>
+              <a:t>18 % anual</a:t>
+            </a:r>
+            <a:endParaRPr lang="en-US" sz="1500" dirty="0"/>
+          </a:p>
+        </p:txBody>
+      </p:sp>
+      <p:sp>
+        <p:nvSpPr>
+          <p:cNvPr id="13" name="Text 11"/>
+          <p:cNvSpPr/>
+          <p:nvPr/>
+        </p:nvSpPr>
+        <p:spPr>
+          <a:xfrm>
+            <a:off x="457200" y="2578608"/>
+            <a:ext cx="2633472" cy="274320"/>
+          </a:xfrm>
+          <a:prstGeom prst="rect">
+            <a:avLst/>
+          </a:prstGeom>
+          <a:noFill/>
+          <a:ln/>
+        </p:spPr>
+        <p:txBody>
+          <a:bodyPr wrap="square" rtlCol="0" anchor="ctr"/>
+          <a:lstStyle/>
+          <a:p>
+            <a:pPr algn="ctr" indent="0" marL="0">
+              <a:buNone/>
+            </a:pPr>
+            <a:r>
+              <a:rPr lang="en-US" sz="950" dirty="0">
+                <a:solidFill>
+                  <a:srgbClr val="718096"/>
+                </a:solidFill>
+                <a:latin typeface="Arial" pitchFamily="34" charset="0"/>
+                <a:ea typeface="Arial" pitchFamily="34" charset="-122"/>
+                <a:cs typeface="Arial" pitchFamily="34" charset="-120"/>
+              </a:rPr>
+              <a:t>DENUE 2024→2025</a:t>
+            </a:r>
+            <a:endParaRPr lang="en-US" sz="950" dirty="0"/>
+          </a:p>
+        </p:txBody>
+      </p:sp>
+      <p:sp>
+        <p:nvSpPr>
+          <p:cNvPr id="14" name="Shape 12"/>
+          <p:cNvSpPr/>
+          <p:nvPr/>
+        </p:nvSpPr>
+        <p:spPr>
+          <a:xfrm>
+            <a:off x="3273552" y="960120"/>
+            <a:ext cx="2633472" cy="2331720"/>
+          </a:xfrm>
+          <a:prstGeom prst="roundRect">
+            <a:avLst>
+              <a:gd name="adj" fmla="val 4706"/>
+            </a:avLst>
+          </a:prstGeom>
+          <a:solidFill>
+            <a:srgbClr val="EFF6FF"/>
+          </a:solidFill>
+          <a:ln w="6350">
+            <a:solidFill>
+              <a:srgbClr val="E2E8F0"/>
+            </a:solidFill>
+            <a:prstDash val="solid"/>
+          </a:ln>
+        </p:spPr>
+      </p:sp>
+      <p:sp>
+        <p:nvSpPr>
+          <p:cNvPr id="15" name="Text 13"/>
+          <p:cNvSpPr/>
+          <p:nvPr/>
+        </p:nvSpPr>
+        <p:spPr>
+          <a:xfrm>
+            <a:off x="3273552" y="1078992"/>
+            <a:ext cx="2633472" cy="640080"/>
+          </a:xfrm>
+          <a:prstGeom prst="rect">
+            <a:avLst/>
+          </a:prstGeom>
+          <a:noFill/>
+          <a:ln/>
+        </p:spPr>
+        <p:txBody>
+          <a:bodyPr wrap="square" rtlCol="0" anchor="ctr"/>
+          <a:lstStyle/>
+          <a:p>
+            <a:pPr algn="ctr" indent="0" marL="0">
+              <a:buNone/>
+            </a:pPr>
+            <a:r>
+              <a:rPr lang="en-US" sz="3200" dirty="0">
+                <a:solidFill>
+                  <a:srgbClr val="000000"/>
+                </a:solidFill>
+              </a:rPr>
+              <a:t>📜</a:t>
+            </a:r>
+            <a:endParaRPr lang="en-US" sz="3200" dirty="0"/>
+          </a:p>
+        </p:txBody>
+      </p:sp>
+      <p:sp>
+        <p:nvSpPr>
+          <p:cNvPr id="16" name="Text 14"/>
+          <p:cNvSpPr/>
+          <p:nvPr/>
+        </p:nvSpPr>
+        <p:spPr>
+          <a:xfrm>
+            <a:off x="3273552" y="1755648"/>
+            <a:ext cx="2633472" cy="804672"/>
+          </a:xfrm>
+          <a:prstGeom prst="rect">
+            <a:avLst/>
+          </a:prstGeom>
+          <a:noFill/>
+          <a:ln/>
+        </p:spPr>
+        <p:txBody>
+          <a:bodyPr wrap="square" rtlCol="0" anchor="ctr"/>
+          <a:lstStyle/>
+          <a:p>
+            <a:pPr algn="ctr" indent="0" marL="0">
+              <a:buNone/>
+            </a:pPr>
+            <a:r>
+              <a:rPr lang="en-US" sz="1500" b="1" dirty="0">
+                <a:solidFill>
+                  <a:srgbClr val="2D3748"/>
+                </a:solidFill>
+                <a:latin typeface="Arial" pitchFamily="34" charset="0"/>
+                <a:ea typeface="Arial" pitchFamily="34" charset="-122"/>
+                <a:cs typeface="Arial" pitchFamily="34" charset="-120"/>
+              </a:rPr>
+              <a:t>La ley ya exige</a:t>
+            </a:r>
+            <a:endParaRPr lang="en-US" sz="1500" dirty="0"/>
+          </a:p>
+          <a:p>
+            <a:pPr algn="ctr" indent="0" marL="0">
+              <a:buNone/>
+            </a:pPr>
+            <a:r>
+              <a:rPr lang="en-US" sz="1500" b="1" dirty="0">
+                <a:solidFill>
+                  <a:srgbClr val="2D3748"/>
+                </a:solidFill>
+                <a:latin typeface="Arial" pitchFamily="34" charset="0"/>
+                <a:ea typeface="Arial" pitchFamily="34" charset="-122"/>
+                <a:cs typeface="Arial" pitchFamily="34" charset="-120"/>
+              </a:rPr>
+              <a:t>los registros</a:t>
+            </a:r>
+            <a:endParaRPr lang="en-US" sz="1500" dirty="0"/>
+          </a:p>
+        </p:txBody>
+      </p:sp>
+      <p:sp>
+        <p:nvSpPr>
+          <p:cNvPr id="17" name="Text 15"/>
+          <p:cNvSpPr/>
+          <p:nvPr/>
+        </p:nvSpPr>
+        <p:spPr>
+          <a:xfrm>
+            <a:off x="3273552" y="2578608"/>
+            <a:ext cx="2633472" cy="274320"/>
+          </a:xfrm>
+          <a:prstGeom prst="rect">
+            <a:avLst/>
+          </a:prstGeom>
+          <a:noFill/>
+          <a:ln/>
+        </p:spPr>
+        <p:txBody>
+          <a:bodyPr wrap="square" rtlCol="0" anchor="ctr"/>
+          <a:lstStyle/>
+          <a:p>
+            <a:pPr algn="ctr" indent="0" marL="0">
+              <a:buNone/>
+            </a:pPr>
+            <a:r>
+              <a:rPr lang="en-US" sz="950" dirty="0">
+                <a:solidFill>
+                  <a:srgbClr val="718096"/>
+                </a:solidFill>
+                <a:latin typeface="Arial" pitchFamily="34" charset="0"/>
+                <a:ea typeface="Arial" pitchFamily="34" charset="-122"/>
+                <a:cs typeface="Arial" pitchFamily="34" charset="-120"/>
+              </a:rPr>
+              <a:t>NOM-031-SSA3-2012 · vigente</a:t>
+            </a:r>
+            <a:endParaRPr lang="en-US" sz="950" dirty="0"/>
+          </a:p>
+        </p:txBody>
+      </p:sp>
+      <p:sp>
+        <p:nvSpPr>
+          <p:cNvPr id="18" name="Shape 16"/>
+          <p:cNvSpPr/>
+          <p:nvPr/>
+        </p:nvSpPr>
+        <p:spPr>
+          <a:xfrm>
+            <a:off x="6089904" y="960120"/>
+            <a:ext cx="2633472" cy="2331720"/>
+          </a:xfrm>
+          <a:prstGeom prst="roundRect">
+            <a:avLst>
+              <a:gd name="adj" fmla="val 4706"/>
+            </a:avLst>
+          </a:prstGeom>
+          <a:solidFill>
+            <a:srgbClr val="FFF7ED"/>
+          </a:solidFill>
+          <a:ln w="6350">
+            <a:solidFill>
+              <a:srgbClr val="E2E8F0"/>
+            </a:solidFill>
+            <a:prstDash val="solid"/>
+          </a:ln>
+        </p:spPr>
+      </p:sp>
+      <p:sp>
+        <p:nvSpPr>
+          <p:cNvPr id="19" name="Text 17"/>
+          <p:cNvSpPr/>
+          <p:nvPr/>
+        </p:nvSpPr>
+        <p:spPr>
+          <a:xfrm>
+            <a:off x="6089904" y="1078992"/>
+            <a:ext cx="2633472" cy="640080"/>
+          </a:xfrm>
+          <a:prstGeom prst="rect">
+            <a:avLst/>
+          </a:prstGeom>
+          <a:noFill/>
+          <a:ln/>
+        </p:spPr>
+        <p:txBody>
+          <a:bodyPr wrap="square" rtlCol="0" anchor="ctr"/>
+          <a:lstStyle/>
+          <a:p>
+            <a:pPr algn="ctr" indent="0" marL="0">
+              <a:buNone/>
+            </a:pPr>
+            <a:r>
+              <a:rPr lang="en-US" sz="3200" dirty="0">
+                <a:solidFill>
+                  <a:srgbClr val="000000"/>
+                </a:solidFill>
+              </a:rPr>
+              <a:t>❌</a:t>
+            </a:r>
+            <a:endParaRPr lang="en-US" sz="3200" dirty="0"/>
+          </a:p>
+        </p:txBody>
+      </p:sp>
+      <p:sp>
+        <p:nvSpPr>
+          <p:cNvPr id="20" name="Text 18"/>
+          <p:cNvSpPr/>
+          <p:nvPr/>
+        </p:nvSpPr>
+        <p:spPr>
+          <a:xfrm>
+            <a:off x="6089904" y="1755648"/>
+            <a:ext cx="2633472" cy="804672"/>
+          </a:xfrm>
+          <a:prstGeom prst="rect">
+            <a:avLst/>
+          </a:prstGeom>
+          <a:noFill/>
+          <a:ln/>
+        </p:spPr>
+        <p:txBody>
+          <a:bodyPr wrap="square" rtlCol="0" anchor="ctr"/>
+          <a:lstStyle/>
+          <a:p>
+            <a:pPr algn="ctr" indent="0" marL="0">
+              <a:buNone/>
+            </a:pPr>
+            <a:r>
+              <a:rPr lang="en-US" sz="1500" b="1" dirty="0">
+                <a:solidFill>
+                  <a:srgbClr val="2D3748"/>
+                </a:solidFill>
+                <a:latin typeface="Arial" pitchFamily="34" charset="0"/>
+                <a:ea typeface="Arial" pitchFamily="34" charset="-122"/>
+                <a:cs typeface="Arial" pitchFamily="34" charset="-120"/>
+              </a:rPr>
+              <a:t>Los competidores</a:t>
+            </a:r>
+            <a:endParaRPr lang="en-US" sz="1500" dirty="0"/>
+          </a:p>
+          <a:p>
+            <a:pPr algn="ctr" indent="0" marL="0">
+              <a:buNone/>
+            </a:pPr>
+            <a:r>
+              <a:rPr lang="en-US" sz="1500" b="1" dirty="0">
+                <a:solidFill>
+                  <a:srgbClr val="2D3748"/>
+                </a:solidFill>
+                <a:latin typeface="Arial" pitchFamily="34" charset="0"/>
+                <a:ea typeface="Arial" pitchFamily="34" charset="-122"/>
+                <a:cs typeface="Arial" pitchFamily="34" charset="-120"/>
+              </a:rPr>
+              <a:t>no los generan</a:t>
+            </a:r>
+            <a:endParaRPr lang="en-US" sz="1500" dirty="0"/>
+          </a:p>
+        </p:txBody>
+      </p:sp>
+      <p:sp>
+        <p:nvSpPr>
+          <p:cNvPr id="21" name="Text 19"/>
+          <p:cNvSpPr/>
+          <p:nvPr/>
+        </p:nvSpPr>
+        <p:spPr>
+          <a:xfrm>
+            <a:off x="6089904" y="2578608"/>
+            <a:ext cx="2633472" cy="274320"/>
+          </a:xfrm>
+          <a:prstGeom prst="rect">
+            <a:avLst/>
+          </a:prstGeom>
+          <a:noFill/>
+          <a:ln/>
+        </p:spPr>
+        <p:txBody>
+          <a:bodyPr wrap="square" rtlCol="0" anchor="ctr"/>
+          <a:lstStyle/>
+          <a:p>
+            <a:pPr algn="ctr" indent="0" marL="0">
+              <a:buNone/>
+            </a:pPr>
+            <a:r>
+              <a:rPr lang="en-US" sz="950" dirty="0">
+                <a:solidFill>
+                  <a:srgbClr val="718096"/>
+                </a:solidFill>
+                <a:latin typeface="Arial" pitchFamily="34" charset="0"/>
+                <a:ea typeface="Arial" pitchFamily="34" charset="-122"/>
+                <a:cs typeface="Arial" pitchFamily="34" charset="-120"/>
+              </a:rPr>
+              <a:t>Cronos Care · GERIGES</a:t>
+            </a:r>
+            <a:endParaRPr lang="en-US" sz="950" dirty="0"/>
+          </a:p>
+        </p:txBody>
+      </p:sp>
+      <p:sp>
+        <p:nvSpPr>
+          <p:cNvPr id="22" name="Text 20"/>
+          <p:cNvSpPr/>
+          <p:nvPr/>
+        </p:nvSpPr>
+        <p:spPr>
+          <a:xfrm>
+            <a:off x="4114800" y="3401568"/>
+            <a:ext cx="658368" cy="502920"/>
+          </a:xfrm>
+          <a:prstGeom prst="rect">
+            <a:avLst/>
+          </a:prstGeom>
+          <a:noFill/>
+          <a:ln/>
+        </p:spPr>
+        <p:txBody>
+          <a:bodyPr wrap="square" rtlCol="0" anchor="ctr"/>
+          <a:lstStyle/>
+          <a:p>
+            <a:pPr algn="ctr" indent="0" marL="0">
+              <a:buNone/>
+            </a:pPr>
+            <a:r>
+              <a:rPr lang="en-US" sz="2800" b="1" dirty="0">
+                <a:solidFill>
+                  <a:srgbClr val="5B8DB8"/>
+                </a:solidFill>
+                <a:latin typeface="Arial" pitchFamily="34" charset="0"/>
+                <a:ea typeface="Arial" pitchFamily="34" charset="-122"/>
+                <a:cs typeface="Arial" pitchFamily="34" charset="-120"/>
+              </a:rPr>
+              <a:t>↓</a:t>
+            </a:r>
+            <a:endParaRPr lang="en-US" sz="2800" dirty="0"/>
+          </a:p>
+        </p:txBody>
+      </p:sp>
+      <p:sp>
+        <p:nvSpPr>
+          <p:cNvPr id="23" name="Shape 21"/>
+          <p:cNvSpPr/>
+          <p:nvPr/>
+        </p:nvSpPr>
+        <p:spPr>
+          <a:xfrm>
+            <a:off x="457200" y="3977640"/>
+            <a:ext cx="8375904" cy="868680"/>
+          </a:xfrm>
+          <a:prstGeom prst="roundRect">
+            <a:avLst>
+              <a:gd name="adj" fmla="val 8421"/>
+            </a:avLst>
+          </a:prstGeom>
+          <a:solidFill>
+            <a:srgbClr val="EFF6FF"/>
+          </a:solidFill>
+          <a:ln w="6350">
+            <a:solidFill>
+              <a:srgbClr val="E2E8F0"/>
+            </a:solidFill>
+            <a:prstDash val="solid"/>
+          </a:ln>
+        </p:spPr>
+      </p:sp>
+      <p:sp>
+        <p:nvSpPr>
+          <p:cNvPr id="24" name="Text 22"/>
+          <p:cNvSpPr/>
+          <p:nvPr/>
+        </p:nvSpPr>
+        <p:spPr>
+          <a:xfrm>
+            <a:off x="640080" y="4041648"/>
+            <a:ext cx="8010144" cy="749808"/>
+          </a:xfrm>
+          <a:prstGeom prst="rect">
+            <a:avLst/>
+          </a:prstGeom>
+          <a:noFill/>
+          <a:ln/>
+        </p:spPr>
+        <p:txBody>
+          <a:bodyPr wrap="square" rtlCol="0" anchor="ctr"/>
+          <a:lstStyle/>
+          <a:p>
+            <a:pPr algn="ctr" indent="0" marL="0">
+              <a:buNone/>
+            </a:pPr>
+            <a:r>
+              <a:rPr lang="en-US" sz="1700" b="1" dirty="0">
+                <a:solidFill>
+                  <a:srgbClr val="3A6B96"/>
+                </a:solidFill>
+                <a:latin typeface="Arial" pitchFamily="34" charset="0"/>
+                <a:ea typeface="Arial" pitchFamily="34" charset="-122"/>
+                <a:cs typeface="Arial" pitchFamily="34" charset="-120"/>
+              </a:rPr>
+              <a:t>El primero que llegue con trazabilidad operativa real</a:t>
+            </a:r>
+            <a:endParaRPr lang="en-US" sz="1700" dirty="0"/>
+          </a:p>
+          <a:p>
+            <a:pPr algn="ctr" indent="0" marL="0">
+              <a:buNone/>
+            </a:pPr>
+            <a:r>
+              <a:rPr lang="en-US" sz="1700" b="1" dirty="0">
+                <a:solidFill>
+                  <a:srgbClr val="3A6B96"/>
+                </a:solidFill>
+                <a:latin typeface="Arial" pitchFamily="34" charset="0"/>
+                <a:ea typeface="Arial" pitchFamily="34" charset="-122"/>
+                <a:cs typeface="Arial" pitchFamily="34" charset="-120"/>
+              </a:rPr>
+              <a:t>se convierte en el estándar del sector.</a:t>
+            </a:r>
+            <a:endParaRPr lang="en-US" sz="1700" dirty="0"/>
+          </a:p>
+        </p:txBody>
+      </p:sp>
+      <p:sp>
+        <p:nvSpPr>
+          <p:cNvPr id="25" name="Shape 23"/>
+          <p:cNvSpPr/>
+          <p:nvPr/>
+        </p:nvSpPr>
+        <p:spPr>
+          <a:xfrm>
+            <a:off x="1645920" y="5029200"/>
+            <a:ext cx="5541264" cy="749808"/>
+          </a:xfrm>
+          <a:prstGeom prst="roundRect">
+            <a:avLst>
+              <a:gd name="adj" fmla="val 9756"/>
+            </a:avLst>
+          </a:prstGeom>
+          <a:solidFill>
+            <a:srgbClr val="F0EDE8"/>
+          </a:solidFill>
+          <a:ln w="6350">
+            <a:solidFill>
+              <a:srgbClr val="E2E8F0"/>
+            </a:solidFill>
+            <a:prstDash val="solid"/>
+          </a:ln>
+        </p:spPr>
+      </p:sp>
+      <p:sp>
+        <p:nvSpPr>
+          <p:cNvPr id="26" name="Text 24"/>
+          <p:cNvSpPr/>
+          <p:nvPr/>
+        </p:nvSpPr>
+        <p:spPr>
+          <a:xfrm>
+            <a:off x="1645920" y="5093208"/>
+            <a:ext cx="5541264" cy="594360"/>
+          </a:xfrm>
+          <a:prstGeom prst="rect">
+            <a:avLst/>
+          </a:prstGeom>
+          <a:noFill/>
+          <a:ln/>
+        </p:spPr>
+        <p:txBody>
+          <a:bodyPr wrap="square" rtlCol="0" anchor="ctr"/>
+          <a:lstStyle/>
+          <a:p>
+            <a:pPr algn="ctr" indent="0" marL="0">
+              <a:buNone/>
+            </a:pPr>
+            <a:r>
+              <a:rPr lang="en-US" sz="1400" b="1" dirty="0">
+                <a:solidFill>
+                  <a:srgbClr val="5B8DB8"/>
+                </a:solidFill>
+                <a:latin typeface="Arial" pitchFamily="34" charset="0"/>
+                <a:ea typeface="Arial" pitchFamily="34" charset="-122"/>
+                <a:cs typeface="Arial" pitchFamily="34" charset="-120"/>
+              </a:rPr>
+              <a:t>🤝  Buscamos 2–3 residencias piloto · Primer trimestre 2027</a:t>
+            </a:r>
+            <a:endParaRPr lang="en-US" sz="1400" dirty="0"/>
+          </a:p>
+        </p:txBody>
+      </p:sp>
+      <p:sp>
+        <p:nvSpPr>
+          <p:cNvPr id="27" name="Text 25"/>
+          <p:cNvSpPr/>
+          <p:nvPr/>
+        </p:nvSpPr>
+        <p:spPr>
+          <a:xfrm>
+            <a:off x="457200" y="5897880"/>
+            <a:ext cx="8375904" cy="365760"/>
+          </a:xfrm>
+          <a:prstGeom prst="rect">
+            <a:avLst/>
+          </a:prstGeom>
+          <a:noFill/>
+          <a:ln/>
+        </p:spPr>
+        <p:txBody>
+          <a:bodyPr wrap="square" rtlCol="0" anchor="ctr"/>
+          <a:lstStyle/>
+          <a:p>
+            <a:pPr algn="ctr" indent="0" marL="0">
+              <a:buNone/>
+            </a:pPr>
+            <a:r>
+              <a:rPr lang="en-US" sz="1800" b="1" dirty="0">
+                <a:solidFill>
+                  <a:srgbClr val="2D3748"/>
+                </a:solidFill>
+                <a:latin typeface="Arial" pitchFamily="34" charset="0"/>
+                <a:ea typeface="Arial" pitchFamily="34" charset="-122"/>
+                <a:cs typeface="Arial" pitchFamily="34" charset="-120"/>
+              </a:rPr>
+              <a:t>Gracias.</a:t>
+            </a:r>
+            <a:endParaRPr lang="en-US" sz="1800" dirty="0"/>
+          </a:p>
+        </p:txBody>
+      </p:sp>
+      <p:sp>
+        <p:nvSpPr>
+          <p:cNvPr id="28" name="Text 26"/>
+          <p:cNvSpPr/>
+          <p:nvPr/>
+        </p:nvSpPr>
+        <p:spPr>
+          <a:xfrm>
+            <a:off x="457200" y="6291072"/>
+            <a:ext cx="8375904" cy="201168"/>
+          </a:xfrm>
+          <a:prstGeom prst="rect">
+            <a:avLst/>
+          </a:prstGeom>
+          <a:noFill/>
+          <a:ln/>
+        </p:spPr>
+        <p:txBody>
+          <a:bodyPr wrap="square" rtlCol="0" anchor="ctr"/>
+          <a:lstStyle/>
+          <a:p>
+            <a:pPr algn="ctr" indent="0" marL="0">
+              <a:buNone/>
+            </a:pPr>
+            <a:r>
+              <a:rPr lang="en-US" dirty="0">
+                <a:solidFill>
+                  <a:srgbClr val="718096"/>
+                </a:solidFill>
+                <a:latin typeface="Arial" pitchFamily="34" charset="0"/>
+                <a:ea typeface="Arial" pitchFamily="34" charset="-122"/>
+                <a:cs typeface="Arial" pitchFamily="34" charset="-120"/>
+              </a:rPr>
+              <a:t>MVP operacional · No dispositivo médico · Datos ficticios · v0.1.0-workshop</a:t>
+            </a:r>
+            <a:endParaRPr lang="en-US" dirty="0"/>
+          </a:p>
+        </p:txBody>
+      </p:sp>
+    </p:spTree>
+  </p:cSld>
+  <p:clrMapOvr>
+    <a:masterClrMapping/>
+  </p:clrMapOvr>
+</p:sld>
+</file>
+
+<file path=ppt/slides/slide14.xml><?xml version="1.0" encoding="utf-8"?>
+<p:sld xmlns:a="http://schemas.openxmlformats.org/drawingml/2006/main" xmlns:r="http://schemas.openxmlformats.org/officeDocument/2006/relationships" xmlns:p="http://schemas.openxmlformats.org/presentationml/2006/main">
+  <p:cSld name="Slide 14">
+    <p:spTree>
+      <p:nvGrpSpPr>
+        <p:cNvPr id="1" name=""/>
+        <p:cNvGrpSpPr/>
+        <p:nvPr/>
+      </p:nvGrpSpPr>
+      <p:grpSpPr>
+        <a:xfrm>
+          <a:off x="0" y="0"/>
+          <a:ext cx="0" cy="0"/>
+          <a:chOff x="0" y="0"/>
+          <a:chExt cx="0" cy="0"/>
+        </a:xfrm>
+      </p:grpSpPr>
+      <p:sp>
+        <p:nvSpPr>
+          <p:cNvPr id="2" name="Shape 0"/>
+          <p:cNvSpPr/>
+          <p:nvPr/>
+        </p:nvSpPr>
+        <p:spPr>
+          <a:xfrm>
+            <a:off x="0" y="0"/>
+            <a:ext cx="12192000" cy="6858000"/>
+          </a:xfrm>
+          <a:prstGeom prst="rect">
+            <a:avLst/>
+          </a:prstGeom>
+          <a:solidFill>
+            <a:srgbClr val="FAFAF8"/>
+          </a:solidFill>
+          <a:ln w="12700">
+            <a:solidFill>
+              <a:srgbClr val="FAFAF8"/>
+            </a:solidFill>
+            <a:prstDash val="solid"/>
+          </a:ln>
+        </p:spPr>
+      </p:sp>
+      <p:sp>
+        <p:nvSpPr>
+          <p:cNvPr id="3" name="Shape 1"/>
+          <p:cNvSpPr/>
+          <p:nvPr/>
+        </p:nvSpPr>
+        <p:spPr>
+          <a:xfrm>
+            <a:off x="7132320" y="-1371600"/>
+            <a:ext cx="3474720" cy="3474720"/>
+          </a:xfrm>
+          <a:prstGeom prst="ellipse">
+            <a:avLst/>
+          </a:prstGeom>
+          <a:solidFill>
+            <a:srgbClr val="7BA68A">
+              <a:alpha val="16000"/>
+            </a:srgbClr>
+          </a:solidFill>
+          <a:ln w="12700">
+            <a:solidFill>
+              <a:srgbClr val="7BA68A">
+                <a:alpha val="16000"/>
+              </a:srgbClr>
+            </a:solidFill>
+            <a:prstDash val="solid"/>
+          </a:ln>
+        </p:spPr>
+      </p:sp>
+      <p:sp>
+        <p:nvSpPr>
+          <p:cNvPr id="4" name="Shape 2"/>
+          <p:cNvSpPr/>
+          <p:nvPr/>
+        </p:nvSpPr>
+        <p:spPr>
+          <a:xfrm>
+            <a:off x="-365760" y="5303520"/>
+            <a:ext cx="2011680" cy="2011680"/>
+          </a:xfrm>
+          <a:prstGeom prst="ellipse">
+            <a:avLst/>
+          </a:prstGeom>
+          <a:solidFill>
+            <a:srgbClr val="A8C4DC">
+              <a:alpha val="20000"/>
+            </a:srgbClr>
+          </a:solidFill>
+          <a:ln w="12700">
+            <a:solidFill>
+              <a:srgbClr val="A8C4DC">
+                <a:alpha val="20000"/>
+              </a:srgbClr>
+            </a:solidFill>
+            <a:prstDash val="solid"/>
+          </a:ln>
+        </p:spPr>
+      </p:sp>
+      <p:sp>
+        <p:nvSpPr>
+          <p:cNvPr id="5" name="Shape 3"/>
+          <p:cNvSpPr/>
+          <p:nvPr/>
+        </p:nvSpPr>
+        <p:spPr>
+          <a:xfrm rot="-1080000">
+            <a:off x="274320" y="5943600"/>
+            <a:ext cx="2286000" cy="0"/>
+          </a:xfrm>
+          <a:prstGeom prst="line">
+            <a:avLst/>
+          </a:prstGeom>
+          <a:noFill/>
+          <a:ln w="12700">
+            <a:solidFill>
+              <a:srgbClr val="E2E8F0"/>
+            </a:solidFill>
+            <a:prstDash val="solid"/>
+          </a:ln>
+        </p:spPr>
+      </p:sp>
+      <p:sp>
+        <p:nvSpPr>
+          <p:cNvPr id="6" name="Shape 4"/>
+          <p:cNvSpPr/>
+          <p:nvPr/>
+        </p:nvSpPr>
+        <p:spPr>
+          <a:xfrm>
+            <a:off x="0" y="0"/>
+            <a:ext cx="12192000" cy="54864"/>
+          </a:xfrm>
+          <a:prstGeom prst="rect">
+            <a:avLst/>
+          </a:prstGeom>
+          <a:solidFill>
+            <a:srgbClr val="5B8DB8"/>
+          </a:solidFill>
+          <a:ln w="12700">
+            <a:solidFill>
+              <a:srgbClr val="5B8DB8"/>
+            </a:solidFill>
+            <a:prstDash val="solid"/>
+          </a:ln>
+        </p:spPr>
+      </p:sp>
+      <p:sp>
+        <p:nvSpPr>
+          <p:cNvPr id="7" name="Shape 5"/>
+          <p:cNvSpPr/>
+          <p:nvPr/>
+        </p:nvSpPr>
+        <p:spPr>
+          <a:xfrm>
+            <a:off x="0" y="6528816"/>
+            <a:ext cx="12192000" cy="54864"/>
+          </a:xfrm>
+          <a:prstGeom prst="rect">
+            <a:avLst/>
+          </a:prstGeom>
+          <a:solidFill>
+            <a:srgbClr val="C4786A"/>
+          </a:solidFill>
+          <a:ln w="12700">
+            <a:solidFill>
+              <a:srgbClr val="C4786A"/>
+            </a:solidFill>
+            <a:prstDash val="solid"/>
+          </a:ln>
+        </p:spPr>
+      </p:sp>
+      <p:sp>
+        <p:nvSpPr>
+          <p:cNvPr id="8" name="Text 6"/>
+          <p:cNvSpPr/>
+          <p:nvPr/>
+        </p:nvSpPr>
+        <p:spPr>
+          <a:xfrm>
+            <a:off x="457200" y="228600"/>
+            <a:ext cx="8375904" cy="502920"/>
+          </a:xfrm>
+          <a:prstGeom prst="rect">
+            <a:avLst/>
+          </a:prstGeom>
+          <a:noFill/>
+          <a:ln/>
+        </p:spPr>
+        <p:txBody>
+          <a:bodyPr wrap="square" rtlCol="0" anchor="ctr"/>
+          <a:lstStyle/>
+          <a:p>
+            <a:pPr indent="0" marL="0">
+              <a:buNone/>
+            </a:pPr>
+            <a:r>
+              <a:rPr lang="en-US" b="1" dirty="0">
+                <a:solidFill>
+                  <a:srgbClr val="2D3748"/>
+                </a:solidFill>
+                <a:latin typeface="Arial" pitchFamily="34" charset="0"/>
+                <a:ea typeface="Arial" pitchFamily="34" charset="-122"/>
+                <a:cs typeface="Arial" pitchFamily="34" charset="-120"/>
+              </a:rPr>
+              <a:t>❓  Preguntas frecuentes — respuestas preparadas</a:t>
+            </a:r>
+            <a:endParaRPr lang="en-US" dirty="0"/>
+          </a:p>
+        </p:txBody>
+      </p:sp>
+      <p:sp>
+        <p:nvSpPr>
+          <p:cNvPr id="9" name="Text 7"/>
+          <p:cNvSpPr/>
+          <p:nvPr/>
+        </p:nvSpPr>
+        <p:spPr>
+          <a:xfrm>
+            <a:off x="457200" y="731520"/>
+            <a:ext cx="8375904" cy="320040"/>
+          </a:xfrm>
+          <a:prstGeom prst="rect">
+            <a:avLst/>
+          </a:prstGeom>
+          <a:noFill/>
+          <a:ln/>
+        </p:spPr>
+        <p:txBody>
+          <a:bodyPr wrap="square" rtlCol="0" anchor="ctr"/>
+          <a:lstStyle/>
+          <a:p>
+            <a:pPr indent="0" marL="0">
+              <a:buNone/>
+            </a:pPr>
+            <a:r>
+              <a:rPr lang="en-US" b="1" dirty="0">
+                <a:solidFill>
+                  <a:srgbClr val="5B8DB8"/>
+                </a:solidFill>
+                <a:latin typeface="Arial" pitchFamily="34" charset="0"/>
+                <a:ea typeface="Arial" pitchFamily="34" charset="-122"/>
+                <a:cs typeface="Arial" pitchFamily="34" charset="-120"/>
+              </a:rPr>
+              <a:t>Solo para uso interno durante la sesión de Q&amp;A</a:t>
+            </a:r>
+            <a:endParaRPr lang="en-US" dirty="0"/>
+          </a:p>
+        </p:txBody>
+      </p:sp>
+      <p:sp>
+        <p:nvSpPr>
+          <p:cNvPr id="10" name="Shape 8"/>
+          <p:cNvSpPr/>
+          <p:nvPr/>
+        </p:nvSpPr>
+        <p:spPr>
+          <a:xfrm>
+            <a:off x="457200" y="1097280"/>
+            <a:ext cx="8375904" cy="0"/>
+          </a:xfrm>
+          <a:prstGeom prst="line">
+            <a:avLst/>
+          </a:prstGeom>
+          <a:noFill/>
+          <a:ln w="12700">
+            <a:solidFill>
+              <a:srgbClr val="E2E8F0"/>
+            </a:solidFill>
+            <a:prstDash val="solid"/>
+          </a:ln>
+        </p:spPr>
+      </p:sp>
+      <p:sp>
+        <p:nvSpPr>
+          <p:cNvPr id="11" name="Shape 9"/>
+          <p:cNvSpPr/>
+          <p:nvPr/>
+        </p:nvSpPr>
+        <p:spPr>
+          <a:xfrm>
+            <a:off x="457200" y="1234440"/>
+            <a:ext cx="8375904" cy="1051560"/>
+          </a:xfrm>
+          <a:prstGeom prst="roundRect">
+            <a:avLst>
+              <a:gd name="adj" fmla="val 8696"/>
+            </a:avLst>
+          </a:prstGeom>
+          <a:solidFill>
+            <a:srgbClr val="F0EDE8"/>
+          </a:solidFill>
+          <a:ln w="6350">
+            <a:solidFill>
+              <a:srgbClr val="E2E8F0"/>
+            </a:solidFill>
+            <a:prstDash val="solid"/>
+          </a:ln>
+        </p:spPr>
+      </p:sp>
+      <p:sp>
+        <p:nvSpPr>
+          <p:cNvPr id="12" name="Text 10"/>
+          <p:cNvSpPr/>
+          <p:nvPr/>
+        </p:nvSpPr>
+        <p:spPr>
+          <a:xfrm>
+            <a:off x="640080" y="1325880"/>
+            <a:ext cx="8010144" cy="329184"/>
+          </a:xfrm>
+          <a:prstGeom prst="rect">
+            <a:avLst/>
+          </a:prstGeom>
+          <a:noFill/>
+          <a:ln/>
+        </p:spPr>
+        <p:txBody>
+          <a:bodyPr wrap="square" rtlCol="0" anchor="ctr"/>
+          <a:lstStyle/>
+          <a:p>
+            <a:pPr indent="0" marL="0">
+              <a:buNone/>
+            </a:pPr>
+            <a:r>
+              <a:rPr lang="en-US" sz="1200" b="1" dirty="0">
+                <a:solidFill>
+                  <a:srgbClr val="3A6B96"/>
+                </a:solidFill>
+                <a:latin typeface="Arial" pitchFamily="34" charset="0"/>
+                <a:ea typeface="Arial" pitchFamily="34" charset="-122"/>
+                <a:cs typeface="Arial" pitchFamily="34" charset="-120"/>
+              </a:rPr>
+              <a:t>P: ¿Tienen clientes?</a:t>
+            </a:r>
+            <a:endParaRPr lang="en-US" sz="1200" dirty="0"/>
+          </a:p>
+        </p:txBody>
+      </p:sp>
+      <p:sp>
+        <p:nvSpPr>
+          <p:cNvPr id="13" name="Text 11"/>
+          <p:cNvSpPr/>
+          <p:nvPr/>
+        </p:nvSpPr>
+        <p:spPr>
+          <a:xfrm>
+            <a:off x="640080" y="1673352"/>
+            <a:ext cx="8010144" cy="530352"/>
+          </a:xfrm>
+          <a:prstGeom prst="rect">
+            <a:avLst/>
+          </a:prstGeom>
+          <a:noFill/>
+          <a:ln/>
+        </p:spPr>
+        <p:txBody>
+          <a:bodyPr wrap="square" rtlCol="0" anchor="ctr"/>
+          <a:lstStyle/>
+          <a:p>
+            <a:pPr indent="0" marL="0">
+              <a:buNone/>
+            </a:pPr>
+            <a:r>
+              <a:rPr lang="en-US" sz="1200" dirty="0">
+                <a:solidFill>
+                  <a:srgbClr val="2D3748"/>
+                </a:solidFill>
+                <a:latin typeface="Arial" pitchFamily="34" charset="0"/>
+                <a:ea typeface="Arial" pitchFamily="34" charset="-122"/>
+                <a:cs typeface="Arial" pitchFamily="34" charset="-120"/>
+              </a:rPr>
+              <a:t>R: Cero clientes hoy. La tracción es de producto. Buscamos los primeros pilotos con este pitch.</a:t>
+            </a:r>
+            <a:endParaRPr lang="en-US" sz="1200" dirty="0"/>
+          </a:p>
+        </p:txBody>
+      </p:sp>
+      <p:sp>
+        <p:nvSpPr>
+          <p:cNvPr id="14" name="Shape 12"/>
+          <p:cNvSpPr/>
+          <p:nvPr/>
+        </p:nvSpPr>
+        <p:spPr>
+          <a:xfrm>
+            <a:off x="457200" y="2404872"/>
+            <a:ext cx="8375904" cy="1051560"/>
+          </a:xfrm>
+          <a:prstGeom prst="roundRect">
+            <a:avLst>
+              <a:gd name="adj" fmla="val 8696"/>
+            </a:avLst>
+          </a:prstGeom>
+          <a:solidFill>
+            <a:srgbClr val="EFF6FF"/>
+          </a:solidFill>
+          <a:ln w="6350">
+            <a:solidFill>
+              <a:srgbClr val="E2E8F0"/>
+            </a:solidFill>
+            <a:prstDash val="solid"/>
+          </a:ln>
+        </p:spPr>
+      </p:sp>
+      <p:sp>
+        <p:nvSpPr>
+          <p:cNvPr id="15" name="Text 13"/>
+          <p:cNvSpPr/>
+          <p:nvPr/>
+        </p:nvSpPr>
+        <p:spPr>
+          <a:xfrm>
+            <a:off x="640080" y="2496312"/>
+            <a:ext cx="8010144" cy="329184"/>
+          </a:xfrm>
+          <a:prstGeom prst="rect">
+            <a:avLst/>
+          </a:prstGeom>
+          <a:noFill/>
+          <a:ln/>
+        </p:spPr>
+        <p:txBody>
+          <a:bodyPr wrap="square" rtlCol="0" anchor="ctr"/>
+          <a:lstStyle/>
+          <a:p>
+            <a:pPr indent="0" marL="0">
+              <a:buNone/>
+            </a:pPr>
+            <a:r>
+              <a:rPr lang="en-US" sz="1200" b="1" dirty="0">
+                <a:solidFill>
+                  <a:srgbClr val="3A6B96"/>
+                </a:solidFill>
+                <a:latin typeface="Arial" pitchFamily="34" charset="0"/>
+                <a:ea typeface="Arial" pitchFamily="34" charset="-122"/>
+                <a:cs typeface="Arial" pitchFamily="34" charset="-120"/>
+              </a:rPr>
+              <a:t>P: ¿Por qué no hay IA en el producto actual?</a:t>
+            </a:r>
+            <a:endParaRPr lang="en-US" sz="1200" dirty="0"/>
+          </a:p>
+        </p:txBody>
+      </p:sp>
+      <p:sp>
+        <p:nvSpPr>
+          <p:cNvPr id="16" name="Text 14"/>
+          <p:cNvSpPr/>
+          <p:nvPr/>
+        </p:nvSpPr>
+        <p:spPr>
+          <a:xfrm>
+            <a:off x="640080" y="2843784"/>
+            <a:ext cx="8010144" cy="530352"/>
+          </a:xfrm>
+          <a:prstGeom prst="rect">
+            <a:avLst/>
+          </a:prstGeom>
+          <a:noFill/>
+          <a:ln/>
+        </p:spPr>
+        <p:txBody>
+          <a:bodyPr wrap="square" rtlCol="0" anchor="ctr"/>
+          <a:lstStyle/>
+          <a:p>
+            <a:pPr indent="0" marL="0">
+              <a:buNone/>
+            </a:pPr>
+            <a:r>
+              <a:rPr lang="en-US" sz="1200" dirty="0">
+                <a:solidFill>
+                  <a:srgbClr val="2D3748"/>
+                </a:solidFill>
+                <a:latin typeface="Arial" pitchFamily="34" charset="0"/>
+                <a:ea typeface="Arial" pitchFamily="34" charset="-122"/>
+                <a:cs typeface="Arial" pitchFamily="34" charset="-120"/>
+              </a:rPr>
+              <a:t>R: Decisión de privacidad: ningún dato de residente sale del dispositivo. La IA entra en v0.2 cuando tengamos datos reales con consentimiento.</a:t>
+            </a:r>
+            <a:endParaRPr lang="en-US" sz="1200" dirty="0"/>
+          </a:p>
+        </p:txBody>
+      </p:sp>
+      <p:sp>
+        <p:nvSpPr>
+          <p:cNvPr id="17" name="Shape 15"/>
+          <p:cNvSpPr/>
+          <p:nvPr/>
+        </p:nvSpPr>
+        <p:spPr>
+          <a:xfrm>
+            <a:off x="457200" y="3575304"/>
+            <a:ext cx="8375904" cy="1051560"/>
+          </a:xfrm>
+          <a:prstGeom prst="roundRect">
+            <a:avLst>
+              <a:gd name="adj" fmla="val 8696"/>
+            </a:avLst>
+          </a:prstGeom>
+          <a:solidFill>
+            <a:srgbClr val="F0EDE8"/>
+          </a:solidFill>
+          <a:ln w="6350">
+            <a:solidFill>
+              <a:srgbClr val="E2E8F0"/>
+            </a:solidFill>
+            <a:prstDash val="solid"/>
+          </a:ln>
+        </p:spPr>
+      </p:sp>
+      <p:sp>
+        <p:nvSpPr>
+          <p:cNvPr id="18" name="Text 16"/>
+          <p:cNvSpPr/>
+          <p:nvPr/>
+        </p:nvSpPr>
+        <p:spPr>
+          <a:xfrm>
+            <a:off x="640080" y="3666744"/>
+            <a:ext cx="8010144" cy="329184"/>
+          </a:xfrm>
+          <a:prstGeom prst="rect">
+            <a:avLst/>
+          </a:prstGeom>
+          <a:noFill/>
+          <a:ln/>
+        </p:spPr>
+        <p:txBody>
+          <a:bodyPr wrap="square" rtlCol="0" anchor="ctr"/>
+          <a:lstStyle/>
+          <a:p>
+            <a:pPr indent="0" marL="0">
+              <a:buNone/>
+            </a:pPr>
+            <a:r>
+              <a:rPr lang="en-US" sz="1200" b="1" dirty="0">
+                <a:solidFill>
+                  <a:srgbClr val="3A6B96"/>
+                </a:solidFill>
+                <a:latin typeface="Arial" pitchFamily="34" charset="0"/>
+                <a:ea typeface="Arial" pitchFamily="34" charset="-122"/>
+                <a:cs typeface="Arial" pitchFamily="34" charset="-120"/>
+              </a:rPr>
+              <a:t>P: ¿Cómo se comparan con Cronos Care?</a:t>
+            </a:r>
+            <a:endParaRPr lang="en-US" sz="1200" dirty="0"/>
+          </a:p>
+        </p:txBody>
+      </p:sp>
+      <p:sp>
+        <p:nvSpPr>
+          <p:cNvPr id="19" name="Text 17"/>
+          <p:cNvSpPr/>
+          <p:nvPr/>
+        </p:nvSpPr>
+        <p:spPr>
+          <a:xfrm>
+            <a:off x="640080" y="4014216"/>
+            <a:ext cx="8010144" cy="530352"/>
+          </a:xfrm>
+          <a:prstGeom prst="rect">
+            <a:avLst/>
+          </a:prstGeom>
+          <a:noFill/>
+          <a:ln/>
+        </p:spPr>
+        <p:txBody>
+          <a:bodyPr wrap="square" rtlCol="0" anchor="ctr"/>
+          <a:lstStyle/>
+          <a:p>
+            <a:pPr indent="0" marL="0">
+              <a:buNone/>
+            </a:pPr>
+            <a:r>
+              <a:rPr lang="en-US" sz="1200" dirty="0">
+                <a:solidFill>
+                  <a:srgbClr val="2D3748"/>
+                </a:solidFill>
+                <a:latin typeface="Arial" pitchFamily="34" charset="0"/>
+                <a:ea typeface="Arial" pitchFamily="34" charset="-122"/>
+                <a:cs typeface="Arial" pitchFamily="34" charset="-120"/>
+              </a:rPr>
+              <a:t>R: Cronos Care tiene +50 residencias en México. Somos complementarios en expediente clínico, directamente superiores en ciclo operativo de ronda.</a:t>
+            </a:r>
+            <a:endParaRPr lang="en-US" sz="1200" dirty="0"/>
+          </a:p>
+        </p:txBody>
+      </p:sp>
+      <p:sp>
+        <p:nvSpPr>
+          <p:cNvPr id="20" name="Shape 18"/>
+          <p:cNvSpPr/>
+          <p:nvPr/>
+        </p:nvSpPr>
+        <p:spPr>
+          <a:xfrm>
+            <a:off x="457200" y="4745736"/>
+            <a:ext cx="8375904" cy="1051560"/>
+          </a:xfrm>
+          <a:prstGeom prst="roundRect">
+            <a:avLst>
+              <a:gd name="adj" fmla="val 8696"/>
+            </a:avLst>
+          </a:prstGeom>
+          <a:solidFill>
+            <a:srgbClr val="EFF6FF"/>
+          </a:solidFill>
+          <a:ln w="6350">
+            <a:solidFill>
+              <a:srgbClr val="E2E8F0"/>
+            </a:solidFill>
+            <a:prstDash val="solid"/>
+          </a:ln>
+        </p:spPr>
+      </p:sp>
+      <p:sp>
+        <p:nvSpPr>
+          <p:cNvPr id="21" name="Text 19"/>
+          <p:cNvSpPr/>
+          <p:nvPr/>
+        </p:nvSpPr>
+        <p:spPr>
+          <a:xfrm>
+            <a:off x="640080" y="4837176"/>
+            <a:ext cx="8010144" cy="329184"/>
+          </a:xfrm>
+          <a:prstGeom prst="rect">
+            <a:avLst/>
+          </a:prstGeom>
+          <a:noFill/>
+          <a:ln/>
+        </p:spPr>
+        <p:txBody>
+          <a:bodyPr wrap="square" rtlCol="0" anchor="ctr"/>
+          <a:lstStyle/>
+          <a:p>
+            <a:pPr indent="0" marL="0">
+              <a:buNone/>
+            </a:pPr>
+            <a:r>
+              <a:rPr lang="en-US" sz="1200" b="1" dirty="0">
+                <a:solidFill>
+                  <a:srgbClr val="3A6B96"/>
+                </a:solidFill>
+                <a:latin typeface="Arial" pitchFamily="34" charset="0"/>
+                <a:ea typeface="Arial" pitchFamily="34" charset="-122"/>
+                <a:cs typeface="Arial" pitchFamily="34" charset="-120"/>
+              </a:rPr>
+              <a:t>P: ¿Quién es el equipo?</a:t>
+            </a:r>
+            <a:endParaRPr lang="en-US" sz="1200" dirty="0"/>
+          </a:p>
+        </p:txBody>
+      </p:sp>
+      <p:sp>
+        <p:nvSpPr>
+          <p:cNvPr id="22" name="Text 20"/>
+          <p:cNvSpPr/>
+          <p:nvPr/>
+        </p:nvSpPr>
+        <p:spPr>
+          <a:xfrm>
+            <a:off x="640080" y="5184648"/>
+            <a:ext cx="8010144" cy="530352"/>
+          </a:xfrm>
+          <a:prstGeom prst="rect">
+            <a:avLst/>
+          </a:prstGeom>
+          <a:noFill/>
+          <a:ln/>
+        </p:spPr>
+        <p:txBody>
+          <a:bodyPr wrap="square" rtlCol="0" anchor="ctr"/>
+          <a:lstStyle/>
+          <a:p>
+            <a:pPr indent="0" marL="0">
+              <a:buNone/>
+            </a:pPr>
+            <a:r>
+              <a:rPr lang="en-US" sz="1200" dirty="0">
+                <a:solidFill>
+                  <a:srgbClr val="2D3748"/>
+                </a:solidFill>
+                <a:latin typeface="Arial" pitchFamily="34" charset="0"/>
+                <a:ea typeface="Arial" pitchFamily="34" charset="-122"/>
+                <a:cs typeface="Arial" pitchFamily="34" charset="-120"/>
+              </a:rPr>
+              <a:t>R: Proyecto individual — 5 roles, 8 fases con gate review en cada una. El método es la evidencia de colaboración estructurada.</a:t>
+            </a:r>
+            <a:endParaRPr lang="en-US" sz="1200" dirty="0"/>
+          </a:p>
+        </p:txBody>
+      </p:sp>
+      <p:sp>
+        <p:nvSpPr>
+          <p:cNvPr id="23" name="Text 21"/>
+          <p:cNvSpPr/>
+          <p:nvPr/>
+        </p:nvSpPr>
+        <p:spPr>
+          <a:xfrm>
+            <a:off x="457200" y="6291072"/>
+            <a:ext cx="8375904" cy="201168"/>
+          </a:xfrm>
+          <a:prstGeom prst="rect">
+            <a:avLst/>
+          </a:prstGeom>
+          <a:noFill/>
+          <a:ln/>
+        </p:spPr>
+        <p:txBody>
+          <a:bodyPr wrap="square" rtlCol="0" anchor="ctr"/>
+          <a:lstStyle/>
+          <a:p>
+            <a:pPr algn="ctr" indent="0" marL="0">
+              <a:buNone/>
+            </a:pPr>
+            <a:r>
+              <a:rPr lang="en-US" dirty="0">
+                <a:solidFill>
+                  <a:srgbClr val="718096"/>
+                </a:solidFill>
+                <a:latin typeface="Arial" pitchFamily="34" charset="0"/>
+                <a:ea typeface="Arial" pitchFamily="34" charset="-122"/>
+                <a:cs typeface="Arial" pitchFamily="34" charset="-120"/>
+              </a:rPr>
+              <a:t>MVP operacional · No dispositivo médico · Datos ficticios</a:t>
+            </a:r>
+            <a:endParaRPr lang="en-US" dirty="0"/>
+          </a:p>
+        </p:txBody>
+      </p:sp>
+    </p:spTree>
+  </p:cSld>
+  <p:clrMapOvr>
+    <a:masterClrMapping/>
+  </p:clrMapOvr>
+</p:sld>
+</file>
+
 <file path=ppt/slides/slide2.xml><?xml version="1.0" encoding="utf-8"?>
 <p:sld xmlns:a="http://schemas.openxmlformats.org/drawingml/2006/main" xmlns:r="http://schemas.openxmlformats.org/officeDocument/2006/relationships" xmlns:p="http://schemas.openxmlformats.org/presentationml/2006/main">
   <p:cSld name="Slide 2">

</xml_diff>

<commit_message>
E3: deck slide 13 — fase paralela B2C mercado familiar
- Nueva slide entre IA/Ciberseg y Cierre
- Comparativa B2B vs B2C: ticket, ciclo de venta, adquisición, SAM
- B2C: familias de adultos mayores · $199–399 MXN/mes · autoservicio
- SAM B2C ~2M familias MX con cuidado activo
- Flywheel: B2C → recomendación a residencia → lead B2B
- Nota al pie: fase proyectada, no comprometida en v0.1.0
- Corrige main() duplicado en el generador

Co-Authored-By: Claude Sonnet 4.6 <noreply@anthropic.com>
</commit_message>
<xml_diff>
--- a/business/CareSignal_Pitch_Deck.pptx
+++ b/business/CareSignal_Pitch_Deck.pptx
@@ -19,9 +19,10 @@
     <p:sldId id="267" r:id="rId13"/>
     <p:sldId id="268" r:id="rId14"/>
     <p:sldId id="269" r:id="rId15"/>
+    <p:sldId id="270" r:id="rId16"/>
   </p:sldIdLst>
   <p:notesMasterIdLst>
-    <p:notesMasterId r:id="rId16"/>
+    <p:notesMasterId r:id="rId17"/>
   </p:notesMasterIdLst>
   <p:sldSz cx="12192000" cy="6858000"/>
   <p:notesSz cx="6858000" cy="12192000"/>
@@ -979,6 +980,94 @@
             <a:fld id="{F7021451-1387-4CA6-816F-3879F97B5CBC}" type="slidenum">
               <a:rPr lang="en-US"/>
               <a:t>14</a:t>
+            </a:fld>
+            <a:endParaRPr lang="en-US"/>
+          </a:p>
+        </p:txBody>
+      </p:sp>
+    </p:spTree>
+    <p:extLst>
+      <p:ext uri="{BB962C8B-B14F-4D97-AF65-F5344CB8AC3E}">
+        <p14:creationId xmlns:p14="http://schemas.microsoft.com/office/powerpoint/2010/main" val="1024086991"/>
+      </p:ext>
+    </p:extLst>
+  </p:cSld>
+  <p:clrMapOvr>
+    <a:masterClrMapping/>
+  </p:clrMapOvr>
+</p:notes>
+</file>
+
+<file path=ppt/notesSlides/notesSlide15.xml><?xml version="1.0" encoding="utf-8"?>
+<p:notes xmlns:a="http://schemas.openxmlformats.org/drawingml/2006/main" xmlns:r="http://schemas.openxmlformats.org/officeDocument/2006/relationships" xmlns:p="http://schemas.openxmlformats.org/presentationml/2006/main">
+  <p:cSld>
+    <p:spTree>
+      <p:nvGrpSpPr>
+        <p:cNvPr id="1" name=""/>
+        <p:cNvGrpSpPr/>
+        <p:nvPr/>
+      </p:nvGrpSpPr>
+      <p:grpSpPr>
+        <a:xfrm>
+          <a:off x="0" y="0"/>
+          <a:ext cx="0" cy="0"/>
+          <a:chOff x="0" y="0"/>
+          <a:chExt cx="0" cy="0"/>
+        </a:xfrm>
+      </p:grpSpPr>
+      <p:sp>
+        <p:nvSpPr>
+          <p:cNvPr id="2" name="Slide Image Placeholder 1"/>
+          <p:cNvSpPr>
+            <a:spLocks noGrp="1" noRot="1" noChangeAspect="1"/>
+          </p:cNvSpPr>
+          <p:nvPr>
+            <p:ph type="sldImg"/>
+          </p:nvPr>
+        </p:nvSpPr>
+        <p:spPr/>
+      </p:sp>
+      <p:sp>
+        <p:nvSpPr>
+          <p:cNvPr id="3" name="Notes Placeholder 2"/>
+          <p:cNvSpPr>
+            <a:spLocks noGrp="1"/>
+          </p:cNvSpPr>
+          <p:nvPr>
+            <p:ph type="body" idx="1"/>
+          </p:nvPr>
+        </p:nvSpPr>
+        <p:spPr/>
+        <p:txBody>
+          <a:bodyPr/>
+          <a:lstStyle/>
+          <a:p>
+            <a:r>
+              <a:rPr lang="en-US" dirty="0"/>
+              <a:t/>
+            </a:r>
+            <a:endParaRPr lang="en-US" dirty="0"/>
+          </a:p>
+        </p:txBody>
+      </p:sp>
+      <p:sp>
+        <p:nvSpPr>
+          <p:cNvPr id="4" name="Slide Number Placeholder 3"/>
+          <p:cNvSpPr>
+            <a:spLocks noGrp="1"/>
+          </p:cNvSpPr>
+          <p:nvPr>
+            <p:ph type="sldNum" sz="quarter" idx="10"/>
+          </p:nvPr>
+        </p:nvSpPr>
+        <p:spPr/>
+        <p:txBody>
+          <a:bodyPr/>
+          <a:lstStyle/>
+          <a:p>
+            <a:fld id="{F7021451-1387-4CA6-816F-3879F97B5CBC}" type="slidenum">
+              <a:rPr lang="en-US"/>
+              <a:t>15</a:t>
             </a:fld>
             <a:endParaRPr lang="en-US"/>
           </a:p>
@@ -4625,7 +4714,7 @@
                 <a:ea typeface="Arial" pitchFamily="34" charset="-122"/>
                 <a:cs typeface="Arial" pitchFamily="34" charset="-120"/>
               </a:rPr>
-              <a:t>SaaS B2B · por residencia / mes · margen bruto &gt; 97 %</a:t>
+              <a:t>Freemium + SaaS B2B · por residencia / mes · margen bruto &gt; 80 %</a:t>
             </a:r>
             <a:endParaRPr lang="en-US" dirty="0"/>
           </a:p>
@@ -4662,12 +4751,335 @@
         </p:nvSpPr>
         <p:spPr>
           <a:xfrm>
-            <a:off x="457200" y="1261872"/>
-            <a:ext cx="2633472" cy="4206240"/>
+            <a:off x="164592" y="1261872"/>
+            <a:ext cx="2011680" cy="4206240"/>
           </a:xfrm>
           <a:prstGeom prst="roundRect">
             <a:avLst>
-              <a:gd name="adj" fmla="val 4167"/>
+              <a:gd name="adj" fmla="val 5455"/>
+            </a:avLst>
+          </a:prstGeom>
+          <a:solidFill>
+            <a:srgbClr val="F0FAF4"/>
+          </a:solidFill>
+          <a:ln w="6350">
+            <a:solidFill>
+              <a:srgbClr val="E2E8F0"/>
+            </a:solidFill>
+            <a:prstDash val="solid"/>
+          </a:ln>
+        </p:spPr>
+      </p:sp>
+      <p:sp>
+        <p:nvSpPr>
+          <p:cNvPr id="12" name="Text 10"/>
+          <p:cNvSpPr/>
+          <p:nvPr/>
+        </p:nvSpPr>
+        <p:spPr>
+          <a:xfrm>
+            <a:off x="164592" y="1417320"/>
+            <a:ext cx="2011680" cy="365760"/>
+          </a:xfrm>
+          <a:prstGeom prst="rect">
+            <a:avLst/>
+          </a:prstGeom>
+          <a:noFill/>
+          <a:ln/>
+        </p:spPr>
+        <p:txBody>
+          <a:bodyPr wrap="square" rtlCol="0" anchor="ctr"/>
+          <a:lstStyle/>
+          <a:p>
+            <a:pPr algn="ctr" indent="0" marL="0">
+              <a:buNone/>
+            </a:pPr>
+            <a:r>
+              <a:rPr lang="en-US" sz="1100" b="1" dirty="0">
+                <a:solidFill>
+                  <a:srgbClr val="2D3748"/>
+                </a:solidFill>
+                <a:latin typeface="Arial" pitchFamily="34" charset="0"/>
+                <a:ea typeface="Arial" pitchFamily="34" charset="-122"/>
+                <a:cs typeface="Arial" pitchFamily="34" charset="-120"/>
+              </a:rPr>
+              <a:t>Demo Operacional</a:t>
+            </a:r>
+            <a:endParaRPr lang="en-US" sz="1100" dirty="0"/>
+          </a:p>
+        </p:txBody>
+      </p:sp>
+      <p:sp>
+        <p:nvSpPr>
+          <p:cNvPr id="13" name="Text 11"/>
+          <p:cNvSpPr/>
+          <p:nvPr/>
+        </p:nvSpPr>
+        <p:spPr>
+          <a:xfrm>
+            <a:off x="164592" y="1828800"/>
+            <a:ext cx="2011680" cy="594360"/>
+          </a:xfrm>
+          <a:prstGeom prst="rect">
+            <a:avLst/>
+          </a:prstGeom>
+          <a:noFill/>
+          <a:ln/>
+        </p:spPr>
+        <p:txBody>
+          <a:bodyPr wrap="square" rtlCol="0" anchor="ctr"/>
+          <a:lstStyle/>
+          <a:p>
+            <a:pPr algn="ctr" indent="0" marL="0">
+              <a:buNone/>
+            </a:pPr>
+            <a:r>
+              <a:rPr lang="en-US" sz="2600" b="1" dirty="0">
+                <a:solidFill>
+                  <a:srgbClr val="1A6B3C"/>
+                </a:solidFill>
+                <a:latin typeface="Arial" pitchFamily="34" charset="0"/>
+                <a:ea typeface="Arial" pitchFamily="34" charset="-122"/>
+                <a:cs typeface="Arial" pitchFamily="34" charset="-120"/>
+              </a:rPr>
+              <a:t>$0</a:t>
+            </a:r>
+            <a:endParaRPr lang="en-US" sz="2600" dirty="0"/>
+          </a:p>
+        </p:txBody>
+      </p:sp>
+      <p:sp>
+        <p:nvSpPr>
+          <p:cNvPr id="14" name="Text 12"/>
+          <p:cNvSpPr/>
+          <p:nvPr/>
+        </p:nvSpPr>
+        <p:spPr>
+          <a:xfrm>
+            <a:off x="164592" y="2423160"/>
+            <a:ext cx="2011680" cy="320040"/>
+          </a:xfrm>
+          <a:prstGeom prst="rect">
+            <a:avLst/>
+          </a:prstGeom>
+          <a:noFill/>
+          <a:ln/>
+        </p:spPr>
+        <p:txBody>
+          <a:bodyPr wrap="square" rtlCol="0" anchor="ctr"/>
+          <a:lstStyle/>
+          <a:p>
+            <a:pPr algn="ctr" indent="0" marL="0">
+              <a:buNone/>
+            </a:pPr>
+            <a:r>
+              <a:rPr lang="en-US" sz="900" dirty="0">
+                <a:solidFill>
+                  <a:srgbClr val="718096"/>
+                </a:solidFill>
+                <a:latin typeface="Arial" pitchFamily="34" charset="0"/>
+                <a:ea typeface="Arial" pitchFamily="34" charset="-122"/>
+                <a:cs typeface="Arial" pitchFamily="34" charset="-120"/>
+              </a:rPr>
+              <a:t>Sin tarjeta · sin límite de tiempo</a:t>
+            </a:r>
+            <a:endParaRPr lang="en-US" sz="900" dirty="0"/>
+          </a:p>
+        </p:txBody>
+      </p:sp>
+      <p:sp>
+        <p:nvSpPr>
+          <p:cNvPr id="15" name="Shape 13"/>
+          <p:cNvSpPr/>
+          <p:nvPr/>
+        </p:nvSpPr>
+        <p:spPr>
+          <a:xfrm>
+            <a:off x="301752" y="2816352"/>
+            <a:ext cx="1737360" cy="0"/>
+          </a:xfrm>
+          <a:prstGeom prst="line">
+            <a:avLst/>
+          </a:prstGeom>
+          <a:noFill/>
+          <a:ln w="6350">
+            <a:solidFill>
+              <a:srgbClr val="E2E8F0"/>
+            </a:solidFill>
+            <a:prstDash val="solid"/>
+          </a:ln>
+        </p:spPr>
+      </p:sp>
+      <p:sp>
+        <p:nvSpPr>
+          <p:cNvPr id="16" name="Text 14"/>
+          <p:cNvSpPr/>
+          <p:nvPr/>
+        </p:nvSpPr>
+        <p:spPr>
+          <a:xfrm>
+            <a:off x="256032" y="2926080"/>
+            <a:ext cx="1828800" cy="420624"/>
+          </a:xfrm>
+          <a:prstGeom prst="rect">
+            <a:avLst/>
+          </a:prstGeom>
+          <a:noFill/>
+          <a:ln/>
+        </p:spPr>
+        <p:txBody>
+          <a:bodyPr wrap="square" rtlCol="0" anchor="ctr"/>
+          <a:lstStyle/>
+          <a:p>
+            <a:pPr algn="ctr" indent="0" marL="0">
+              <a:buNone/>
+            </a:pPr>
+            <a:r>
+              <a:rPr lang="en-US" sz="1000" dirty="0">
+                <a:solidFill>
+                  <a:srgbClr val="2D3748"/>
+                </a:solidFill>
+                <a:latin typeface="Arial" pitchFamily="34" charset="0"/>
+                <a:ea typeface="Arial" pitchFamily="34" charset="-122"/>
+                <a:cs typeface="Arial" pitchFamily="34" charset="-120"/>
+              </a:rPr>
+              <a:t>Hasta 8 residentes</a:t>
+            </a:r>
+            <a:endParaRPr lang="en-US" sz="1000" dirty="0"/>
+          </a:p>
+        </p:txBody>
+      </p:sp>
+      <p:sp>
+        <p:nvSpPr>
+          <p:cNvPr id="17" name="Text 15"/>
+          <p:cNvSpPr/>
+          <p:nvPr/>
+        </p:nvSpPr>
+        <p:spPr>
+          <a:xfrm>
+            <a:off x="256032" y="3419856"/>
+            <a:ext cx="1828800" cy="420624"/>
+          </a:xfrm>
+          <a:prstGeom prst="rect">
+            <a:avLst/>
+          </a:prstGeom>
+          <a:noFill/>
+          <a:ln/>
+        </p:spPr>
+        <p:txBody>
+          <a:bodyPr wrap="square" rtlCol="0" anchor="ctr"/>
+          <a:lstStyle/>
+          <a:p>
+            <a:pPr algn="ctr" indent="0" marL="0">
+              <a:buNone/>
+            </a:pPr>
+            <a:r>
+              <a:rPr lang="en-US" sz="1000" dirty="0">
+                <a:solidFill>
+                  <a:srgbClr val="2D3748"/>
+                </a:solidFill>
+                <a:latin typeface="Arial" pitchFamily="34" charset="0"/>
+                <a:ea typeface="Arial" pitchFamily="34" charset="-122"/>
+                <a:cs typeface="Arial" pitchFamily="34" charset="-120"/>
+              </a:rPr>
+              <a:t>1 usuario activo</a:t>
+            </a:r>
+            <a:endParaRPr lang="en-US" sz="1000" dirty="0"/>
+          </a:p>
+        </p:txBody>
+      </p:sp>
+      <p:sp>
+        <p:nvSpPr>
+          <p:cNvPr id="18" name="Text 16"/>
+          <p:cNvSpPr/>
+          <p:nvPr/>
+        </p:nvSpPr>
+        <p:spPr>
+          <a:xfrm>
+            <a:off x="256032" y="3913632"/>
+            <a:ext cx="1828800" cy="420624"/>
+          </a:xfrm>
+          <a:prstGeom prst="rect">
+            <a:avLst/>
+          </a:prstGeom>
+          <a:noFill/>
+          <a:ln/>
+        </p:spPr>
+        <p:txBody>
+          <a:bodyPr wrap="square" rtlCol="0" anchor="ctr"/>
+          <a:lstStyle/>
+          <a:p>
+            <a:pPr algn="ctr" indent="0" marL="0">
+              <a:buNone/>
+            </a:pPr>
+            <a:r>
+              <a:rPr lang="en-US" sz="1000" dirty="0">
+                <a:solidFill>
+                  <a:srgbClr val="2D3748"/>
+                </a:solidFill>
+                <a:latin typeface="Arial" pitchFamily="34" charset="0"/>
+                <a:ea typeface="Arial" pitchFamily="34" charset="-122"/>
+                <a:cs typeface="Arial" pitchFamily="34" charset="-120"/>
+              </a:rPr>
+              <a:t>Rondas básicas</a:t>
+            </a:r>
+            <a:endParaRPr lang="en-US" sz="1000" dirty="0"/>
+          </a:p>
+        </p:txBody>
+      </p:sp>
+      <p:sp>
+        <p:nvSpPr>
+          <p:cNvPr id="19" name="Text 17"/>
+          <p:cNvSpPr/>
+          <p:nvPr/>
+        </p:nvSpPr>
+        <p:spPr>
+          <a:xfrm>
+            <a:off x="256032" y="4407408"/>
+            <a:ext cx="1828800" cy="420624"/>
+          </a:xfrm>
+          <a:prstGeom prst="rect">
+            <a:avLst/>
+          </a:prstGeom>
+          <a:noFill/>
+          <a:ln/>
+        </p:spPr>
+        <p:txBody>
+          <a:bodyPr wrap="square" rtlCol="0" anchor="ctr"/>
+          <a:lstStyle/>
+          <a:p>
+            <a:pPr algn="ctr" indent="0" marL="0">
+              <a:buNone/>
+            </a:pPr>
+            <a:r>
+              <a:rPr lang="en-US" sz="1000" b="1" dirty="0">
+                <a:solidFill>
+                  <a:srgbClr val="5B8DB8"/>
+                </a:solidFill>
+                <a:latin typeface="Arial" pitchFamily="34" charset="0"/>
+                <a:ea typeface="Arial" pitchFamily="34" charset="-122"/>
+                <a:cs typeface="Arial" pitchFamily="34" charset="-120"/>
+              </a:rPr>
+              <a:t>Sin responsabilidad legal</a:t>
+            </a:r>
+            <a:endParaRPr lang="en-US" sz="1000" dirty="0"/>
+          </a:p>
+        </p:txBody>
+      </p:sp>
+      <p:sp>
+        <p:nvSpPr>
+          <p:cNvPr id="20" name="Shape 18"/>
+          <p:cNvSpPr/>
+          <p:nvPr/>
+        </p:nvSpPr>
+        <p:spPr>
+          <a:xfrm>
+            <a:off x="2340864" y="1261872"/>
+            <a:ext cx="2011680" cy="4206240"/>
+          </a:xfrm>
+          <a:prstGeom prst="roundRect">
+            <a:avLst>
+              <a:gd name="adj" fmla="val 5455"/>
             </a:avLst>
           </a:prstGeom>
           <a:solidFill>
@@ -4683,30 +5095,30 @@
       </p:sp>
       <p:sp>
         <p:nvSpPr>
-          <p:cNvPr id="12" name="Text 10"/>
-          <p:cNvSpPr/>
-          <p:nvPr/>
-        </p:nvSpPr>
-        <p:spPr>
-          <a:xfrm>
-            <a:off x="457200" y="1417320"/>
-            <a:ext cx="2633472" cy="365760"/>
-          </a:xfrm>
-          <a:prstGeom prst="rect">
-            <a:avLst/>
-          </a:prstGeom>
-          <a:noFill/>
-          <a:ln/>
-        </p:spPr>
-        <p:txBody>
-          <a:bodyPr wrap="square" rtlCol="0" anchor="ctr"/>
-          <a:lstStyle/>
-          <a:p>
-            <a:pPr algn="ctr" indent="0" marL="0">
-              <a:buNone/>
-            </a:pPr>
-            <a:r>
-              <a:rPr lang="en-US" sz="1500" b="1" dirty="0">
+          <p:cNvPr id="21" name="Text 19"/>
+          <p:cNvSpPr/>
+          <p:nvPr/>
+        </p:nvSpPr>
+        <p:spPr>
+          <a:xfrm>
+            <a:off x="2340864" y="1417320"/>
+            <a:ext cx="2011680" cy="365760"/>
+          </a:xfrm>
+          <a:prstGeom prst="rect">
+            <a:avLst/>
+          </a:prstGeom>
+          <a:noFill/>
+          <a:ln/>
+        </p:spPr>
+        <p:txBody>
+          <a:bodyPr wrap="square" rtlCol="0" anchor="ctr"/>
+          <a:lstStyle/>
+          <a:p>
+            <a:pPr algn="ctr" indent="0" marL="0">
+              <a:buNone/>
+            </a:pPr>
+            <a:r>
+              <a:rPr lang="en-US" sz="1100" b="1" dirty="0">
                 <a:solidFill>
                   <a:srgbClr val="2D3748"/>
                 </a:solidFill>
@@ -4716,36 +5128,36 @@
               </a:rPr>
               <a:t>Esencial</a:t>
             </a:r>
-            <a:endParaRPr lang="en-US" sz="1500" dirty="0"/>
-          </a:p>
-        </p:txBody>
-      </p:sp>
-      <p:sp>
-        <p:nvSpPr>
-          <p:cNvPr id="13" name="Text 11"/>
-          <p:cNvSpPr/>
-          <p:nvPr/>
-        </p:nvSpPr>
-        <p:spPr>
-          <a:xfrm>
-            <a:off x="457200" y="1828800"/>
-            <a:ext cx="2633472" cy="640080"/>
-          </a:xfrm>
-          <a:prstGeom prst="rect">
-            <a:avLst/>
-          </a:prstGeom>
-          <a:noFill/>
-          <a:ln/>
-        </p:spPr>
-        <p:txBody>
-          <a:bodyPr wrap="square" rtlCol="0" anchor="ctr"/>
-          <a:lstStyle/>
-          <a:p>
-            <a:pPr algn="ctr" indent="0" marL="0">
-              <a:buNone/>
-            </a:pPr>
-            <a:r>
-              <a:rPr lang="en-US" sz="3200" b="1" dirty="0">
+            <a:endParaRPr lang="en-US" sz="1100" dirty="0"/>
+          </a:p>
+        </p:txBody>
+      </p:sp>
+      <p:sp>
+        <p:nvSpPr>
+          <p:cNvPr id="22" name="Text 20"/>
+          <p:cNvSpPr/>
+          <p:nvPr/>
+        </p:nvSpPr>
+        <p:spPr>
+          <a:xfrm>
+            <a:off x="2340864" y="1828800"/>
+            <a:ext cx="2011680" cy="594360"/>
+          </a:xfrm>
+          <a:prstGeom prst="rect">
+            <a:avLst/>
+          </a:prstGeom>
+          <a:noFill/>
+          <a:ln/>
+        </p:spPr>
+        <p:txBody>
+          <a:bodyPr wrap="square" rtlCol="0" anchor="ctr"/>
+          <a:lstStyle/>
+          <a:p>
+            <a:pPr algn="ctr" indent="0" marL="0">
+              <a:buNone/>
+            </a:pPr>
+            <a:r>
+              <a:rPr lang="en-US" sz="2600" b="1" dirty="0">
                 <a:solidFill>
                   <a:srgbClr val="5B8DB8"/>
                 </a:solidFill>
@@ -4753,38 +5165,38 @@
                 <a:ea typeface="Arial" pitchFamily="34" charset="-122"/>
                 <a:cs typeface="Arial" pitchFamily="34" charset="-120"/>
               </a:rPr>
-              <a:t>$1,490</a:t>
-            </a:r>
-            <a:endParaRPr lang="en-US" sz="3200" dirty="0"/>
-          </a:p>
-        </p:txBody>
-      </p:sp>
-      <p:sp>
-        <p:nvSpPr>
-          <p:cNvPr id="14" name="Text 12"/>
-          <p:cNvSpPr/>
-          <p:nvPr/>
-        </p:nvSpPr>
-        <p:spPr>
-          <a:xfrm>
-            <a:off x="457200" y="2487168"/>
-            <a:ext cx="2633472" cy="274320"/>
-          </a:xfrm>
-          <a:prstGeom prst="rect">
-            <a:avLst/>
-          </a:prstGeom>
-          <a:noFill/>
-          <a:ln/>
-        </p:spPr>
-        <p:txBody>
-          <a:bodyPr wrap="square" rtlCol="0" anchor="ctr"/>
-          <a:lstStyle/>
-          <a:p>
-            <a:pPr algn="ctr" indent="0" marL="0">
-              <a:buNone/>
-            </a:pPr>
-            <a:r>
-              <a:rPr lang="en-US" sz="1100" dirty="0">
+              <a:t>$1,990</a:t>
+            </a:r>
+            <a:endParaRPr lang="en-US" sz="2600" dirty="0"/>
+          </a:p>
+        </p:txBody>
+      </p:sp>
+      <p:sp>
+        <p:nvSpPr>
+          <p:cNvPr id="23" name="Text 21"/>
+          <p:cNvSpPr/>
+          <p:nvPr/>
+        </p:nvSpPr>
+        <p:spPr>
+          <a:xfrm>
+            <a:off x="2340864" y="2423160"/>
+            <a:ext cx="2011680" cy="320040"/>
+          </a:xfrm>
+          <a:prstGeom prst="rect">
+            <a:avLst/>
+          </a:prstGeom>
+          <a:noFill/>
+          <a:ln/>
+        </p:spPr>
+        <p:txBody>
+          <a:bodyPr wrap="square" rtlCol="0" anchor="ctr"/>
+          <a:lstStyle/>
+          <a:p>
+            <a:pPr algn="ctr" indent="0" marL="0">
+              <a:buNone/>
+            </a:pPr>
+            <a:r>
+              <a:rPr lang="en-US" sz="900" dirty="0">
                 <a:solidFill>
                   <a:srgbClr val="718096"/>
                 </a:solidFill>
@@ -4794,20 +5206,20 @@
               </a:rPr>
               <a:t>MXN / mes</a:t>
             </a:r>
-            <a:endParaRPr lang="en-US" sz="1100" dirty="0"/>
-          </a:p>
-        </p:txBody>
-      </p:sp>
-      <p:sp>
-        <p:nvSpPr>
-          <p:cNvPr id="15" name="Shape 13"/>
-          <p:cNvSpPr/>
-          <p:nvPr/>
-        </p:nvSpPr>
-        <p:spPr>
-          <a:xfrm>
-            <a:off x="640080" y="2834640"/>
-            <a:ext cx="2267712" cy="0"/>
+            <a:endParaRPr lang="en-US" sz="900" dirty="0"/>
+          </a:p>
+        </p:txBody>
+      </p:sp>
+      <p:sp>
+        <p:nvSpPr>
+          <p:cNvPr id="24" name="Shape 22"/>
+          <p:cNvSpPr/>
+          <p:nvPr/>
+        </p:nvSpPr>
+        <p:spPr>
+          <a:xfrm>
+            <a:off x="2478024" y="2816352"/>
+            <a:ext cx="1737360" cy="0"/>
           </a:xfrm>
           <a:prstGeom prst="line">
             <a:avLst/>
@@ -4823,30 +5235,30 @@
       </p:sp>
       <p:sp>
         <p:nvSpPr>
-          <p:cNvPr id="16" name="Text 14"/>
-          <p:cNvSpPr/>
-          <p:nvPr/>
-        </p:nvSpPr>
-        <p:spPr>
-          <a:xfrm>
-            <a:off x="594360" y="2944368"/>
-            <a:ext cx="2359152" cy="420624"/>
-          </a:xfrm>
-          <a:prstGeom prst="rect">
-            <a:avLst/>
-          </a:prstGeom>
-          <a:noFill/>
-          <a:ln/>
-        </p:spPr>
-        <p:txBody>
-          <a:bodyPr wrap="square" rtlCol="0" anchor="ctr"/>
-          <a:lstStyle/>
-          <a:p>
-            <a:pPr algn="ctr" indent="0" marL="0">
-              <a:buNone/>
-            </a:pPr>
-            <a:r>
-              <a:rPr lang="en-US" sz="1150" dirty="0">
+          <p:cNvPr id="25" name="Text 23"/>
+          <p:cNvSpPr/>
+          <p:nvPr/>
+        </p:nvSpPr>
+        <p:spPr>
+          <a:xfrm>
+            <a:off x="2432304" y="2926080"/>
+            <a:ext cx="1828800" cy="420624"/>
+          </a:xfrm>
+          <a:prstGeom prst="rect">
+            <a:avLst/>
+          </a:prstGeom>
+          <a:noFill/>
+          <a:ln/>
+        </p:spPr>
+        <p:txBody>
+          <a:bodyPr wrap="square" rtlCol="0" anchor="ctr"/>
+          <a:lstStyle/>
+          <a:p>
+            <a:pPr algn="ctr" indent="0" marL="0">
+              <a:buNone/>
+            </a:pPr>
+            <a:r>
+              <a:rPr lang="en-US" sz="1000" dirty="0">
                 <a:solidFill>
                   <a:srgbClr val="2D3748"/>
                 </a:solidFill>
@@ -4854,38 +5266,38 @@
                 <a:ea typeface="Arial" pitchFamily="34" charset="-122"/>
                 <a:cs typeface="Arial" pitchFamily="34" charset="-120"/>
               </a:rPr>
-              <a:t>Hasta 25 residentes</a:t>
-            </a:r>
-            <a:endParaRPr lang="en-US" sz="1150" dirty="0"/>
-          </a:p>
-        </p:txBody>
-      </p:sp>
-      <p:sp>
-        <p:nvSpPr>
-          <p:cNvPr id="17" name="Text 15"/>
-          <p:cNvSpPr/>
-          <p:nvPr/>
-        </p:nvSpPr>
-        <p:spPr>
-          <a:xfrm>
-            <a:off x="594360" y="3438144"/>
-            <a:ext cx="2359152" cy="420624"/>
-          </a:xfrm>
-          <a:prstGeom prst="rect">
-            <a:avLst/>
-          </a:prstGeom>
-          <a:noFill/>
-          <a:ln/>
-        </p:spPr>
-        <p:txBody>
-          <a:bodyPr wrap="square" rtlCol="0" anchor="ctr"/>
-          <a:lstStyle/>
-          <a:p>
-            <a:pPr algn="ctr" indent="0" marL="0">
-              <a:buNone/>
-            </a:pPr>
-            <a:r>
-              <a:rPr lang="en-US" sz="1150" dirty="0">
+              <a:t>Hasta 30 residentes</a:t>
+            </a:r>
+            <a:endParaRPr lang="en-US" sz="1000" dirty="0"/>
+          </a:p>
+        </p:txBody>
+      </p:sp>
+      <p:sp>
+        <p:nvSpPr>
+          <p:cNvPr id="26" name="Text 24"/>
+          <p:cNvSpPr/>
+          <p:nvPr/>
+        </p:nvSpPr>
+        <p:spPr>
+          <a:xfrm>
+            <a:off x="2432304" y="3419856"/>
+            <a:ext cx="1828800" cy="420624"/>
+          </a:xfrm>
+          <a:prstGeom prst="rect">
+            <a:avLst/>
+          </a:prstGeom>
+          <a:noFill/>
+          <a:ln/>
+        </p:spPr>
+        <p:txBody>
+          <a:bodyPr wrap="square" rtlCol="0" anchor="ctr"/>
+          <a:lstStyle/>
+          <a:p>
+            <a:pPr algn="ctr" indent="0" marL="0">
+              <a:buNone/>
+            </a:pPr>
+            <a:r>
+              <a:rPr lang="en-US" sz="1000" dirty="0">
                 <a:solidFill>
                   <a:srgbClr val="2D3748"/>
                 </a:solidFill>
@@ -4893,38 +5305,38 @@
                 <a:ea typeface="Arial" pitchFamily="34" charset="-122"/>
                 <a:cs typeface="Arial" pitchFamily="34" charset="-120"/>
               </a:rPr>
-              <a:t>1 supervisor</a:t>
-            </a:r>
-            <a:endParaRPr lang="en-US" sz="1150" dirty="0"/>
-          </a:p>
-        </p:txBody>
-      </p:sp>
-      <p:sp>
-        <p:nvSpPr>
-          <p:cNvPr id="18" name="Text 16"/>
-          <p:cNvSpPr/>
-          <p:nvPr/>
-        </p:nvSpPr>
-        <p:spPr>
-          <a:xfrm>
-            <a:off x="594360" y="3931920"/>
-            <a:ext cx="2359152" cy="420624"/>
-          </a:xfrm>
-          <a:prstGeom prst="rect">
-            <a:avLst/>
-          </a:prstGeom>
-          <a:noFill/>
-          <a:ln/>
-        </p:spPr>
-        <p:txBody>
-          <a:bodyPr wrap="square" rtlCol="0" anchor="ctr"/>
-          <a:lstStyle/>
-          <a:p>
-            <a:pPr algn="ctr" indent="0" marL="0">
-              <a:buNone/>
-            </a:pPr>
-            <a:r>
-              <a:rPr lang="en-US" sz="1150" dirty="0">
+              <a:t>3 usuarios</a:t>
+            </a:r>
+            <a:endParaRPr lang="en-US" sz="1000" dirty="0"/>
+          </a:p>
+        </p:txBody>
+      </p:sp>
+      <p:sp>
+        <p:nvSpPr>
+          <p:cNvPr id="27" name="Text 25"/>
+          <p:cNvSpPr/>
+          <p:nvPr/>
+        </p:nvSpPr>
+        <p:spPr>
+          <a:xfrm>
+            <a:off x="2432304" y="3913632"/>
+            <a:ext cx="1828800" cy="420624"/>
+          </a:xfrm>
+          <a:prstGeom prst="rect">
+            <a:avLst/>
+          </a:prstGeom>
+          <a:noFill/>
+          <a:ln/>
+        </p:spPr>
+        <p:txBody>
+          <a:bodyPr wrap="square" rtlCol="0" anchor="ctr"/>
+          <a:lstStyle/>
+          <a:p>
+            <a:pPr algn="ctr" indent="0" marL="0">
+              <a:buNone/>
+            </a:pPr>
+            <a:r>
+              <a:rPr lang="en-US" sz="1000" dirty="0">
                 <a:solidFill>
                   <a:srgbClr val="2D3748"/>
                 </a:solidFill>
@@ -4932,38 +5344,38 @@
                 <a:ea typeface="Arial" pitchFamily="34" charset="-122"/>
                 <a:cs typeface="Arial" pitchFamily="34" charset="-120"/>
               </a:rPr>
-              <a:t>Hasta 5 cuidadores</a:t>
-            </a:r>
-            <a:endParaRPr lang="en-US" sz="1150" dirty="0"/>
-          </a:p>
-        </p:txBody>
-      </p:sp>
-      <p:sp>
-        <p:nvSpPr>
-          <p:cNvPr id="19" name="Text 17"/>
-          <p:cNvSpPr/>
-          <p:nvPr/>
-        </p:nvSpPr>
-        <p:spPr>
-          <a:xfrm>
-            <a:off x="594360" y="4425696"/>
-            <a:ext cx="2359152" cy="420624"/>
-          </a:xfrm>
-          <a:prstGeom prst="rect">
-            <a:avLst/>
-          </a:prstGeom>
-          <a:noFill/>
-          <a:ln/>
-        </p:spPr>
-        <p:txBody>
-          <a:bodyPr wrap="square" rtlCol="0" anchor="ctr"/>
-          <a:lstStyle/>
-          <a:p>
-            <a:pPr algn="ctr" indent="0" marL="0">
-              <a:buNone/>
-            </a:pPr>
-            <a:r>
-              <a:rPr lang="en-US" sz="1150" b="1" dirty="0">
+              <a:t>Alertas + auditoría</a:t>
+            </a:r>
+            <a:endParaRPr lang="en-US" sz="1000" dirty="0"/>
+          </a:p>
+        </p:txBody>
+      </p:sp>
+      <p:sp>
+        <p:nvSpPr>
+          <p:cNvPr id="28" name="Text 26"/>
+          <p:cNvSpPr/>
+          <p:nvPr/>
+        </p:nvSpPr>
+        <p:spPr>
+          <a:xfrm>
+            <a:off x="2432304" y="4407408"/>
+            <a:ext cx="1828800" cy="420624"/>
+          </a:xfrm>
+          <a:prstGeom prst="rect">
+            <a:avLst/>
+          </a:prstGeom>
+          <a:noFill/>
+          <a:ln/>
+        </p:spPr>
+        <p:txBody>
+          <a:bodyPr wrap="square" rtlCol="0" anchor="ctr"/>
+          <a:lstStyle/>
+          <a:p>
+            <a:pPr algn="ctr" indent="0" marL="0">
+              <a:buNone/>
+            </a:pPr>
+            <a:r>
+              <a:rPr lang="en-US" sz="1000" b="1" dirty="0">
                 <a:solidFill>
                   <a:srgbClr val="5B8DB8"/>
                 </a:solidFill>
@@ -4973,24 +5385,24 @@
               </a:rPr>
               <a:t>Residencias pequeñas</a:t>
             </a:r>
-            <a:endParaRPr lang="en-US" sz="1150" dirty="0"/>
-          </a:p>
-        </p:txBody>
-      </p:sp>
-      <p:sp>
-        <p:nvSpPr>
-          <p:cNvPr id="20" name="Shape 18"/>
-          <p:cNvSpPr/>
-          <p:nvPr/>
-        </p:nvSpPr>
-        <p:spPr>
-          <a:xfrm>
-            <a:off x="3273552" y="1261872"/>
-            <a:ext cx="2633472" cy="4206240"/>
+            <a:endParaRPr lang="en-US" sz="1000" dirty="0"/>
+          </a:p>
+        </p:txBody>
+      </p:sp>
+      <p:sp>
+        <p:nvSpPr>
+          <p:cNvPr id="29" name="Shape 27"/>
+          <p:cNvSpPr/>
+          <p:nvPr/>
+        </p:nvSpPr>
+        <p:spPr>
+          <a:xfrm>
+            <a:off x="4517136" y="1261872"/>
+            <a:ext cx="2011680" cy="4206240"/>
           </a:xfrm>
           <a:prstGeom prst="roundRect">
             <a:avLst>
-              <a:gd name="adj" fmla="val 4167"/>
+              <a:gd name="adj" fmla="val 5455"/>
             </a:avLst>
           </a:prstGeom>
           <a:solidFill>
@@ -5006,14 +5418,14 @@
       </p:sp>
       <p:sp>
         <p:nvSpPr>
-          <p:cNvPr id="21" name="Shape 19"/>
-          <p:cNvSpPr/>
-          <p:nvPr/>
-        </p:nvSpPr>
-        <p:spPr>
-          <a:xfrm>
-            <a:off x="3639312" y="1188720"/>
-            <a:ext cx="1874520" cy="292608"/>
+          <p:cNvPr id="30" name="Shape 28"/>
+          <p:cNvSpPr/>
+          <p:nvPr/>
+        </p:nvSpPr>
+        <p:spPr>
+          <a:xfrm>
+            <a:off x="4791456" y="1188720"/>
+            <a:ext cx="1463040" cy="292608"/>
           </a:xfrm>
           <a:prstGeom prst="roundRect">
             <a:avLst>
@@ -5033,14 +5445,14 @@
       </p:sp>
       <p:sp>
         <p:nvSpPr>
-          <p:cNvPr id="22" name="Text 20"/>
-          <p:cNvSpPr/>
-          <p:nvPr/>
-        </p:nvSpPr>
-        <p:spPr>
-          <a:xfrm>
-            <a:off x="3639312" y="1188720"/>
-            <a:ext cx="1874520" cy="292608"/>
+          <p:cNvPr id="31" name="Text 29"/>
+          <p:cNvSpPr/>
+          <p:nvPr/>
+        </p:nvSpPr>
+        <p:spPr>
+          <a:xfrm>
+            <a:off x="4791456" y="1188720"/>
+            <a:ext cx="1463040" cy="292608"/>
           </a:xfrm>
           <a:prstGeom prst="rect">
             <a:avLst/>
@@ -5064,7 +5476,7 @@
                 <a:ea typeface="Arial" pitchFamily="34" charset="-122"/>
                 <a:cs typeface="Arial" pitchFamily="34" charset="-120"/>
               </a:rPr>
-              <a:t>Más popular</a:t>
+              <a:t>Sweet spot</a:t>
             </a:r>
             <a:endParaRPr lang="en-US" sz="900" dirty="0"/>
           </a:p>
@@ -5072,30 +5484,30 @@
       </p:sp>
       <p:sp>
         <p:nvSpPr>
-          <p:cNvPr id="23" name="Text 21"/>
-          <p:cNvSpPr/>
-          <p:nvPr/>
-        </p:nvSpPr>
-        <p:spPr>
-          <a:xfrm>
-            <a:off x="3273552" y="1417320"/>
-            <a:ext cx="2633472" cy="365760"/>
-          </a:xfrm>
-          <a:prstGeom prst="rect">
-            <a:avLst/>
-          </a:prstGeom>
-          <a:noFill/>
-          <a:ln/>
-        </p:spPr>
-        <p:txBody>
-          <a:bodyPr wrap="square" rtlCol="0" anchor="ctr"/>
-          <a:lstStyle/>
-          <a:p>
-            <a:pPr algn="ctr" indent="0" marL="0">
-              <a:buNone/>
-            </a:pPr>
-            <a:r>
-              <a:rPr lang="en-US" sz="1500" b="1" dirty="0">
+          <p:cNvPr id="32" name="Text 30"/>
+          <p:cNvSpPr/>
+          <p:nvPr/>
+        </p:nvSpPr>
+        <p:spPr>
+          <a:xfrm>
+            <a:off x="4517136" y="1417320"/>
+            <a:ext cx="2011680" cy="365760"/>
+          </a:xfrm>
+          <a:prstGeom prst="rect">
+            <a:avLst/>
+          </a:prstGeom>
+          <a:noFill/>
+          <a:ln/>
+        </p:spPr>
+        <p:txBody>
+          <a:bodyPr wrap="square" rtlCol="0" anchor="ctr"/>
+          <a:lstStyle/>
+          <a:p>
+            <a:pPr algn="ctr" indent="0" marL="0">
+              <a:buNone/>
+            </a:pPr>
+            <a:r>
+              <a:rPr lang="en-US" sz="1100" b="1" dirty="0">
                 <a:solidFill>
                   <a:srgbClr val="2D3748"/>
                 </a:solidFill>
@@ -5105,36 +5517,36 @@
               </a:rPr>
               <a:t>Profesional</a:t>
             </a:r>
-            <a:endParaRPr lang="en-US" sz="1500" dirty="0"/>
-          </a:p>
-        </p:txBody>
-      </p:sp>
-      <p:sp>
-        <p:nvSpPr>
-          <p:cNvPr id="24" name="Text 22"/>
-          <p:cNvSpPr/>
-          <p:nvPr/>
-        </p:nvSpPr>
-        <p:spPr>
-          <a:xfrm>
-            <a:off x="3273552" y="1828800"/>
-            <a:ext cx="2633472" cy="640080"/>
-          </a:xfrm>
-          <a:prstGeom prst="rect">
-            <a:avLst/>
-          </a:prstGeom>
-          <a:noFill/>
-          <a:ln/>
-        </p:spPr>
-        <p:txBody>
-          <a:bodyPr wrap="square" rtlCol="0" anchor="ctr"/>
-          <a:lstStyle/>
-          <a:p>
-            <a:pPr algn="ctr" indent="0" marL="0">
-              <a:buNone/>
-            </a:pPr>
-            <a:r>
-              <a:rPr lang="en-US" sz="3200" b="1" dirty="0">
+            <a:endParaRPr lang="en-US" sz="1100" dirty="0"/>
+          </a:p>
+        </p:txBody>
+      </p:sp>
+      <p:sp>
+        <p:nvSpPr>
+          <p:cNvPr id="33" name="Text 31"/>
+          <p:cNvSpPr/>
+          <p:nvPr/>
+        </p:nvSpPr>
+        <p:spPr>
+          <a:xfrm>
+            <a:off x="4517136" y="1828800"/>
+            <a:ext cx="2011680" cy="594360"/>
+          </a:xfrm>
+          <a:prstGeom prst="rect">
+            <a:avLst/>
+          </a:prstGeom>
+          <a:noFill/>
+          <a:ln/>
+        </p:spPr>
+        <p:txBody>
+          <a:bodyPr wrap="square" rtlCol="0" anchor="ctr"/>
+          <a:lstStyle/>
+          <a:p>
+            <a:pPr algn="ctr" indent="0" marL="0">
+              <a:buNone/>
+            </a:pPr>
+            <a:r>
+              <a:rPr lang="en-US" sz="2600" b="1" dirty="0">
                 <a:solidFill>
                   <a:srgbClr val="3A6B96"/>
                 </a:solidFill>
@@ -5142,38 +5554,38 @@
                 <a:ea typeface="Arial" pitchFamily="34" charset="-122"/>
                 <a:cs typeface="Arial" pitchFamily="34" charset="-120"/>
               </a:rPr>
-              <a:t>$3,490</a:t>
-            </a:r>
-            <a:endParaRPr lang="en-US" sz="3200" dirty="0"/>
-          </a:p>
-        </p:txBody>
-      </p:sp>
-      <p:sp>
-        <p:nvSpPr>
-          <p:cNvPr id="25" name="Text 23"/>
-          <p:cNvSpPr/>
-          <p:nvPr/>
-        </p:nvSpPr>
-        <p:spPr>
-          <a:xfrm>
-            <a:off x="3273552" y="2487168"/>
-            <a:ext cx="2633472" cy="274320"/>
-          </a:xfrm>
-          <a:prstGeom prst="rect">
-            <a:avLst/>
-          </a:prstGeom>
-          <a:noFill/>
-          <a:ln/>
-        </p:spPr>
-        <p:txBody>
-          <a:bodyPr wrap="square" rtlCol="0" anchor="ctr"/>
-          <a:lstStyle/>
-          <a:p>
-            <a:pPr algn="ctr" indent="0" marL="0">
-              <a:buNone/>
-            </a:pPr>
-            <a:r>
-              <a:rPr lang="en-US" sz="1100" dirty="0">
+              <a:t>$3,990</a:t>
+            </a:r>
+            <a:endParaRPr lang="en-US" sz="2600" dirty="0"/>
+          </a:p>
+        </p:txBody>
+      </p:sp>
+      <p:sp>
+        <p:nvSpPr>
+          <p:cNvPr id="34" name="Text 32"/>
+          <p:cNvSpPr/>
+          <p:nvPr/>
+        </p:nvSpPr>
+        <p:spPr>
+          <a:xfrm>
+            <a:off x="4517136" y="2423160"/>
+            <a:ext cx="2011680" cy="320040"/>
+          </a:xfrm>
+          <a:prstGeom prst="rect">
+            <a:avLst/>
+          </a:prstGeom>
+          <a:noFill/>
+          <a:ln/>
+        </p:spPr>
+        <p:txBody>
+          <a:bodyPr wrap="square" rtlCol="0" anchor="ctr"/>
+          <a:lstStyle/>
+          <a:p>
+            <a:pPr algn="ctr" indent="0" marL="0">
+              <a:buNone/>
+            </a:pPr>
+            <a:r>
+              <a:rPr lang="en-US" sz="900" dirty="0">
                 <a:solidFill>
                   <a:srgbClr val="718096"/>
                 </a:solidFill>
@@ -5183,20 +5595,20 @@
               </a:rPr>
               <a:t>MXN / mes</a:t>
             </a:r>
-            <a:endParaRPr lang="en-US" sz="1100" dirty="0"/>
-          </a:p>
-        </p:txBody>
-      </p:sp>
-      <p:sp>
-        <p:nvSpPr>
-          <p:cNvPr id="26" name="Shape 24"/>
-          <p:cNvSpPr/>
-          <p:nvPr/>
-        </p:nvSpPr>
-        <p:spPr>
-          <a:xfrm>
-            <a:off x="3456432" y="2834640"/>
-            <a:ext cx="2267712" cy="0"/>
+            <a:endParaRPr lang="en-US" sz="900" dirty="0"/>
+          </a:p>
+        </p:txBody>
+      </p:sp>
+      <p:sp>
+        <p:nvSpPr>
+          <p:cNvPr id="35" name="Shape 33"/>
+          <p:cNvSpPr/>
+          <p:nvPr/>
+        </p:nvSpPr>
+        <p:spPr>
+          <a:xfrm>
+            <a:off x="4654296" y="2816352"/>
+            <a:ext cx="1737360" cy="0"/>
           </a:xfrm>
           <a:prstGeom prst="line">
             <a:avLst/>
@@ -5212,30 +5624,30 @@
       </p:sp>
       <p:sp>
         <p:nvSpPr>
-          <p:cNvPr id="27" name="Text 25"/>
-          <p:cNvSpPr/>
-          <p:nvPr/>
-        </p:nvSpPr>
-        <p:spPr>
-          <a:xfrm>
-            <a:off x="3410712" y="2944368"/>
-            <a:ext cx="2359152" cy="420624"/>
-          </a:xfrm>
-          <a:prstGeom prst="rect">
-            <a:avLst/>
-          </a:prstGeom>
-          <a:noFill/>
-          <a:ln/>
-        </p:spPr>
-        <p:txBody>
-          <a:bodyPr wrap="square" rtlCol="0" anchor="ctr"/>
-          <a:lstStyle/>
-          <a:p>
-            <a:pPr algn="ctr" indent="0" marL="0">
-              <a:buNone/>
-            </a:pPr>
-            <a:r>
-              <a:rPr lang="en-US" sz="1150" dirty="0">
+          <p:cNvPr id="36" name="Text 34"/>
+          <p:cNvSpPr/>
+          <p:nvPr/>
+        </p:nvSpPr>
+        <p:spPr>
+          <a:xfrm>
+            <a:off x="4608576" y="2926080"/>
+            <a:ext cx="1828800" cy="420624"/>
+          </a:xfrm>
+          <a:prstGeom prst="rect">
+            <a:avLst/>
+          </a:prstGeom>
+          <a:noFill/>
+          <a:ln/>
+        </p:spPr>
+        <p:txBody>
+          <a:bodyPr wrap="square" rtlCol="0" anchor="ctr"/>
+          <a:lstStyle/>
+          <a:p>
+            <a:pPr algn="ctr" indent="0" marL="0">
+              <a:buNone/>
+            </a:pPr>
+            <a:r>
+              <a:rPr lang="en-US" sz="1000" dirty="0">
                 <a:solidFill>
                   <a:srgbClr val="2D3748"/>
                 </a:solidFill>
@@ -5243,38 +5655,38 @@
                 <a:ea typeface="Arial" pitchFamily="34" charset="-122"/>
                 <a:cs typeface="Arial" pitchFamily="34" charset="-120"/>
               </a:rPr>
-              <a:t>Hasta 75 residentes</a:t>
-            </a:r>
-            <a:endParaRPr lang="en-US" sz="1150" dirty="0"/>
-          </a:p>
-        </p:txBody>
-      </p:sp>
-      <p:sp>
-        <p:nvSpPr>
-          <p:cNvPr id="28" name="Text 26"/>
-          <p:cNvSpPr/>
-          <p:nvPr/>
-        </p:nvSpPr>
-        <p:spPr>
-          <a:xfrm>
-            <a:off x="3410712" y="3438144"/>
-            <a:ext cx="2359152" cy="420624"/>
-          </a:xfrm>
-          <a:prstGeom prst="rect">
-            <a:avLst/>
-          </a:prstGeom>
-          <a:noFill/>
-          <a:ln/>
-        </p:spPr>
-        <p:txBody>
-          <a:bodyPr wrap="square" rtlCol="0" anchor="ctr"/>
-          <a:lstStyle/>
-          <a:p>
-            <a:pPr algn="ctr" indent="0" marL="0">
-              <a:buNone/>
-            </a:pPr>
-            <a:r>
-              <a:rPr lang="en-US" sz="1150" dirty="0">
+              <a:t>Hasta 80 residentes</a:t>
+            </a:r>
+            <a:endParaRPr lang="en-US" sz="1000" dirty="0"/>
+          </a:p>
+        </p:txBody>
+      </p:sp>
+      <p:sp>
+        <p:nvSpPr>
+          <p:cNvPr id="37" name="Text 35"/>
+          <p:cNvSpPr/>
+          <p:nvPr/>
+        </p:nvSpPr>
+        <p:spPr>
+          <a:xfrm>
+            <a:off x="4608576" y="3419856"/>
+            <a:ext cx="1828800" cy="420624"/>
+          </a:xfrm>
+          <a:prstGeom prst="rect">
+            <a:avLst/>
+          </a:prstGeom>
+          <a:noFill/>
+          <a:ln/>
+        </p:spPr>
+        <p:txBody>
+          <a:bodyPr wrap="square" rtlCol="0" anchor="ctr"/>
+          <a:lstStyle/>
+          <a:p>
+            <a:pPr algn="ctr" indent="0" marL="0">
+              <a:buNone/>
+            </a:pPr>
+            <a:r>
+              <a:rPr lang="en-US" sz="1000" dirty="0">
                 <a:solidFill>
                   <a:srgbClr val="2D3748"/>
                 </a:solidFill>
@@ -5282,38 +5694,38 @@
                 <a:ea typeface="Arial" pitchFamily="34" charset="-122"/>
                 <a:cs typeface="Arial" pitchFamily="34" charset="-120"/>
               </a:rPr>
-              <a:t>Hasta 3 supervisores</a:t>
-            </a:r>
-            <a:endParaRPr lang="en-US" sz="1150" dirty="0"/>
-          </a:p>
-        </p:txBody>
-      </p:sp>
-      <p:sp>
-        <p:nvSpPr>
-          <p:cNvPr id="29" name="Text 27"/>
-          <p:cNvSpPr/>
-          <p:nvPr/>
-        </p:nvSpPr>
-        <p:spPr>
-          <a:xfrm>
-            <a:off x="3410712" y="3931920"/>
-            <a:ext cx="2359152" cy="420624"/>
-          </a:xfrm>
-          <a:prstGeom prst="rect">
-            <a:avLst/>
-          </a:prstGeom>
-          <a:noFill/>
-          <a:ln/>
-        </p:spPr>
-        <p:txBody>
-          <a:bodyPr wrap="square" rtlCol="0" anchor="ctr"/>
-          <a:lstStyle/>
-          <a:p>
-            <a:pPr algn="ctr" indent="0" marL="0">
-              <a:buNone/>
-            </a:pPr>
-            <a:r>
-              <a:rPr lang="en-US" sz="1150" dirty="0">
+              <a:t>Hasta 10 usuarios</a:t>
+            </a:r>
+            <a:endParaRPr lang="en-US" sz="1000" dirty="0"/>
+          </a:p>
+        </p:txBody>
+      </p:sp>
+      <p:sp>
+        <p:nvSpPr>
+          <p:cNvPr id="38" name="Text 36"/>
+          <p:cNvSpPr/>
+          <p:nvPr/>
+        </p:nvSpPr>
+        <p:spPr>
+          <a:xfrm>
+            <a:off x="4608576" y="3913632"/>
+            <a:ext cx="1828800" cy="420624"/>
+          </a:xfrm>
+          <a:prstGeom prst="rect">
+            <a:avLst/>
+          </a:prstGeom>
+          <a:noFill/>
+          <a:ln/>
+        </p:spPr>
+        <p:txBody>
+          <a:bodyPr wrap="square" rtlCol="0" anchor="ctr"/>
+          <a:lstStyle/>
+          <a:p>
+            <a:pPr algn="ctr" indent="0" marL="0">
+              <a:buNone/>
+            </a:pPr>
+            <a:r>
+              <a:rPr lang="en-US" sz="1000" dirty="0">
                 <a:solidFill>
                   <a:srgbClr val="2D3748"/>
                 </a:solidFill>
@@ -5321,38 +5733,38 @@
                 <a:ea typeface="Arial" pitchFamily="34" charset="-122"/>
                 <a:cs typeface="Arial" pitchFamily="34" charset="-120"/>
               </a:rPr>
-              <a:t>Hasta 15 cuidadores</a:t>
-            </a:r>
-            <a:endParaRPr lang="en-US" sz="1150" dirty="0"/>
-          </a:p>
-        </p:txBody>
-      </p:sp>
-      <p:sp>
-        <p:nvSpPr>
-          <p:cNvPr id="30" name="Text 28"/>
-          <p:cNvSpPr/>
-          <p:nvPr/>
-        </p:nvSpPr>
-        <p:spPr>
-          <a:xfrm>
-            <a:off x="3410712" y="4425696"/>
-            <a:ext cx="2359152" cy="420624"/>
-          </a:xfrm>
-          <a:prstGeom prst="rect">
-            <a:avLst/>
-          </a:prstGeom>
-          <a:noFill/>
-          <a:ln/>
-        </p:spPr>
-        <p:txBody>
-          <a:bodyPr wrap="square" rtlCol="0" anchor="ctr"/>
-          <a:lstStyle/>
-          <a:p>
-            <a:pPr algn="ctr" indent="0" marL="0">
-              <a:buNone/>
-            </a:pPr>
-            <a:r>
-              <a:rPr lang="en-US" sz="1150" b="1" dirty="0">
+              <a:t>Dashboard supervisor</a:t>
+            </a:r>
+            <a:endParaRPr lang="en-US" sz="1000" dirty="0"/>
+          </a:p>
+        </p:txBody>
+      </p:sp>
+      <p:sp>
+        <p:nvSpPr>
+          <p:cNvPr id="39" name="Text 37"/>
+          <p:cNvSpPr/>
+          <p:nvPr/>
+        </p:nvSpPr>
+        <p:spPr>
+          <a:xfrm>
+            <a:off x="4608576" y="4407408"/>
+            <a:ext cx="1828800" cy="420624"/>
+          </a:xfrm>
+          <a:prstGeom prst="rect">
+            <a:avLst/>
+          </a:prstGeom>
+          <a:noFill/>
+          <a:ln/>
+        </p:spPr>
+        <p:txBody>
+          <a:bodyPr wrap="square" rtlCol="0" anchor="ctr"/>
+          <a:lstStyle/>
+          <a:p>
+            <a:pPr algn="ctr" indent="0" marL="0">
+              <a:buNone/>
+            </a:pPr>
+            <a:r>
+              <a:rPr lang="en-US" sz="1000" b="1" dirty="0">
                 <a:solidFill>
                   <a:srgbClr val="5B8DB8"/>
                 </a:solidFill>
@@ -5362,24 +5774,24 @@
               </a:rPr>
               <a:t>Residencias medianas</a:t>
             </a:r>
-            <a:endParaRPr lang="en-US" sz="1150" dirty="0"/>
-          </a:p>
-        </p:txBody>
-      </p:sp>
-      <p:sp>
-        <p:nvSpPr>
-          <p:cNvPr id="31" name="Shape 29"/>
-          <p:cNvSpPr/>
-          <p:nvPr/>
-        </p:nvSpPr>
-        <p:spPr>
-          <a:xfrm>
-            <a:off x="6089904" y="1261872"/>
-            <a:ext cx="2633472" cy="4206240"/>
+            <a:endParaRPr lang="en-US" sz="1000" dirty="0"/>
+          </a:p>
+        </p:txBody>
+      </p:sp>
+      <p:sp>
+        <p:nvSpPr>
+          <p:cNvPr id="40" name="Shape 38"/>
+          <p:cNvSpPr/>
+          <p:nvPr/>
+        </p:nvSpPr>
+        <p:spPr>
+          <a:xfrm>
+            <a:off x="6693408" y="1261872"/>
+            <a:ext cx="2011680" cy="4206240"/>
           </a:xfrm>
           <a:prstGeom prst="roundRect">
             <a:avLst>
-              <a:gd name="adj" fmla="val 4167"/>
+              <a:gd name="adj" fmla="val 5455"/>
             </a:avLst>
           </a:prstGeom>
           <a:solidFill>
@@ -5395,30 +5807,30 @@
       </p:sp>
       <p:sp>
         <p:nvSpPr>
-          <p:cNvPr id="32" name="Text 30"/>
-          <p:cNvSpPr/>
-          <p:nvPr/>
-        </p:nvSpPr>
-        <p:spPr>
-          <a:xfrm>
-            <a:off x="6089904" y="1417320"/>
-            <a:ext cx="2633472" cy="365760"/>
-          </a:xfrm>
-          <a:prstGeom prst="rect">
-            <a:avLst/>
-          </a:prstGeom>
-          <a:noFill/>
-          <a:ln/>
-        </p:spPr>
-        <p:txBody>
-          <a:bodyPr wrap="square" rtlCol="0" anchor="ctr"/>
-          <a:lstStyle/>
-          <a:p>
-            <a:pPr algn="ctr" indent="0" marL="0">
-              <a:buNone/>
-            </a:pPr>
-            <a:r>
-              <a:rPr lang="en-US" sz="1500" b="1" dirty="0">
+          <p:cNvPr id="41" name="Text 39"/>
+          <p:cNvSpPr/>
+          <p:nvPr/>
+        </p:nvSpPr>
+        <p:spPr>
+          <a:xfrm>
+            <a:off x="6693408" y="1417320"/>
+            <a:ext cx="2011680" cy="365760"/>
+          </a:xfrm>
+          <a:prstGeom prst="rect">
+            <a:avLst/>
+          </a:prstGeom>
+          <a:noFill/>
+          <a:ln/>
+        </p:spPr>
+        <p:txBody>
+          <a:bodyPr wrap="square" rtlCol="0" anchor="ctr"/>
+          <a:lstStyle/>
+          <a:p>
+            <a:pPr algn="ctr" indent="0" marL="0">
+              <a:buNone/>
+            </a:pPr>
+            <a:r>
+              <a:rPr lang="en-US" sz="1100" b="1" dirty="0">
                 <a:solidFill>
                   <a:srgbClr val="2D3748"/>
                 </a:solidFill>
@@ -5428,36 +5840,36 @@
               </a:rPr>
               <a:t>Institucional</a:t>
             </a:r>
-            <a:endParaRPr lang="en-US" sz="1500" dirty="0"/>
-          </a:p>
-        </p:txBody>
-      </p:sp>
-      <p:sp>
-        <p:nvSpPr>
-          <p:cNvPr id="33" name="Text 31"/>
-          <p:cNvSpPr/>
-          <p:nvPr/>
-        </p:nvSpPr>
-        <p:spPr>
-          <a:xfrm>
-            <a:off x="6089904" y="1828800"/>
-            <a:ext cx="2633472" cy="640080"/>
-          </a:xfrm>
-          <a:prstGeom prst="rect">
-            <a:avLst/>
-          </a:prstGeom>
-          <a:noFill/>
-          <a:ln/>
-        </p:spPr>
-        <p:txBody>
-          <a:bodyPr wrap="square" rtlCol="0" anchor="ctr"/>
-          <a:lstStyle/>
-          <a:p>
-            <a:pPr algn="ctr" indent="0" marL="0">
-              <a:buNone/>
-            </a:pPr>
-            <a:r>
-              <a:rPr lang="en-US" sz="3200" b="1" dirty="0">
+            <a:endParaRPr lang="en-US" sz="1100" dirty="0"/>
+          </a:p>
+        </p:txBody>
+      </p:sp>
+      <p:sp>
+        <p:nvSpPr>
+          <p:cNvPr id="42" name="Text 40"/>
+          <p:cNvSpPr/>
+          <p:nvPr/>
+        </p:nvSpPr>
+        <p:spPr>
+          <a:xfrm>
+            <a:off x="6693408" y="1828800"/>
+            <a:ext cx="2011680" cy="594360"/>
+          </a:xfrm>
+          <a:prstGeom prst="rect">
+            <a:avLst/>
+          </a:prstGeom>
+          <a:noFill/>
+          <a:ln/>
+        </p:spPr>
+        <p:txBody>
+          <a:bodyPr wrap="square" rtlCol="0" anchor="ctr"/>
+          <a:lstStyle/>
+          <a:p>
+            <a:pPr algn="ctr" indent="0" marL="0">
+              <a:buNone/>
+            </a:pPr>
+            <a:r>
+              <a:rPr lang="en-US" sz="2600" b="1" dirty="0">
                 <a:solidFill>
                   <a:srgbClr val="5B8DB8"/>
                 </a:solidFill>
@@ -5465,38 +5877,38 @@
                 <a:ea typeface="Arial" pitchFamily="34" charset="-122"/>
                 <a:cs typeface="Arial" pitchFamily="34" charset="-120"/>
               </a:rPr>
-              <a:t>$6,990</a:t>
-            </a:r>
-            <a:endParaRPr lang="en-US" sz="3200" dirty="0"/>
-          </a:p>
-        </p:txBody>
-      </p:sp>
-      <p:sp>
-        <p:nvSpPr>
-          <p:cNvPr id="34" name="Text 32"/>
-          <p:cNvSpPr/>
-          <p:nvPr/>
-        </p:nvSpPr>
-        <p:spPr>
-          <a:xfrm>
-            <a:off x="6089904" y="2487168"/>
-            <a:ext cx="2633472" cy="274320"/>
-          </a:xfrm>
-          <a:prstGeom prst="rect">
-            <a:avLst/>
-          </a:prstGeom>
-          <a:noFill/>
-          <a:ln/>
-        </p:spPr>
-        <p:txBody>
-          <a:bodyPr wrap="square" rtlCol="0" anchor="ctr"/>
-          <a:lstStyle/>
-          <a:p>
-            <a:pPr algn="ctr" indent="0" marL="0">
-              <a:buNone/>
-            </a:pPr>
-            <a:r>
-              <a:rPr lang="en-US" sz="1100" dirty="0">
+              <a:t>$8,490</a:t>
+            </a:r>
+            <a:endParaRPr lang="en-US" sz="2600" dirty="0"/>
+          </a:p>
+        </p:txBody>
+      </p:sp>
+      <p:sp>
+        <p:nvSpPr>
+          <p:cNvPr id="43" name="Text 41"/>
+          <p:cNvSpPr/>
+          <p:nvPr/>
+        </p:nvSpPr>
+        <p:spPr>
+          <a:xfrm>
+            <a:off x="6693408" y="2423160"/>
+            <a:ext cx="2011680" cy="320040"/>
+          </a:xfrm>
+          <a:prstGeom prst="rect">
+            <a:avLst/>
+          </a:prstGeom>
+          <a:noFill/>
+          <a:ln/>
+        </p:spPr>
+        <p:txBody>
+          <a:bodyPr wrap="square" rtlCol="0" anchor="ctr"/>
+          <a:lstStyle/>
+          <a:p>
+            <a:pPr algn="ctr" indent="0" marL="0">
+              <a:buNone/>
+            </a:pPr>
+            <a:r>
+              <a:rPr lang="en-US" sz="900" dirty="0">
                 <a:solidFill>
                   <a:srgbClr val="718096"/>
                 </a:solidFill>
@@ -5506,20 +5918,20 @@
               </a:rPr>
               <a:t>MXN / mes</a:t>
             </a:r>
-            <a:endParaRPr lang="en-US" sz="1100" dirty="0"/>
-          </a:p>
-        </p:txBody>
-      </p:sp>
-      <p:sp>
-        <p:nvSpPr>
-          <p:cNvPr id="35" name="Shape 33"/>
-          <p:cNvSpPr/>
-          <p:nvPr/>
-        </p:nvSpPr>
-        <p:spPr>
-          <a:xfrm>
-            <a:off x="6272784" y="2834640"/>
-            <a:ext cx="2267712" cy="0"/>
+            <a:endParaRPr lang="en-US" sz="900" dirty="0"/>
+          </a:p>
+        </p:txBody>
+      </p:sp>
+      <p:sp>
+        <p:nvSpPr>
+          <p:cNvPr id="44" name="Shape 42"/>
+          <p:cNvSpPr/>
+          <p:nvPr/>
+        </p:nvSpPr>
+        <p:spPr>
+          <a:xfrm>
+            <a:off x="6830568" y="2816352"/>
+            <a:ext cx="1737360" cy="0"/>
           </a:xfrm>
           <a:prstGeom prst="line">
             <a:avLst/>
@@ -5535,30 +5947,30 @@
       </p:sp>
       <p:sp>
         <p:nvSpPr>
-          <p:cNvPr id="36" name="Text 34"/>
-          <p:cNvSpPr/>
-          <p:nvPr/>
-        </p:nvSpPr>
-        <p:spPr>
-          <a:xfrm>
-            <a:off x="6227064" y="2944368"/>
-            <a:ext cx="2359152" cy="420624"/>
-          </a:xfrm>
-          <a:prstGeom prst="rect">
-            <a:avLst/>
-          </a:prstGeom>
-          <a:noFill/>
-          <a:ln/>
-        </p:spPr>
-        <p:txBody>
-          <a:bodyPr wrap="square" rtlCol="0" anchor="ctr"/>
-          <a:lstStyle/>
-          <a:p>
-            <a:pPr algn="ctr" indent="0" marL="0">
-              <a:buNone/>
-            </a:pPr>
-            <a:r>
-              <a:rPr lang="en-US" sz="1150" dirty="0">
+          <p:cNvPr id="45" name="Text 43"/>
+          <p:cNvSpPr/>
+          <p:nvPr/>
+        </p:nvSpPr>
+        <p:spPr>
+          <a:xfrm>
+            <a:off x="6784848" y="2926080"/>
+            <a:ext cx="1828800" cy="420624"/>
+          </a:xfrm>
+          <a:prstGeom prst="rect">
+            <a:avLst/>
+          </a:prstGeom>
+          <a:noFill/>
+          <a:ln/>
+        </p:spPr>
+        <p:txBody>
+          <a:bodyPr wrap="square" rtlCol="0" anchor="ctr"/>
+          <a:lstStyle/>
+          <a:p>
+            <a:pPr algn="ctr" indent="0" marL="0">
+              <a:buNone/>
+            </a:pPr>
+            <a:r>
+              <a:rPr lang="en-US" sz="1000" dirty="0">
                 <a:solidFill>
                   <a:srgbClr val="2D3748"/>
                 </a:solidFill>
@@ -5566,38 +5978,77 @@
                 <a:ea typeface="Arial" pitchFamily="34" charset="-122"/>
                 <a:cs typeface="Arial" pitchFamily="34" charset="-120"/>
               </a:rPr>
+              <a:t>Sin límite · multi-sede</a:t>
+            </a:r>
+            <a:endParaRPr lang="en-US" sz="1000" dirty="0"/>
+          </a:p>
+        </p:txBody>
+      </p:sp>
+      <p:sp>
+        <p:nvSpPr>
+          <p:cNvPr id="46" name="Text 44"/>
+          <p:cNvSpPr/>
+          <p:nvPr/>
+        </p:nvSpPr>
+        <p:spPr>
+          <a:xfrm>
+            <a:off x="6784848" y="3419856"/>
+            <a:ext cx="1828800" cy="420624"/>
+          </a:xfrm>
+          <a:prstGeom prst="rect">
+            <a:avLst/>
+          </a:prstGeom>
+          <a:noFill/>
+          <a:ln/>
+        </p:spPr>
+        <p:txBody>
+          <a:bodyPr wrap="square" rtlCol="0" anchor="ctr"/>
+          <a:lstStyle/>
+          <a:p>
+            <a:pPr algn="ctr" indent="0" marL="0">
+              <a:buNone/>
+            </a:pPr>
+            <a:r>
+              <a:rPr lang="en-US" sz="1000" dirty="0">
+                <a:solidFill>
+                  <a:srgbClr val="2D3748"/>
+                </a:solidFill>
+                <a:latin typeface="Arial" pitchFamily="34" charset="0"/>
+                <a:ea typeface="Arial" pitchFamily="34" charset="-122"/>
+                <a:cs typeface="Arial" pitchFamily="34" charset="-120"/>
+              </a:rPr>
               <a:t>Sin límite</a:t>
             </a:r>
-            <a:endParaRPr lang="en-US" sz="1150" dirty="0"/>
-          </a:p>
-        </p:txBody>
-      </p:sp>
-      <p:sp>
-        <p:nvSpPr>
-          <p:cNvPr id="37" name="Text 35"/>
-          <p:cNvSpPr/>
-          <p:nvPr/>
-        </p:nvSpPr>
-        <p:spPr>
-          <a:xfrm>
-            <a:off x="6227064" y="3438144"/>
-            <a:ext cx="2359152" cy="420624"/>
-          </a:xfrm>
-          <a:prstGeom prst="rect">
-            <a:avLst/>
-          </a:prstGeom>
-          <a:noFill/>
-          <a:ln/>
-        </p:spPr>
-        <p:txBody>
-          <a:bodyPr wrap="square" rtlCol="0" anchor="ctr"/>
-          <a:lstStyle/>
-          <a:p>
-            <a:pPr algn="ctr" indent="0" marL="0">
-              <a:buNone/>
-            </a:pPr>
-            <a:r>
-              <a:rPr lang="en-US" sz="1150" dirty="0">
+            <a:endParaRPr lang="en-US" sz="1000" dirty="0"/>
+          </a:p>
+        </p:txBody>
+      </p:sp>
+      <p:sp>
+        <p:nvSpPr>
+          <p:cNvPr id="47" name="Text 45"/>
+          <p:cNvSpPr/>
+          <p:nvPr/>
+        </p:nvSpPr>
+        <p:spPr>
+          <a:xfrm>
+            <a:off x="6784848" y="3913632"/>
+            <a:ext cx="1828800" cy="420624"/>
+          </a:xfrm>
+          <a:prstGeom prst="rect">
+            <a:avLst/>
+          </a:prstGeom>
+          <a:noFill/>
+          <a:ln/>
+        </p:spPr>
+        <p:txBody>
+          <a:bodyPr wrap="square" rtlCol="0" anchor="ctr"/>
+          <a:lstStyle/>
+          <a:p>
+            <a:pPr algn="ctr" indent="0" marL="0">
+              <a:buNone/>
+            </a:pPr>
+            <a:r>
+              <a:rPr lang="en-US" sz="1000" dirty="0">
                 <a:solidFill>
                   <a:srgbClr val="2D3748"/>
                 </a:solidFill>
@@ -5605,77 +6056,38 @@
                 <a:ea typeface="Arial" pitchFamily="34" charset="-122"/>
                 <a:cs typeface="Arial" pitchFamily="34" charset="-120"/>
               </a:rPr>
-              <a:t>Sin límite</a:t>
-            </a:r>
-            <a:endParaRPr lang="en-US" sz="1150" dirty="0"/>
-          </a:p>
-        </p:txBody>
-      </p:sp>
-      <p:sp>
-        <p:nvSpPr>
-          <p:cNvPr id="38" name="Text 36"/>
-          <p:cNvSpPr/>
-          <p:nvPr/>
-        </p:nvSpPr>
-        <p:spPr>
-          <a:xfrm>
-            <a:off x="6227064" y="3931920"/>
-            <a:ext cx="2359152" cy="420624"/>
-          </a:xfrm>
-          <a:prstGeom prst="rect">
-            <a:avLst/>
-          </a:prstGeom>
-          <a:noFill/>
-          <a:ln/>
-        </p:spPr>
-        <p:txBody>
-          <a:bodyPr wrap="square" rtlCol="0" anchor="ctr"/>
-          <a:lstStyle/>
-          <a:p>
-            <a:pPr algn="ctr" indent="0" marL="0">
-              <a:buNone/>
-            </a:pPr>
-            <a:r>
-              <a:rPr lang="en-US" sz="1150" dirty="0">
-                <a:solidFill>
-                  <a:srgbClr val="2D3748"/>
-                </a:solidFill>
-                <a:latin typeface="Arial" pitchFamily="34" charset="0"/>
-                <a:ea typeface="Arial" pitchFamily="34" charset="-122"/>
-                <a:cs typeface="Arial" pitchFamily="34" charset="-120"/>
-              </a:rPr>
-              <a:t>Sin límite</a:t>
-            </a:r>
-            <a:endParaRPr lang="en-US" sz="1150" dirty="0"/>
-          </a:p>
-        </p:txBody>
-      </p:sp>
-      <p:sp>
-        <p:nvSpPr>
-          <p:cNvPr id="39" name="Text 37"/>
-          <p:cNvSpPr/>
-          <p:nvPr/>
-        </p:nvSpPr>
-        <p:spPr>
-          <a:xfrm>
-            <a:off x="6227064" y="4425696"/>
-            <a:ext cx="2359152" cy="420624"/>
-          </a:xfrm>
-          <a:prstGeom prst="rect">
-            <a:avLst/>
-          </a:prstGeom>
-          <a:noFill/>
-          <a:ln/>
-        </p:spPr>
-        <p:txBody>
-          <a:bodyPr wrap="square" rtlCol="0" anchor="ctr"/>
-          <a:lstStyle/>
-          <a:p>
-            <a:pPr algn="ctr" indent="0" marL="0">
-              <a:buNone/>
-            </a:pPr>
-            <a:r>
-              <a:rPr lang="en-US" sz="1150" b="1" dirty="0">
+              <a:t>SLA + soporte dedicado</a:t>
+            </a:r>
+            <a:endParaRPr lang="en-US" sz="1000" dirty="0"/>
+          </a:p>
+        </p:txBody>
+      </p:sp>
+      <p:sp>
+        <p:nvSpPr>
+          <p:cNvPr id="48" name="Text 46"/>
+          <p:cNvSpPr/>
+          <p:nvPr/>
+        </p:nvSpPr>
+        <p:spPr>
+          <a:xfrm>
+            <a:off x="6784848" y="4407408"/>
+            <a:ext cx="1828800" cy="420624"/>
+          </a:xfrm>
+          <a:prstGeom prst="rect">
+            <a:avLst/>
+          </a:prstGeom>
+          <a:noFill/>
+          <a:ln/>
+        </p:spPr>
+        <p:txBody>
+          <a:bodyPr wrap="square" rtlCol="0" anchor="ctr"/>
+          <a:lstStyle/>
+          <a:p>
+            <a:pPr algn="ctr" indent="0" marL="0">
+              <a:buNone/>
+            </a:pPr>
+            <a:r>
+              <a:rPr lang="en-US" sz="1000" b="1" dirty="0">
                 <a:solidFill>
                   <a:srgbClr val="5B8DB8"/>
                 </a:solidFill>
@@ -5683,15 +6095,15 @@
                 <a:ea typeface="Arial" pitchFamily="34" charset="-122"/>
                 <a:cs typeface="Arial" pitchFamily="34" charset="-120"/>
               </a:rPr>
-              <a:t>Cadenas · soporte prioritario</a:t>
-            </a:r>
-            <a:endParaRPr lang="en-US" sz="1150" dirty="0"/>
-          </a:p>
-        </p:txBody>
-      </p:sp>
-      <p:sp>
-        <p:nvSpPr>
-          <p:cNvPr id="40" name="Text 38"/>
+              <a:t>Cadenas institucionales</a:t>
+            </a:r>
+            <a:endParaRPr lang="en-US" sz="1000" dirty="0"/>
+          </a:p>
+        </p:txBody>
+      </p:sp>
+      <p:sp>
+        <p:nvSpPr>
+          <p:cNvPr id="49" name="Text 47"/>
           <p:cNvSpPr/>
           <p:nvPr/>
         </p:nvSpPr>
@@ -5722,7 +6134,7 @@
                 <a:ea typeface="Arial" pitchFamily="34" charset="-122"/>
                 <a:cs typeface="Arial" pitchFamily="34" charset="-120"/>
               </a:rPr>
-              <a:t>⚠️ Precios de referencia — no validados con clientes. Declarar ante jueces.</a:t>
+              <a:t>⚠️ Precios de referencia — no validados con clientes reales. El tier Freemium opera sin SLA ni responsabilidad legal. Declarar ante jueces.</a:t>
             </a:r>
             <a:endParaRPr lang="en-US" dirty="0"/>
           </a:p>
@@ -7179,6 +7591,2022 @@
         </p:nvSpPr>
         <p:spPr>
           <a:xfrm>
+            <a:off x="8138160" y="0"/>
+            <a:ext cx="694944" cy="6858000"/>
+          </a:xfrm>
+          <a:prstGeom prst="rect">
+            <a:avLst/>
+          </a:prstGeom>
+          <a:solidFill>
+            <a:srgbClr val="A8C4DC">
+              <a:alpha val="12000"/>
+            </a:srgbClr>
+          </a:solidFill>
+          <a:ln w="12700">
+            <a:solidFill>
+              <a:srgbClr val="A8C4DC">
+                <a:alpha val="12000"/>
+              </a:srgbClr>
+            </a:solidFill>
+            <a:prstDash val="solid"/>
+          </a:ln>
+        </p:spPr>
+      </p:sp>
+      <p:sp>
+        <p:nvSpPr>
+          <p:cNvPr id="4" name="Shape 2"/>
+          <p:cNvSpPr/>
+          <p:nvPr/>
+        </p:nvSpPr>
+        <p:spPr>
+          <a:xfrm>
+            <a:off x="3474720" y="5120640"/>
+            <a:ext cx="2377440" cy="2377440"/>
+          </a:xfrm>
+          <a:prstGeom prst="ellipse">
+            <a:avLst/>
+          </a:prstGeom>
+          <a:solidFill>
+            <a:srgbClr val="C4786A">
+              <a:alpha val="10000"/>
+            </a:srgbClr>
+          </a:solidFill>
+          <a:ln w="12700">
+            <a:solidFill>
+              <a:srgbClr val="C4786A">
+                <a:alpha val="10000"/>
+              </a:srgbClr>
+            </a:solidFill>
+            <a:prstDash val="solid"/>
+          </a:ln>
+        </p:spPr>
+      </p:sp>
+      <p:sp>
+        <p:nvSpPr>
+          <p:cNvPr id="5" name="Shape 3"/>
+          <p:cNvSpPr/>
+          <p:nvPr/>
+        </p:nvSpPr>
+        <p:spPr>
+          <a:xfrm>
+            <a:off x="0" y="0"/>
+            <a:ext cx="12192000" cy="54864"/>
+          </a:xfrm>
+          <a:prstGeom prst="rect">
+            <a:avLst/>
+          </a:prstGeom>
+          <a:solidFill>
+            <a:srgbClr val="5B8DB8"/>
+          </a:solidFill>
+          <a:ln w="12700">
+            <a:solidFill>
+              <a:srgbClr val="5B8DB8"/>
+            </a:solidFill>
+            <a:prstDash val="solid"/>
+          </a:ln>
+        </p:spPr>
+      </p:sp>
+      <p:sp>
+        <p:nvSpPr>
+          <p:cNvPr id="6" name="Shape 4"/>
+          <p:cNvSpPr/>
+          <p:nvPr/>
+        </p:nvSpPr>
+        <p:spPr>
+          <a:xfrm>
+            <a:off x="0" y="6528816"/>
+            <a:ext cx="12192000" cy="54864"/>
+          </a:xfrm>
+          <a:prstGeom prst="rect">
+            <a:avLst/>
+          </a:prstGeom>
+          <a:solidFill>
+            <a:srgbClr val="C4786A"/>
+          </a:solidFill>
+          <a:ln w="12700">
+            <a:solidFill>
+              <a:srgbClr val="C4786A"/>
+            </a:solidFill>
+            <a:prstDash val="solid"/>
+          </a:ln>
+        </p:spPr>
+      </p:sp>
+      <p:sp>
+        <p:nvSpPr>
+          <p:cNvPr id="7" name="Text 5"/>
+          <p:cNvSpPr/>
+          <p:nvPr/>
+        </p:nvSpPr>
+        <p:spPr>
+          <a:xfrm>
+            <a:off x="457200" y="201168"/>
+            <a:ext cx="8375904" cy="502920"/>
+          </a:xfrm>
+          <a:prstGeom prst="rect">
+            <a:avLst/>
+          </a:prstGeom>
+          <a:noFill/>
+          <a:ln/>
+        </p:spPr>
+        <p:txBody>
+          <a:bodyPr wrap="square" rtlCol="0" anchor="ctr"/>
+          <a:lstStyle/>
+          <a:p>
+            <a:pPr indent="0" marL="0">
+              <a:buNone/>
+            </a:pPr>
+            <a:r>
+              <a:rPr lang="en-US" b="1" dirty="0">
+                <a:solidFill>
+                  <a:srgbClr val="2D3748"/>
+                </a:solidFill>
+                <a:latin typeface="Arial" pitchFamily="34" charset="0"/>
+                <a:ea typeface="Arial" pitchFamily="34" charset="-122"/>
+                <a:cs typeface="Arial" pitchFamily="34" charset="-120"/>
+              </a:rPr>
+              <a:t>👨‍👩‍👧  Fase paralela — Mercado familiar (B2C)</a:t>
+            </a:r>
+            <a:endParaRPr lang="en-US" dirty="0"/>
+          </a:p>
+        </p:txBody>
+      </p:sp>
+      <p:sp>
+        <p:nvSpPr>
+          <p:cNvPr id="8" name="Text 6"/>
+          <p:cNvSpPr/>
+          <p:nvPr/>
+        </p:nvSpPr>
+        <p:spPr>
+          <a:xfrm>
+            <a:off x="457200" y="713232"/>
+            <a:ext cx="8375904" cy="292608"/>
+          </a:xfrm>
+          <a:prstGeom prst="rect">
+            <a:avLst/>
+          </a:prstGeom>
+          <a:noFill/>
+          <a:ln/>
+        </p:spPr>
+        <p:txBody>
+          <a:bodyPr wrap="square" rtlCol="0" anchor="ctr"/>
+          <a:lstStyle/>
+          <a:p>
+            <a:pPr indent="0" marL="0">
+              <a:buNone/>
+            </a:pPr>
+            <a:r>
+              <a:rPr lang="en-US" b="1" dirty="0">
+                <a:solidFill>
+                  <a:srgbClr val="5B8DB8"/>
+                </a:solidFill>
+                <a:latin typeface="Arial" pitchFamily="34" charset="0"/>
+                <a:ea typeface="Arial" pitchFamily="34" charset="-122"/>
+                <a:cs typeface="Arial" pitchFamily="34" charset="-120"/>
+              </a:rPr>
+              <a:t>La misma plataforma · dos puertas de entrada · conversión cruzada B2C → B2B</a:t>
+            </a:r>
+            <a:endParaRPr lang="en-US" dirty="0"/>
+          </a:p>
+        </p:txBody>
+      </p:sp>
+      <p:sp>
+        <p:nvSpPr>
+          <p:cNvPr id="9" name="Shape 7"/>
+          <p:cNvSpPr/>
+          <p:nvPr/>
+        </p:nvSpPr>
+        <p:spPr>
+          <a:xfrm>
+            <a:off x="457200" y="1060704"/>
+            <a:ext cx="8375904" cy="0"/>
+          </a:xfrm>
+          <a:prstGeom prst="line">
+            <a:avLst/>
+          </a:prstGeom>
+          <a:noFill/>
+          <a:ln w="12700">
+            <a:solidFill>
+              <a:srgbClr val="E2E8F0"/>
+            </a:solidFill>
+            <a:prstDash val="solid"/>
+          </a:ln>
+        </p:spPr>
+      </p:sp>
+      <p:sp>
+        <p:nvSpPr>
+          <p:cNvPr id="10" name="Shape 8"/>
+          <p:cNvSpPr/>
+          <p:nvPr/>
+        </p:nvSpPr>
+        <p:spPr>
+          <a:xfrm>
+            <a:off x="365760" y="1170432"/>
+            <a:ext cx="3840480" cy="3383280"/>
+          </a:xfrm>
+          <a:prstGeom prst="roundRect">
+            <a:avLst>
+              <a:gd name="adj" fmla="val 2162"/>
+            </a:avLst>
+          </a:prstGeom>
+          <a:solidFill>
+            <a:srgbClr val="EFF6FF"/>
+          </a:solidFill>
+          <a:ln w="6350">
+            <a:solidFill>
+              <a:srgbClr val="E2E8F0"/>
+            </a:solidFill>
+            <a:prstDash val="solid"/>
+          </a:ln>
+        </p:spPr>
+      </p:sp>
+      <p:sp>
+        <p:nvSpPr>
+          <p:cNvPr id="11" name="Text 9"/>
+          <p:cNvSpPr/>
+          <p:nvPr/>
+        </p:nvSpPr>
+        <p:spPr>
+          <a:xfrm>
+            <a:off x="502920" y="1243584"/>
+            <a:ext cx="3547872" cy="329184"/>
+          </a:xfrm>
+          <a:prstGeom prst="rect">
+            <a:avLst/>
+          </a:prstGeom>
+          <a:noFill/>
+          <a:ln/>
+        </p:spPr>
+        <p:txBody>
+          <a:bodyPr wrap="square" rtlCol="0" anchor="ctr"/>
+          <a:lstStyle/>
+          <a:p>
+            <a:pPr algn="ctr" indent="0" marL="0">
+              <a:buNone/>
+            </a:pPr>
+            <a:r>
+              <a:rPr lang="en-US" sz="1200" b="1" dirty="0">
+                <a:solidFill>
+                  <a:srgbClr val="3A6B96"/>
+                </a:solidFill>
+                <a:latin typeface="Arial" pitchFamily="34" charset="0"/>
+                <a:ea typeface="Arial" pitchFamily="34" charset="-122"/>
+                <a:cs typeface="Arial" pitchFamily="34" charset="-120"/>
+              </a:rPr>
+              <a:t>B2B (canal actual)</a:t>
+            </a:r>
+            <a:endParaRPr lang="en-US" sz="1200" dirty="0"/>
+          </a:p>
+        </p:txBody>
+      </p:sp>
+      <p:sp>
+        <p:nvSpPr>
+          <p:cNvPr id="12" name="Text 10"/>
+          <p:cNvSpPr/>
+          <p:nvPr/>
+        </p:nvSpPr>
+        <p:spPr>
+          <a:xfrm>
+            <a:off x="502920" y="1645920"/>
+            <a:ext cx="365760" cy="384048"/>
+          </a:xfrm>
+          <a:prstGeom prst="rect">
+            <a:avLst/>
+          </a:prstGeom>
+          <a:noFill/>
+          <a:ln/>
+        </p:spPr>
+        <p:txBody>
+          <a:bodyPr wrap="square" rtlCol="0" anchor="ctr"/>
+          <a:lstStyle/>
+          <a:p>
+            <a:pPr algn="ctr" indent="0" marL="0">
+              <a:buNone/>
+            </a:pPr>
+            <a:r>
+              <a:rPr lang="en-US" sz="1400" dirty="0">
+                <a:solidFill>
+                  <a:srgbClr val="000000"/>
+                </a:solidFill>
+              </a:rPr>
+              <a:t>🏢</a:t>
+            </a:r>
+            <a:endParaRPr lang="en-US" sz="1400" dirty="0"/>
+          </a:p>
+        </p:txBody>
+      </p:sp>
+      <p:sp>
+        <p:nvSpPr>
+          <p:cNvPr id="13" name="Text 11"/>
+          <p:cNvSpPr/>
+          <p:nvPr/>
+        </p:nvSpPr>
+        <p:spPr>
+          <a:xfrm>
+            <a:off x="896112" y="1645920"/>
+            <a:ext cx="1097280" cy="384048"/>
+          </a:xfrm>
+          <a:prstGeom prst="rect">
+            <a:avLst/>
+          </a:prstGeom>
+          <a:noFill/>
+          <a:ln/>
+        </p:spPr>
+        <p:txBody>
+          <a:bodyPr wrap="square" rtlCol="0" anchor="ctr"/>
+          <a:lstStyle/>
+          <a:p>
+            <a:pPr indent="0" marL="0">
+              <a:buNone/>
+            </a:pPr>
+            <a:r>
+              <a:rPr lang="en-US" sz="1000" b="1" dirty="0">
+                <a:solidFill>
+                  <a:srgbClr val="718096"/>
+                </a:solidFill>
+                <a:latin typeface="Arial" pitchFamily="34" charset="0"/>
+                <a:ea typeface="Arial" pitchFamily="34" charset="-122"/>
+                <a:cs typeface="Arial" pitchFamily="34" charset="-120"/>
+              </a:rPr>
+              <a:t>Cliente</a:t>
+            </a:r>
+            <a:endParaRPr lang="en-US" sz="1000" dirty="0"/>
+          </a:p>
+        </p:txBody>
+      </p:sp>
+      <p:sp>
+        <p:nvSpPr>
+          <p:cNvPr id="14" name="Text 12"/>
+          <p:cNvSpPr/>
+          <p:nvPr/>
+        </p:nvSpPr>
+        <p:spPr>
+          <a:xfrm>
+            <a:off x="2011680" y="1645920"/>
+            <a:ext cx="2011680" cy="384048"/>
+          </a:xfrm>
+          <a:prstGeom prst="rect">
+            <a:avLst/>
+          </a:prstGeom>
+          <a:noFill/>
+          <a:ln/>
+        </p:spPr>
+        <p:txBody>
+          <a:bodyPr wrap="square" rtlCol="0" anchor="ctr"/>
+          <a:lstStyle/>
+          <a:p>
+            <a:pPr indent="0" marL="0">
+              <a:buNone/>
+            </a:pPr>
+            <a:r>
+              <a:rPr lang="en-US" sz="1050" dirty="0">
+                <a:solidFill>
+                  <a:srgbClr val="2D3748"/>
+                </a:solidFill>
+                <a:latin typeface="Arial" pitchFamily="34" charset="0"/>
+                <a:ea typeface="Arial" pitchFamily="34" charset="-122"/>
+                <a:cs typeface="Arial" pitchFamily="34" charset="-120"/>
+              </a:rPr>
+              <a:t>Director de residencia</a:t>
+            </a:r>
+            <a:endParaRPr lang="en-US" sz="1050" dirty="0"/>
+          </a:p>
+        </p:txBody>
+      </p:sp>
+      <p:sp>
+        <p:nvSpPr>
+          <p:cNvPr id="15" name="Text 13"/>
+          <p:cNvSpPr/>
+          <p:nvPr/>
+        </p:nvSpPr>
+        <p:spPr>
+          <a:xfrm>
+            <a:off x="502920" y="2103120"/>
+            <a:ext cx="365760" cy="384048"/>
+          </a:xfrm>
+          <a:prstGeom prst="rect">
+            <a:avLst/>
+          </a:prstGeom>
+          <a:noFill/>
+          <a:ln/>
+        </p:spPr>
+        <p:txBody>
+          <a:bodyPr wrap="square" rtlCol="0" anchor="ctr"/>
+          <a:lstStyle/>
+          <a:p>
+            <a:pPr algn="ctr" indent="0" marL="0">
+              <a:buNone/>
+            </a:pPr>
+            <a:r>
+              <a:rPr lang="en-US" sz="1400" dirty="0">
+                <a:solidFill>
+                  <a:srgbClr val="000000"/>
+                </a:solidFill>
+              </a:rPr>
+              <a:t>💰</a:t>
+            </a:r>
+            <a:endParaRPr lang="en-US" sz="1400" dirty="0"/>
+          </a:p>
+        </p:txBody>
+      </p:sp>
+      <p:sp>
+        <p:nvSpPr>
+          <p:cNvPr id="16" name="Text 14"/>
+          <p:cNvSpPr/>
+          <p:nvPr/>
+        </p:nvSpPr>
+        <p:spPr>
+          <a:xfrm>
+            <a:off x="896112" y="2103120"/>
+            <a:ext cx="1097280" cy="384048"/>
+          </a:xfrm>
+          <a:prstGeom prst="rect">
+            <a:avLst/>
+          </a:prstGeom>
+          <a:noFill/>
+          <a:ln/>
+        </p:spPr>
+        <p:txBody>
+          <a:bodyPr wrap="square" rtlCol="0" anchor="ctr"/>
+          <a:lstStyle/>
+          <a:p>
+            <a:pPr indent="0" marL="0">
+              <a:buNone/>
+            </a:pPr>
+            <a:r>
+              <a:rPr lang="en-US" sz="1000" b="1" dirty="0">
+                <a:solidFill>
+                  <a:srgbClr val="718096"/>
+                </a:solidFill>
+                <a:latin typeface="Arial" pitchFamily="34" charset="0"/>
+                <a:ea typeface="Arial" pitchFamily="34" charset="-122"/>
+                <a:cs typeface="Arial" pitchFamily="34" charset="-120"/>
+              </a:rPr>
+              <a:t>Ticket</a:t>
+            </a:r>
+            <a:endParaRPr lang="en-US" sz="1000" dirty="0"/>
+          </a:p>
+        </p:txBody>
+      </p:sp>
+      <p:sp>
+        <p:nvSpPr>
+          <p:cNvPr id="17" name="Text 15"/>
+          <p:cNvSpPr/>
+          <p:nvPr/>
+        </p:nvSpPr>
+        <p:spPr>
+          <a:xfrm>
+            <a:off x="2011680" y="2103120"/>
+            <a:ext cx="2011680" cy="384048"/>
+          </a:xfrm>
+          <a:prstGeom prst="rect">
+            <a:avLst/>
+          </a:prstGeom>
+          <a:noFill/>
+          <a:ln/>
+        </p:spPr>
+        <p:txBody>
+          <a:bodyPr wrap="square" rtlCol="0" anchor="ctr"/>
+          <a:lstStyle/>
+          <a:p>
+            <a:pPr indent="0" marL="0">
+              <a:buNone/>
+            </a:pPr>
+            <a:r>
+              <a:rPr lang="en-US" sz="1050" dirty="0">
+                <a:solidFill>
+                  <a:srgbClr val="2D3748"/>
+                </a:solidFill>
+                <a:latin typeface="Arial" pitchFamily="34" charset="0"/>
+                <a:ea typeface="Arial" pitchFamily="34" charset="-122"/>
+                <a:cs typeface="Arial" pitchFamily="34" charset="-120"/>
+              </a:rPr>
+              <a:t>$1,990 – $8,490 MXN/mes</a:t>
+            </a:r>
+            <a:endParaRPr lang="en-US" sz="1050" dirty="0"/>
+          </a:p>
+        </p:txBody>
+      </p:sp>
+      <p:sp>
+        <p:nvSpPr>
+          <p:cNvPr id="18" name="Text 16"/>
+          <p:cNvSpPr/>
+          <p:nvPr/>
+        </p:nvSpPr>
+        <p:spPr>
+          <a:xfrm>
+            <a:off x="502920" y="2560320"/>
+            <a:ext cx="365760" cy="384048"/>
+          </a:xfrm>
+          <a:prstGeom prst="rect">
+            <a:avLst/>
+          </a:prstGeom>
+          <a:noFill/>
+          <a:ln/>
+        </p:spPr>
+        <p:txBody>
+          <a:bodyPr wrap="square" rtlCol="0" anchor="ctr"/>
+          <a:lstStyle/>
+          <a:p>
+            <a:pPr algn="ctr" indent="0" marL="0">
+              <a:buNone/>
+            </a:pPr>
+            <a:r>
+              <a:rPr lang="en-US" sz="1400" dirty="0">
+                <a:solidFill>
+                  <a:srgbClr val="000000"/>
+                </a:solidFill>
+              </a:rPr>
+              <a:t>⏱</a:t>
+            </a:r>
+            <a:endParaRPr lang="en-US" sz="1400" dirty="0"/>
+          </a:p>
+        </p:txBody>
+      </p:sp>
+      <p:sp>
+        <p:nvSpPr>
+          <p:cNvPr id="19" name="Text 17"/>
+          <p:cNvSpPr/>
+          <p:nvPr/>
+        </p:nvSpPr>
+        <p:spPr>
+          <a:xfrm>
+            <a:off x="896112" y="2560320"/>
+            <a:ext cx="1097280" cy="384048"/>
+          </a:xfrm>
+          <a:prstGeom prst="rect">
+            <a:avLst/>
+          </a:prstGeom>
+          <a:noFill/>
+          <a:ln/>
+        </p:spPr>
+        <p:txBody>
+          <a:bodyPr wrap="square" rtlCol="0" anchor="ctr"/>
+          <a:lstStyle/>
+          <a:p>
+            <a:pPr indent="0" marL="0">
+              <a:buNone/>
+            </a:pPr>
+            <a:r>
+              <a:rPr lang="en-US" sz="1000" b="1" dirty="0">
+                <a:solidFill>
+                  <a:srgbClr val="718096"/>
+                </a:solidFill>
+                <a:latin typeface="Arial" pitchFamily="34" charset="0"/>
+                <a:ea typeface="Arial" pitchFamily="34" charset="-122"/>
+                <a:cs typeface="Arial" pitchFamily="34" charset="-120"/>
+              </a:rPr>
+              <a:t>Ciclo de venta</a:t>
+            </a:r>
+            <a:endParaRPr lang="en-US" sz="1000" dirty="0"/>
+          </a:p>
+        </p:txBody>
+      </p:sp>
+      <p:sp>
+        <p:nvSpPr>
+          <p:cNvPr id="20" name="Text 18"/>
+          <p:cNvSpPr/>
+          <p:nvPr/>
+        </p:nvSpPr>
+        <p:spPr>
+          <a:xfrm>
+            <a:off x="2011680" y="2560320"/>
+            <a:ext cx="2011680" cy="384048"/>
+          </a:xfrm>
+          <a:prstGeom prst="rect">
+            <a:avLst/>
+          </a:prstGeom>
+          <a:noFill/>
+          <a:ln/>
+        </p:spPr>
+        <p:txBody>
+          <a:bodyPr wrap="square" rtlCol="0" anchor="ctr"/>
+          <a:lstStyle/>
+          <a:p>
+            <a:pPr indent="0" marL="0">
+              <a:buNone/>
+            </a:pPr>
+            <a:r>
+              <a:rPr lang="en-US" sz="1050" dirty="0">
+                <a:solidFill>
+                  <a:srgbClr val="2D3748"/>
+                </a:solidFill>
+                <a:latin typeface="Arial" pitchFamily="34" charset="0"/>
+                <a:ea typeface="Arial" pitchFamily="34" charset="-122"/>
+                <a:cs typeface="Arial" pitchFamily="34" charset="-120"/>
+              </a:rPr>
+              <a:t>2–6 meses · B2B largo</a:t>
+            </a:r>
+            <a:endParaRPr lang="en-US" sz="1050" dirty="0"/>
+          </a:p>
+        </p:txBody>
+      </p:sp>
+      <p:sp>
+        <p:nvSpPr>
+          <p:cNvPr id="21" name="Text 19"/>
+          <p:cNvSpPr/>
+          <p:nvPr/>
+        </p:nvSpPr>
+        <p:spPr>
+          <a:xfrm>
+            <a:off x="502920" y="3017520"/>
+            <a:ext cx="365760" cy="384048"/>
+          </a:xfrm>
+          <a:prstGeom prst="rect">
+            <a:avLst/>
+          </a:prstGeom>
+          <a:noFill/>
+          <a:ln/>
+        </p:spPr>
+        <p:txBody>
+          <a:bodyPr wrap="square" rtlCol="0" anchor="ctr"/>
+          <a:lstStyle/>
+          <a:p>
+            <a:pPr algn="ctr" indent="0" marL="0">
+              <a:buNone/>
+            </a:pPr>
+            <a:r>
+              <a:rPr lang="en-US" sz="1400" dirty="0">
+                <a:solidFill>
+                  <a:srgbClr val="000000"/>
+                </a:solidFill>
+              </a:rPr>
+              <a:t>📣</a:t>
+            </a:r>
+            <a:endParaRPr lang="en-US" sz="1400" dirty="0"/>
+          </a:p>
+        </p:txBody>
+      </p:sp>
+      <p:sp>
+        <p:nvSpPr>
+          <p:cNvPr id="22" name="Text 20"/>
+          <p:cNvSpPr/>
+          <p:nvPr/>
+        </p:nvSpPr>
+        <p:spPr>
+          <a:xfrm>
+            <a:off x="896112" y="3017520"/>
+            <a:ext cx="1097280" cy="384048"/>
+          </a:xfrm>
+          <a:prstGeom prst="rect">
+            <a:avLst/>
+          </a:prstGeom>
+          <a:noFill/>
+          <a:ln/>
+        </p:spPr>
+        <p:txBody>
+          <a:bodyPr wrap="square" rtlCol="0" anchor="ctr"/>
+          <a:lstStyle/>
+          <a:p>
+            <a:pPr indent="0" marL="0">
+              <a:buNone/>
+            </a:pPr>
+            <a:r>
+              <a:rPr lang="en-US" sz="1000" b="1" dirty="0">
+                <a:solidFill>
+                  <a:srgbClr val="718096"/>
+                </a:solidFill>
+                <a:latin typeface="Arial" pitchFamily="34" charset="0"/>
+                <a:ea typeface="Arial" pitchFamily="34" charset="-122"/>
+                <a:cs typeface="Arial" pitchFamily="34" charset="-120"/>
+              </a:rPr>
+              <a:t>Adquisición</a:t>
+            </a:r>
+            <a:endParaRPr lang="en-US" sz="1000" dirty="0"/>
+          </a:p>
+        </p:txBody>
+      </p:sp>
+      <p:sp>
+        <p:nvSpPr>
+          <p:cNvPr id="23" name="Text 21"/>
+          <p:cNvSpPr/>
+          <p:nvPr/>
+        </p:nvSpPr>
+        <p:spPr>
+          <a:xfrm>
+            <a:off x="2011680" y="3017520"/>
+            <a:ext cx="2011680" cy="384048"/>
+          </a:xfrm>
+          <a:prstGeom prst="rect">
+            <a:avLst/>
+          </a:prstGeom>
+          <a:noFill/>
+          <a:ln/>
+        </p:spPr>
+        <p:txBody>
+          <a:bodyPr wrap="square" rtlCol="0" anchor="ctr"/>
+          <a:lstStyle/>
+          <a:p>
+            <a:pPr indent="0" marL="0">
+              <a:buNone/>
+            </a:pPr>
+            <a:r>
+              <a:rPr lang="en-US" sz="1050" dirty="0">
+                <a:solidFill>
+                  <a:srgbClr val="2D3748"/>
+                </a:solidFill>
+                <a:latin typeface="Arial" pitchFamily="34" charset="0"/>
+                <a:ea typeface="Arial" pitchFamily="34" charset="-122"/>
+                <a:cs typeface="Arial" pitchFamily="34" charset="-120"/>
+              </a:rPr>
+              <a:t>Ventas de campo</a:t>
+            </a:r>
+            <a:endParaRPr lang="en-US" sz="1050" dirty="0"/>
+          </a:p>
+        </p:txBody>
+      </p:sp>
+      <p:sp>
+        <p:nvSpPr>
+          <p:cNvPr id="24" name="Text 22"/>
+          <p:cNvSpPr/>
+          <p:nvPr/>
+        </p:nvSpPr>
+        <p:spPr>
+          <a:xfrm>
+            <a:off x="502920" y="3474720"/>
+            <a:ext cx="365760" cy="384048"/>
+          </a:xfrm>
+          <a:prstGeom prst="rect">
+            <a:avLst/>
+          </a:prstGeom>
+          <a:noFill/>
+          <a:ln/>
+        </p:spPr>
+        <p:txBody>
+          <a:bodyPr wrap="square" rtlCol="0" anchor="ctr"/>
+          <a:lstStyle/>
+          <a:p>
+            <a:pPr algn="ctr" indent="0" marL="0">
+              <a:buNone/>
+            </a:pPr>
+            <a:r>
+              <a:rPr lang="en-US" sz="1400" dirty="0">
+                <a:solidFill>
+                  <a:srgbClr val="000000"/>
+                </a:solidFill>
+              </a:rPr>
+              <a:t>📊</a:t>
+            </a:r>
+            <a:endParaRPr lang="en-US" sz="1400" dirty="0"/>
+          </a:p>
+        </p:txBody>
+      </p:sp>
+      <p:sp>
+        <p:nvSpPr>
+          <p:cNvPr id="25" name="Text 23"/>
+          <p:cNvSpPr/>
+          <p:nvPr/>
+        </p:nvSpPr>
+        <p:spPr>
+          <a:xfrm>
+            <a:off x="896112" y="3474720"/>
+            <a:ext cx="1097280" cy="384048"/>
+          </a:xfrm>
+          <a:prstGeom prst="rect">
+            <a:avLst/>
+          </a:prstGeom>
+          <a:noFill/>
+          <a:ln/>
+        </p:spPr>
+        <p:txBody>
+          <a:bodyPr wrap="square" rtlCol="0" anchor="ctr"/>
+          <a:lstStyle/>
+          <a:p>
+            <a:pPr indent="0" marL="0">
+              <a:buNone/>
+            </a:pPr>
+            <a:r>
+              <a:rPr lang="en-US" sz="1000" b="1" dirty="0">
+                <a:solidFill>
+                  <a:srgbClr val="718096"/>
+                </a:solidFill>
+                <a:latin typeface="Arial" pitchFamily="34" charset="0"/>
+                <a:ea typeface="Arial" pitchFamily="34" charset="-122"/>
+                <a:cs typeface="Arial" pitchFamily="34" charset="-120"/>
+              </a:rPr>
+              <a:t>SAM México</a:t>
+            </a:r>
+            <a:endParaRPr lang="en-US" sz="1000" dirty="0"/>
+          </a:p>
+        </p:txBody>
+      </p:sp>
+      <p:sp>
+        <p:nvSpPr>
+          <p:cNvPr id="26" name="Text 24"/>
+          <p:cNvSpPr/>
+          <p:nvPr/>
+        </p:nvSpPr>
+        <p:spPr>
+          <a:xfrm>
+            <a:off x="2011680" y="3474720"/>
+            <a:ext cx="2011680" cy="384048"/>
+          </a:xfrm>
+          <a:prstGeom prst="rect">
+            <a:avLst/>
+          </a:prstGeom>
+          <a:noFill/>
+          <a:ln/>
+        </p:spPr>
+        <p:txBody>
+          <a:bodyPr wrap="square" rtlCol="0" anchor="ctr"/>
+          <a:lstStyle/>
+          <a:p>
+            <a:pPr indent="0" marL="0">
+              <a:buNone/>
+            </a:pPr>
+            <a:r>
+              <a:rPr lang="en-US" sz="1050" dirty="0">
+                <a:solidFill>
+                  <a:srgbClr val="2D3748"/>
+                </a:solidFill>
+                <a:latin typeface="Arial" pitchFamily="34" charset="0"/>
+                <a:ea typeface="Arial" pitchFamily="34" charset="-122"/>
+                <a:cs typeface="Arial" pitchFamily="34" charset="-120"/>
+              </a:rPr>
+              <a:t>~1,200 residencias</a:t>
+            </a:r>
+            <a:endParaRPr lang="en-US" sz="1050" dirty="0"/>
+          </a:p>
+        </p:txBody>
+      </p:sp>
+      <p:sp>
+        <p:nvSpPr>
+          <p:cNvPr id="27" name="Text 25"/>
+          <p:cNvSpPr/>
+          <p:nvPr/>
+        </p:nvSpPr>
+        <p:spPr>
+          <a:xfrm>
+            <a:off x="4160520" y="2651760"/>
+            <a:ext cx="548640" cy="502920"/>
+          </a:xfrm>
+          <a:prstGeom prst="rect">
+            <a:avLst/>
+          </a:prstGeom>
+          <a:noFill/>
+          <a:ln/>
+        </p:spPr>
+        <p:txBody>
+          <a:bodyPr wrap="square" rtlCol="0" anchor="ctr"/>
+          <a:lstStyle/>
+          <a:p>
+            <a:pPr algn="ctr" indent="0" marL="0">
+              <a:buNone/>
+            </a:pPr>
+            <a:r>
+              <a:rPr lang="en-US" sz="2400" b="1" dirty="0">
+                <a:solidFill>
+                  <a:srgbClr val="5B8DB8"/>
+                </a:solidFill>
+                <a:latin typeface="Arial" pitchFamily="34" charset="0"/>
+                <a:ea typeface="Arial" pitchFamily="34" charset="-122"/>
+                <a:cs typeface="Arial" pitchFamily="34" charset="-120"/>
+              </a:rPr>
+              <a:t>⇄</a:t>
+            </a:r>
+            <a:endParaRPr lang="en-US" sz="2400" dirty="0"/>
+          </a:p>
+        </p:txBody>
+      </p:sp>
+      <p:sp>
+        <p:nvSpPr>
+          <p:cNvPr id="28" name="Shape 26"/>
+          <p:cNvSpPr/>
+          <p:nvPr/>
+        </p:nvSpPr>
+        <p:spPr>
+          <a:xfrm>
+            <a:off x="4626864" y="1170432"/>
+            <a:ext cx="4151376" cy="3383280"/>
+          </a:xfrm>
+          <a:prstGeom prst="roundRect">
+            <a:avLst>
+              <a:gd name="adj" fmla="val 2162"/>
+            </a:avLst>
+          </a:prstGeom>
+          <a:solidFill>
+            <a:srgbClr val="FFF7ED"/>
+          </a:solidFill>
+          <a:ln w="6350">
+            <a:solidFill>
+              <a:srgbClr val="E2E8F0"/>
+            </a:solidFill>
+            <a:prstDash val="solid"/>
+          </a:ln>
+        </p:spPr>
+      </p:sp>
+      <p:sp>
+        <p:nvSpPr>
+          <p:cNvPr id="29" name="Text 27"/>
+          <p:cNvSpPr/>
+          <p:nvPr/>
+        </p:nvSpPr>
+        <p:spPr>
+          <a:xfrm>
+            <a:off x="4736592" y="1243584"/>
+            <a:ext cx="3840480" cy="329184"/>
+          </a:xfrm>
+          <a:prstGeom prst="rect">
+            <a:avLst/>
+          </a:prstGeom>
+          <a:noFill/>
+          <a:ln/>
+        </p:spPr>
+        <p:txBody>
+          <a:bodyPr wrap="square" rtlCol="0" anchor="ctr"/>
+          <a:lstStyle/>
+          <a:p>
+            <a:pPr algn="ctr" indent="0" marL="0">
+              <a:buNone/>
+            </a:pPr>
+            <a:r>
+              <a:rPr lang="en-US" sz="1200" b="1" dirty="0">
+                <a:solidFill>
+                  <a:srgbClr val="C4786A"/>
+                </a:solidFill>
+                <a:latin typeface="Arial" pitchFamily="34" charset="0"/>
+                <a:ea typeface="Arial" pitchFamily="34" charset="-122"/>
+                <a:cs typeface="Arial" pitchFamily="34" charset="-120"/>
+              </a:rPr>
+              <a:t>B2C — Fase paralela  🆕</a:t>
+            </a:r>
+            <a:endParaRPr lang="en-US" sz="1200" dirty="0"/>
+          </a:p>
+        </p:txBody>
+      </p:sp>
+      <p:sp>
+        <p:nvSpPr>
+          <p:cNvPr id="30" name="Text 28"/>
+          <p:cNvSpPr/>
+          <p:nvPr/>
+        </p:nvSpPr>
+        <p:spPr>
+          <a:xfrm>
+            <a:off x="4736592" y="1645920"/>
+            <a:ext cx="365760" cy="384048"/>
+          </a:xfrm>
+          <a:prstGeom prst="rect">
+            <a:avLst/>
+          </a:prstGeom>
+          <a:noFill/>
+          <a:ln/>
+        </p:spPr>
+        <p:txBody>
+          <a:bodyPr wrap="square" rtlCol="0" anchor="ctr"/>
+          <a:lstStyle/>
+          <a:p>
+            <a:pPr algn="ctr" indent="0" marL="0">
+              <a:buNone/>
+            </a:pPr>
+            <a:r>
+              <a:rPr lang="en-US" sz="1400" dirty="0">
+                <a:solidFill>
+                  <a:srgbClr val="000000"/>
+                </a:solidFill>
+              </a:rPr>
+              <a:t>👪</a:t>
+            </a:r>
+            <a:endParaRPr lang="en-US" sz="1400" dirty="0"/>
+          </a:p>
+        </p:txBody>
+      </p:sp>
+      <p:sp>
+        <p:nvSpPr>
+          <p:cNvPr id="31" name="Text 29"/>
+          <p:cNvSpPr/>
+          <p:nvPr/>
+        </p:nvSpPr>
+        <p:spPr>
+          <a:xfrm>
+            <a:off x="5138928" y="1645920"/>
+            <a:ext cx="1097280" cy="384048"/>
+          </a:xfrm>
+          <a:prstGeom prst="rect">
+            <a:avLst/>
+          </a:prstGeom>
+          <a:noFill/>
+          <a:ln/>
+        </p:spPr>
+        <p:txBody>
+          <a:bodyPr wrap="square" rtlCol="0" anchor="ctr"/>
+          <a:lstStyle/>
+          <a:p>
+            <a:pPr indent="0" marL="0">
+              <a:buNone/>
+            </a:pPr>
+            <a:r>
+              <a:rPr lang="en-US" sz="1000" b="1" dirty="0">
+                <a:solidFill>
+                  <a:srgbClr val="718096"/>
+                </a:solidFill>
+                <a:latin typeface="Arial" pitchFamily="34" charset="0"/>
+                <a:ea typeface="Arial" pitchFamily="34" charset="-122"/>
+                <a:cs typeface="Arial" pitchFamily="34" charset="-120"/>
+              </a:rPr>
+              <a:t>Cliente</a:t>
+            </a:r>
+            <a:endParaRPr lang="en-US" sz="1000" dirty="0"/>
+          </a:p>
+        </p:txBody>
+      </p:sp>
+      <p:sp>
+        <p:nvSpPr>
+          <p:cNvPr id="32" name="Text 30"/>
+          <p:cNvSpPr/>
+          <p:nvPr/>
+        </p:nvSpPr>
+        <p:spPr>
+          <a:xfrm>
+            <a:off x="6254496" y="1645920"/>
+            <a:ext cx="2450592" cy="384048"/>
+          </a:xfrm>
+          <a:prstGeom prst="rect">
+            <a:avLst/>
+          </a:prstGeom>
+          <a:noFill/>
+          <a:ln/>
+        </p:spPr>
+        <p:txBody>
+          <a:bodyPr wrap="square" rtlCol="0" anchor="ctr"/>
+          <a:lstStyle/>
+          <a:p>
+            <a:pPr indent="0" marL="0">
+              <a:buNone/>
+            </a:pPr>
+            <a:r>
+              <a:rPr lang="en-US" sz="1050" dirty="0">
+                <a:solidFill>
+                  <a:srgbClr val="2D3748"/>
+                </a:solidFill>
+                <a:latin typeface="Arial" pitchFamily="34" charset="0"/>
+                <a:ea typeface="Arial" pitchFamily="34" charset="-122"/>
+                <a:cs typeface="Arial" pitchFamily="34" charset="-120"/>
+              </a:rPr>
+              <a:t>Familia de adulto mayor</a:t>
+            </a:r>
+            <a:endParaRPr lang="en-US" sz="1050" dirty="0"/>
+          </a:p>
+        </p:txBody>
+      </p:sp>
+      <p:sp>
+        <p:nvSpPr>
+          <p:cNvPr id="33" name="Text 31"/>
+          <p:cNvSpPr/>
+          <p:nvPr/>
+        </p:nvSpPr>
+        <p:spPr>
+          <a:xfrm>
+            <a:off x="4736592" y="2103120"/>
+            <a:ext cx="365760" cy="384048"/>
+          </a:xfrm>
+          <a:prstGeom prst="rect">
+            <a:avLst/>
+          </a:prstGeom>
+          <a:noFill/>
+          <a:ln/>
+        </p:spPr>
+        <p:txBody>
+          <a:bodyPr wrap="square" rtlCol="0" anchor="ctr"/>
+          <a:lstStyle/>
+          <a:p>
+            <a:pPr algn="ctr" indent="0" marL="0">
+              <a:buNone/>
+            </a:pPr>
+            <a:r>
+              <a:rPr lang="en-US" sz="1400" dirty="0">
+                <a:solidFill>
+                  <a:srgbClr val="000000"/>
+                </a:solidFill>
+              </a:rPr>
+              <a:t>💰</a:t>
+            </a:r>
+            <a:endParaRPr lang="en-US" sz="1400" dirty="0"/>
+          </a:p>
+        </p:txBody>
+      </p:sp>
+      <p:sp>
+        <p:nvSpPr>
+          <p:cNvPr id="34" name="Text 32"/>
+          <p:cNvSpPr/>
+          <p:nvPr/>
+        </p:nvSpPr>
+        <p:spPr>
+          <a:xfrm>
+            <a:off x="5138928" y="2103120"/>
+            <a:ext cx="1097280" cy="384048"/>
+          </a:xfrm>
+          <a:prstGeom prst="rect">
+            <a:avLst/>
+          </a:prstGeom>
+          <a:noFill/>
+          <a:ln/>
+        </p:spPr>
+        <p:txBody>
+          <a:bodyPr wrap="square" rtlCol="0" anchor="ctr"/>
+          <a:lstStyle/>
+          <a:p>
+            <a:pPr indent="0" marL="0">
+              <a:buNone/>
+            </a:pPr>
+            <a:r>
+              <a:rPr lang="en-US" sz="1000" b="1" dirty="0">
+                <a:solidFill>
+                  <a:srgbClr val="718096"/>
+                </a:solidFill>
+                <a:latin typeface="Arial" pitchFamily="34" charset="0"/>
+                <a:ea typeface="Arial" pitchFamily="34" charset="-122"/>
+                <a:cs typeface="Arial" pitchFamily="34" charset="-120"/>
+              </a:rPr>
+              <a:t>Ticket</a:t>
+            </a:r>
+            <a:endParaRPr lang="en-US" sz="1000" dirty="0"/>
+          </a:p>
+        </p:txBody>
+      </p:sp>
+      <p:sp>
+        <p:nvSpPr>
+          <p:cNvPr id="35" name="Text 33"/>
+          <p:cNvSpPr/>
+          <p:nvPr/>
+        </p:nvSpPr>
+        <p:spPr>
+          <a:xfrm>
+            <a:off x="6254496" y="2103120"/>
+            <a:ext cx="2450592" cy="384048"/>
+          </a:xfrm>
+          <a:prstGeom prst="rect">
+            <a:avLst/>
+          </a:prstGeom>
+          <a:noFill/>
+          <a:ln/>
+        </p:spPr>
+        <p:txBody>
+          <a:bodyPr wrap="square" rtlCol="0" anchor="ctr"/>
+          <a:lstStyle/>
+          <a:p>
+            <a:pPr indent="0" marL="0">
+              <a:buNone/>
+            </a:pPr>
+            <a:r>
+              <a:rPr lang="en-US" sz="1050" dirty="0">
+                <a:solidFill>
+                  <a:srgbClr val="2D3748"/>
+                </a:solidFill>
+                <a:latin typeface="Arial" pitchFamily="34" charset="0"/>
+                <a:ea typeface="Arial" pitchFamily="34" charset="-122"/>
+                <a:cs typeface="Arial" pitchFamily="34" charset="-120"/>
+              </a:rPr>
+              <a:t>$199 – $399 MXN/mes</a:t>
+            </a:r>
+            <a:endParaRPr lang="en-US" sz="1050" dirty="0"/>
+          </a:p>
+        </p:txBody>
+      </p:sp>
+      <p:sp>
+        <p:nvSpPr>
+          <p:cNvPr id="36" name="Text 34"/>
+          <p:cNvSpPr/>
+          <p:nvPr/>
+        </p:nvSpPr>
+        <p:spPr>
+          <a:xfrm>
+            <a:off x="4736592" y="2560320"/>
+            <a:ext cx="365760" cy="384048"/>
+          </a:xfrm>
+          <a:prstGeom prst="rect">
+            <a:avLst/>
+          </a:prstGeom>
+          <a:noFill/>
+          <a:ln/>
+        </p:spPr>
+        <p:txBody>
+          <a:bodyPr wrap="square" rtlCol="0" anchor="ctr"/>
+          <a:lstStyle/>
+          <a:p>
+            <a:pPr algn="ctr" indent="0" marL="0">
+              <a:buNone/>
+            </a:pPr>
+            <a:r>
+              <a:rPr lang="en-US" sz="1400" dirty="0">
+                <a:solidFill>
+                  <a:srgbClr val="000000"/>
+                </a:solidFill>
+              </a:rPr>
+              <a:t>⚡</a:t>
+            </a:r>
+            <a:endParaRPr lang="en-US" sz="1400" dirty="0"/>
+          </a:p>
+        </p:txBody>
+      </p:sp>
+      <p:sp>
+        <p:nvSpPr>
+          <p:cNvPr id="37" name="Text 35"/>
+          <p:cNvSpPr/>
+          <p:nvPr/>
+        </p:nvSpPr>
+        <p:spPr>
+          <a:xfrm>
+            <a:off x="5138928" y="2560320"/>
+            <a:ext cx="1097280" cy="384048"/>
+          </a:xfrm>
+          <a:prstGeom prst="rect">
+            <a:avLst/>
+          </a:prstGeom>
+          <a:noFill/>
+          <a:ln/>
+        </p:spPr>
+        <p:txBody>
+          <a:bodyPr wrap="square" rtlCol="0" anchor="ctr"/>
+          <a:lstStyle/>
+          <a:p>
+            <a:pPr indent="0" marL="0">
+              <a:buNone/>
+            </a:pPr>
+            <a:r>
+              <a:rPr lang="en-US" sz="1000" b="1" dirty="0">
+                <a:solidFill>
+                  <a:srgbClr val="718096"/>
+                </a:solidFill>
+                <a:latin typeface="Arial" pitchFamily="34" charset="0"/>
+                <a:ea typeface="Arial" pitchFamily="34" charset="-122"/>
+                <a:cs typeface="Arial" pitchFamily="34" charset="-120"/>
+              </a:rPr>
+              <a:t>Ciclo de venta</a:t>
+            </a:r>
+            <a:endParaRPr lang="en-US" sz="1000" dirty="0"/>
+          </a:p>
+        </p:txBody>
+      </p:sp>
+      <p:sp>
+        <p:nvSpPr>
+          <p:cNvPr id="38" name="Text 36"/>
+          <p:cNvSpPr/>
+          <p:nvPr/>
+        </p:nvSpPr>
+        <p:spPr>
+          <a:xfrm>
+            <a:off x="6254496" y="2560320"/>
+            <a:ext cx="2450592" cy="384048"/>
+          </a:xfrm>
+          <a:prstGeom prst="rect">
+            <a:avLst/>
+          </a:prstGeom>
+          <a:noFill/>
+          <a:ln/>
+        </p:spPr>
+        <p:txBody>
+          <a:bodyPr wrap="square" rtlCol="0" anchor="ctr"/>
+          <a:lstStyle/>
+          <a:p>
+            <a:pPr indent="0" marL="0">
+              <a:buNone/>
+            </a:pPr>
+            <a:r>
+              <a:rPr lang="en-US" sz="1050" dirty="0">
+                <a:solidFill>
+                  <a:srgbClr val="2D3748"/>
+                </a:solidFill>
+                <a:latin typeface="Arial" pitchFamily="34" charset="0"/>
+                <a:ea typeface="Arial" pitchFamily="34" charset="-122"/>
+                <a:cs typeface="Arial" pitchFamily="34" charset="-120"/>
+              </a:rPr>
+              <a:t>&lt; 5 min · autoservicio</a:t>
+            </a:r>
+            <a:endParaRPr lang="en-US" sz="1050" dirty="0"/>
+          </a:p>
+        </p:txBody>
+      </p:sp>
+      <p:sp>
+        <p:nvSpPr>
+          <p:cNvPr id="39" name="Text 37"/>
+          <p:cNvSpPr/>
+          <p:nvPr/>
+        </p:nvSpPr>
+        <p:spPr>
+          <a:xfrm>
+            <a:off x="4736592" y="3017520"/>
+            <a:ext cx="365760" cy="384048"/>
+          </a:xfrm>
+          <a:prstGeom prst="rect">
+            <a:avLst/>
+          </a:prstGeom>
+          <a:noFill/>
+          <a:ln/>
+        </p:spPr>
+        <p:txBody>
+          <a:bodyPr wrap="square" rtlCol="0" anchor="ctr"/>
+          <a:lstStyle/>
+          <a:p>
+            <a:pPr algn="ctr" indent="0" marL="0">
+              <a:buNone/>
+            </a:pPr>
+            <a:r>
+              <a:rPr lang="en-US" sz="1400" dirty="0">
+                <a:solidFill>
+                  <a:srgbClr val="000000"/>
+                </a:solidFill>
+              </a:rPr>
+              <a:t>📱</a:t>
+            </a:r>
+            <a:endParaRPr lang="en-US" sz="1400" dirty="0"/>
+          </a:p>
+        </p:txBody>
+      </p:sp>
+      <p:sp>
+        <p:nvSpPr>
+          <p:cNvPr id="40" name="Text 38"/>
+          <p:cNvSpPr/>
+          <p:nvPr/>
+        </p:nvSpPr>
+        <p:spPr>
+          <a:xfrm>
+            <a:off x="5138928" y="3017520"/>
+            <a:ext cx="1097280" cy="384048"/>
+          </a:xfrm>
+          <a:prstGeom prst="rect">
+            <a:avLst/>
+          </a:prstGeom>
+          <a:noFill/>
+          <a:ln/>
+        </p:spPr>
+        <p:txBody>
+          <a:bodyPr wrap="square" rtlCol="0" anchor="ctr"/>
+          <a:lstStyle/>
+          <a:p>
+            <a:pPr indent="0" marL="0">
+              <a:buNone/>
+            </a:pPr>
+            <a:r>
+              <a:rPr lang="en-US" sz="1000" b="1" dirty="0">
+                <a:solidFill>
+                  <a:srgbClr val="718096"/>
+                </a:solidFill>
+                <a:latin typeface="Arial" pitchFamily="34" charset="0"/>
+                <a:ea typeface="Arial" pitchFamily="34" charset="-122"/>
+                <a:cs typeface="Arial" pitchFamily="34" charset="-120"/>
+              </a:rPr>
+              <a:t>Adquisición</a:t>
+            </a:r>
+            <a:endParaRPr lang="en-US" sz="1000" dirty="0"/>
+          </a:p>
+        </p:txBody>
+      </p:sp>
+      <p:sp>
+        <p:nvSpPr>
+          <p:cNvPr id="41" name="Text 39"/>
+          <p:cNvSpPr/>
+          <p:nvPr/>
+        </p:nvSpPr>
+        <p:spPr>
+          <a:xfrm>
+            <a:off x="6254496" y="3017520"/>
+            <a:ext cx="2450592" cy="384048"/>
+          </a:xfrm>
+          <a:prstGeom prst="rect">
+            <a:avLst/>
+          </a:prstGeom>
+          <a:noFill/>
+          <a:ln/>
+        </p:spPr>
+        <p:txBody>
+          <a:bodyPr wrap="square" rtlCol="0" anchor="ctr"/>
+          <a:lstStyle/>
+          <a:p>
+            <a:pPr indent="0" marL="0">
+              <a:buNone/>
+            </a:pPr>
+            <a:r>
+              <a:rPr lang="en-US" sz="1050" dirty="0">
+                <a:solidFill>
+                  <a:srgbClr val="2D3748"/>
+                </a:solidFill>
+                <a:latin typeface="Arial" pitchFamily="34" charset="0"/>
+                <a:ea typeface="Arial" pitchFamily="34" charset="-122"/>
+                <a:cs typeface="Arial" pitchFamily="34" charset="-120"/>
+              </a:rPr>
+              <a:t>App stores · redes sociales</a:t>
+            </a:r>
+            <a:endParaRPr lang="en-US" sz="1050" dirty="0"/>
+          </a:p>
+        </p:txBody>
+      </p:sp>
+      <p:sp>
+        <p:nvSpPr>
+          <p:cNvPr id="42" name="Text 40"/>
+          <p:cNvSpPr/>
+          <p:nvPr/>
+        </p:nvSpPr>
+        <p:spPr>
+          <a:xfrm>
+            <a:off x="4736592" y="3474720"/>
+            <a:ext cx="365760" cy="384048"/>
+          </a:xfrm>
+          <a:prstGeom prst="rect">
+            <a:avLst/>
+          </a:prstGeom>
+          <a:noFill/>
+          <a:ln/>
+        </p:spPr>
+        <p:txBody>
+          <a:bodyPr wrap="square" rtlCol="0" anchor="ctr"/>
+          <a:lstStyle/>
+          <a:p>
+            <a:pPr algn="ctr" indent="0" marL="0">
+              <a:buNone/>
+            </a:pPr>
+            <a:r>
+              <a:rPr lang="en-US" sz="1400" dirty="0">
+                <a:solidFill>
+                  <a:srgbClr val="000000"/>
+                </a:solidFill>
+              </a:rPr>
+              <a:t>📊</a:t>
+            </a:r>
+            <a:endParaRPr lang="en-US" sz="1400" dirty="0"/>
+          </a:p>
+        </p:txBody>
+      </p:sp>
+      <p:sp>
+        <p:nvSpPr>
+          <p:cNvPr id="43" name="Text 41"/>
+          <p:cNvSpPr/>
+          <p:nvPr/>
+        </p:nvSpPr>
+        <p:spPr>
+          <a:xfrm>
+            <a:off x="5138928" y="3474720"/>
+            <a:ext cx="1097280" cy="384048"/>
+          </a:xfrm>
+          <a:prstGeom prst="rect">
+            <a:avLst/>
+          </a:prstGeom>
+          <a:noFill/>
+          <a:ln/>
+        </p:spPr>
+        <p:txBody>
+          <a:bodyPr wrap="square" rtlCol="0" anchor="ctr"/>
+          <a:lstStyle/>
+          <a:p>
+            <a:pPr indent="0" marL="0">
+              <a:buNone/>
+            </a:pPr>
+            <a:r>
+              <a:rPr lang="en-US" sz="1000" b="1" dirty="0">
+                <a:solidFill>
+                  <a:srgbClr val="718096"/>
+                </a:solidFill>
+                <a:latin typeface="Arial" pitchFamily="34" charset="0"/>
+                <a:ea typeface="Arial" pitchFamily="34" charset="-122"/>
+                <a:cs typeface="Arial" pitchFamily="34" charset="-120"/>
+              </a:rPr>
+              <a:t>SAM México</a:t>
+            </a:r>
+            <a:endParaRPr lang="en-US" sz="1000" dirty="0"/>
+          </a:p>
+        </p:txBody>
+      </p:sp>
+      <p:sp>
+        <p:nvSpPr>
+          <p:cNvPr id="44" name="Text 42"/>
+          <p:cNvSpPr/>
+          <p:nvPr/>
+        </p:nvSpPr>
+        <p:spPr>
+          <a:xfrm>
+            <a:off x="6254496" y="3474720"/>
+            <a:ext cx="2450592" cy="384048"/>
+          </a:xfrm>
+          <a:prstGeom prst="rect">
+            <a:avLst/>
+          </a:prstGeom>
+          <a:noFill/>
+          <a:ln/>
+        </p:spPr>
+        <p:txBody>
+          <a:bodyPr wrap="square" rtlCol="0" anchor="ctr"/>
+          <a:lstStyle/>
+          <a:p>
+            <a:pPr indent="0" marL="0">
+              <a:buNone/>
+            </a:pPr>
+            <a:r>
+              <a:rPr lang="en-US" sz="1050" dirty="0">
+                <a:solidFill>
+                  <a:srgbClr val="2D3748"/>
+                </a:solidFill>
+                <a:latin typeface="Arial" pitchFamily="34" charset="0"/>
+                <a:ea typeface="Arial" pitchFamily="34" charset="-122"/>
+                <a:cs typeface="Arial" pitchFamily="34" charset="-120"/>
+              </a:rPr>
+              <a:t>~2M familias con cuidado activo</a:t>
+            </a:r>
+            <a:endParaRPr lang="en-US" sz="1050" dirty="0"/>
+          </a:p>
+        </p:txBody>
+      </p:sp>
+      <p:sp>
+        <p:nvSpPr>
+          <p:cNvPr id="45" name="Shape 43"/>
+          <p:cNvSpPr/>
+          <p:nvPr/>
+        </p:nvSpPr>
+        <p:spPr>
+          <a:xfrm>
+            <a:off x="365760" y="4663440"/>
+            <a:ext cx="8375904" cy="1005840"/>
+          </a:xfrm>
+          <a:prstGeom prst="roundRect">
+            <a:avLst>
+              <a:gd name="adj" fmla="val 7273"/>
+            </a:avLst>
+          </a:prstGeom>
+          <a:solidFill>
+            <a:srgbClr val="F0FAF4"/>
+          </a:solidFill>
+          <a:ln w="6350">
+            <a:solidFill>
+              <a:srgbClr val="E2E8F0"/>
+            </a:solidFill>
+            <a:prstDash val="solid"/>
+          </a:ln>
+        </p:spPr>
+      </p:sp>
+      <p:sp>
+        <p:nvSpPr>
+          <p:cNvPr id="46" name="Text 44"/>
+          <p:cNvSpPr/>
+          <p:nvPr/>
+        </p:nvSpPr>
+        <p:spPr>
+          <a:xfrm>
+            <a:off x="548640" y="4709160"/>
+            <a:ext cx="1828800" cy="320040"/>
+          </a:xfrm>
+          <a:prstGeom prst="rect">
+            <a:avLst/>
+          </a:prstGeom>
+          <a:noFill/>
+          <a:ln/>
+        </p:spPr>
+        <p:txBody>
+          <a:bodyPr wrap="square" rtlCol="0" anchor="ctr"/>
+          <a:lstStyle/>
+          <a:p>
+            <a:pPr indent="0" marL="0">
+              <a:buNone/>
+            </a:pPr>
+            <a:r>
+              <a:rPr lang="en-US" sz="1100" b="1" dirty="0">
+                <a:solidFill>
+                  <a:srgbClr val="7BA68A"/>
+                </a:solidFill>
+                <a:latin typeface="Arial" pitchFamily="34" charset="0"/>
+                <a:ea typeface="Arial" pitchFamily="34" charset="-122"/>
+                <a:cs typeface="Arial" pitchFamily="34" charset="-120"/>
+              </a:rPr>
+              <a:t>🔄  El flywheel</a:t>
+            </a:r>
+            <a:endParaRPr lang="en-US" sz="1100" dirty="0"/>
+          </a:p>
+        </p:txBody>
+      </p:sp>
+      <p:sp>
+        <p:nvSpPr>
+          <p:cNvPr id="47" name="Text 45"/>
+          <p:cNvSpPr/>
+          <p:nvPr/>
+        </p:nvSpPr>
+        <p:spPr>
+          <a:xfrm>
+            <a:off x="457200" y="5047488"/>
+            <a:ext cx="1078992" cy="530352"/>
+          </a:xfrm>
+          <a:prstGeom prst="rect">
+            <a:avLst/>
+          </a:prstGeom>
+          <a:noFill/>
+          <a:ln/>
+        </p:spPr>
+        <p:txBody>
+          <a:bodyPr wrap="square" rtlCol="0" anchor="ctr"/>
+          <a:lstStyle/>
+          <a:p>
+            <a:pPr algn="ctr" indent="0" marL="0">
+              <a:buNone/>
+            </a:pPr>
+            <a:r>
+              <a:rPr lang="en-US" sz="900" b="1" dirty="0">
+                <a:solidFill>
+                  <a:srgbClr val="2D3748"/>
+                </a:solidFill>
+                <a:latin typeface="Arial" pitchFamily="34" charset="0"/>
+                <a:ea typeface="Arial" pitchFamily="34" charset="-122"/>
+                <a:cs typeface="Arial" pitchFamily="34" charset="-120"/>
+              </a:rPr>
+              <a:t>Familia adopta</a:t>
+            </a:r>
+            <a:endParaRPr lang="en-US" sz="900" dirty="0"/>
+          </a:p>
+          <a:p>
+            <a:pPr algn="ctr" indent="0" marL="0">
+              <a:buNone/>
+            </a:pPr>
+            <a:r>
+              <a:rPr lang="en-US" sz="900" b="1" dirty="0">
+                <a:solidFill>
+                  <a:srgbClr val="2D3748"/>
+                </a:solidFill>
+                <a:latin typeface="Arial" pitchFamily="34" charset="0"/>
+                <a:ea typeface="Arial" pitchFamily="34" charset="-122"/>
+                <a:cs typeface="Arial" pitchFamily="34" charset="-120"/>
+              </a:rPr>
+              <a:t>CareSignal en casa</a:t>
+            </a:r>
+            <a:endParaRPr lang="en-US" sz="900" dirty="0"/>
+          </a:p>
+        </p:txBody>
+      </p:sp>
+      <p:sp>
+        <p:nvSpPr>
+          <p:cNvPr id="48" name="Text 46"/>
+          <p:cNvSpPr/>
+          <p:nvPr/>
+        </p:nvSpPr>
+        <p:spPr>
+          <a:xfrm>
+            <a:off x="1627632" y="5047488"/>
+            <a:ext cx="365760" cy="530352"/>
+          </a:xfrm>
+          <a:prstGeom prst="rect">
+            <a:avLst/>
+          </a:prstGeom>
+          <a:noFill/>
+          <a:ln/>
+        </p:spPr>
+        <p:txBody>
+          <a:bodyPr wrap="square" rtlCol="0" anchor="ctr"/>
+          <a:lstStyle/>
+          <a:p>
+            <a:pPr algn="ctr" indent="0" marL="0">
+              <a:buNone/>
+            </a:pPr>
+            <a:r>
+              <a:rPr lang="en-US" sz="1600" dirty="0">
+                <a:solidFill>
+                  <a:srgbClr val="5B8DB8"/>
+                </a:solidFill>
+                <a:latin typeface="Arial" pitchFamily="34" charset="0"/>
+                <a:ea typeface="Arial" pitchFamily="34" charset="-122"/>
+                <a:cs typeface="Arial" pitchFamily="34" charset="-120"/>
+              </a:rPr>
+              <a:t>→</a:t>
+            </a:r>
+            <a:endParaRPr lang="en-US" sz="1600" dirty="0"/>
+          </a:p>
+        </p:txBody>
+      </p:sp>
+      <p:sp>
+        <p:nvSpPr>
+          <p:cNvPr id="49" name="Text 47"/>
+          <p:cNvSpPr/>
+          <p:nvPr/>
+        </p:nvSpPr>
+        <p:spPr>
+          <a:xfrm>
+            <a:off x="2798064" y="5047488"/>
+            <a:ext cx="1078992" cy="530352"/>
+          </a:xfrm>
+          <a:prstGeom prst="rect">
+            <a:avLst/>
+          </a:prstGeom>
+          <a:noFill/>
+          <a:ln/>
+        </p:spPr>
+        <p:txBody>
+          <a:bodyPr wrap="square" rtlCol="0" anchor="ctr"/>
+          <a:lstStyle/>
+          <a:p>
+            <a:pPr algn="ctr" indent="0" marL="0">
+              <a:buNone/>
+            </a:pPr>
+            <a:r>
+              <a:rPr lang="en-US" sz="900" b="1" dirty="0">
+                <a:solidFill>
+                  <a:srgbClr val="2D3748"/>
+                </a:solidFill>
+                <a:latin typeface="Arial" pitchFamily="34" charset="0"/>
+                <a:ea typeface="Arial" pitchFamily="34" charset="-122"/>
+                <a:cs typeface="Arial" pitchFamily="34" charset="-120"/>
+              </a:rPr>
+              <a:t>Familiar ingresa</a:t>
+            </a:r>
+            <a:endParaRPr lang="en-US" sz="900" dirty="0"/>
+          </a:p>
+          <a:p>
+            <a:pPr algn="ctr" indent="0" marL="0">
+              <a:buNone/>
+            </a:pPr>
+            <a:r>
+              <a:rPr lang="en-US" sz="900" b="1" dirty="0">
+                <a:solidFill>
+                  <a:srgbClr val="2D3748"/>
+                </a:solidFill>
+                <a:latin typeface="Arial" pitchFamily="34" charset="0"/>
+                <a:ea typeface="Arial" pitchFamily="34" charset="-122"/>
+                <a:cs typeface="Arial" pitchFamily="34" charset="-120"/>
+              </a:rPr>
+              <a:t>a una residencia</a:t>
+            </a:r>
+            <a:endParaRPr lang="en-US" sz="900" dirty="0"/>
+          </a:p>
+        </p:txBody>
+      </p:sp>
+      <p:sp>
+        <p:nvSpPr>
+          <p:cNvPr id="50" name="Text 48"/>
+          <p:cNvSpPr/>
+          <p:nvPr/>
+        </p:nvSpPr>
+        <p:spPr>
+          <a:xfrm>
+            <a:off x="3968496" y="5047488"/>
+            <a:ext cx="365760" cy="530352"/>
+          </a:xfrm>
+          <a:prstGeom prst="rect">
+            <a:avLst/>
+          </a:prstGeom>
+          <a:noFill/>
+          <a:ln/>
+        </p:spPr>
+        <p:txBody>
+          <a:bodyPr wrap="square" rtlCol="0" anchor="ctr"/>
+          <a:lstStyle/>
+          <a:p>
+            <a:pPr algn="ctr" indent="0" marL="0">
+              <a:buNone/>
+            </a:pPr>
+            <a:r>
+              <a:rPr lang="en-US" sz="1600" dirty="0">
+                <a:solidFill>
+                  <a:srgbClr val="5B8DB8"/>
+                </a:solidFill>
+                <a:latin typeface="Arial" pitchFamily="34" charset="0"/>
+                <a:ea typeface="Arial" pitchFamily="34" charset="-122"/>
+                <a:cs typeface="Arial" pitchFamily="34" charset="-120"/>
+              </a:rPr>
+              <a:t>→</a:t>
+            </a:r>
+            <a:endParaRPr lang="en-US" sz="1600" dirty="0"/>
+          </a:p>
+        </p:txBody>
+      </p:sp>
+      <p:sp>
+        <p:nvSpPr>
+          <p:cNvPr id="51" name="Text 49"/>
+          <p:cNvSpPr/>
+          <p:nvPr/>
+        </p:nvSpPr>
+        <p:spPr>
+          <a:xfrm>
+            <a:off x="5138928" y="5047488"/>
+            <a:ext cx="1078992" cy="530352"/>
+          </a:xfrm>
+          <a:prstGeom prst="rect">
+            <a:avLst/>
+          </a:prstGeom>
+          <a:noFill/>
+          <a:ln/>
+        </p:spPr>
+        <p:txBody>
+          <a:bodyPr wrap="square" rtlCol="0" anchor="ctr"/>
+          <a:lstStyle/>
+          <a:p>
+            <a:pPr algn="ctr" indent="0" marL="0">
+              <a:buNone/>
+            </a:pPr>
+            <a:r>
+              <a:rPr lang="en-US" sz="900" b="1" dirty="0">
+                <a:solidFill>
+                  <a:srgbClr val="2D3748"/>
+                </a:solidFill>
+                <a:latin typeface="Arial" pitchFamily="34" charset="0"/>
+                <a:ea typeface="Arial" pitchFamily="34" charset="-122"/>
+                <a:cs typeface="Arial" pitchFamily="34" charset="-120"/>
+              </a:rPr>
+              <a:t>Familia recomienda</a:t>
+            </a:r>
+            <a:endParaRPr lang="en-US" sz="900" dirty="0"/>
+          </a:p>
+          <a:p>
+            <a:pPr algn="ctr" indent="0" marL="0">
+              <a:buNone/>
+            </a:pPr>
+            <a:r>
+              <a:rPr lang="en-US" sz="900" b="1" dirty="0">
+                <a:solidFill>
+                  <a:srgbClr val="2D3748"/>
+                </a:solidFill>
+                <a:latin typeface="Arial" pitchFamily="34" charset="0"/>
+                <a:ea typeface="Arial" pitchFamily="34" charset="-122"/>
+                <a:cs typeface="Arial" pitchFamily="34" charset="-120"/>
+              </a:rPr>
+              <a:t>CareSignal al director</a:t>
+            </a:r>
+            <a:endParaRPr lang="en-US" sz="900" dirty="0"/>
+          </a:p>
+        </p:txBody>
+      </p:sp>
+      <p:sp>
+        <p:nvSpPr>
+          <p:cNvPr id="52" name="Text 50"/>
+          <p:cNvSpPr/>
+          <p:nvPr/>
+        </p:nvSpPr>
+        <p:spPr>
+          <a:xfrm>
+            <a:off x="6309360" y="5047488"/>
+            <a:ext cx="365760" cy="530352"/>
+          </a:xfrm>
+          <a:prstGeom prst="rect">
+            <a:avLst/>
+          </a:prstGeom>
+          <a:noFill/>
+          <a:ln/>
+        </p:spPr>
+        <p:txBody>
+          <a:bodyPr wrap="square" rtlCol="0" anchor="ctr"/>
+          <a:lstStyle/>
+          <a:p>
+            <a:pPr algn="ctr" indent="0" marL="0">
+              <a:buNone/>
+            </a:pPr>
+            <a:r>
+              <a:rPr lang="en-US" sz="1600" dirty="0">
+                <a:solidFill>
+                  <a:srgbClr val="5B8DB8"/>
+                </a:solidFill>
+                <a:latin typeface="Arial" pitchFamily="34" charset="0"/>
+                <a:ea typeface="Arial" pitchFamily="34" charset="-122"/>
+                <a:cs typeface="Arial" pitchFamily="34" charset="-120"/>
+              </a:rPr>
+              <a:t>→</a:t>
+            </a:r>
+            <a:endParaRPr lang="en-US" sz="1600" dirty="0"/>
+          </a:p>
+        </p:txBody>
+      </p:sp>
+      <p:sp>
+        <p:nvSpPr>
+          <p:cNvPr id="53" name="Text 51"/>
+          <p:cNvSpPr/>
+          <p:nvPr/>
+        </p:nvSpPr>
+        <p:spPr>
+          <a:xfrm>
+            <a:off x="7479792" y="5047488"/>
+            <a:ext cx="1078992" cy="530352"/>
+          </a:xfrm>
+          <a:prstGeom prst="rect">
+            <a:avLst/>
+          </a:prstGeom>
+          <a:noFill/>
+          <a:ln/>
+        </p:spPr>
+        <p:txBody>
+          <a:bodyPr wrap="square" rtlCol="0" anchor="ctr"/>
+          <a:lstStyle/>
+          <a:p>
+            <a:pPr algn="ctr" indent="0" marL="0">
+              <a:buNone/>
+            </a:pPr>
+            <a:r>
+              <a:rPr lang="en-US" sz="900" b="1" dirty="0">
+                <a:solidFill>
+                  <a:srgbClr val="2D3748"/>
+                </a:solidFill>
+                <a:latin typeface="Arial" pitchFamily="34" charset="0"/>
+                <a:ea typeface="Arial" pitchFamily="34" charset="-122"/>
+                <a:cs typeface="Arial" pitchFamily="34" charset="-120"/>
+              </a:rPr>
+              <a:t>Residencia</a:t>
+            </a:r>
+            <a:endParaRPr lang="en-US" sz="900" dirty="0"/>
+          </a:p>
+          <a:p>
+            <a:pPr algn="ctr" indent="0" marL="0">
+              <a:buNone/>
+            </a:pPr>
+            <a:r>
+              <a:rPr lang="en-US" sz="900" b="1" dirty="0">
+                <a:solidFill>
+                  <a:srgbClr val="2D3748"/>
+                </a:solidFill>
+                <a:latin typeface="Arial" pitchFamily="34" charset="0"/>
+                <a:ea typeface="Arial" pitchFamily="34" charset="-122"/>
+                <a:cs typeface="Arial" pitchFamily="34" charset="-120"/>
+              </a:rPr>
+              <a:t>contrata (B2B)</a:t>
+            </a:r>
+            <a:endParaRPr lang="en-US" sz="900" dirty="0"/>
+          </a:p>
+        </p:txBody>
+      </p:sp>
+      <p:sp>
+        <p:nvSpPr>
+          <p:cNvPr id="54" name="Text 52"/>
+          <p:cNvSpPr/>
+          <p:nvPr/>
+        </p:nvSpPr>
+        <p:spPr>
+          <a:xfrm>
+            <a:off x="457200" y="6291072"/>
+            <a:ext cx="8375904" cy="201168"/>
+          </a:xfrm>
+          <a:prstGeom prst="rect">
+            <a:avLst/>
+          </a:prstGeom>
+          <a:noFill/>
+          <a:ln/>
+        </p:spPr>
+        <p:txBody>
+          <a:bodyPr wrap="square" rtlCol="0" anchor="ctr"/>
+          <a:lstStyle/>
+          <a:p>
+            <a:pPr algn="l" indent="0" marL="0">
+              <a:buNone/>
+            </a:pPr>
+            <a:r>
+              <a:rPr lang="en-US" dirty="0">
+                <a:solidFill>
+                  <a:srgbClr val="718096"/>
+                </a:solidFill>
+                <a:latin typeface="Arial" pitchFamily="34" charset="0"/>
+                <a:ea typeface="Arial" pitchFamily="34" charset="-122"/>
+                <a:cs typeface="Arial" pitchFamily="34" charset="-120"/>
+              </a:rPr>
+              <a:t>⚠️ Fase B2C proyectada — requiere versión móvil y validación de mercado. No comprometida en v0.1.0.</a:t>
+            </a:r>
+            <a:endParaRPr lang="en-US" dirty="0"/>
+          </a:p>
+        </p:txBody>
+      </p:sp>
+    </p:spTree>
+  </p:cSld>
+  <p:clrMapOvr>
+    <a:masterClrMapping/>
+  </p:clrMapOvr>
+</p:sld>
+</file>
+
+<file path=ppt/slides/slide14.xml><?xml version="1.0" encoding="utf-8"?>
+<p:sld xmlns:a="http://schemas.openxmlformats.org/drawingml/2006/main" xmlns:r="http://schemas.openxmlformats.org/officeDocument/2006/relationships" xmlns:p="http://schemas.openxmlformats.org/presentationml/2006/main">
+  <p:cSld name="Slide 14">
+    <p:spTree>
+      <p:nvGrpSpPr>
+        <p:cNvPr id="1" name=""/>
+        <p:cNvGrpSpPr/>
+        <p:nvPr/>
+      </p:nvGrpSpPr>
+      <p:grpSpPr>
+        <a:xfrm>
+          <a:off x="0" y="0"/>
+          <a:ext cx="0" cy="0"/>
+          <a:chOff x="0" y="0"/>
+          <a:chExt cx="0" cy="0"/>
+        </a:xfrm>
+      </p:grpSpPr>
+      <p:sp>
+        <p:nvSpPr>
+          <p:cNvPr id="2" name="Shape 0"/>
+          <p:cNvSpPr/>
+          <p:nvPr/>
+        </p:nvSpPr>
+        <p:spPr>
+          <a:xfrm>
+            <a:off x="0" y="0"/>
+            <a:ext cx="12192000" cy="6858000"/>
+          </a:xfrm>
+          <a:prstGeom prst="rect">
+            <a:avLst/>
+          </a:prstGeom>
+          <a:solidFill>
+            <a:srgbClr val="FAFAF8"/>
+          </a:solidFill>
+          <a:ln w="12700">
+            <a:solidFill>
+              <a:srgbClr val="FAFAF8"/>
+            </a:solidFill>
+            <a:prstDash val="solid"/>
+          </a:ln>
+        </p:spPr>
+      </p:sp>
+      <p:sp>
+        <p:nvSpPr>
+          <p:cNvPr id="3" name="Shape 1"/>
+          <p:cNvSpPr/>
+          <p:nvPr/>
+        </p:nvSpPr>
+        <p:spPr>
+          <a:xfrm>
             <a:off x="6583680" y="4389120"/>
             <a:ext cx="3840480" cy="3840480"/>
           </a:xfrm>
@@ -8118,9 +10546,9 @@
 </p:sld>
 </file>
 
-<file path=ppt/slides/slide14.xml><?xml version="1.0" encoding="utf-8"?>
+<file path=ppt/slides/slide15.xml><?xml version="1.0" encoding="utf-8"?>
 <p:sld xmlns:a="http://schemas.openxmlformats.org/drawingml/2006/main" xmlns:r="http://schemas.openxmlformats.org/officeDocument/2006/relationships" xmlns:p="http://schemas.openxmlformats.org/presentationml/2006/main">
-  <p:cSld name="Slide 14">
+  <p:cSld name="Slide 15">
     <p:spTree>
       <p:nvGrpSpPr>
         <p:cNvPr id="1" name=""/>

</xml_diff>